<commit_message>
Handout: add the hybrid simulation and empirical modeling approach
Co-Authored-By: Claude Sonnet 5.5 <noreply@anthropic.com>
</commit_message>
<xml_diff>
--- a/dashboard/public/haav-handout.pptx
+++ b/dashboard/public/haav-handout.pptx
@@ -3473,7 +3473,7 @@
         <p:spPr>
           <a:xfrm>
             <a:off x="512064" y="3017520"/>
-            <a:ext cx="2468880" cy="457200"/>
+            <a:ext cx="2697480" cy="457200"/>
           </a:xfrm>
           <a:prstGeom prst="rect">
             <a:avLst/>
@@ -3507,8 +3507,8 @@
         </p:nvSpPr>
         <p:spPr>
           <a:xfrm>
-            <a:off x="512064" y="3547872"/>
-            <a:ext cx="2468880" cy="914400"/>
+            <a:off x="512064" y="3529584"/>
+            <a:ext cx="2697480" cy="1005840"/>
           </a:xfrm>
           <a:prstGeom prst="rect">
             <a:avLst/>
@@ -3523,11 +3523,11 @@
           <a:p>
             <a:pPr algn="l">
               <a:lnSpc>
-                <a:spcPct val="120000"/>
+                <a:spcPct val="115000"/>
               </a:lnSpc>
             </a:pPr>
             <a:r>
-              <a:rPr sz="900" b="0">
+              <a:rPr sz="850" b="0">
                 <a:solidFill>
                   <a:srgbClr val="3F3F46"/>
                 </a:solidFill>
@@ -3536,7 +3536,7 @@
               <a:t>We build the model from physics up. Each constraint cuts the space of possible boats, and the optimizer finds the fastest one left. Hull resistance comes from </a:t>
             </a:r>
             <a:r>
-              <a:rPr sz="900" b="1">
+              <a:rPr sz="850" b="1">
                 <a:solidFill>
                   <a:srgbClr val="3F3F46"/>
                 </a:solidFill>
@@ -3545,13 +3545,13 @@
               <a:t>Savitsky's planing-hull model</a:t>
             </a:r>
             <a:r>
-              <a:rPr sz="900" b="0">
+              <a:rPr sz="850" b="0">
                 <a:solidFill>
                   <a:srgbClr val="3F3F46"/>
                 </a:solidFill>
                 <a:latin typeface="Arial"/>
               </a:rPr>
-              <a:t>.</a:t>
+              <a:t>. As we build and test, we keep updating the model and adding constraints: a hybrid of simulation and empirical data.</a:t>
             </a:r>
           </a:p>
         </p:txBody>
@@ -3564,8 +3564,8 @@
         </p:nvSpPr>
         <p:spPr>
           <a:xfrm>
-            <a:off x="512064" y="4526280"/>
-            <a:ext cx="2468880" cy="365760"/>
+            <a:off x="512064" y="4572000"/>
+            <a:ext cx="2697480" cy="274320"/>
           </a:xfrm>
           <a:prstGeom prst="rect">
             <a:avLst/>

</xml_diff>

<commit_message>
Handout: remove the illustrative note under the model text
Co-Authored-By: Claude Sonnet 5.5 <noreply@anthropic.com>
</commit_message>
<xml_diff>
--- a/dashboard/public/haav-handout.pptx
+++ b/dashboard/public/haav-handout.pptx
@@ -3558,42 +3558,7 @@
       </p:sp>
       <p:sp>
         <p:nvSpPr>
-          <p:cNvPr id="14" name="Model note"/>
-          <p:cNvSpPr txBox="1"/>
-          <p:nvPr/>
-        </p:nvSpPr>
-        <p:spPr>
-          <a:xfrm>
-            <a:off x="512064" y="4572000"/>
-            <a:ext cx="2697480" cy="274320"/>
-          </a:xfrm>
-          <a:prstGeom prst="rect">
-            <a:avLst/>
-          </a:prstGeom>
-          <a:noFill/>
-        </p:spPr>
-        <p:txBody>
-          <a:bodyPr wrap="square" lIns="0" rIns="0" tIns="0" bIns="0" anchor="t">
-            <a:spAutoFit/>
-          </a:bodyPr>
-          <a:lstStyle/>
-          <a:p>
-            <a:pPr algn="l"/>
-            <a:r>
-              <a:rPr sz="800" b="0">
-                <a:solidFill>
-                  <a:srgbClr val="71717A"/>
-                </a:solidFill>
-                <a:latin typeface="Arial"/>
-              </a:rPr>
-              <a:t>Illustrative: lines are constraints, dots are integer choices, red is what the 6 kW drive adds.</a:t>
-            </a:r>
-          </a:p>
-        </p:txBody>
-      </p:sp>
-      <p:sp>
-        <p:nvSpPr>
-          <p:cNvPr id="15" name="Graph plate"/>
+          <p:cNvPr id="14" name="Graph plate"/>
           <p:cNvSpPr/>
           <p:nvPr/>
         </p:nvSpPr>
@@ -3639,7 +3604,7 @@
       </p:sp>
       <p:pic>
         <p:nvPicPr>
-          <p:cNvPr id="16" name="Feasible-region graph" descr="graph.png"/>
+          <p:cNvPr id="15" name="Feasible-region graph" descr="graph.png"/>
           <p:cNvPicPr>
             <a:picLocks noChangeAspect="1"/>
           </p:cNvPicPr>
@@ -3663,7 +3628,7 @@
       </p:pic>
       <p:sp>
         <p:nvSpPr>
-          <p:cNvPr id="17" name="Label: Engineers from across UW–Madison"/>
+          <p:cNvPr id="16" name="Label: Engineers from across UW–Madison"/>
           <p:cNvSpPr txBox="1"/>
           <p:nvPr/>
         </p:nvSpPr>
@@ -3698,7 +3663,7 @@
       </p:sp>
       <p:sp>
         <p:nvSpPr>
-          <p:cNvPr id="18" name="Engineers text"/>
+          <p:cNvPr id="17" name="Engineers text"/>
           <p:cNvSpPr txBox="1"/>
           <p:nvPr/>
         </p:nvSpPr>
@@ -3733,7 +3698,7 @@
       </p:sp>
       <p:sp>
         <p:nvSpPr>
-          <p:cNvPr id="19" name="Tile: Industrial"/>
+          <p:cNvPr id="18" name="Tile: Industrial"/>
           <p:cNvSpPr/>
           <p:nvPr/>
         </p:nvSpPr>
@@ -3779,7 +3744,7 @@
       </p:sp>
       <p:sp>
         <p:nvSpPr>
-          <p:cNvPr id="20" name="Tile title: Industrial"/>
+          <p:cNvPr id="19" name="Tile title: Industrial"/>
           <p:cNvSpPr txBox="1"/>
           <p:nvPr/>
         </p:nvSpPr>
@@ -3814,7 +3779,7 @@
       </p:sp>
       <p:sp>
         <p:nvSpPr>
-          <p:cNvPr id="21" name="Tile text: Industrial"/>
+          <p:cNvPr id="20" name="Tile text: Industrial"/>
           <p:cNvSpPr txBox="1"/>
           <p:nvPr/>
         </p:nvSpPr>
@@ -3853,7 +3818,7 @@
       </p:sp>
       <p:sp>
         <p:nvSpPr>
-          <p:cNvPr id="22" name="Tile: Mechanical"/>
+          <p:cNvPr id="21" name="Tile: Mechanical"/>
           <p:cNvSpPr/>
           <p:nvPr/>
         </p:nvSpPr>
@@ -3899,7 +3864,7 @@
       </p:sp>
       <p:sp>
         <p:nvSpPr>
-          <p:cNvPr id="23" name="Tile title: Mechanical"/>
+          <p:cNvPr id="22" name="Tile title: Mechanical"/>
           <p:cNvSpPr txBox="1"/>
           <p:nvPr/>
         </p:nvSpPr>
@@ -3934,7 +3899,7 @@
       </p:sp>
       <p:sp>
         <p:nvSpPr>
-          <p:cNvPr id="24" name="Tile text: Mechanical"/>
+          <p:cNvPr id="23" name="Tile text: Mechanical"/>
           <p:cNvSpPr txBox="1"/>
           <p:nvPr/>
         </p:nvSpPr>
@@ -3973,7 +3938,7 @@
       </p:sp>
       <p:sp>
         <p:nvSpPr>
-          <p:cNvPr id="25" name="Tile: Electrical"/>
+          <p:cNvPr id="24" name="Tile: Electrical"/>
           <p:cNvSpPr/>
           <p:nvPr/>
         </p:nvSpPr>
@@ -4019,7 +3984,7 @@
       </p:sp>
       <p:sp>
         <p:nvSpPr>
-          <p:cNvPr id="26" name="Tile title: Electrical"/>
+          <p:cNvPr id="25" name="Tile title: Electrical"/>
           <p:cNvSpPr txBox="1"/>
           <p:nvPr/>
         </p:nvSpPr>
@@ -4054,7 +4019,7 @@
       </p:sp>
       <p:sp>
         <p:nvSpPr>
-          <p:cNvPr id="27" name="Tile text: Electrical"/>
+          <p:cNvPr id="26" name="Tile text: Electrical"/>
           <p:cNvSpPr txBox="1"/>
           <p:nvPr/>
         </p:nvSpPr>
@@ -4093,7 +4058,7 @@
       </p:sp>
       <p:sp>
         <p:nvSpPr>
-          <p:cNvPr id="28" name="Tile: Computer"/>
+          <p:cNvPr id="27" name="Tile: Computer"/>
           <p:cNvSpPr/>
           <p:nvPr/>
         </p:nvSpPr>
@@ -4139,7 +4104,7 @@
       </p:sp>
       <p:sp>
         <p:nvSpPr>
-          <p:cNvPr id="29" name="Tile title: Computer"/>
+          <p:cNvPr id="28" name="Tile title: Computer"/>
           <p:cNvSpPr txBox="1"/>
           <p:nvPr/>
         </p:nvSpPr>
@@ -4174,7 +4139,7 @@
       </p:sp>
       <p:sp>
         <p:nvSpPr>
-          <p:cNvPr id="30" name="Tile text: Computer"/>
+          <p:cNvPr id="29" name="Tile text: Computer"/>
           <p:cNvSpPr txBox="1"/>
           <p:nvPr/>
         </p:nvSpPr>
@@ -4213,7 +4178,7 @@
       </p:sp>
       <p:sp>
         <p:nvSpPr>
-          <p:cNvPr id="31" name="Label: Our approach"/>
+          <p:cNvPr id="30" name="Label: Our approach"/>
           <p:cNvSpPr txBox="1"/>
           <p:nvPr/>
         </p:nvSpPr>
@@ -4248,7 +4213,7 @@
       </p:sp>
       <p:sp>
         <p:nvSpPr>
-          <p:cNvPr id="32" name="Card: Hull"/>
+          <p:cNvPr id="31" name="Card: Hull"/>
           <p:cNvSpPr/>
           <p:nvPr/>
         </p:nvSpPr>
@@ -4296,7 +4261,7 @@
       </p:sp>
       <p:sp>
         <p:nvSpPr>
-          <p:cNvPr id="33" name="Card title: Hull"/>
+          <p:cNvPr id="32" name="Card title: Hull"/>
           <p:cNvSpPr txBox="1"/>
           <p:nvPr/>
         </p:nvSpPr>
@@ -4331,7 +4296,7 @@
       </p:sp>
       <p:sp>
         <p:nvSpPr>
-          <p:cNvPr id="34" name="Card strategy: Hull"/>
+          <p:cNvPr id="33" name="Card strategy: Hull"/>
           <p:cNvSpPr txBox="1"/>
           <p:nvPr/>
         </p:nvSpPr>
@@ -4366,7 +4331,7 @@
       </p:sp>
       <p:sp>
         <p:nvSpPr>
-          <p:cNvPr id="35" name="Card rule: Hull"/>
+          <p:cNvPr id="34" name="Card rule: Hull"/>
           <p:cNvSpPr/>
           <p:nvPr/>
         </p:nvSpPr>
@@ -4410,7 +4375,7 @@
       </p:sp>
       <p:sp>
         <p:nvSpPr>
-          <p:cNvPr id="36" name="Card points: Hull"/>
+          <p:cNvPr id="35" name="Card points: Hull"/>
           <p:cNvSpPr txBox="1"/>
           <p:nvPr/>
         </p:nvSpPr>
@@ -4508,7 +4473,7 @@
       </p:sp>
       <p:sp>
         <p:nvSpPr>
-          <p:cNvPr id="37" name="Card: Electric"/>
+          <p:cNvPr id="36" name="Card: Electric"/>
           <p:cNvSpPr/>
           <p:nvPr/>
         </p:nvSpPr>
@@ -4556,7 +4521,7 @@
       </p:sp>
       <p:sp>
         <p:nvSpPr>
-          <p:cNvPr id="38" name="Card title: Electric"/>
+          <p:cNvPr id="37" name="Card title: Electric"/>
           <p:cNvSpPr txBox="1"/>
           <p:nvPr/>
         </p:nvSpPr>
@@ -4591,7 +4556,7 @@
       </p:sp>
       <p:sp>
         <p:nvSpPr>
-          <p:cNvPr id="39" name="Card strategy: Electric"/>
+          <p:cNvPr id="38" name="Card strategy: Electric"/>
           <p:cNvSpPr txBox="1"/>
           <p:nvPr/>
         </p:nvSpPr>
@@ -4626,7 +4591,7 @@
       </p:sp>
       <p:sp>
         <p:nvSpPr>
-          <p:cNvPr id="40" name="Card rule: Electric"/>
+          <p:cNvPr id="39" name="Card rule: Electric"/>
           <p:cNvSpPr/>
           <p:nvPr/>
         </p:nvSpPr>
@@ -4670,7 +4635,7 @@
       </p:sp>
       <p:sp>
         <p:nvSpPr>
-          <p:cNvPr id="41" name="Card points: Electric"/>
+          <p:cNvPr id="40" name="Card points: Electric"/>
           <p:cNvSpPr txBox="1"/>
           <p:nvPr/>
         </p:nvSpPr>
@@ -4768,7 +4733,7 @@
       </p:sp>
       <p:sp>
         <p:nvSpPr>
-          <p:cNvPr id="42" name="Card: Autonomous"/>
+          <p:cNvPr id="41" name="Card: Autonomous"/>
           <p:cNvSpPr/>
           <p:nvPr/>
         </p:nvSpPr>
@@ -4816,7 +4781,7 @@
       </p:sp>
       <p:sp>
         <p:nvSpPr>
-          <p:cNvPr id="43" name="Card title: Autonomous"/>
+          <p:cNvPr id="42" name="Card title: Autonomous"/>
           <p:cNvSpPr txBox="1"/>
           <p:nvPr/>
         </p:nvSpPr>
@@ -4851,7 +4816,7 @@
       </p:sp>
       <p:sp>
         <p:nvSpPr>
-          <p:cNvPr id="44" name="Card strategy: Autonomous"/>
+          <p:cNvPr id="43" name="Card strategy: Autonomous"/>
           <p:cNvSpPr txBox="1"/>
           <p:nvPr/>
         </p:nvSpPr>
@@ -4886,7 +4851,7 @@
       </p:sp>
       <p:sp>
         <p:nvSpPr>
-          <p:cNvPr id="45" name="Card rule: Autonomous"/>
+          <p:cNvPr id="44" name="Card rule: Autonomous"/>
           <p:cNvSpPr/>
           <p:nvPr/>
         </p:nvSpPr>
@@ -4930,7 +4895,7 @@
       </p:sp>
       <p:sp>
         <p:nvSpPr>
-          <p:cNvPr id="46" name="Card points: Autonomous"/>
+          <p:cNvPr id="45" name="Card points: Autonomous"/>
           <p:cNvSpPr txBox="1"/>
           <p:nvPr/>
         </p:nvSpPr>
@@ -5028,7 +4993,7 @@
       </p:sp>
       <p:sp>
         <p:nvSpPr>
-          <p:cNvPr id="47" name="Label: Timeline"/>
+          <p:cNvPr id="46" name="Label: Timeline"/>
           <p:cNvSpPr txBox="1"/>
           <p:nvPr/>
         </p:nvSpPr>
@@ -5063,7 +5028,7 @@
       </p:sp>
       <p:sp>
         <p:nvSpPr>
-          <p:cNvPr id="48" name="Timeline rule: Hull design"/>
+          <p:cNvPr id="47" name="Timeline rule: Hull design"/>
           <p:cNvSpPr/>
           <p:nvPr/>
         </p:nvSpPr>
@@ -5107,7 +5072,7 @@
       </p:sp>
       <p:sp>
         <p:nvSpPr>
-          <p:cNvPr id="49" name="Timeline date: Hull design"/>
+          <p:cNvPr id="48" name="Timeline date: Hull design"/>
           <p:cNvSpPr txBox="1"/>
           <p:nvPr/>
         </p:nvSpPr>
@@ -5142,7 +5107,7 @@
       </p:sp>
       <p:sp>
         <p:nvSpPr>
-          <p:cNvPr id="50" name="Timeline label: Hull design"/>
+          <p:cNvPr id="49" name="Timeline label: Hull design"/>
           <p:cNvSpPr txBox="1"/>
           <p:nvPr/>
         </p:nvSpPr>
@@ -5177,7 +5142,7 @@
       </p:sp>
       <p:sp>
         <p:nvSpPr>
-          <p:cNvPr id="51" name="Timeline rule: Electrical design"/>
+          <p:cNvPr id="50" name="Timeline rule: Electrical design"/>
           <p:cNvSpPr/>
           <p:nvPr/>
         </p:nvSpPr>
@@ -5221,7 +5186,7 @@
       </p:sp>
       <p:sp>
         <p:nvSpPr>
-          <p:cNvPr id="52" name="Timeline date: Electrical design"/>
+          <p:cNvPr id="51" name="Timeline date: Electrical design"/>
           <p:cNvSpPr txBox="1"/>
           <p:nvPr/>
         </p:nvSpPr>
@@ -5256,7 +5221,7 @@
       </p:sp>
       <p:sp>
         <p:nvSpPr>
-          <p:cNvPr id="53" name="Timeline label: Electrical design"/>
+          <p:cNvPr id="52" name="Timeline label: Electrical design"/>
           <p:cNvSpPr txBox="1"/>
           <p:nvPr/>
         </p:nvSpPr>
@@ -5291,7 +5256,7 @@
       </p:sp>
       <p:sp>
         <p:nvSpPr>
-          <p:cNvPr id="54" name="Timeline rule: Hull built"/>
+          <p:cNvPr id="53" name="Timeline rule: Hull built"/>
           <p:cNvSpPr/>
           <p:nvPr/>
         </p:nvSpPr>
@@ -5335,7 +5300,7 @@
       </p:sp>
       <p:sp>
         <p:nvSpPr>
-          <p:cNvPr id="55" name="Timeline date: Hull built"/>
+          <p:cNvPr id="54" name="Timeline date: Hull built"/>
           <p:cNvSpPr txBox="1"/>
           <p:nvPr/>
         </p:nvSpPr>
@@ -5370,7 +5335,7 @@
       </p:sp>
       <p:sp>
         <p:nvSpPr>
-          <p:cNvPr id="56" name="Timeline label: Hull built"/>
+          <p:cNvPr id="55" name="Timeline label: Hull built"/>
           <p:cNvSpPr txBox="1"/>
           <p:nvPr/>
         </p:nvSpPr>
@@ -5405,7 +5370,7 @@
       </p:sp>
       <p:sp>
         <p:nvSpPr>
-          <p:cNvPr id="57" name="Timeline rule: First drive"/>
+          <p:cNvPr id="56" name="Timeline rule: First drive"/>
           <p:cNvSpPr/>
           <p:nvPr/>
         </p:nvSpPr>
@@ -5449,7 +5414,7 @@
       </p:sp>
       <p:sp>
         <p:nvSpPr>
-          <p:cNvPr id="58" name="Timeline date: First drive"/>
+          <p:cNvPr id="57" name="Timeline date: First drive"/>
           <p:cNvSpPr txBox="1"/>
           <p:nvPr/>
         </p:nvSpPr>
@@ -5484,7 +5449,7 @@
       </p:sp>
       <p:sp>
         <p:nvSpPr>
-          <p:cNvPr id="59" name="Timeline label: First drive"/>
+          <p:cNvPr id="58" name="Timeline label: First drive"/>
           <p:cNvSpPr txBox="1"/>
           <p:nvPr/>
         </p:nvSpPr>
@@ -5519,7 +5484,7 @@
       </p:sp>
       <p:sp>
         <p:nvSpPr>
-          <p:cNvPr id="60" name="Timeline rule: First fast drive"/>
+          <p:cNvPr id="59" name="Timeline rule: First fast drive"/>
           <p:cNvSpPr/>
           <p:nvPr/>
         </p:nvSpPr>
@@ -5563,7 +5528,7 @@
       </p:sp>
       <p:sp>
         <p:nvSpPr>
-          <p:cNvPr id="61" name="Timeline date: First fast drive"/>
+          <p:cNvPr id="60" name="Timeline date: First fast drive"/>
           <p:cNvSpPr txBox="1"/>
           <p:nvPr/>
         </p:nvSpPr>
@@ -5598,7 +5563,7 @@
       </p:sp>
       <p:sp>
         <p:nvSpPr>
-          <p:cNvPr id="62" name="Timeline label: First fast drive"/>
+          <p:cNvPr id="61" name="Timeline label: First fast drive"/>
           <p:cNvSpPr txBox="1"/>
           <p:nvPr/>
         </p:nvSpPr>
@@ -5633,7 +5598,7 @@
       </p:sp>
       <p:sp>
         <p:nvSpPr>
-          <p:cNvPr id="63" name="Timeline rule: Tuning and testing"/>
+          <p:cNvPr id="62" name="Timeline rule: Tuning and testing"/>
           <p:cNvSpPr/>
           <p:nvPr/>
         </p:nvSpPr>
@@ -5677,7 +5642,7 @@
       </p:sp>
       <p:sp>
         <p:nvSpPr>
-          <p:cNvPr id="64" name="Timeline date: Tuning and testing"/>
+          <p:cNvPr id="63" name="Timeline date: Tuning and testing"/>
           <p:cNvSpPr txBox="1"/>
           <p:nvPr/>
         </p:nvSpPr>
@@ -5712,7 +5677,7 @@
       </p:sp>
       <p:sp>
         <p:nvSpPr>
-          <p:cNvPr id="65" name="Timeline label: Tuning and testing"/>
+          <p:cNvPr id="64" name="Timeline label: Tuning and testing"/>
           <p:cNvSpPr txBox="1"/>
           <p:nvPr/>
         </p:nvSpPr>
@@ -5747,7 +5712,7 @@
       </p:sp>
       <p:sp>
         <p:nvSpPr>
-          <p:cNvPr id="66" name="Footer band"/>
+          <p:cNvPr id="65" name="Footer band"/>
           <p:cNvSpPr/>
           <p:nvPr/>
         </p:nvSpPr>
@@ -5791,7 +5756,7 @@
       </p:sp>
       <p:sp>
         <p:nvSpPr>
-          <p:cNvPr id="67" name="Footer title"/>
+          <p:cNvPr id="66" name="Footer title"/>
           <p:cNvSpPr txBox="1"/>
           <p:nvPr/>
         </p:nvSpPr>
@@ -5826,7 +5791,7 @@
       </p:sp>
       <p:sp>
         <p:nvSpPr>
-          <p:cNvPr id="68" name="Footer tagline"/>
+          <p:cNvPr id="67" name="Footer tagline"/>
           <p:cNvSpPr txBox="1"/>
           <p:nvPr/>
         </p:nvSpPr>
@@ -5861,7 +5826,7 @@
       </p:sp>
       <p:sp>
         <p:nvSpPr>
-          <p:cNvPr id="69" name="Footer link label"/>
+          <p:cNvPr id="68" name="Footer link label"/>
           <p:cNvSpPr txBox="1"/>
           <p:nvPr/>
         </p:nvSpPr>
@@ -5896,7 +5861,7 @@
       </p:sp>
       <p:sp>
         <p:nvSpPr>
-          <p:cNvPr id="70" name="Footer link"/>
+          <p:cNvPr id="69" name="Footer link"/>
           <p:cNvSpPr txBox="1"/>
           <p:nvPr/>
         </p:nvSpPr>
@@ -5931,7 +5896,7 @@
       </p:sp>
       <p:sp>
         <p:nvSpPr>
-          <p:cNvPr id="71" name="Footer contact label"/>
+          <p:cNvPr id="70" name="Footer contact label"/>
           <p:cNvSpPr txBox="1"/>
           <p:nvPr/>
         </p:nvSpPr>
@@ -5966,7 +5931,7 @@
       </p:sp>
       <p:sp>
         <p:nvSpPr>
-          <p:cNvPr id="72" name="Footer contact name"/>
+          <p:cNvPr id="71" name="Footer contact name"/>
           <p:cNvSpPr txBox="1"/>
           <p:nvPr/>
         </p:nvSpPr>
@@ -6001,7 +5966,7 @@
       </p:sp>
       <p:sp>
         <p:nvSpPr>
-          <p:cNvPr id="73" name="Footer contact email"/>
+          <p:cNvPr id="72" name="Footer contact email"/>
           <p:cNvSpPr txBox="1"/>
           <p:nvPr/>
         </p:nvSpPr>

</xml_diff>

<commit_message>
Handout: remove the graph
Co-Authored-By: Claude Sonnet 5.5 <noreply@anthropic.com>
</commit_message>
<xml_diff>
--- a/dashboard/public/haav-handout.pptx
+++ b/dashboard/public/haav-handout.pptx
@@ -3427,11 +3427,11 @@
         <p:spPr>
           <a:xfrm>
             <a:off x="384048" y="2852928"/>
-            <a:ext cx="7004304" cy="2057400"/>
+            <a:ext cx="7004304" cy="1216152"/>
           </a:xfrm>
           <a:prstGeom prst="roundRect">
             <a:avLst>
-              <a:gd name="adj" fmla="val 4444"/>
+              <a:gd name="adj" fmla="val 7518"/>
             </a:avLst>
           </a:prstGeom>
           <a:solidFill>
@@ -3472,8 +3472,8 @@
         </p:nvSpPr>
         <p:spPr>
           <a:xfrm>
-            <a:off x="512064" y="3017520"/>
-            <a:ext cx="2697480" cy="457200"/>
+            <a:off x="548640" y="2990088"/>
+            <a:ext cx="6675120" cy="274320"/>
           </a:xfrm>
           <a:prstGeom prst="rect">
             <a:avLst/>
@@ -3488,7 +3488,7 @@
           <a:p>
             <a:pPr algn="l"/>
             <a:r>
-              <a:rPr sz="1200" b="1">
+              <a:rPr sz="1300" b="1">
                 <a:solidFill>
                   <a:srgbClr val="18181B"/>
                 </a:solidFill>
@@ -3507,8 +3507,8 @@
         </p:nvSpPr>
         <p:spPr>
           <a:xfrm>
-            <a:off x="512064" y="3529584"/>
-            <a:ext cx="2697480" cy="1005840"/>
+            <a:off x="548640" y="3310128"/>
+            <a:ext cx="6675120" cy="685800"/>
           </a:xfrm>
           <a:prstGeom prst="rect">
             <a:avLst/>
@@ -3523,11 +3523,11 @@
           <a:p>
             <a:pPr algn="l">
               <a:lnSpc>
-                <a:spcPct val="115000"/>
+                <a:spcPct val="120000"/>
               </a:lnSpc>
             </a:pPr>
             <a:r>
-              <a:rPr sz="850" b="0">
+              <a:rPr sz="1000" b="0">
                 <a:solidFill>
                   <a:srgbClr val="3F3F46"/>
                 </a:solidFill>
@@ -3536,7 +3536,7 @@
               <a:t>We build the model from physics up. Each constraint cuts the space of possible boats, and the optimizer finds the fastest one left. Hull resistance comes from </a:t>
             </a:r>
             <a:r>
-              <a:rPr sz="850" b="1">
+              <a:rPr sz="1000" b="1">
                 <a:solidFill>
                   <a:srgbClr val="3F3F46"/>
                 </a:solidFill>
@@ -3545,7 +3545,7 @@
               <a:t>Savitsky's planing-hull model</a:t>
             </a:r>
             <a:r>
-              <a:rPr sz="850" b="0">
+              <a:rPr sz="1000" b="0">
                 <a:solidFill>
                   <a:srgbClr val="3F3F46"/>
                 </a:solidFill>
@@ -3558,22 +3558,92 @@
       </p:sp>
       <p:sp>
         <p:nvSpPr>
-          <p:cNvPr id="14" name="Graph plate"/>
+          <p:cNvPr id="14" name="Label: Engineers from across UW–Madison"/>
+          <p:cNvSpPr txBox="1"/>
+          <p:nvPr/>
+        </p:nvSpPr>
+        <p:spPr>
+          <a:xfrm>
+            <a:off x="384048" y="4389120"/>
+            <a:ext cx="4572000" cy="182880"/>
+          </a:xfrm>
+          <a:prstGeom prst="rect">
+            <a:avLst/>
+          </a:prstGeom>
+          <a:noFill/>
+        </p:spPr>
+        <p:txBody>
+          <a:bodyPr wrap="square" lIns="0" rIns="0" tIns="0" bIns="0" anchor="t">
+            <a:spAutoFit/>
+          </a:bodyPr>
+          <a:lstStyle/>
+          <a:p>
+            <a:pPr algn="l"/>
+            <a:r>
+              <a:rPr sz="800" b="1">
+                <a:solidFill>
+                  <a:srgbClr val="71717A"/>
+                </a:solidFill>
+                <a:latin typeface="Arial"/>
+              </a:rPr>
+              <a:t>ENGINEERS FROM ACROSS UW–MADISON</a:t>
+            </a:r>
+          </a:p>
+        </p:txBody>
+      </p:sp>
+      <p:sp>
+        <p:nvSpPr>
+          <p:cNvPr id="15" name="Engineers text"/>
+          <p:cNvSpPr txBox="1"/>
+          <p:nvPr/>
+        </p:nvSpPr>
+        <p:spPr>
+          <a:xfrm>
+            <a:off x="384048" y="4572000"/>
+            <a:ext cx="7004304" cy="182880"/>
+          </a:xfrm>
+          <a:prstGeom prst="rect">
+            <a:avLst/>
+          </a:prstGeom>
+          <a:noFill/>
+        </p:spPr>
+        <p:txBody>
+          <a:bodyPr wrap="square" lIns="0" rIns="0" tIns="0" bIns="0" anchor="t">
+            <a:spAutoFit/>
+          </a:bodyPr>
+          <a:lstStyle/>
+          <a:p>
+            <a:pPr algn="l"/>
+            <a:r>
+              <a:rPr sz="900" b="0">
+                <a:solidFill>
+                  <a:srgbClr val="3F3F46"/>
+                </a:solidFill>
+                <a:latin typeface="Arial"/>
+              </a:rPr>
+              <a:t>Each segment of the boat is covered, and members have worked at Tesla, Northrop Grumman, Xcel Energy and Milwaukee Tool.</a:t>
+            </a:r>
+          </a:p>
+        </p:txBody>
+      </p:sp>
+      <p:sp>
+        <p:nvSpPr>
+          <p:cNvPr id="16" name="Tile: Industrial"/>
           <p:cNvSpPr/>
           <p:nvPr/>
         </p:nvSpPr>
         <p:spPr>
           <a:xfrm>
-            <a:off x="3355848" y="2953512"/>
-            <a:ext cx="3913632" cy="1856231"/>
+            <a:off x="384048" y="4828032"/>
+            <a:ext cx="1655064" cy="713232"/>
           </a:xfrm>
           <a:prstGeom prst="roundRect">
             <a:avLst>
-              <a:gd name="adj" fmla="val 3940"/>
+              <a:gd name="adj" fmla="val 8974"/>
             </a:avLst>
           </a:prstGeom>
           <a:solidFill>
-            <a:srgbClr val="FFFFFF"/>
+            <a:srgbClr val="F4F4F5"/>
           </a:solidFill>
           <a:ln>
             <a:noFill/>
@@ -3602,40 +3672,16 @@
           </a:p>
         </p:txBody>
       </p:sp>
-      <p:pic>
-        <p:nvPicPr>
-          <p:cNvPr id="15" name="Feasible-region graph" descr="graph.png"/>
-          <p:cNvPicPr>
-            <a:picLocks noChangeAspect="1"/>
-          </p:cNvPicPr>
-          <p:nvPr/>
-        </p:nvPicPr>
-        <p:blipFill>
-          <a:blip r:embed="rId4"/>
-          <a:stretch>
-            <a:fillRect/>
-          </a:stretch>
-        </p:blipFill>
-        <p:spPr>
-          <a:xfrm>
-            <a:off x="3447288" y="3017520"/>
-            <a:ext cx="3730752" cy="1667866"/>
-          </a:xfrm>
-          <a:prstGeom prst="rect">
-            <a:avLst/>
-          </a:prstGeom>
-        </p:spPr>
-      </p:pic>
-      <p:sp>
-        <p:nvSpPr>
-          <p:cNvPr id="16" name="Label: Engineers from across UW–Madison"/>
+      <p:sp>
+        <p:nvSpPr>
+          <p:cNvPr id="17" name="Tile title: Industrial"/>
           <p:cNvSpPr txBox="1"/>
           <p:nvPr/>
         </p:nvSpPr>
         <p:spPr>
           <a:xfrm>
-            <a:off x="384048" y="5138928"/>
-            <a:ext cx="4572000" cy="182880"/>
+            <a:off x="484632" y="4892040"/>
+            <a:ext cx="1472184" cy="182880"/>
           </a:xfrm>
           <a:prstGeom prst="rect">
             <a:avLst/>
@@ -3650,27 +3696,27 @@
           <a:p>
             <a:pPr algn="l"/>
             <a:r>
-              <a:rPr sz="800" b="1">
-                <a:solidFill>
-                  <a:srgbClr val="71717A"/>
+              <a:rPr sz="1100" b="1">
+                <a:solidFill>
+                  <a:srgbClr val="C5050C"/>
                 </a:solidFill>
                 <a:latin typeface="Arial"/>
               </a:rPr>
-              <a:t>ENGINEERS FROM ACROSS UW–MADISON</a:t>
-            </a:r>
-          </a:p>
-        </p:txBody>
-      </p:sp>
-      <p:sp>
-        <p:nvSpPr>
-          <p:cNvPr id="17" name="Engineers text"/>
+              <a:t>Industrial</a:t>
+            </a:r>
+          </a:p>
+        </p:txBody>
+      </p:sp>
+      <p:sp>
+        <p:nvSpPr>
+          <p:cNvPr id="18" name="Tile text: Industrial"/>
           <p:cNvSpPr txBox="1"/>
           <p:nvPr/>
         </p:nvSpPr>
         <p:spPr>
           <a:xfrm>
-            <a:off x="384048" y="5321808"/>
-            <a:ext cx="7004304" cy="182880"/>
+            <a:off x="484632" y="5102352"/>
+            <a:ext cx="1472184" cy="411480"/>
           </a:xfrm>
           <a:prstGeom prst="rect">
             <a:avLst/>
@@ -3683,7 +3729,11 @@
           </a:bodyPr>
           <a:lstStyle/>
           <a:p>
-            <a:pPr algn="l"/>
+            <a:pPr algn="l">
+              <a:lnSpc>
+                <a:spcPct val="110000"/>
+              </a:lnSpc>
+            </a:pPr>
             <a:r>
               <a:rPr sz="900" b="0">
                 <a:solidFill>
@@ -3691,20 +3741,20 @@
                 </a:solidFill>
                 <a:latin typeface="Arial"/>
               </a:rPr>
-              <a:t>Each segment of the boat is covered, and members have worked at Tesla, Northrop Grumman, Xcel Energy and Milwaukee Tool.</a:t>
-            </a:r>
-          </a:p>
-        </p:txBody>
-      </p:sp>
-      <p:sp>
-        <p:nvSpPr>
-          <p:cNvPr id="18" name="Tile: Industrial"/>
+              <a:t>Optimization, composites and manufacturing</a:t>
+            </a:r>
+          </a:p>
+        </p:txBody>
+      </p:sp>
+      <p:sp>
+        <p:nvSpPr>
+          <p:cNvPr id="19" name="Tile: Mechanical"/>
           <p:cNvSpPr/>
           <p:nvPr/>
         </p:nvSpPr>
         <p:spPr>
           <a:xfrm>
-            <a:off x="384048" y="5577840"/>
+            <a:off x="2157984" y="4828032"/>
             <a:ext cx="1655064" cy="713232"/>
           </a:xfrm>
           <a:prstGeom prst="roundRect">
@@ -3744,13 +3794,13 @@
       </p:sp>
       <p:sp>
         <p:nvSpPr>
-          <p:cNvPr id="19" name="Tile title: Industrial"/>
+          <p:cNvPr id="20" name="Tile title: Mechanical"/>
           <p:cNvSpPr txBox="1"/>
           <p:nvPr/>
         </p:nvSpPr>
         <p:spPr>
           <a:xfrm>
-            <a:off x="484632" y="5641848"/>
+            <a:off x="2258568" y="4892040"/>
             <a:ext cx="1472184" cy="182880"/>
           </a:xfrm>
           <a:prstGeom prst="rect">
@@ -3772,20 +3822,20 @@
                 </a:solidFill>
                 <a:latin typeface="Arial"/>
               </a:rPr>
-              <a:t>Industrial</a:t>
-            </a:r>
-          </a:p>
-        </p:txBody>
-      </p:sp>
-      <p:sp>
-        <p:nvSpPr>
-          <p:cNvPr id="20" name="Tile text: Industrial"/>
+              <a:t>Mechanical</a:t>
+            </a:r>
+          </a:p>
+        </p:txBody>
+      </p:sp>
+      <p:sp>
+        <p:nvSpPr>
+          <p:cNvPr id="21" name="Tile text: Mechanical"/>
           <p:cNvSpPr txBox="1"/>
           <p:nvPr/>
         </p:nvSpPr>
         <p:spPr>
           <a:xfrm>
-            <a:off x="484632" y="5852160"/>
+            <a:off x="2258568" y="5102352"/>
             <a:ext cx="1472184" cy="411480"/>
           </a:xfrm>
           <a:prstGeom prst="rect">
@@ -3811,20 +3861,20 @@
                 </a:solidFill>
                 <a:latin typeface="Arial"/>
               </a:rPr>
-              <a:t>Optimization, composites and manufacturing</a:t>
-            </a:r>
-          </a:p>
-        </p:txBody>
-      </p:sp>
-      <p:sp>
-        <p:nvSpPr>
-          <p:cNvPr id="21" name="Tile: Mechanical"/>
+              <a:t>Structures, CAD and fabrication</a:t>
+            </a:r>
+          </a:p>
+        </p:txBody>
+      </p:sp>
+      <p:sp>
+        <p:nvSpPr>
+          <p:cNvPr id="22" name="Tile: Electrical"/>
           <p:cNvSpPr/>
           <p:nvPr/>
         </p:nvSpPr>
         <p:spPr>
           <a:xfrm>
-            <a:off x="2157984" y="5577840"/>
+            <a:off x="3931920" y="4828032"/>
             <a:ext cx="1655064" cy="713232"/>
           </a:xfrm>
           <a:prstGeom prst="roundRect">
@@ -3864,13 +3914,13 @@
       </p:sp>
       <p:sp>
         <p:nvSpPr>
-          <p:cNvPr id="22" name="Tile title: Mechanical"/>
+          <p:cNvPr id="23" name="Tile title: Electrical"/>
           <p:cNvSpPr txBox="1"/>
           <p:nvPr/>
         </p:nvSpPr>
         <p:spPr>
           <a:xfrm>
-            <a:off x="2258568" y="5641848"/>
+            <a:off x="4032504" y="4892040"/>
             <a:ext cx="1472184" cy="182880"/>
           </a:xfrm>
           <a:prstGeom prst="rect">
@@ -3892,20 +3942,20 @@
                 </a:solidFill>
                 <a:latin typeface="Arial"/>
               </a:rPr>
-              <a:t>Mechanical</a:t>
-            </a:r>
-          </a:p>
-        </p:txBody>
-      </p:sp>
-      <p:sp>
-        <p:nvSpPr>
-          <p:cNvPr id="23" name="Tile text: Mechanical"/>
+              <a:t>Electrical</a:t>
+            </a:r>
+          </a:p>
+        </p:txBody>
+      </p:sp>
+      <p:sp>
+        <p:nvSpPr>
+          <p:cNvPr id="24" name="Tile text: Electrical"/>
           <p:cNvSpPr txBox="1"/>
           <p:nvPr/>
         </p:nvSpPr>
         <p:spPr>
           <a:xfrm>
-            <a:off x="2258568" y="5852160"/>
+            <a:off x="4032504" y="5102352"/>
             <a:ext cx="1472184" cy="411480"/>
           </a:xfrm>
           <a:prstGeom prst="rect">
@@ -3931,20 +3981,20 @@
                 </a:solidFill>
                 <a:latin typeface="Arial"/>
               </a:rPr>
-              <a:t>Structures, CAD and fabrication</a:t>
-            </a:r>
-          </a:p>
-        </p:txBody>
-      </p:sp>
-      <p:sp>
-        <p:nvSpPr>
-          <p:cNvPr id="24" name="Tile: Electrical"/>
+              <a:t>Power, battery and high voltage</a:t>
+            </a:r>
+          </a:p>
+        </p:txBody>
+      </p:sp>
+      <p:sp>
+        <p:nvSpPr>
+          <p:cNvPr id="25" name="Tile: Computer"/>
           <p:cNvSpPr/>
           <p:nvPr/>
         </p:nvSpPr>
         <p:spPr>
           <a:xfrm>
-            <a:off x="3931920" y="5577840"/>
+            <a:off x="5705856" y="4828032"/>
             <a:ext cx="1655064" cy="713232"/>
           </a:xfrm>
           <a:prstGeom prst="roundRect">
@@ -3984,13 +4034,13 @@
       </p:sp>
       <p:sp>
         <p:nvSpPr>
-          <p:cNvPr id="25" name="Tile title: Electrical"/>
+          <p:cNvPr id="26" name="Tile title: Computer"/>
           <p:cNvSpPr txBox="1"/>
           <p:nvPr/>
         </p:nvSpPr>
         <p:spPr>
           <a:xfrm>
-            <a:off x="4032504" y="5641848"/>
+            <a:off x="5806440" y="4892040"/>
             <a:ext cx="1472184" cy="182880"/>
           </a:xfrm>
           <a:prstGeom prst="rect">
@@ -4012,20 +4062,20 @@
                 </a:solidFill>
                 <a:latin typeface="Arial"/>
               </a:rPr>
-              <a:t>Electrical</a:t>
-            </a:r>
-          </a:p>
-        </p:txBody>
-      </p:sp>
-      <p:sp>
-        <p:nvSpPr>
-          <p:cNvPr id="26" name="Tile text: Electrical"/>
+              <a:t>Computer</a:t>
+            </a:r>
+          </a:p>
+        </p:txBody>
+      </p:sp>
+      <p:sp>
+        <p:nvSpPr>
+          <p:cNvPr id="27" name="Tile text: Computer"/>
           <p:cNvSpPr txBox="1"/>
           <p:nvPr/>
         </p:nvSpPr>
         <p:spPr>
           <a:xfrm>
-            <a:off x="4032504" y="5852160"/>
+            <a:off x="5806440" y="5102352"/>
             <a:ext cx="1472184" cy="411480"/>
           </a:xfrm>
           <a:prstGeom prst="rect">
@@ -4051,32 +4101,69 @@
                 </a:solidFill>
                 <a:latin typeface="Arial"/>
               </a:rPr>
-              <a:t>Power, battery and high voltage</a:t>
-            </a:r>
-          </a:p>
-        </p:txBody>
-      </p:sp>
-      <p:sp>
-        <p:nvSpPr>
-          <p:cNvPr id="27" name="Tile: Computer"/>
+              <a:t>Embedded, firmware and software</a:t>
+            </a:r>
+          </a:p>
+        </p:txBody>
+      </p:sp>
+      <p:sp>
+        <p:nvSpPr>
+          <p:cNvPr id="28" name="Label: Our approach"/>
+          <p:cNvSpPr txBox="1"/>
+          <p:nvPr/>
+        </p:nvSpPr>
+        <p:spPr>
+          <a:xfrm>
+            <a:off x="384048" y="5852160"/>
+            <a:ext cx="3657600" cy="182880"/>
+          </a:xfrm>
+          <a:prstGeom prst="rect">
+            <a:avLst/>
+          </a:prstGeom>
+          <a:noFill/>
+        </p:spPr>
+        <p:txBody>
+          <a:bodyPr wrap="square" lIns="0" rIns="0" tIns="0" bIns="0" anchor="t">
+            <a:spAutoFit/>
+          </a:bodyPr>
+          <a:lstStyle/>
+          <a:p>
+            <a:pPr algn="l"/>
+            <a:r>
+              <a:rPr sz="800" b="1">
+                <a:solidFill>
+                  <a:srgbClr val="71717A"/>
+                </a:solidFill>
+                <a:latin typeface="Arial"/>
+              </a:rPr>
+              <a:t>OUR APPROACH</a:t>
+            </a:r>
+          </a:p>
+        </p:txBody>
+      </p:sp>
+      <p:sp>
+        <p:nvSpPr>
+          <p:cNvPr id="29" name="Card: Hull"/>
           <p:cNvSpPr/>
           <p:nvPr/>
         </p:nvSpPr>
         <p:spPr>
           <a:xfrm>
-            <a:off x="5705856" y="5577840"/>
-            <a:ext cx="1655064" cy="713232"/>
+            <a:off x="384048" y="6062472"/>
+            <a:ext cx="2240280" cy="1783080"/>
           </a:xfrm>
           <a:prstGeom prst="roundRect">
             <a:avLst>
-              <a:gd name="adj" fmla="val 8974"/>
+              <a:gd name="adj" fmla="val 5128"/>
             </a:avLst>
           </a:prstGeom>
           <a:solidFill>
-            <a:srgbClr val="F4F4F5"/>
+            <a:srgbClr val="FFFFFF"/>
           </a:solidFill>
-          <a:ln>
-            <a:noFill/>
+          <a:ln w="9525">
+            <a:solidFill>
+              <a:srgbClr val="E4E4E7"/>
+            </a:solidFill>
           </a:ln>
           <a:effectLst/>
         </p:spPr>
@@ -4104,14 +4191,14 @@
       </p:sp>
       <p:sp>
         <p:nvSpPr>
-          <p:cNvPr id="28" name="Tile title: Computer"/>
+          <p:cNvPr id="30" name="Card title: Hull"/>
           <p:cNvSpPr txBox="1"/>
           <p:nvPr/>
         </p:nvSpPr>
         <p:spPr>
           <a:xfrm>
-            <a:off x="5806440" y="5641848"/>
-            <a:ext cx="1472184" cy="182880"/>
+            <a:off x="521207" y="6172200"/>
+            <a:ext cx="1965960" cy="274320"/>
           </a:xfrm>
           <a:prstGeom prst="rect">
             <a:avLst/>
@@ -4126,27 +4213,27 @@
           <a:p>
             <a:pPr algn="l"/>
             <a:r>
-              <a:rPr sz="1100" b="1">
-                <a:solidFill>
-                  <a:srgbClr val="C5050C"/>
+              <a:rPr sz="1500" b="1">
+                <a:solidFill>
+                  <a:srgbClr val="18181B"/>
                 </a:solidFill>
                 <a:latin typeface="Arial"/>
               </a:rPr>
-              <a:t>Computer</a:t>
-            </a:r>
-          </a:p>
-        </p:txBody>
-      </p:sp>
-      <p:sp>
-        <p:nvSpPr>
-          <p:cNvPr id="29" name="Tile text: Computer"/>
+              <a:t>Hull</a:t>
+            </a:r>
+          </a:p>
+        </p:txBody>
+      </p:sp>
+      <p:sp>
+        <p:nvSpPr>
+          <p:cNvPr id="31" name="Card strategy: Hull"/>
           <p:cNvSpPr txBox="1"/>
           <p:nvPr/>
         </p:nvSpPr>
         <p:spPr>
           <a:xfrm>
-            <a:off x="5806440" y="5852160"/>
-            <a:ext cx="1472184" cy="411480"/>
+            <a:off x="521207" y="6510528"/>
+            <a:ext cx="1965960" cy="228600"/>
           </a:xfrm>
           <a:prstGeom prst="rect">
             <a:avLst/>
@@ -4159,81 +4246,38 @@
           </a:bodyPr>
           <a:lstStyle/>
           <a:p>
-            <a:pPr algn="l">
-              <a:lnSpc>
-                <a:spcPct val="110000"/>
-              </a:lnSpc>
-            </a:pPr>
-            <a:r>
-              <a:rPr sz="900" b="0">
-                <a:solidFill>
-                  <a:srgbClr val="3F3F46"/>
+            <a:pPr algn="l"/>
+            <a:r>
+              <a:rPr sz="1050" b="1">
+                <a:solidFill>
+                  <a:srgbClr val="18181B"/>
                 </a:solidFill>
                 <a:latin typeface="Arial"/>
               </a:rPr>
-              <a:t>Embedded, firmware and software</a:t>
-            </a:r>
-          </a:p>
-        </p:txBody>
-      </p:sp>
-      <p:sp>
-        <p:nvSpPr>
-          <p:cNvPr id="30" name="Label: Our approach"/>
-          <p:cNvSpPr txBox="1"/>
-          <p:nvPr/>
-        </p:nvSpPr>
-        <p:spPr>
-          <a:xfrm>
-            <a:off x="384048" y="6556248"/>
-            <a:ext cx="3657600" cy="182880"/>
-          </a:xfrm>
-          <a:prstGeom prst="rect">
-            <a:avLst/>
-          </a:prstGeom>
-          <a:noFill/>
-        </p:spPr>
-        <p:txBody>
-          <a:bodyPr wrap="square" lIns="0" rIns="0" tIns="0" bIns="0" anchor="t">
-            <a:spAutoFit/>
-          </a:bodyPr>
-          <a:lstStyle/>
-          <a:p>
-            <a:pPr algn="l"/>
-            <a:r>
-              <a:rPr sz="800" b="1">
-                <a:solidFill>
-                  <a:srgbClr val="71717A"/>
-                </a:solidFill>
-                <a:latin typeface="Arial"/>
-              </a:rPr>
-              <a:t>OUR APPROACH</a:t>
-            </a:r>
-          </a:p>
-        </p:txBody>
-      </p:sp>
-      <p:sp>
-        <p:nvSpPr>
-          <p:cNvPr id="31" name="Card: Hull"/>
+              <a:t>Plane well and stay light.</a:t>
+            </a:r>
+          </a:p>
+        </p:txBody>
+      </p:sp>
+      <p:sp>
+        <p:nvSpPr>
+          <p:cNvPr id="32" name="Card rule: Hull"/>
           <p:cNvSpPr/>
           <p:nvPr/>
         </p:nvSpPr>
         <p:spPr>
           <a:xfrm>
-            <a:off x="384048" y="6766560"/>
-            <a:ext cx="2240280" cy="1536192"/>
-          </a:xfrm>
-          <a:prstGeom prst="roundRect">
-            <a:avLst>
-              <a:gd name="adj" fmla="val 5952"/>
-            </a:avLst>
+            <a:off x="521207" y="6821424"/>
+            <a:ext cx="1965960" cy="9144"/>
+          </a:xfrm>
+          <a:prstGeom prst="rect">
+            <a:avLst/>
           </a:prstGeom>
           <a:solidFill>
-            <a:srgbClr val="FFFFFF"/>
+            <a:srgbClr val="E4E4E7"/>
           </a:solidFill>
-          <a:ln w="9525">
-            <a:solidFill>
-              <a:srgbClr val="E4E4E7"/>
-            </a:solidFill>
+          <a:ln>
+            <a:noFill/>
           </a:ln>
           <a:effectLst/>
         </p:spPr>
@@ -4261,14 +4305,14 @@
       </p:sp>
       <p:sp>
         <p:nvSpPr>
-          <p:cNvPr id="32" name="Card title: Hull"/>
+          <p:cNvPr id="33" name="Card points: Hull"/>
           <p:cNvSpPr txBox="1"/>
           <p:nvPr/>
         </p:nvSpPr>
         <p:spPr>
           <a:xfrm>
-            <a:off x="521207" y="6858000"/>
-            <a:ext cx="1965960" cy="274320"/>
+            <a:off x="521207" y="6931152"/>
+            <a:ext cx="1965960" cy="822960"/>
           </a:xfrm>
           <a:prstGeom prst="rect">
             <a:avLst/>
@@ -4281,73 +4325,105 @@
           </a:bodyPr>
           <a:lstStyle/>
           <a:p>
-            <a:pPr algn="l"/>
-            <a:r>
-              <a:rPr sz="1500" b="1">
-                <a:solidFill>
-                  <a:srgbClr val="18181B"/>
+            <a:pPr algn="l">
+              <a:lnSpc>
+                <a:spcPct val="175000"/>
+              </a:lnSpc>
+            </a:pPr>
+            <a:r>
+              <a:rPr sz="600" b="0">
+                <a:solidFill>
+                  <a:srgbClr val="C5050C"/>
                 </a:solidFill>
                 <a:latin typeface="Arial"/>
               </a:rPr>
-              <a:t>Hull</a:t>
-            </a:r>
-          </a:p>
-        </p:txBody>
-      </p:sp>
-      <p:sp>
-        <p:nvSpPr>
-          <p:cNvPr id="33" name="Card strategy: Hull"/>
-          <p:cNvSpPr txBox="1"/>
-          <p:nvPr/>
-        </p:nvSpPr>
-        <p:spPr>
-          <a:xfrm>
-            <a:off x="521207" y="7187184"/>
-            <a:ext cx="1965960" cy="228600"/>
-          </a:xfrm>
-          <a:prstGeom prst="rect">
-            <a:avLst/>
-          </a:prstGeom>
-          <a:noFill/>
-        </p:spPr>
-        <p:txBody>
-          <a:bodyPr wrap="square" lIns="0" rIns="0" tIns="0" bIns="0" anchor="t">
-            <a:spAutoFit/>
-          </a:bodyPr>
-          <a:lstStyle/>
-          <a:p>
-            <a:pPr algn="l"/>
-            <a:r>
-              <a:rPr sz="1050" b="1">
-                <a:solidFill>
-                  <a:srgbClr val="18181B"/>
+              <a:t>●  </a:t>
+            </a:r>
+            <a:r>
+              <a:rPr sz="900" b="0">
+                <a:solidFill>
+                  <a:srgbClr val="3F3F46"/>
                 </a:solidFill>
                 <a:latin typeface="Arial"/>
               </a:rPr>
-              <a:t>Plane well and stay light.</a:t>
-            </a:r>
-          </a:p>
-        </p:txBody>
-      </p:sp>
-      <p:sp>
-        <p:nvSpPr>
-          <p:cNvPr id="34" name="Card rule: Hull"/>
+              <a:t>Hybrid planing composite hull</a:t>
+            </a:r>
+          </a:p>
+          <a:p>
+            <a:pPr algn="l">
+              <a:lnSpc>
+                <a:spcPct val="175000"/>
+              </a:lnSpc>
+            </a:pPr>
+            <a:r>
+              <a:rPr sz="600" b="0">
+                <a:solidFill>
+                  <a:srgbClr val="C5050C"/>
+                </a:solidFill>
+                <a:latin typeface="Arial"/>
+              </a:rPr>
+              <a:t>●  </a:t>
+            </a:r>
+            <a:r>
+              <a:rPr sz="900" b="0">
+                <a:solidFill>
+                  <a:srgbClr val="3F3F46"/>
+                </a:solidFill>
+                <a:latin typeface="Arial"/>
+              </a:rPr>
+              <a:t>Shape tuned by optimization</a:t>
+            </a:r>
+          </a:p>
+          <a:p>
+            <a:pPr algn="l">
+              <a:lnSpc>
+                <a:spcPct val="175000"/>
+              </a:lnSpc>
+            </a:pPr>
+            <a:r>
+              <a:rPr sz="600" b="0">
+                <a:solidFill>
+                  <a:srgbClr val="C5050C"/>
+                </a:solidFill>
+                <a:latin typeface="Arial"/>
+              </a:rPr>
+              <a:t>●  </a:t>
+            </a:r>
+            <a:r>
+              <a:rPr sz="900" b="0">
+                <a:solidFill>
+                  <a:srgbClr val="3F3F46"/>
+                </a:solidFill>
+                <a:latin typeface="Arial"/>
+              </a:rPr>
+              <a:t>Resistance checked in CFD first</a:t>
+            </a:r>
+          </a:p>
+        </p:txBody>
+      </p:sp>
+      <p:sp>
+        <p:nvSpPr>
+          <p:cNvPr id="34" name="Card: Electric"/>
           <p:cNvSpPr/>
           <p:nvPr/>
         </p:nvSpPr>
         <p:spPr>
           <a:xfrm>
-            <a:off x="521207" y="7479792"/>
-            <a:ext cx="1965960" cy="9144"/>
-          </a:xfrm>
-          <a:prstGeom prst="rect">
-            <a:avLst/>
+            <a:off x="2743200" y="6062472"/>
+            <a:ext cx="2240280" cy="1783080"/>
+          </a:xfrm>
+          <a:prstGeom prst="roundRect">
+            <a:avLst>
+              <a:gd name="adj" fmla="val 5128"/>
+            </a:avLst>
           </a:prstGeom>
           <a:solidFill>
-            <a:srgbClr val="E4E4E7"/>
+            <a:srgbClr val="FFFFFF"/>
           </a:solidFill>
-          <a:ln>
-            <a:noFill/>
+          <a:ln w="9525">
+            <a:solidFill>
+              <a:srgbClr val="E4E4E7"/>
+            </a:solidFill>
           </a:ln>
           <a:effectLst/>
         </p:spPr>
@@ -4375,14 +4451,14 @@
       </p:sp>
       <p:sp>
         <p:nvSpPr>
-          <p:cNvPr id="35" name="Card points: Hull"/>
+          <p:cNvPr id="35" name="Card title: Electric"/>
           <p:cNvSpPr txBox="1"/>
           <p:nvPr/>
         </p:nvSpPr>
         <p:spPr>
           <a:xfrm>
-            <a:off x="521207" y="7562088"/>
-            <a:ext cx="1965960" cy="685800"/>
+            <a:off x="2880360" y="6172200"/>
+            <a:ext cx="1965960" cy="274320"/>
           </a:xfrm>
           <a:prstGeom prst="rect">
             <a:avLst/>
@@ -4395,105 +4471,73 @@
           </a:bodyPr>
           <a:lstStyle/>
           <a:p>
-            <a:pPr algn="l">
-              <a:lnSpc>
-                <a:spcPct val="145000"/>
-              </a:lnSpc>
-            </a:pPr>
-            <a:r>
-              <a:rPr sz="600" b="0">
-                <a:solidFill>
-                  <a:srgbClr val="C5050C"/>
+            <a:pPr algn="l"/>
+            <a:r>
+              <a:rPr sz="1500" b="1">
+                <a:solidFill>
+                  <a:srgbClr val="18181B"/>
                 </a:solidFill>
                 <a:latin typeface="Arial"/>
               </a:rPr>
-              <a:t>●  </a:t>
-            </a:r>
-            <a:r>
-              <a:rPr sz="900" b="0">
-                <a:solidFill>
-                  <a:srgbClr val="3F3F46"/>
+              <a:t>Electric</a:t>
+            </a:r>
+          </a:p>
+        </p:txBody>
+      </p:sp>
+      <p:sp>
+        <p:nvSpPr>
+          <p:cNvPr id="36" name="Card strategy: Electric"/>
+          <p:cNvSpPr txBox="1"/>
+          <p:nvPr/>
+        </p:nvSpPr>
+        <p:spPr>
+          <a:xfrm>
+            <a:off x="2880360" y="6510528"/>
+            <a:ext cx="1965960" cy="228600"/>
+          </a:xfrm>
+          <a:prstGeom prst="rect">
+            <a:avLst/>
+          </a:prstGeom>
+          <a:noFill/>
+        </p:spPr>
+        <p:txBody>
+          <a:bodyPr wrap="square" lIns="0" rIns="0" tIns="0" bIns="0" anchor="t">
+            <a:spAutoFit/>
+          </a:bodyPr>
+          <a:lstStyle/>
+          <a:p>
+            <a:pPr algn="l"/>
+            <a:r>
+              <a:rPr sz="1050" b="1">
+                <a:solidFill>
+                  <a:srgbClr val="18181B"/>
                 </a:solidFill>
                 <a:latin typeface="Arial"/>
               </a:rPr>
-              <a:t>Hybrid planing composite hull</a:t>
-            </a:r>
-          </a:p>
-          <a:p>
-            <a:pPr algn="l">
-              <a:lnSpc>
-                <a:spcPct val="145000"/>
-              </a:lnSpc>
-            </a:pPr>
-            <a:r>
-              <a:rPr sz="600" b="0">
-                <a:solidFill>
-                  <a:srgbClr val="C5050C"/>
-                </a:solidFill>
-                <a:latin typeface="Arial"/>
-              </a:rPr>
-              <a:t>●  </a:t>
-            </a:r>
-            <a:r>
-              <a:rPr sz="900" b="0">
-                <a:solidFill>
-                  <a:srgbClr val="3F3F46"/>
-                </a:solidFill>
-                <a:latin typeface="Arial"/>
-              </a:rPr>
-              <a:t>Shape tuned by optimization</a:t>
-            </a:r>
-          </a:p>
-          <a:p>
-            <a:pPr algn="l">
-              <a:lnSpc>
-                <a:spcPct val="145000"/>
-              </a:lnSpc>
-            </a:pPr>
-            <a:r>
-              <a:rPr sz="600" b="0">
-                <a:solidFill>
-                  <a:srgbClr val="C5050C"/>
-                </a:solidFill>
-                <a:latin typeface="Arial"/>
-              </a:rPr>
-              <a:t>●  </a:t>
-            </a:r>
-            <a:r>
-              <a:rPr sz="900" b="0">
-                <a:solidFill>
-                  <a:srgbClr val="3F3F46"/>
-                </a:solidFill>
-                <a:latin typeface="Arial"/>
-              </a:rPr>
-              <a:t>Resistance checked in CFD first</a:t>
-            </a:r>
-          </a:p>
-        </p:txBody>
-      </p:sp>
-      <p:sp>
-        <p:nvSpPr>
-          <p:cNvPr id="36" name="Card: Electric"/>
+              <a:t>Every watt-hour to speed.</a:t>
+            </a:r>
+          </a:p>
+        </p:txBody>
+      </p:sp>
+      <p:sp>
+        <p:nvSpPr>
+          <p:cNvPr id="37" name="Card rule: Electric"/>
           <p:cNvSpPr/>
           <p:nvPr/>
         </p:nvSpPr>
         <p:spPr>
           <a:xfrm>
-            <a:off x="2743200" y="6766560"/>
-            <a:ext cx="2240280" cy="1536192"/>
-          </a:xfrm>
-          <a:prstGeom prst="roundRect">
-            <a:avLst>
-              <a:gd name="adj" fmla="val 5952"/>
-            </a:avLst>
+            <a:off x="2880360" y="6821424"/>
+            <a:ext cx="1965960" cy="9144"/>
+          </a:xfrm>
+          <a:prstGeom prst="rect">
+            <a:avLst/>
           </a:prstGeom>
           <a:solidFill>
-            <a:srgbClr val="FFFFFF"/>
+            <a:srgbClr val="E4E4E7"/>
           </a:solidFill>
-          <a:ln w="9525">
-            <a:solidFill>
-              <a:srgbClr val="E4E4E7"/>
-            </a:solidFill>
+          <a:ln>
+            <a:noFill/>
           </a:ln>
           <a:effectLst/>
         </p:spPr>
@@ -4521,14 +4565,14 @@
       </p:sp>
       <p:sp>
         <p:nvSpPr>
-          <p:cNvPr id="37" name="Card title: Electric"/>
+          <p:cNvPr id="38" name="Card points: Electric"/>
           <p:cNvSpPr txBox="1"/>
           <p:nvPr/>
         </p:nvSpPr>
         <p:spPr>
           <a:xfrm>
-            <a:off x="2880360" y="6858000"/>
-            <a:ext cx="1965960" cy="274320"/>
+            <a:off x="2880360" y="6931152"/>
+            <a:ext cx="1965960" cy="822960"/>
           </a:xfrm>
           <a:prstGeom prst="rect">
             <a:avLst/>
@@ -4541,73 +4585,105 @@
           </a:bodyPr>
           <a:lstStyle/>
           <a:p>
-            <a:pPr algn="l"/>
-            <a:r>
-              <a:rPr sz="1500" b="1">
-                <a:solidFill>
-                  <a:srgbClr val="18181B"/>
+            <a:pPr algn="l">
+              <a:lnSpc>
+                <a:spcPct val="175000"/>
+              </a:lnSpc>
+            </a:pPr>
+            <a:r>
+              <a:rPr sz="600" b="0">
+                <a:solidFill>
+                  <a:srgbClr val="C5050C"/>
                 </a:solidFill>
                 <a:latin typeface="Arial"/>
               </a:rPr>
-              <a:t>Electric</a:t>
-            </a:r>
-          </a:p>
-        </p:txBody>
-      </p:sp>
-      <p:sp>
-        <p:nvSpPr>
-          <p:cNvPr id="38" name="Card strategy: Electric"/>
-          <p:cNvSpPr txBox="1"/>
-          <p:nvPr/>
-        </p:nvSpPr>
-        <p:spPr>
-          <a:xfrm>
-            <a:off x="2880360" y="7187184"/>
-            <a:ext cx="1965960" cy="228600"/>
-          </a:xfrm>
-          <a:prstGeom prst="rect">
-            <a:avLst/>
-          </a:prstGeom>
-          <a:noFill/>
-        </p:spPr>
-        <p:txBody>
-          <a:bodyPr wrap="square" lIns="0" rIns="0" tIns="0" bIns="0" anchor="t">
-            <a:spAutoFit/>
-          </a:bodyPr>
-          <a:lstStyle/>
-          <a:p>
-            <a:pPr algn="l"/>
-            <a:r>
-              <a:rPr sz="1050" b="1">
-                <a:solidFill>
-                  <a:srgbClr val="18181B"/>
+              <a:t>●  </a:t>
+            </a:r>
+            <a:r>
+              <a:rPr sz="900" b="0">
+                <a:solidFill>
+                  <a:srgbClr val="3F3F46"/>
                 </a:solidFill>
                 <a:latin typeface="Arial"/>
               </a:rPr>
-              <a:t>Every watt-hour to speed.</a:t>
-            </a:r>
-          </a:p>
-        </p:txBody>
-      </p:sp>
-      <p:sp>
-        <p:nvSpPr>
-          <p:cNvPr id="39" name="Card rule: Electric"/>
+              <a:t>High-voltage battery storage</a:t>
+            </a:r>
+          </a:p>
+          <a:p>
+            <a:pPr algn="l">
+              <a:lnSpc>
+                <a:spcPct val="175000"/>
+              </a:lnSpc>
+            </a:pPr>
+            <a:r>
+              <a:rPr sz="600" b="0">
+                <a:solidFill>
+                  <a:srgbClr val="C5050C"/>
+                </a:solidFill>
+                <a:latin typeface="Arial"/>
+              </a:rPr>
+              <a:t>●  </a:t>
+            </a:r>
+            <a:r>
+              <a:rPr sz="900" b="0">
+                <a:solidFill>
+                  <a:srgbClr val="3F3F46"/>
+                </a:solidFill>
+                <a:latin typeface="Arial"/>
+              </a:rPr>
+              <a:t>Propulsion sized by the model</a:t>
+            </a:r>
+          </a:p>
+          <a:p>
+            <a:pPr algn="l">
+              <a:lnSpc>
+                <a:spcPct val="175000"/>
+              </a:lnSpc>
+            </a:pPr>
+            <a:r>
+              <a:rPr sz="600" b="0">
+                <a:solidFill>
+                  <a:srgbClr val="C5050C"/>
+                </a:solidFill>
+                <a:latin typeface="Arial"/>
+              </a:rPr>
+              <a:t>●  </a:t>
+            </a:r>
+            <a:r>
+              <a:rPr sz="900" b="0">
+                <a:solidFill>
+                  <a:srgbClr val="3F3F46"/>
+                </a:solidFill>
+                <a:latin typeface="Arial"/>
+              </a:rPr>
+              <a:t>Propulsion and cooling co-designed</a:t>
+            </a:r>
+          </a:p>
+        </p:txBody>
+      </p:sp>
+      <p:sp>
+        <p:nvSpPr>
+          <p:cNvPr id="39" name="Card: Autonomous"/>
           <p:cNvSpPr/>
           <p:nvPr/>
         </p:nvSpPr>
         <p:spPr>
           <a:xfrm>
-            <a:off x="2880360" y="7479792"/>
-            <a:ext cx="1965960" cy="9144"/>
-          </a:xfrm>
-          <a:prstGeom prst="rect">
-            <a:avLst/>
+            <a:off x="5102352" y="6062472"/>
+            <a:ext cx="2240280" cy="1783080"/>
+          </a:xfrm>
+          <a:prstGeom prst="roundRect">
+            <a:avLst>
+              <a:gd name="adj" fmla="val 5128"/>
+            </a:avLst>
           </a:prstGeom>
           <a:solidFill>
-            <a:srgbClr val="E4E4E7"/>
+            <a:srgbClr val="FFFFFF"/>
           </a:solidFill>
-          <a:ln>
-            <a:noFill/>
+          <a:ln w="9525">
+            <a:solidFill>
+              <a:srgbClr val="E4E4E7"/>
+            </a:solidFill>
           </a:ln>
           <a:effectLst/>
         </p:spPr>
@@ -4635,14 +4711,14 @@
       </p:sp>
       <p:sp>
         <p:nvSpPr>
-          <p:cNvPr id="40" name="Card points: Electric"/>
+          <p:cNvPr id="40" name="Card title: Autonomous"/>
           <p:cNvSpPr txBox="1"/>
           <p:nvPr/>
         </p:nvSpPr>
         <p:spPr>
           <a:xfrm>
-            <a:off x="2880360" y="7562088"/>
-            <a:ext cx="1965960" cy="685800"/>
+            <a:off x="5239512" y="6172200"/>
+            <a:ext cx="1965960" cy="274320"/>
           </a:xfrm>
           <a:prstGeom prst="rect">
             <a:avLst/>
@@ -4655,105 +4731,73 @@
           </a:bodyPr>
           <a:lstStyle/>
           <a:p>
-            <a:pPr algn="l">
-              <a:lnSpc>
-                <a:spcPct val="145000"/>
-              </a:lnSpc>
-            </a:pPr>
-            <a:r>
-              <a:rPr sz="600" b="0">
-                <a:solidFill>
-                  <a:srgbClr val="C5050C"/>
+            <a:pPr algn="l"/>
+            <a:r>
+              <a:rPr sz="1500" b="1">
+                <a:solidFill>
+                  <a:srgbClr val="18181B"/>
                 </a:solidFill>
                 <a:latin typeface="Arial"/>
               </a:rPr>
-              <a:t>●  </a:t>
-            </a:r>
-            <a:r>
-              <a:rPr sz="900" b="0">
-                <a:solidFill>
-                  <a:srgbClr val="3F3F46"/>
+              <a:t>Autonomous</a:t>
+            </a:r>
+          </a:p>
+        </p:txBody>
+      </p:sp>
+      <p:sp>
+        <p:nvSpPr>
+          <p:cNvPr id="41" name="Card strategy: Autonomous"/>
+          <p:cNvSpPr txBox="1"/>
+          <p:nvPr/>
+        </p:nvSpPr>
+        <p:spPr>
+          <a:xfrm>
+            <a:off x="5239512" y="6510528"/>
+            <a:ext cx="1965960" cy="228600"/>
+          </a:xfrm>
+          <a:prstGeom prst="rect">
+            <a:avLst/>
+          </a:prstGeom>
+          <a:noFill/>
+        </p:spPr>
+        <p:txBody>
+          <a:bodyPr wrap="square" lIns="0" rIns="0" tIns="0" bIns="0" anchor="t">
+            <a:spAutoFit/>
+          </a:bodyPr>
+          <a:lstStyle/>
+          <a:p>
+            <a:pPr algn="l"/>
+            <a:r>
+              <a:rPr sz="1050" b="1">
+                <a:solidFill>
+                  <a:srgbClr val="18181B"/>
                 </a:solidFill>
                 <a:latin typeface="Arial"/>
               </a:rPr>
-              <a:t>High-voltage battery storage</a:t>
-            </a:r>
-          </a:p>
-          <a:p>
-            <a:pPr algn="l">
-              <a:lnSpc>
-                <a:spcPct val="145000"/>
-              </a:lnSpc>
-            </a:pPr>
-            <a:r>
-              <a:rPr sz="600" b="0">
-                <a:solidFill>
-                  <a:srgbClr val="C5050C"/>
-                </a:solidFill>
-                <a:latin typeface="Arial"/>
-              </a:rPr>
-              <a:t>●  </a:t>
-            </a:r>
-            <a:r>
-              <a:rPr sz="900" b="0">
-                <a:solidFill>
-                  <a:srgbClr val="3F3F46"/>
-                </a:solidFill>
-                <a:latin typeface="Arial"/>
-              </a:rPr>
-              <a:t>Propulsion sized by the model</a:t>
-            </a:r>
-          </a:p>
-          <a:p>
-            <a:pPr algn="l">
-              <a:lnSpc>
-                <a:spcPct val="145000"/>
-              </a:lnSpc>
-            </a:pPr>
-            <a:r>
-              <a:rPr sz="600" b="0">
-                <a:solidFill>
-                  <a:srgbClr val="C5050C"/>
-                </a:solidFill>
-                <a:latin typeface="Arial"/>
-              </a:rPr>
-              <a:t>●  </a:t>
-            </a:r>
-            <a:r>
-              <a:rPr sz="900" b="0">
-                <a:solidFill>
-                  <a:srgbClr val="3F3F46"/>
-                </a:solidFill>
-                <a:latin typeface="Arial"/>
-              </a:rPr>
-              <a:t>Propulsion and cooling co-designed</a:t>
-            </a:r>
-          </a:p>
-        </p:txBody>
-      </p:sp>
-      <p:sp>
-        <p:nvSpPr>
-          <p:cNvPr id="41" name="Card: Autonomous"/>
+              <a:t>Find the way, unaided.</a:t>
+            </a:r>
+          </a:p>
+        </p:txBody>
+      </p:sp>
+      <p:sp>
+        <p:nvSpPr>
+          <p:cNvPr id="42" name="Card rule: Autonomous"/>
           <p:cNvSpPr/>
           <p:nvPr/>
         </p:nvSpPr>
         <p:spPr>
           <a:xfrm>
-            <a:off x="5102352" y="6766560"/>
-            <a:ext cx="2240280" cy="1536192"/>
-          </a:xfrm>
-          <a:prstGeom prst="roundRect">
-            <a:avLst>
-              <a:gd name="adj" fmla="val 5952"/>
-            </a:avLst>
+            <a:off x="5239512" y="6821424"/>
+            <a:ext cx="1965960" cy="9144"/>
+          </a:xfrm>
+          <a:prstGeom prst="rect">
+            <a:avLst/>
           </a:prstGeom>
           <a:solidFill>
-            <a:srgbClr val="FFFFFF"/>
+            <a:srgbClr val="E4E4E7"/>
           </a:solidFill>
-          <a:ln w="9525">
-            <a:solidFill>
-              <a:srgbClr val="E4E4E7"/>
-            </a:solidFill>
+          <a:ln>
+            <a:noFill/>
           </a:ln>
           <a:effectLst/>
         </p:spPr>
@@ -4781,14 +4825,14 @@
       </p:sp>
       <p:sp>
         <p:nvSpPr>
-          <p:cNvPr id="42" name="Card title: Autonomous"/>
+          <p:cNvPr id="43" name="Card points: Autonomous"/>
           <p:cNvSpPr txBox="1"/>
           <p:nvPr/>
         </p:nvSpPr>
         <p:spPr>
           <a:xfrm>
-            <a:off x="5239512" y="6858000"/>
-            <a:ext cx="1965960" cy="274320"/>
+            <a:off x="5239512" y="6931152"/>
+            <a:ext cx="1965960" cy="822960"/>
           </a:xfrm>
           <a:prstGeom prst="rect">
             <a:avLst/>
@@ -4801,29 +4845,92 @@
           </a:bodyPr>
           <a:lstStyle/>
           <a:p>
-            <a:pPr algn="l"/>
-            <a:r>
-              <a:rPr sz="1500" b="1">
-                <a:solidFill>
-                  <a:srgbClr val="18181B"/>
+            <a:pPr algn="l">
+              <a:lnSpc>
+                <a:spcPct val="175000"/>
+              </a:lnSpc>
+            </a:pPr>
+            <a:r>
+              <a:rPr sz="600" b="0">
+                <a:solidFill>
+                  <a:srgbClr val="C5050C"/>
                 </a:solidFill>
                 <a:latin typeface="Arial"/>
               </a:rPr>
-              <a:t>Autonomous</a:t>
-            </a:r>
-          </a:p>
-        </p:txBody>
-      </p:sp>
-      <p:sp>
-        <p:nvSpPr>
-          <p:cNvPr id="43" name="Card strategy: Autonomous"/>
+              <a:t>●  </a:t>
+            </a:r>
+            <a:r>
+              <a:rPr sz="900" b="0">
+                <a:solidFill>
+                  <a:srgbClr val="3F3F46"/>
+                </a:solidFill>
+                <a:latin typeface="Arial"/>
+              </a:rPr>
+              <a:t>GPS, IMU and LIDAR sensing</a:t>
+            </a:r>
+          </a:p>
+          <a:p>
+            <a:pPr algn="l">
+              <a:lnSpc>
+                <a:spcPct val="175000"/>
+              </a:lnSpc>
+            </a:pPr>
+            <a:r>
+              <a:rPr sz="600" b="0">
+                <a:solidFill>
+                  <a:srgbClr val="C5050C"/>
+                </a:solidFill>
+                <a:latin typeface="Arial"/>
+              </a:rPr>
+              <a:t>●  </a:t>
+            </a:r>
+            <a:r>
+              <a:rPr sz="900" b="0">
+                <a:solidFill>
+                  <a:srgbClr val="3F3F46"/>
+                </a:solidFill>
+                <a:latin typeface="Arial"/>
+              </a:rPr>
+              <a:t>Firmware protects the battery</a:t>
+            </a:r>
+          </a:p>
+          <a:p>
+            <a:pPr algn="l">
+              <a:lnSpc>
+                <a:spcPct val="175000"/>
+              </a:lnSpc>
+            </a:pPr>
+            <a:r>
+              <a:rPr sz="600" b="0">
+                <a:solidFill>
+                  <a:srgbClr val="C5050C"/>
+                </a:solidFill>
+                <a:latin typeface="Arial"/>
+              </a:rPr>
+              <a:t>●  </a:t>
+            </a:r>
+            <a:r>
+              <a:rPr sz="900" b="0">
+                <a:solidFill>
+                  <a:srgbClr val="3F3F46"/>
+                </a:solidFill>
+                <a:latin typeface="Arial"/>
+              </a:rPr>
+              <a:t>Software plans the route</a:t>
+            </a:r>
+          </a:p>
+        </p:txBody>
+      </p:sp>
+      <p:sp>
+        <p:nvSpPr>
+          <p:cNvPr id="44" name="Label: Timeline"/>
           <p:cNvSpPr txBox="1"/>
           <p:nvPr/>
         </p:nvSpPr>
         <p:spPr>
           <a:xfrm>
-            <a:off x="5239512" y="7187184"/>
-            <a:ext cx="1965960" cy="228600"/>
+            <a:off x="384048" y="8183879"/>
+            <a:ext cx="3657600" cy="182880"/>
           </a:xfrm>
           <a:prstGeom prst="rect">
             <a:avLst/>
@@ -4838,33 +4945,33 @@
           <a:p>
             <a:pPr algn="l"/>
             <a:r>
-              <a:rPr sz="1050" b="1">
-                <a:solidFill>
-                  <a:srgbClr val="18181B"/>
+              <a:rPr sz="800" b="1">
+                <a:solidFill>
+                  <a:srgbClr val="71717A"/>
                 </a:solidFill>
                 <a:latin typeface="Arial"/>
               </a:rPr>
-              <a:t>Find the way, unaided.</a:t>
-            </a:r>
-          </a:p>
-        </p:txBody>
-      </p:sp>
-      <p:sp>
-        <p:nvSpPr>
-          <p:cNvPr id="44" name="Card rule: Autonomous"/>
+              <a:t>TIMELINE</a:t>
+            </a:r>
+          </a:p>
+        </p:txBody>
+      </p:sp>
+      <p:sp>
+        <p:nvSpPr>
+          <p:cNvPr id="45" name="Timeline rule: Hull design"/>
           <p:cNvSpPr/>
           <p:nvPr/>
         </p:nvSpPr>
         <p:spPr>
           <a:xfrm>
-            <a:off x="5239512" y="7479792"/>
-            <a:ext cx="1965960" cy="9144"/>
+            <a:off x="384048" y="8439912"/>
+            <a:ext cx="1075944" cy="22860"/>
           </a:xfrm>
           <a:prstGeom prst="rect">
             <a:avLst/>
           </a:prstGeom>
           <a:solidFill>
-            <a:srgbClr val="E4E4E7"/>
+            <a:srgbClr val="C5050C"/>
           </a:solidFill>
           <a:ln>
             <a:noFill/>
@@ -4895,14 +5002,14 @@
       </p:sp>
       <p:sp>
         <p:nvSpPr>
-          <p:cNvPr id="45" name="Card points: Autonomous"/>
+          <p:cNvPr id="46" name="Timeline date: Hull design"/>
           <p:cNvSpPr txBox="1"/>
           <p:nvPr/>
         </p:nvSpPr>
         <p:spPr>
           <a:xfrm>
-            <a:off x="5239512" y="7562088"/>
-            <a:ext cx="1965960" cy="685800"/>
+            <a:off x="384048" y="8503920"/>
+            <a:ext cx="1075944" cy="182880"/>
           </a:xfrm>
           <a:prstGeom prst="rect">
             <a:avLst/>
@@ -4915,92 +5022,29 @@
           </a:bodyPr>
           <a:lstStyle/>
           <a:p>
-            <a:pPr algn="l">
-              <a:lnSpc>
-                <a:spcPct val="145000"/>
-              </a:lnSpc>
-            </a:pPr>
-            <a:r>
-              <a:rPr sz="600" b="0">
-                <a:solidFill>
-                  <a:srgbClr val="C5050C"/>
+            <a:pPr algn="l"/>
+            <a:r>
+              <a:rPr sz="900" b="1">
+                <a:solidFill>
+                  <a:srgbClr val="18181B"/>
                 </a:solidFill>
                 <a:latin typeface="Arial"/>
               </a:rPr>
-              <a:t>●  </a:t>
-            </a:r>
-            <a:r>
-              <a:rPr sz="900" b="0">
-                <a:solidFill>
-                  <a:srgbClr val="3F3F46"/>
-                </a:solidFill>
-                <a:latin typeface="Arial"/>
-              </a:rPr>
-              <a:t>GPS, IMU and LIDAR sensing</a:t>
-            </a:r>
-          </a:p>
-          <a:p>
-            <a:pPr algn="l">
-              <a:lnSpc>
-                <a:spcPct val="145000"/>
-              </a:lnSpc>
-            </a:pPr>
-            <a:r>
-              <a:rPr sz="600" b="0">
-                <a:solidFill>
-                  <a:srgbClr val="C5050C"/>
-                </a:solidFill>
-                <a:latin typeface="Arial"/>
-              </a:rPr>
-              <a:t>●  </a:t>
-            </a:r>
-            <a:r>
-              <a:rPr sz="900" b="0">
-                <a:solidFill>
-                  <a:srgbClr val="3F3F46"/>
-                </a:solidFill>
-                <a:latin typeface="Arial"/>
-              </a:rPr>
-              <a:t>Firmware protects the battery</a:t>
-            </a:r>
-          </a:p>
-          <a:p>
-            <a:pPr algn="l">
-              <a:lnSpc>
-                <a:spcPct val="145000"/>
-              </a:lnSpc>
-            </a:pPr>
-            <a:r>
-              <a:rPr sz="600" b="0">
-                <a:solidFill>
-                  <a:srgbClr val="C5050C"/>
-                </a:solidFill>
-                <a:latin typeface="Arial"/>
-              </a:rPr>
-              <a:t>●  </a:t>
-            </a:r>
-            <a:r>
-              <a:rPr sz="900" b="0">
-                <a:solidFill>
-                  <a:srgbClr val="3F3F46"/>
-                </a:solidFill>
-                <a:latin typeface="Arial"/>
-              </a:rPr>
-              <a:t>Software plans the route</a:t>
-            </a:r>
-          </a:p>
-        </p:txBody>
-      </p:sp>
-      <p:sp>
-        <p:nvSpPr>
-          <p:cNvPr id="46" name="Label: Timeline"/>
+              <a:t>Oct 25</a:t>
+            </a:r>
+          </a:p>
+        </p:txBody>
+      </p:sp>
+      <p:sp>
+        <p:nvSpPr>
+          <p:cNvPr id="47" name="Timeline label: Hull design"/>
           <p:cNvSpPr txBox="1"/>
           <p:nvPr/>
         </p:nvSpPr>
         <p:spPr>
           <a:xfrm>
-            <a:off x="384048" y="8412480"/>
-            <a:ext cx="3657600" cy="182880"/>
+            <a:off x="384048" y="8677656"/>
+            <a:ext cx="1075944" cy="182880"/>
           </a:xfrm>
           <a:prstGeom prst="rect">
             <a:avLst/>
@@ -5015,26 +5059,26 @@
           <a:p>
             <a:pPr algn="l"/>
             <a:r>
-              <a:rPr sz="800" b="1">
-                <a:solidFill>
-                  <a:srgbClr val="71717A"/>
+              <a:rPr sz="900" b="0">
+                <a:solidFill>
+                  <a:srgbClr val="3F3F46"/>
                 </a:solidFill>
                 <a:latin typeface="Arial"/>
               </a:rPr>
-              <a:t>TIMELINE</a:t>
-            </a:r>
-          </a:p>
-        </p:txBody>
-      </p:sp>
-      <p:sp>
-        <p:nvSpPr>
-          <p:cNvPr id="47" name="Timeline rule: Hull design"/>
+              <a:t>Hull design</a:t>
+            </a:r>
+          </a:p>
+        </p:txBody>
+      </p:sp>
+      <p:sp>
+        <p:nvSpPr>
+          <p:cNvPr id="48" name="Timeline rule: Electrical design"/>
           <p:cNvSpPr/>
           <p:nvPr/>
         </p:nvSpPr>
         <p:spPr>
           <a:xfrm>
-            <a:off x="384048" y="8668512"/>
+            <a:off x="1569720" y="8439912"/>
             <a:ext cx="1075944" cy="22860"/>
           </a:xfrm>
           <a:prstGeom prst="rect">
@@ -5072,13 +5116,13 @@
       </p:sp>
       <p:sp>
         <p:nvSpPr>
-          <p:cNvPr id="48" name="Timeline date: Hull design"/>
+          <p:cNvPr id="49" name="Timeline date: Electrical design"/>
           <p:cNvSpPr txBox="1"/>
           <p:nvPr/>
         </p:nvSpPr>
         <p:spPr>
           <a:xfrm>
-            <a:off x="384048" y="8732520"/>
+            <a:off x="1569720" y="8503920"/>
             <a:ext cx="1075944" cy="182880"/>
           </a:xfrm>
           <a:prstGeom prst="rect">
@@ -5100,20 +5144,20 @@
                 </a:solidFill>
                 <a:latin typeface="Arial"/>
               </a:rPr>
-              <a:t>Oct 25</a:t>
-            </a:r>
-          </a:p>
-        </p:txBody>
-      </p:sp>
-      <p:sp>
-        <p:nvSpPr>
-          <p:cNvPr id="49" name="Timeline label: Hull design"/>
+              <a:t>Nov 15</a:t>
+            </a:r>
+          </a:p>
+        </p:txBody>
+      </p:sp>
+      <p:sp>
+        <p:nvSpPr>
+          <p:cNvPr id="50" name="Timeline label: Electrical design"/>
           <p:cNvSpPr txBox="1"/>
           <p:nvPr/>
         </p:nvSpPr>
         <p:spPr>
           <a:xfrm>
-            <a:off x="384048" y="8906256"/>
+            <a:off x="1569720" y="8677656"/>
             <a:ext cx="1075944" cy="182880"/>
           </a:xfrm>
           <a:prstGeom prst="rect">
@@ -5135,20 +5179,20 @@
                 </a:solidFill>
                 <a:latin typeface="Arial"/>
               </a:rPr>
-              <a:t>Hull design</a:t>
-            </a:r>
-          </a:p>
-        </p:txBody>
-      </p:sp>
-      <p:sp>
-        <p:nvSpPr>
-          <p:cNvPr id="50" name="Timeline rule: Electrical design"/>
+              <a:t>Electrical design</a:t>
+            </a:r>
+          </a:p>
+        </p:txBody>
+      </p:sp>
+      <p:sp>
+        <p:nvSpPr>
+          <p:cNvPr id="51" name="Timeline rule: Hull built"/>
           <p:cNvSpPr/>
           <p:nvPr/>
         </p:nvSpPr>
         <p:spPr>
           <a:xfrm>
-            <a:off x="1569720" y="8668512"/>
+            <a:off x="2755392" y="8439912"/>
             <a:ext cx="1075944" cy="22860"/>
           </a:xfrm>
           <a:prstGeom prst="rect">
@@ -5186,13 +5230,13 @@
       </p:sp>
       <p:sp>
         <p:nvSpPr>
-          <p:cNvPr id="51" name="Timeline date: Electrical design"/>
+          <p:cNvPr id="52" name="Timeline date: Hull built"/>
           <p:cNvSpPr txBox="1"/>
           <p:nvPr/>
         </p:nvSpPr>
         <p:spPr>
           <a:xfrm>
-            <a:off x="1569720" y="8732520"/>
+            <a:off x="2755392" y="8503920"/>
             <a:ext cx="1075944" cy="182880"/>
           </a:xfrm>
           <a:prstGeom prst="rect">
@@ -5214,20 +5258,20 @@
                 </a:solidFill>
                 <a:latin typeface="Arial"/>
               </a:rPr>
-              <a:t>Nov 15</a:t>
-            </a:r>
-          </a:p>
-        </p:txBody>
-      </p:sp>
-      <p:sp>
-        <p:nvSpPr>
-          <p:cNvPr id="52" name="Timeline label: Electrical design"/>
+              <a:t>Nov 25</a:t>
+            </a:r>
+          </a:p>
+        </p:txBody>
+      </p:sp>
+      <p:sp>
+        <p:nvSpPr>
+          <p:cNvPr id="53" name="Timeline label: Hull built"/>
           <p:cNvSpPr txBox="1"/>
           <p:nvPr/>
         </p:nvSpPr>
         <p:spPr>
           <a:xfrm>
-            <a:off x="1569720" y="8906256"/>
+            <a:off x="2755392" y="8677656"/>
             <a:ext cx="1075944" cy="182880"/>
           </a:xfrm>
           <a:prstGeom prst="rect">
@@ -5249,20 +5293,20 @@
                 </a:solidFill>
                 <a:latin typeface="Arial"/>
               </a:rPr>
-              <a:t>Electrical design</a:t>
-            </a:r>
-          </a:p>
-        </p:txBody>
-      </p:sp>
-      <p:sp>
-        <p:nvSpPr>
-          <p:cNvPr id="53" name="Timeline rule: Hull built"/>
+              <a:t>Hull built</a:t>
+            </a:r>
+          </a:p>
+        </p:txBody>
+      </p:sp>
+      <p:sp>
+        <p:nvSpPr>
+          <p:cNvPr id="54" name="Timeline rule: First drive"/>
           <p:cNvSpPr/>
           <p:nvPr/>
         </p:nvSpPr>
         <p:spPr>
           <a:xfrm>
-            <a:off x="2755392" y="8668512"/>
+            <a:off x="3941064" y="8439912"/>
             <a:ext cx="1075944" cy="22860"/>
           </a:xfrm>
           <a:prstGeom prst="rect">
@@ -5300,13 +5344,13 @@
       </p:sp>
       <p:sp>
         <p:nvSpPr>
-          <p:cNvPr id="54" name="Timeline date: Hull built"/>
+          <p:cNvPr id="55" name="Timeline date: First drive"/>
           <p:cNvSpPr txBox="1"/>
           <p:nvPr/>
         </p:nvSpPr>
         <p:spPr>
           <a:xfrm>
-            <a:off x="2755392" y="8732520"/>
+            <a:off x="3941064" y="8503920"/>
             <a:ext cx="1075944" cy="182880"/>
           </a:xfrm>
           <a:prstGeom prst="rect">
@@ -5328,20 +5372,20 @@
                 </a:solidFill>
                 <a:latin typeface="Arial"/>
               </a:rPr>
-              <a:t>Nov 25</a:t>
-            </a:r>
-          </a:p>
-        </p:txBody>
-      </p:sp>
-      <p:sp>
-        <p:nvSpPr>
-          <p:cNvPr id="55" name="Timeline label: Hull built"/>
+              <a:t>Jan 25</a:t>
+            </a:r>
+          </a:p>
+        </p:txBody>
+      </p:sp>
+      <p:sp>
+        <p:nvSpPr>
+          <p:cNvPr id="56" name="Timeline label: First drive"/>
           <p:cNvSpPr txBox="1"/>
           <p:nvPr/>
         </p:nvSpPr>
         <p:spPr>
           <a:xfrm>
-            <a:off x="2755392" y="8906256"/>
+            <a:off x="3941064" y="8677656"/>
             <a:ext cx="1075944" cy="182880"/>
           </a:xfrm>
           <a:prstGeom prst="rect">
@@ -5363,20 +5407,20 @@
                 </a:solidFill>
                 <a:latin typeface="Arial"/>
               </a:rPr>
-              <a:t>Hull built</a:t>
-            </a:r>
-          </a:p>
-        </p:txBody>
-      </p:sp>
-      <p:sp>
-        <p:nvSpPr>
-          <p:cNvPr id="56" name="Timeline rule: First drive"/>
+              <a:t>First drive</a:t>
+            </a:r>
+          </a:p>
+        </p:txBody>
+      </p:sp>
+      <p:sp>
+        <p:nvSpPr>
+          <p:cNvPr id="57" name="Timeline rule: First fast drive"/>
           <p:cNvSpPr/>
           <p:nvPr/>
         </p:nvSpPr>
         <p:spPr>
           <a:xfrm>
-            <a:off x="3941064" y="8668512"/>
+            <a:off x="5126736" y="8439912"/>
             <a:ext cx="1075944" cy="22860"/>
           </a:xfrm>
           <a:prstGeom prst="rect">
@@ -5414,13 +5458,13 @@
       </p:sp>
       <p:sp>
         <p:nvSpPr>
-          <p:cNvPr id="57" name="Timeline date: First drive"/>
+          <p:cNvPr id="58" name="Timeline date: First fast drive"/>
           <p:cNvSpPr txBox="1"/>
           <p:nvPr/>
         </p:nvSpPr>
         <p:spPr>
           <a:xfrm>
-            <a:off x="3941064" y="8732520"/>
+            <a:off x="5126736" y="8503920"/>
             <a:ext cx="1075944" cy="182880"/>
           </a:xfrm>
           <a:prstGeom prst="rect">
@@ -5442,20 +5486,20 @@
                 </a:solidFill>
                 <a:latin typeface="Arial"/>
               </a:rPr>
-              <a:t>Jan 25</a:t>
-            </a:r>
-          </a:p>
-        </p:txBody>
-      </p:sp>
-      <p:sp>
-        <p:nvSpPr>
-          <p:cNvPr id="58" name="Timeline label: First drive"/>
+              <a:t>Feb 15</a:t>
+            </a:r>
+          </a:p>
+        </p:txBody>
+      </p:sp>
+      <p:sp>
+        <p:nvSpPr>
+          <p:cNvPr id="59" name="Timeline label: First fast drive"/>
           <p:cNvSpPr txBox="1"/>
           <p:nvPr/>
         </p:nvSpPr>
         <p:spPr>
           <a:xfrm>
-            <a:off x="3941064" y="8906256"/>
+            <a:off x="5126736" y="8677656"/>
             <a:ext cx="1075944" cy="182880"/>
           </a:xfrm>
           <a:prstGeom prst="rect">
@@ -5477,20 +5521,20 @@
                 </a:solidFill>
                 <a:latin typeface="Arial"/>
               </a:rPr>
-              <a:t>First drive</a:t>
-            </a:r>
-          </a:p>
-        </p:txBody>
-      </p:sp>
-      <p:sp>
-        <p:nvSpPr>
-          <p:cNvPr id="59" name="Timeline rule: First fast drive"/>
+              <a:t>First fast drive</a:t>
+            </a:r>
+          </a:p>
+        </p:txBody>
+      </p:sp>
+      <p:sp>
+        <p:nvSpPr>
+          <p:cNvPr id="60" name="Timeline rule: Tuning and testing"/>
           <p:cNvSpPr/>
           <p:nvPr/>
         </p:nvSpPr>
         <p:spPr>
           <a:xfrm>
-            <a:off x="5126736" y="8668512"/>
+            <a:off x="6312408" y="8439912"/>
             <a:ext cx="1075944" cy="22860"/>
           </a:xfrm>
           <a:prstGeom prst="rect">
@@ -5528,13 +5572,13 @@
       </p:sp>
       <p:sp>
         <p:nvSpPr>
-          <p:cNvPr id="60" name="Timeline date: First fast drive"/>
+          <p:cNvPr id="61" name="Timeline date: Tuning and testing"/>
           <p:cNvSpPr txBox="1"/>
           <p:nvPr/>
         </p:nvSpPr>
         <p:spPr>
           <a:xfrm>
-            <a:off x="5126736" y="8732520"/>
+            <a:off x="6312408" y="8503920"/>
             <a:ext cx="1075944" cy="182880"/>
           </a:xfrm>
           <a:prstGeom prst="rect">
@@ -5556,20 +5600,20 @@
                 </a:solidFill>
                 <a:latin typeface="Arial"/>
               </a:rPr>
-              <a:t>Feb 15</a:t>
-            </a:r>
-          </a:p>
-        </p:txBody>
-      </p:sp>
-      <p:sp>
-        <p:nvSpPr>
-          <p:cNvPr id="61" name="Timeline label: First fast drive"/>
+              <a:t>Mar 15</a:t>
+            </a:r>
+          </a:p>
+        </p:txBody>
+      </p:sp>
+      <p:sp>
+        <p:nvSpPr>
+          <p:cNvPr id="62" name="Timeline label: Tuning and testing"/>
           <p:cNvSpPr txBox="1"/>
           <p:nvPr/>
         </p:nvSpPr>
         <p:spPr>
           <a:xfrm>
-            <a:off x="5126736" y="8906256"/>
+            <a:off x="6312408" y="8677656"/>
             <a:ext cx="1075944" cy="182880"/>
           </a:xfrm>
           <a:prstGeom prst="rect">
@@ -5591,27 +5635,27 @@
                 </a:solidFill>
                 <a:latin typeface="Arial"/>
               </a:rPr>
-              <a:t>First fast drive</a:t>
-            </a:r>
-          </a:p>
-        </p:txBody>
-      </p:sp>
-      <p:sp>
-        <p:nvSpPr>
-          <p:cNvPr id="62" name="Timeline rule: Tuning and testing"/>
+              <a:t>Tuning and testing</a:t>
+            </a:r>
+          </a:p>
+        </p:txBody>
+      </p:sp>
+      <p:sp>
+        <p:nvSpPr>
+          <p:cNvPr id="63" name="Footer band"/>
           <p:cNvSpPr/>
           <p:nvPr/>
         </p:nvSpPr>
         <p:spPr>
           <a:xfrm>
-            <a:off x="6312408" y="8668512"/>
-            <a:ext cx="1075944" cy="22860"/>
+            <a:off x="0" y="9299448"/>
+            <a:ext cx="7772400" cy="758952"/>
           </a:xfrm>
           <a:prstGeom prst="rect">
             <a:avLst/>
           </a:prstGeom>
           <a:solidFill>
-            <a:srgbClr val="C5050C"/>
+            <a:srgbClr val="18181B"/>
           </a:solidFill>
           <a:ln>
             <a:noFill/>
@@ -5642,14 +5686,14 @@
       </p:sp>
       <p:sp>
         <p:nvSpPr>
-          <p:cNvPr id="63" name="Timeline date: Tuning and testing"/>
+          <p:cNvPr id="64" name="Footer title"/>
           <p:cNvSpPr txBox="1"/>
           <p:nvPr/>
         </p:nvSpPr>
         <p:spPr>
           <a:xfrm>
-            <a:off x="6312408" y="8732520"/>
-            <a:ext cx="1075944" cy="182880"/>
+            <a:off x="384048" y="9445752"/>
+            <a:ext cx="2743200" cy="228600"/>
           </a:xfrm>
           <a:prstGeom prst="rect">
             <a:avLst/>
@@ -5664,27 +5708,27 @@
           <a:p>
             <a:pPr algn="l"/>
             <a:r>
-              <a:rPr sz="900" b="1">
-                <a:solidFill>
-                  <a:srgbClr val="18181B"/>
+              <a:rPr sz="1500" b="1">
+                <a:solidFill>
+                  <a:srgbClr val="FFFFFF"/>
                 </a:solidFill>
                 <a:latin typeface="Arial"/>
               </a:rPr>
-              <a:t>Mar 15</a:t>
-            </a:r>
-          </a:p>
-        </p:txBody>
-      </p:sp>
-      <p:sp>
-        <p:nvSpPr>
-          <p:cNvPr id="64" name="Timeline label: Tuning and testing"/>
+              <a:t>Sponsor the build</a:t>
+            </a:r>
+          </a:p>
+        </p:txBody>
+      </p:sp>
+      <p:sp>
+        <p:nvSpPr>
+          <p:cNvPr id="65" name="Footer tagline"/>
           <p:cNvSpPr txBox="1"/>
           <p:nvPr/>
         </p:nvSpPr>
         <p:spPr>
           <a:xfrm>
-            <a:off x="6312408" y="8906256"/>
-            <a:ext cx="1075944" cy="182880"/>
+            <a:off x="384048" y="9710928"/>
+            <a:ext cx="2926080" cy="182880"/>
           </a:xfrm>
           <a:prstGeom prst="rect">
             <a:avLst/>
@@ -5699,71 +5743,27 @@
           <a:p>
             <a:pPr algn="l"/>
             <a:r>
-              <a:rPr sz="900" b="0">
-                <a:solidFill>
-                  <a:srgbClr val="3F3F46"/>
+              <a:rPr sz="850" b="0">
+                <a:solidFill>
+                  <a:srgbClr val="B5B5BB"/>
                 </a:solidFill>
                 <a:latin typeface="Arial"/>
               </a:rPr>
-              <a:t>Tuning and testing</a:t>
-            </a:r>
-          </a:p>
-        </p:txBody>
-      </p:sp>
-      <p:sp>
-        <p:nvSpPr>
-          <p:cNvPr id="65" name="Footer band"/>
-          <p:cNvSpPr/>
-          <p:nvPr/>
-        </p:nvSpPr>
-        <p:spPr>
-          <a:xfrm>
-            <a:off x="0" y="9299448"/>
-            <a:ext cx="7772400" cy="758952"/>
-          </a:xfrm>
-          <a:prstGeom prst="rect">
-            <a:avLst/>
-          </a:prstGeom>
-          <a:solidFill>
-            <a:srgbClr val="18181B"/>
-          </a:solidFill>
-          <a:ln>
-            <a:noFill/>
-          </a:ln>
-          <a:effectLst/>
-        </p:spPr>
-        <p:style>
-          <a:lnRef idx="1">
-            <a:schemeClr val="accent1"/>
-          </a:lnRef>
-          <a:fillRef idx="3">
-            <a:schemeClr val="accent1"/>
-          </a:fillRef>
-          <a:effectRef idx="2">
-            <a:schemeClr val="accent1"/>
-          </a:effectRef>
-          <a:fontRef idx="minor">
-            <a:schemeClr val="lt1"/>
-          </a:fontRef>
-        </p:style>
-        <p:txBody>
-          <a:bodyPr rtlCol="0" anchor="ctr"/>
-          <a:lstStyle/>
-          <a:p>
-            <a:pPr algn="ctr"/>
-          </a:p>
-        </p:txBody>
-      </p:sp>
-      <p:sp>
-        <p:nvSpPr>
-          <p:cNvPr id="66" name="Footer title"/>
+              <a:t>We are looking for funds, parts and advisors.</a:t>
+            </a:r>
+          </a:p>
+        </p:txBody>
+      </p:sp>
+      <p:sp>
+        <p:nvSpPr>
+          <p:cNvPr id="66" name="Footer link label"/>
           <p:cNvSpPr txBox="1"/>
           <p:nvPr/>
         </p:nvSpPr>
         <p:spPr>
           <a:xfrm>
-            <a:off x="384048" y="9445752"/>
-            <a:ext cx="2743200" cy="228600"/>
+            <a:off x="2971800" y="9418320"/>
+            <a:ext cx="1828800" cy="182880"/>
           </a:xfrm>
           <a:prstGeom prst="rect">
             <a:avLst/>
@@ -5776,29 +5776,29 @@
           </a:bodyPr>
           <a:lstStyle/>
           <a:p>
-            <a:pPr algn="l"/>
-            <a:r>
-              <a:rPr sz="1500" b="1">
-                <a:solidFill>
-                  <a:srgbClr val="FFFFFF"/>
+            <a:pPr algn="ctr"/>
+            <a:r>
+              <a:rPr sz="800" b="0">
+                <a:solidFill>
+                  <a:srgbClr val="9A9AA2"/>
                 </a:solidFill>
                 <a:latin typeface="Arial"/>
               </a:rPr>
-              <a:t>Sponsor the build</a:t>
-            </a:r>
-          </a:p>
-        </p:txBody>
-      </p:sp>
-      <p:sp>
-        <p:nvSpPr>
-          <p:cNvPr id="67" name="Footer tagline"/>
+              <a:t>LEARN MORE</a:t>
+            </a:r>
+          </a:p>
+        </p:txBody>
+      </p:sp>
+      <p:sp>
+        <p:nvSpPr>
+          <p:cNvPr id="67" name="Footer link"/>
           <p:cNvSpPr txBox="1"/>
           <p:nvPr/>
         </p:nvSpPr>
         <p:spPr>
           <a:xfrm>
-            <a:off x="384048" y="9710928"/>
-            <a:ext cx="2926080" cy="182880"/>
+            <a:off x="2971800" y="9601200"/>
+            <a:ext cx="1828800" cy="274320"/>
           </a:xfrm>
           <a:prstGeom prst="rect">
             <a:avLst/>
@@ -5811,29 +5811,29 @@
           </a:bodyPr>
           <a:lstStyle/>
           <a:p>
-            <a:pPr algn="l"/>
-            <a:r>
-              <a:rPr sz="850" b="0">
-                <a:solidFill>
-                  <a:srgbClr val="B5B5BB"/>
+            <a:pPr algn="ctr"/>
+            <a:r>
+              <a:rPr sz="1400" b="1">
+                <a:solidFill>
+                  <a:srgbClr val="FFFFFF"/>
                 </a:solidFill>
                 <a:latin typeface="Arial"/>
               </a:rPr>
-              <a:t>We are looking for funds, parts and advisors.</a:t>
-            </a:r>
-          </a:p>
-        </p:txBody>
-      </p:sp>
-      <p:sp>
-        <p:nvSpPr>
-          <p:cNvPr id="68" name="Footer link label"/>
+              <a:t>bit.ly/haav</a:t>
+            </a:r>
+          </a:p>
+        </p:txBody>
+      </p:sp>
+      <p:sp>
+        <p:nvSpPr>
+          <p:cNvPr id="68" name="Footer contact label"/>
           <p:cNvSpPr txBox="1"/>
           <p:nvPr/>
         </p:nvSpPr>
         <p:spPr>
           <a:xfrm>
-            <a:off x="2971800" y="9418320"/>
-            <a:ext cx="1828800" cy="182880"/>
+            <a:off x="4846320" y="9390888"/>
+            <a:ext cx="2542032" cy="182880"/>
           </a:xfrm>
           <a:prstGeom prst="rect">
             <a:avLst/>
@@ -5846,7 +5846,7 @@
           </a:bodyPr>
           <a:lstStyle/>
           <a:p>
-            <a:pPr algn="ctr"/>
+            <a:pPr algn="r"/>
             <a:r>
               <a:rPr sz="800" b="0">
                 <a:solidFill>
@@ -5854,21 +5854,21 @@
                 </a:solidFill>
                 <a:latin typeface="Arial"/>
               </a:rPr>
-              <a:t>LEARN MORE</a:t>
-            </a:r>
-          </a:p>
-        </p:txBody>
-      </p:sp>
-      <p:sp>
-        <p:nvSpPr>
-          <p:cNvPr id="69" name="Footer link"/>
+              <a:t>CONTACT</a:t>
+            </a:r>
+          </a:p>
+        </p:txBody>
+      </p:sp>
+      <p:sp>
+        <p:nvSpPr>
+          <p:cNvPr id="69" name="Footer contact name"/>
           <p:cNvSpPr txBox="1"/>
           <p:nvPr/>
         </p:nvSpPr>
         <p:spPr>
           <a:xfrm>
-            <a:off x="2971800" y="9601200"/>
-            <a:ext cx="1828800" cy="274320"/>
+            <a:off x="4846320" y="9555480"/>
+            <a:ext cx="2542032" cy="201168"/>
           </a:xfrm>
           <a:prstGeom prst="rect">
             <a:avLst/>
@@ -5881,76 +5881,6 @@
           </a:bodyPr>
           <a:lstStyle/>
           <a:p>
-            <a:pPr algn="ctr"/>
-            <a:r>
-              <a:rPr sz="1400" b="1">
-                <a:solidFill>
-                  <a:srgbClr val="FFFFFF"/>
-                </a:solidFill>
-                <a:latin typeface="Arial"/>
-              </a:rPr>
-              <a:t>bit.ly/haav</a:t>
-            </a:r>
-          </a:p>
-        </p:txBody>
-      </p:sp>
-      <p:sp>
-        <p:nvSpPr>
-          <p:cNvPr id="70" name="Footer contact label"/>
-          <p:cNvSpPr txBox="1"/>
-          <p:nvPr/>
-        </p:nvSpPr>
-        <p:spPr>
-          <a:xfrm>
-            <a:off x="4846320" y="9390888"/>
-            <a:ext cx="2542032" cy="182880"/>
-          </a:xfrm>
-          <a:prstGeom prst="rect">
-            <a:avLst/>
-          </a:prstGeom>
-          <a:noFill/>
-        </p:spPr>
-        <p:txBody>
-          <a:bodyPr wrap="square" lIns="0" rIns="0" tIns="0" bIns="0" anchor="t">
-            <a:spAutoFit/>
-          </a:bodyPr>
-          <a:lstStyle/>
-          <a:p>
-            <a:pPr algn="r"/>
-            <a:r>
-              <a:rPr sz="800" b="0">
-                <a:solidFill>
-                  <a:srgbClr val="9A9AA2"/>
-                </a:solidFill>
-                <a:latin typeface="Arial"/>
-              </a:rPr>
-              <a:t>CONTACT</a:t>
-            </a:r>
-          </a:p>
-        </p:txBody>
-      </p:sp>
-      <p:sp>
-        <p:nvSpPr>
-          <p:cNvPr id="71" name="Footer contact name"/>
-          <p:cNvSpPr txBox="1"/>
-          <p:nvPr/>
-        </p:nvSpPr>
-        <p:spPr>
-          <a:xfrm>
-            <a:off x="4846320" y="9555480"/>
-            <a:ext cx="2542032" cy="201168"/>
-          </a:xfrm>
-          <a:prstGeom prst="rect">
-            <a:avLst/>
-          </a:prstGeom>
-          <a:noFill/>
-        </p:spPr>
-        <p:txBody>
-          <a:bodyPr wrap="square" lIns="0" rIns="0" tIns="0" bIns="0" anchor="t">
-            <a:spAutoFit/>
-          </a:bodyPr>
-          <a:lstStyle/>
-          <a:p>
             <a:pPr algn="r"/>
             <a:r>
               <a:rPr sz="1050" b="1">
@@ -5966,7 +5896,7 @@
       </p:sp>
       <p:sp>
         <p:nvSpPr>
-          <p:cNvPr id="72" name="Footer contact email"/>
+          <p:cNvPr id="70" name="Footer contact email"/>
           <p:cNvSpPr txBox="1"/>
           <p:nvPr/>
         </p:nvSpPr>

</xml_diff>

<commit_message>
Timeline: add design freeze, drop preliminary BOM; ask for people to build the BOM
Co-Authored-By: Claude Sonnet 5.5 <noreply@anthropic.com>
</commit_message>
<xml_diff>
--- a/dashboard/public/haav-handout.pptx
+++ b/dashboard/public/haav-handout.pptx
@@ -5072,7 +5072,7 @@
       </p:sp>
       <p:sp>
         <p:nvSpPr>
-          <p:cNvPr id="48" name="Timeline rule: Electrical design"/>
+          <p:cNvPr id="48" name="Timeline rule: Hull built"/>
           <p:cNvSpPr/>
           <p:nvPr/>
         </p:nvSpPr>
@@ -5116,7 +5116,7 @@
       </p:sp>
       <p:sp>
         <p:nvSpPr>
-          <p:cNvPr id="49" name="Timeline date: Electrical design"/>
+          <p:cNvPr id="49" name="Timeline date: Hull built"/>
           <p:cNvSpPr txBox="1"/>
           <p:nvPr/>
         </p:nvSpPr>
@@ -5144,14 +5144,14 @@
                 </a:solidFill>
                 <a:latin typeface="Arial"/>
               </a:rPr>
-              <a:t>Nov 15</a:t>
-            </a:r>
-          </a:p>
-        </p:txBody>
-      </p:sp>
-      <p:sp>
-        <p:nvSpPr>
-          <p:cNvPr id="50" name="Timeline label: Electrical design"/>
+              <a:t>Nov 25</a:t>
+            </a:r>
+          </a:p>
+        </p:txBody>
+      </p:sp>
+      <p:sp>
+        <p:nvSpPr>
+          <p:cNvPr id="50" name="Timeline label: Hull built"/>
           <p:cNvSpPr txBox="1"/>
           <p:nvPr/>
         </p:nvSpPr>
@@ -5179,14 +5179,14 @@
                 </a:solidFill>
                 <a:latin typeface="Arial"/>
               </a:rPr>
-              <a:t>Electrical design</a:t>
-            </a:r>
-          </a:p>
-        </p:txBody>
-      </p:sp>
-      <p:sp>
-        <p:nvSpPr>
-          <p:cNvPr id="51" name="Timeline rule: Hull built"/>
+              <a:t>Hull built</a:t>
+            </a:r>
+          </a:p>
+        </p:txBody>
+      </p:sp>
+      <p:sp>
+        <p:nvSpPr>
+          <p:cNvPr id="51" name="Timeline rule: Mech and electrical design frozen"/>
           <p:cNvSpPr/>
           <p:nvPr/>
         </p:nvSpPr>
@@ -5230,7 +5230,7 @@
       </p:sp>
       <p:sp>
         <p:nvSpPr>
-          <p:cNvPr id="52" name="Timeline date: Hull built"/>
+          <p:cNvPr id="52" name="Timeline date: Mech and electrical design frozen"/>
           <p:cNvSpPr txBox="1"/>
           <p:nvPr/>
         </p:nvSpPr>
@@ -5258,14 +5258,14 @@
                 </a:solidFill>
                 <a:latin typeface="Arial"/>
               </a:rPr>
-              <a:t>Nov 25</a:t>
-            </a:r>
-          </a:p>
-        </p:txBody>
-      </p:sp>
-      <p:sp>
-        <p:nvSpPr>
-          <p:cNvPr id="53" name="Timeline label: Hull built"/>
+              <a:t>Dec 1</a:t>
+            </a:r>
+          </a:p>
+        </p:txBody>
+      </p:sp>
+      <p:sp>
+        <p:nvSpPr>
+          <p:cNvPr id="53" name="Timeline label: Mech and electrical design frozen"/>
           <p:cNvSpPr txBox="1"/>
           <p:nvPr/>
         </p:nvSpPr>
@@ -5293,7 +5293,7 @@
                 </a:solidFill>
                 <a:latin typeface="Arial"/>
               </a:rPr>
-              <a:t>Hull built</a:t>
+              <a:t>Mech and electrical design frozen</a:t>
             </a:r>
           </a:p>
         </p:txBody>
@@ -5727,8 +5727,8 @@
         </p:nvSpPr>
         <p:spPr>
           <a:xfrm>
-            <a:off x="384048" y="9710928"/>
-            <a:ext cx="2926080" cy="182880"/>
+            <a:off x="384048" y="9692640"/>
+            <a:ext cx="2514600" cy="365760"/>
           </a:xfrm>
           <a:prstGeom prst="rect">
             <a:avLst/>
@@ -5749,7 +5749,7 @@
                 </a:solidFill>
                 <a:latin typeface="Arial"/>
               </a:rPr>
-              <a:t>We are looking for funds, parts and advisors.</a:t>
+              <a:t>We are looking for funds, parts, advisors and people to build our BOM as we design.</a:t>
             </a:r>
           </a:p>
         </p:txBody>

</xml_diff>

<commit_message>
Replace the timeline with the full build plan, on the site and handout
Co-Authored-By: Claude Sonnet 5.5 <noreply@anthropic.com>
</commit_message>
<xml_diff>
--- a/dashboard/public/haav-handout.pptx
+++ b/dashboard/public/haav-handout.pptx
@@ -4150,11 +4150,11 @@
         <p:spPr>
           <a:xfrm>
             <a:off x="384048" y="6062472"/>
-            <a:ext cx="2240280" cy="1783080"/>
+            <a:ext cx="2240280" cy="1600200"/>
           </a:xfrm>
           <a:prstGeom prst="roundRect">
             <a:avLst>
-              <a:gd name="adj" fmla="val 5128"/>
+              <a:gd name="adj" fmla="val 5714"/>
             </a:avLst>
           </a:prstGeom>
           <a:solidFill>
@@ -4327,7 +4327,7 @@
           <a:p>
             <a:pPr algn="l">
               <a:lnSpc>
-                <a:spcPct val="175000"/>
+                <a:spcPct val="155000"/>
               </a:lnSpc>
             </a:pPr>
             <a:r>
@@ -4352,7 +4352,7 @@
           <a:p>
             <a:pPr algn="l">
               <a:lnSpc>
-                <a:spcPct val="175000"/>
+                <a:spcPct val="155000"/>
               </a:lnSpc>
             </a:pPr>
             <a:r>
@@ -4377,7 +4377,7 @@
           <a:p>
             <a:pPr algn="l">
               <a:lnSpc>
-                <a:spcPct val="175000"/>
+                <a:spcPct val="155000"/>
               </a:lnSpc>
             </a:pPr>
             <a:r>
@@ -4410,11 +4410,11 @@
         <p:spPr>
           <a:xfrm>
             <a:off x="2743200" y="6062472"/>
-            <a:ext cx="2240280" cy="1783080"/>
+            <a:ext cx="2240280" cy="1600200"/>
           </a:xfrm>
           <a:prstGeom prst="roundRect">
             <a:avLst>
-              <a:gd name="adj" fmla="val 5128"/>
+              <a:gd name="adj" fmla="val 5714"/>
             </a:avLst>
           </a:prstGeom>
           <a:solidFill>
@@ -4587,7 +4587,7 @@
           <a:p>
             <a:pPr algn="l">
               <a:lnSpc>
-                <a:spcPct val="175000"/>
+                <a:spcPct val="155000"/>
               </a:lnSpc>
             </a:pPr>
             <a:r>
@@ -4612,7 +4612,7 @@
           <a:p>
             <a:pPr algn="l">
               <a:lnSpc>
-                <a:spcPct val="175000"/>
+                <a:spcPct val="155000"/>
               </a:lnSpc>
             </a:pPr>
             <a:r>
@@ -4637,7 +4637,7 @@
           <a:p>
             <a:pPr algn="l">
               <a:lnSpc>
-                <a:spcPct val="175000"/>
+                <a:spcPct val="155000"/>
               </a:lnSpc>
             </a:pPr>
             <a:r>
@@ -4670,11 +4670,11 @@
         <p:spPr>
           <a:xfrm>
             <a:off x="5102352" y="6062472"/>
-            <a:ext cx="2240280" cy="1783080"/>
+            <a:ext cx="2240280" cy="1600200"/>
           </a:xfrm>
           <a:prstGeom prst="roundRect">
             <a:avLst>
-              <a:gd name="adj" fmla="val 5128"/>
+              <a:gd name="adj" fmla="val 5714"/>
             </a:avLst>
           </a:prstGeom>
           <a:solidFill>
@@ -4847,7 +4847,7 @@
           <a:p>
             <a:pPr algn="l">
               <a:lnSpc>
-                <a:spcPct val="175000"/>
+                <a:spcPct val="155000"/>
               </a:lnSpc>
             </a:pPr>
             <a:r>
@@ -4872,7 +4872,7 @@
           <a:p>
             <a:pPr algn="l">
               <a:lnSpc>
-                <a:spcPct val="175000"/>
+                <a:spcPct val="155000"/>
               </a:lnSpc>
             </a:pPr>
             <a:r>
@@ -4897,7 +4897,7 @@
           <a:p>
             <a:pPr algn="l">
               <a:lnSpc>
-                <a:spcPct val="175000"/>
+                <a:spcPct val="155000"/>
               </a:lnSpc>
             </a:pPr>
             <a:r>
@@ -4929,7 +4929,7 @@
         </p:nvSpPr>
         <p:spPr>
           <a:xfrm>
-            <a:off x="384048" y="8183879"/>
+            <a:off x="384048" y="7790688"/>
             <a:ext cx="3657600" cy="182880"/>
           </a:xfrm>
           <a:prstGeom prst="rect">
@@ -4958,20 +4958,20 @@
       </p:sp>
       <p:sp>
         <p:nvSpPr>
-          <p:cNvPr id="45" name="Timeline rule: Hull design"/>
+          <p:cNvPr id="45" name="Timeline rule: Current hull design frozen"/>
           <p:cNvSpPr/>
           <p:nvPr/>
         </p:nvSpPr>
         <p:spPr>
           <a:xfrm>
-            <a:off x="384048" y="8439912"/>
-            <a:ext cx="1075944" cy="22860"/>
+            <a:off x="384048" y="8010144"/>
+            <a:ext cx="3364992" cy="9144"/>
           </a:xfrm>
           <a:prstGeom prst="rect">
             <a:avLst/>
           </a:prstGeom>
           <a:solidFill>
-            <a:srgbClr val="C5050C"/>
+            <a:srgbClr val="E4E4E7"/>
           </a:solidFill>
           <a:ln>
             <a:noFill/>
@@ -5002,14 +5002,14 @@
       </p:sp>
       <p:sp>
         <p:nvSpPr>
-          <p:cNvPr id="46" name="Timeline date: Hull design"/>
+          <p:cNvPr id="46" name="Timeline date: Current hull design frozen"/>
           <p:cNvSpPr txBox="1"/>
           <p:nvPr/>
         </p:nvSpPr>
         <p:spPr>
           <a:xfrm>
-            <a:off x="384048" y="8503920"/>
-            <a:ext cx="1075944" cy="182880"/>
+            <a:off x="384048" y="8051292"/>
+            <a:ext cx="1051560" cy="146304"/>
           </a:xfrm>
           <a:prstGeom prst="rect">
             <a:avLst/>
@@ -5024,9 +5024,9 @@
           <a:p>
             <a:pPr algn="l"/>
             <a:r>
-              <a:rPr sz="900" b="1">
-                <a:solidFill>
-                  <a:srgbClr val="18181B"/>
+              <a:rPr sz="800" b="1">
+                <a:solidFill>
+                  <a:srgbClr val="C5050C"/>
                 </a:solidFill>
                 <a:latin typeface="Arial"/>
               </a:rPr>
@@ -5037,14 +5037,14 @@
       </p:sp>
       <p:sp>
         <p:nvSpPr>
-          <p:cNvPr id="47" name="Timeline label: Hull design"/>
+          <p:cNvPr id="47" name="Timeline label: Current hull design frozen"/>
           <p:cNvSpPr txBox="1"/>
           <p:nvPr/>
         </p:nvSpPr>
         <p:spPr>
           <a:xfrm>
-            <a:off x="384048" y="8677656"/>
-            <a:ext cx="1075944" cy="182880"/>
+            <a:off x="1481328" y="8051292"/>
+            <a:ext cx="2267712" cy="146304"/>
           </a:xfrm>
           <a:prstGeom prst="rect">
             <a:avLst/>
@@ -5059,33 +5059,33 @@
           <a:p>
             <a:pPr algn="l"/>
             <a:r>
-              <a:rPr sz="900" b="0">
+              <a:rPr sz="800" b="0">
                 <a:solidFill>
                   <a:srgbClr val="3F3F46"/>
                 </a:solidFill>
                 <a:latin typeface="Arial"/>
               </a:rPr>
-              <a:t>Hull design</a:t>
-            </a:r>
-          </a:p>
-        </p:txBody>
-      </p:sp>
-      <p:sp>
-        <p:nvSpPr>
-          <p:cNvPr id="48" name="Timeline rule: Hull built"/>
+              <a:t>Current hull design frozen</a:t>
+            </a:r>
+          </a:p>
+        </p:txBody>
+      </p:sp>
+      <p:sp>
+        <p:nvSpPr>
+          <p:cNvPr id="48" name="Timeline rule: Preliminary design review"/>
           <p:cNvSpPr/>
           <p:nvPr/>
         </p:nvSpPr>
         <p:spPr>
           <a:xfrm>
-            <a:off x="1569720" y="8439912"/>
-            <a:ext cx="1075944" cy="22860"/>
+            <a:off x="384048" y="8211312"/>
+            <a:ext cx="3364992" cy="9144"/>
           </a:xfrm>
           <a:prstGeom prst="rect">
             <a:avLst/>
           </a:prstGeom>
           <a:solidFill>
-            <a:srgbClr val="C5050C"/>
+            <a:srgbClr val="E4E4E7"/>
           </a:solidFill>
           <a:ln>
             <a:noFill/>
@@ -5116,14 +5116,14 @@
       </p:sp>
       <p:sp>
         <p:nvSpPr>
-          <p:cNvPr id="49" name="Timeline date: Hull built"/>
+          <p:cNvPr id="49" name="Timeline date: Preliminary design review"/>
           <p:cNvSpPr txBox="1"/>
           <p:nvPr/>
         </p:nvSpPr>
         <p:spPr>
           <a:xfrm>
-            <a:off x="1569720" y="8503920"/>
-            <a:ext cx="1075944" cy="182880"/>
+            <a:off x="384048" y="8252460"/>
+            <a:ext cx="1051560" cy="146304"/>
           </a:xfrm>
           <a:prstGeom prst="rect">
             <a:avLst/>
@@ -5138,27 +5138,27 @@
           <a:p>
             <a:pPr algn="l"/>
             <a:r>
-              <a:rPr sz="900" b="1">
-                <a:solidFill>
-                  <a:srgbClr val="18181B"/>
-                </a:solidFill>
-                <a:latin typeface="Arial"/>
-              </a:rPr>
-              <a:t>Nov 25</a:t>
-            </a:r>
-          </a:p>
-        </p:txBody>
-      </p:sp>
-      <p:sp>
-        <p:nvSpPr>
-          <p:cNvPr id="50" name="Timeline label: Hull built"/>
+              <a:rPr sz="800" b="1">
+                <a:solidFill>
+                  <a:srgbClr val="C5050C"/>
+                </a:solidFill>
+                <a:latin typeface="Arial"/>
+              </a:rPr>
+              <a:t>Nov 15</a:t>
+            </a:r>
+          </a:p>
+        </p:txBody>
+      </p:sp>
+      <p:sp>
+        <p:nvSpPr>
+          <p:cNvPr id="50" name="Timeline label: Preliminary design review"/>
           <p:cNvSpPr txBox="1"/>
           <p:nvPr/>
         </p:nvSpPr>
         <p:spPr>
           <a:xfrm>
-            <a:off x="1569720" y="8677656"/>
-            <a:ext cx="1075944" cy="182880"/>
+            <a:off x="1481328" y="8252460"/>
+            <a:ext cx="2267712" cy="146304"/>
           </a:xfrm>
           <a:prstGeom prst="rect">
             <a:avLst/>
@@ -5173,33 +5173,33 @@
           <a:p>
             <a:pPr algn="l"/>
             <a:r>
-              <a:rPr sz="900" b="0">
+              <a:rPr sz="800" b="0">
                 <a:solidFill>
                   <a:srgbClr val="3F3F46"/>
                 </a:solidFill>
                 <a:latin typeface="Arial"/>
               </a:rPr>
-              <a:t>Hull built</a:t>
-            </a:r>
-          </a:p>
-        </p:txBody>
-      </p:sp>
-      <p:sp>
-        <p:nvSpPr>
-          <p:cNvPr id="51" name="Timeline rule: Mech and electrical design frozen"/>
+              <a:t>Preliminary design review</a:t>
+            </a:r>
+          </a:p>
+        </p:txBody>
+      </p:sp>
+      <p:sp>
+        <p:nvSpPr>
+          <p:cNvPr id="51" name="Timeline rule: Mechanical and electrical design frozen"/>
           <p:cNvSpPr/>
           <p:nvPr/>
         </p:nvSpPr>
         <p:spPr>
           <a:xfrm>
-            <a:off x="2755392" y="8439912"/>
-            <a:ext cx="1075944" cy="22860"/>
+            <a:off x="384048" y="8412480"/>
+            <a:ext cx="3364992" cy="9144"/>
           </a:xfrm>
           <a:prstGeom prst="rect">
             <a:avLst/>
           </a:prstGeom>
           <a:solidFill>
-            <a:srgbClr val="C5050C"/>
+            <a:srgbClr val="E4E4E7"/>
           </a:solidFill>
           <a:ln>
             <a:noFill/>
@@ -5230,14 +5230,14 @@
       </p:sp>
       <p:sp>
         <p:nvSpPr>
-          <p:cNvPr id="52" name="Timeline date: Mech and electrical design frozen"/>
+          <p:cNvPr id="52" name="Timeline date: Mechanical and electrical design frozen"/>
           <p:cNvSpPr txBox="1"/>
           <p:nvPr/>
         </p:nvSpPr>
         <p:spPr>
           <a:xfrm>
-            <a:off x="2755392" y="8503920"/>
-            <a:ext cx="1075944" cy="182880"/>
+            <a:off x="384048" y="8453628"/>
+            <a:ext cx="1051560" cy="146304"/>
           </a:xfrm>
           <a:prstGeom prst="rect">
             <a:avLst/>
@@ -5252,9 +5252,9 @@
           <a:p>
             <a:pPr algn="l"/>
             <a:r>
-              <a:rPr sz="900" b="1">
-                <a:solidFill>
-                  <a:srgbClr val="18181B"/>
+              <a:rPr sz="800" b="1">
+                <a:solidFill>
+                  <a:srgbClr val="C5050C"/>
                 </a:solidFill>
                 <a:latin typeface="Arial"/>
               </a:rPr>
@@ -5265,14 +5265,14 @@
       </p:sp>
       <p:sp>
         <p:nvSpPr>
-          <p:cNvPr id="53" name="Timeline label: Mech and electrical design frozen"/>
+          <p:cNvPr id="53" name="Timeline label: Mechanical and electrical design frozen"/>
           <p:cNvSpPr txBox="1"/>
           <p:nvPr/>
         </p:nvSpPr>
         <p:spPr>
           <a:xfrm>
-            <a:off x="2755392" y="8677656"/>
-            <a:ext cx="1075944" cy="182880"/>
+            <a:off x="1481328" y="8453628"/>
+            <a:ext cx="2267712" cy="146304"/>
           </a:xfrm>
           <a:prstGeom prst="rect">
             <a:avLst/>
@@ -5287,33 +5287,33 @@
           <a:p>
             <a:pPr algn="l"/>
             <a:r>
-              <a:rPr sz="900" b="0">
+              <a:rPr sz="800" b="0">
                 <a:solidFill>
                   <a:srgbClr val="3F3F46"/>
                 </a:solidFill>
                 <a:latin typeface="Arial"/>
               </a:rPr>
-              <a:t>Mech and electrical design frozen</a:t>
-            </a:r>
-          </a:p>
-        </p:txBody>
-      </p:sp>
-      <p:sp>
-        <p:nvSpPr>
-          <p:cNvPr id="54" name="Timeline rule: First drive"/>
+              <a:t>Mechanical and electrical design frozen</a:t>
+            </a:r>
+          </a:p>
+        </p:txBody>
+      </p:sp>
+      <p:sp>
+        <p:nvSpPr>
+          <p:cNvPr id="54" name="Timeline rule: Build the hull and composite parts"/>
           <p:cNvSpPr/>
           <p:nvPr/>
         </p:nvSpPr>
         <p:spPr>
           <a:xfrm>
-            <a:off x="3941064" y="8439912"/>
-            <a:ext cx="1075944" cy="22860"/>
+            <a:off x="384048" y="8613648"/>
+            <a:ext cx="3364992" cy="9144"/>
           </a:xfrm>
           <a:prstGeom prst="rect">
             <a:avLst/>
           </a:prstGeom>
           <a:solidFill>
-            <a:srgbClr val="C5050C"/>
+            <a:srgbClr val="E4E4E7"/>
           </a:solidFill>
           <a:ln>
             <a:noFill/>
@@ -5344,14 +5344,14 @@
       </p:sp>
       <p:sp>
         <p:nvSpPr>
-          <p:cNvPr id="55" name="Timeline date: First drive"/>
+          <p:cNvPr id="55" name="Timeline date: Build the hull and composite parts"/>
           <p:cNvSpPr txBox="1"/>
           <p:nvPr/>
         </p:nvSpPr>
         <p:spPr>
           <a:xfrm>
-            <a:off x="3941064" y="8503920"/>
-            <a:ext cx="1075944" cy="182880"/>
+            <a:off x="384048" y="8654796"/>
+            <a:ext cx="1051560" cy="146304"/>
           </a:xfrm>
           <a:prstGeom prst="rect">
             <a:avLst/>
@@ -5366,27 +5366,27 @@
           <a:p>
             <a:pPr algn="l"/>
             <a:r>
-              <a:rPr sz="900" b="1">
-                <a:solidFill>
-                  <a:srgbClr val="18181B"/>
-                </a:solidFill>
-                <a:latin typeface="Arial"/>
-              </a:rPr>
-              <a:t>Jan 25</a:t>
-            </a:r>
-          </a:p>
-        </p:txBody>
-      </p:sp>
-      <p:sp>
-        <p:nvSpPr>
-          <p:cNvPr id="56" name="Timeline label: First drive"/>
+              <a:rPr sz="800" b="1">
+                <a:solidFill>
+                  <a:srgbClr val="C5050C"/>
+                </a:solidFill>
+                <a:latin typeface="Arial"/>
+              </a:rPr>
+              <a:t>December</a:t>
+            </a:r>
+          </a:p>
+        </p:txBody>
+      </p:sp>
+      <p:sp>
+        <p:nvSpPr>
+          <p:cNvPr id="56" name="Timeline label: Build the hull and composite parts"/>
           <p:cNvSpPr txBox="1"/>
           <p:nvPr/>
         </p:nvSpPr>
         <p:spPr>
           <a:xfrm>
-            <a:off x="3941064" y="8677656"/>
-            <a:ext cx="1075944" cy="182880"/>
+            <a:off x="1481328" y="8654796"/>
+            <a:ext cx="2267712" cy="146304"/>
           </a:xfrm>
           <a:prstGeom prst="rect">
             <a:avLst/>
@@ -5401,33 +5401,33 @@
           <a:p>
             <a:pPr algn="l"/>
             <a:r>
-              <a:rPr sz="900" b="0">
+              <a:rPr sz="800" b="0">
                 <a:solidFill>
                   <a:srgbClr val="3F3F46"/>
                 </a:solidFill>
                 <a:latin typeface="Arial"/>
               </a:rPr>
-              <a:t>First drive</a:t>
-            </a:r>
-          </a:p>
-        </p:txBody>
-      </p:sp>
-      <p:sp>
-        <p:nvSpPr>
-          <p:cNvPr id="57" name="Timeline rule: First fast drive"/>
+              <a:t>Build the hull and composite parts</a:t>
+            </a:r>
+          </a:p>
+        </p:txBody>
+      </p:sp>
+      <p:sp>
+        <p:nvSpPr>
+          <p:cNvPr id="57" name="Timeline rule: First float and tow test"/>
           <p:cNvSpPr/>
           <p:nvPr/>
         </p:nvSpPr>
         <p:spPr>
           <a:xfrm>
-            <a:off x="5126736" y="8439912"/>
-            <a:ext cx="1075944" cy="22860"/>
+            <a:off x="384048" y="8814816"/>
+            <a:ext cx="3364992" cy="9144"/>
           </a:xfrm>
           <a:prstGeom prst="rect">
             <a:avLst/>
           </a:prstGeom>
           <a:solidFill>
-            <a:srgbClr val="C5050C"/>
+            <a:srgbClr val="E4E4E7"/>
           </a:solidFill>
           <a:ln>
             <a:noFill/>
@@ -5458,14 +5458,14 @@
       </p:sp>
       <p:sp>
         <p:nvSpPr>
-          <p:cNvPr id="58" name="Timeline date: First fast drive"/>
+          <p:cNvPr id="58" name="Timeline date: First float and tow test"/>
           <p:cNvSpPr txBox="1"/>
           <p:nvPr/>
         </p:nvSpPr>
         <p:spPr>
           <a:xfrm>
-            <a:off x="5126736" y="8503920"/>
-            <a:ext cx="1075944" cy="182880"/>
+            <a:off x="384048" y="8855964"/>
+            <a:ext cx="1051560" cy="146304"/>
           </a:xfrm>
           <a:prstGeom prst="rect">
             <a:avLst/>
@@ -5480,27 +5480,27 @@
           <a:p>
             <a:pPr algn="l"/>
             <a:r>
-              <a:rPr sz="900" b="1">
-                <a:solidFill>
-                  <a:srgbClr val="18181B"/>
-                </a:solidFill>
-                <a:latin typeface="Arial"/>
-              </a:rPr>
-              <a:t>Feb 15</a:t>
-            </a:r>
-          </a:p>
-        </p:txBody>
-      </p:sp>
-      <p:sp>
-        <p:nvSpPr>
-          <p:cNvPr id="59" name="Timeline label: First fast drive"/>
+              <a:rPr sz="800" b="1">
+                <a:solidFill>
+                  <a:srgbClr val="C5050C"/>
+                </a:solidFill>
+                <a:latin typeface="Arial"/>
+              </a:rPr>
+              <a:t>Early January</a:t>
+            </a:r>
+          </a:p>
+        </p:txBody>
+      </p:sp>
+      <p:sp>
+        <p:nvSpPr>
+          <p:cNvPr id="59" name="Timeline label: First float and tow test"/>
           <p:cNvSpPr txBox="1"/>
           <p:nvPr/>
         </p:nvSpPr>
         <p:spPr>
           <a:xfrm>
-            <a:off x="5126736" y="8677656"/>
-            <a:ext cx="1075944" cy="182880"/>
+            <a:off x="1481328" y="8855964"/>
+            <a:ext cx="2267712" cy="146304"/>
           </a:xfrm>
           <a:prstGeom prst="rect">
             <a:avLst/>
@@ -5515,33 +5515,33 @@
           <a:p>
             <a:pPr algn="l"/>
             <a:r>
-              <a:rPr sz="900" b="0">
+              <a:rPr sz="800" b="0">
                 <a:solidFill>
                   <a:srgbClr val="3F3F46"/>
                 </a:solidFill>
                 <a:latin typeface="Arial"/>
               </a:rPr>
-              <a:t>First fast drive</a:t>
-            </a:r>
-          </a:p>
-        </p:txBody>
-      </p:sp>
-      <p:sp>
-        <p:nvSpPr>
-          <p:cNvPr id="60" name="Timeline rule: Tuning and testing"/>
+              <a:t>First float and tow test</a:t>
+            </a:r>
+          </a:p>
+        </p:txBody>
+      </p:sp>
+      <p:sp>
+        <p:nvSpPr>
+          <p:cNvPr id="60" name="Timeline rule: Manufacture and assemble everything"/>
           <p:cNvSpPr/>
           <p:nvPr/>
         </p:nvSpPr>
         <p:spPr>
           <a:xfrm>
-            <a:off x="6312408" y="8439912"/>
-            <a:ext cx="1075944" cy="22860"/>
+            <a:off x="384048" y="9015984"/>
+            <a:ext cx="3364992" cy="9144"/>
           </a:xfrm>
           <a:prstGeom prst="rect">
             <a:avLst/>
           </a:prstGeom>
           <a:solidFill>
-            <a:srgbClr val="C5050C"/>
+            <a:srgbClr val="E4E4E7"/>
           </a:solidFill>
           <a:ln>
             <a:noFill/>
@@ -5572,14 +5572,14 @@
       </p:sp>
       <p:sp>
         <p:nvSpPr>
-          <p:cNvPr id="61" name="Timeline date: Tuning and testing"/>
+          <p:cNvPr id="61" name="Timeline date: Manufacture and assemble everything"/>
           <p:cNvSpPr txBox="1"/>
           <p:nvPr/>
         </p:nvSpPr>
         <p:spPr>
           <a:xfrm>
-            <a:off x="6312408" y="8503920"/>
-            <a:ext cx="1075944" cy="182880"/>
+            <a:off x="384048" y="9057132"/>
+            <a:ext cx="1051560" cy="146304"/>
           </a:xfrm>
           <a:prstGeom prst="rect">
             <a:avLst/>
@@ -5594,27 +5594,27 @@
           <a:p>
             <a:pPr algn="l"/>
             <a:r>
-              <a:rPr sz="900" b="1">
-                <a:solidFill>
-                  <a:srgbClr val="18181B"/>
-                </a:solidFill>
-                <a:latin typeface="Arial"/>
-              </a:rPr>
-              <a:t>Mar 15</a:t>
-            </a:r>
-          </a:p>
-        </p:txBody>
-      </p:sp>
-      <p:sp>
-        <p:nvSpPr>
-          <p:cNvPr id="62" name="Timeline label: Tuning and testing"/>
+              <a:rPr sz="800" b="1">
+                <a:solidFill>
+                  <a:srgbClr val="C5050C"/>
+                </a:solidFill>
+                <a:latin typeface="Arial"/>
+              </a:rPr>
+              <a:t>January</a:t>
+            </a:r>
+          </a:p>
+        </p:txBody>
+      </p:sp>
+      <p:sp>
+        <p:nvSpPr>
+          <p:cNvPr id="62" name="Timeline label: Manufacture and assemble everything"/>
           <p:cNvSpPr txBox="1"/>
           <p:nvPr/>
         </p:nvSpPr>
         <p:spPr>
           <a:xfrm>
-            <a:off x="6312408" y="8677656"/>
-            <a:ext cx="1075944" cy="182880"/>
+            <a:off x="1481328" y="9057132"/>
+            <a:ext cx="2267712" cy="146304"/>
           </a:xfrm>
           <a:prstGeom prst="rect">
             <a:avLst/>
@@ -5629,20 +5629,590 @@
           <a:p>
             <a:pPr algn="l"/>
             <a:r>
-              <a:rPr sz="900" b="0">
+              <a:rPr sz="800" b="0">
                 <a:solidFill>
                   <a:srgbClr val="3F3F46"/>
                 </a:solidFill>
                 <a:latin typeface="Arial"/>
               </a:rPr>
-              <a:t>Tuning and testing</a:t>
-            </a:r>
-          </a:p>
-        </p:txBody>
-      </p:sp>
-      <p:sp>
-        <p:nvSpPr>
-          <p:cNvPr id="63" name="Footer band"/>
+              <a:t>Manufacture and assemble everything</a:t>
+            </a:r>
+          </a:p>
+        </p:txBody>
+      </p:sp>
+      <p:sp>
+        <p:nvSpPr>
+          <p:cNvPr id="63" name="Timeline rule: Build likely spare parts, in parallel"/>
+          <p:cNvSpPr/>
+          <p:nvPr/>
+        </p:nvSpPr>
+        <p:spPr>
+          <a:xfrm>
+            <a:off x="4023360" y="8010144"/>
+            <a:ext cx="3364992" cy="9144"/>
+          </a:xfrm>
+          <a:prstGeom prst="rect">
+            <a:avLst/>
+          </a:prstGeom>
+          <a:solidFill>
+            <a:srgbClr val="E4E4E7"/>
+          </a:solidFill>
+          <a:ln>
+            <a:noFill/>
+          </a:ln>
+          <a:effectLst/>
+        </p:spPr>
+        <p:style>
+          <a:lnRef idx="1">
+            <a:schemeClr val="accent1"/>
+          </a:lnRef>
+          <a:fillRef idx="3">
+            <a:schemeClr val="accent1"/>
+          </a:fillRef>
+          <a:effectRef idx="2">
+            <a:schemeClr val="accent1"/>
+          </a:effectRef>
+          <a:fontRef idx="minor">
+            <a:schemeClr val="lt1"/>
+          </a:fontRef>
+        </p:style>
+        <p:txBody>
+          <a:bodyPr rtlCol="0" anchor="ctr"/>
+          <a:lstStyle/>
+          <a:p>
+            <a:pPr algn="ctr"/>
+          </a:p>
+        </p:txBody>
+      </p:sp>
+      <p:sp>
+        <p:nvSpPr>
+          <p:cNvPr id="64" name="Timeline date: Build likely spare parts, in parallel"/>
+          <p:cNvSpPr txBox="1"/>
+          <p:nvPr/>
+        </p:nvSpPr>
+        <p:spPr>
+          <a:xfrm>
+            <a:off x="4023360" y="8051292"/>
+            <a:ext cx="1051560" cy="146304"/>
+          </a:xfrm>
+          <a:prstGeom prst="rect">
+            <a:avLst/>
+          </a:prstGeom>
+          <a:noFill/>
+        </p:spPr>
+        <p:txBody>
+          <a:bodyPr wrap="square" lIns="0" rIns="0" tIns="0" bIns="0" anchor="t">
+            <a:spAutoFit/>
+          </a:bodyPr>
+          <a:lstStyle/>
+          <a:p>
+            <a:pPr algn="l"/>
+            <a:r>
+              <a:rPr sz="800" b="1">
+                <a:solidFill>
+                  <a:srgbClr val="C5050C"/>
+                </a:solidFill>
+                <a:latin typeface="Arial"/>
+              </a:rPr>
+              <a:t>Jan–Feb</a:t>
+            </a:r>
+          </a:p>
+        </p:txBody>
+      </p:sp>
+      <p:sp>
+        <p:nvSpPr>
+          <p:cNvPr id="65" name="Timeline label: Build likely spare parts, in parallel"/>
+          <p:cNvSpPr txBox="1"/>
+          <p:nvPr/>
+        </p:nvSpPr>
+        <p:spPr>
+          <a:xfrm>
+            <a:off x="5120640" y="8051292"/>
+            <a:ext cx="2267712" cy="146304"/>
+          </a:xfrm>
+          <a:prstGeom prst="rect">
+            <a:avLst/>
+          </a:prstGeom>
+          <a:noFill/>
+        </p:spPr>
+        <p:txBody>
+          <a:bodyPr wrap="square" lIns="0" rIns="0" tIns="0" bIns="0" anchor="t">
+            <a:spAutoFit/>
+          </a:bodyPr>
+          <a:lstStyle/>
+          <a:p>
+            <a:pPr algn="l"/>
+            <a:r>
+              <a:rPr sz="800" b="0">
+                <a:solidFill>
+                  <a:srgbClr val="3F3F46"/>
+                </a:solidFill>
+                <a:latin typeface="Arial"/>
+              </a:rPr>
+              <a:t>Build likely spare parts, in parallel</a:t>
+            </a:r>
+          </a:p>
+        </p:txBody>
+      </p:sp>
+      <p:sp>
+        <p:nvSpPr>
+          <p:cNvPr id="66" name="Timeline rule: Zeroth nautical mile"/>
+          <p:cNvSpPr/>
+          <p:nvPr/>
+        </p:nvSpPr>
+        <p:spPr>
+          <a:xfrm>
+            <a:off x="4023360" y="8211312"/>
+            <a:ext cx="3364992" cy="9144"/>
+          </a:xfrm>
+          <a:prstGeom prst="rect">
+            <a:avLst/>
+          </a:prstGeom>
+          <a:solidFill>
+            <a:srgbClr val="E4E4E7"/>
+          </a:solidFill>
+          <a:ln>
+            <a:noFill/>
+          </a:ln>
+          <a:effectLst/>
+        </p:spPr>
+        <p:style>
+          <a:lnRef idx="1">
+            <a:schemeClr val="accent1"/>
+          </a:lnRef>
+          <a:fillRef idx="3">
+            <a:schemeClr val="accent1"/>
+          </a:fillRef>
+          <a:effectRef idx="2">
+            <a:schemeClr val="accent1"/>
+          </a:effectRef>
+          <a:fontRef idx="minor">
+            <a:schemeClr val="lt1"/>
+          </a:fontRef>
+        </p:style>
+        <p:txBody>
+          <a:bodyPr rtlCol="0" anchor="ctr"/>
+          <a:lstStyle/>
+          <a:p>
+            <a:pPr algn="ctr"/>
+          </a:p>
+        </p:txBody>
+      </p:sp>
+      <p:sp>
+        <p:nvSpPr>
+          <p:cNvPr id="67" name="Timeline date: Zeroth nautical mile"/>
+          <p:cNvSpPr txBox="1"/>
+          <p:nvPr/>
+        </p:nvSpPr>
+        <p:spPr>
+          <a:xfrm>
+            <a:off x="4023360" y="8252460"/>
+            <a:ext cx="1051560" cy="146304"/>
+          </a:xfrm>
+          <a:prstGeom prst="rect">
+            <a:avLst/>
+          </a:prstGeom>
+          <a:noFill/>
+        </p:spPr>
+        <p:txBody>
+          <a:bodyPr wrap="square" lIns="0" rIns="0" tIns="0" bIns="0" anchor="t">
+            <a:spAutoFit/>
+          </a:bodyPr>
+          <a:lstStyle/>
+          <a:p>
+            <a:pPr algn="l"/>
+            <a:r>
+              <a:rPr sz="800" b="1">
+                <a:solidFill>
+                  <a:srgbClr val="C5050C"/>
+                </a:solidFill>
+                <a:latin typeface="Arial"/>
+              </a:rPr>
+              <a:t>End of January</a:t>
+            </a:r>
+          </a:p>
+        </p:txBody>
+      </p:sp>
+      <p:sp>
+        <p:nvSpPr>
+          <p:cNvPr id="68" name="Timeline label: Zeroth nautical mile"/>
+          <p:cNvSpPr txBox="1"/>
+          <p:nvPr/>
+        </p:nvSpPr>
+        <p:spPr>
+          <a:xfrm>
+            <a:off x="5120640" y="8252460"/>
+            <a:ext cx="2267712" cy="146304"/>
+          </a:xfrm>
+          <a:prstGeom prst="rect">
+            <a:avLst/>
+          </a:prstGeom>
+          <a:noFill/>
+        </p:spPr>
+        <p:txBody>
+          <a:bodyPr wrap="square" lIns="0" rIns="0" tIns="0" bIns="0" anchor="t">
+            <a:spAutoFit/>
+          </a:bodyPr>
+          <a:lstStyle/>
+          <a:p>
+            <a:pPr algn="l"/>
+            <a:r>
+              <a:rPr sz="800" b="0">
+                <a:solidFill>
+                  <a:srgbClr val="3F3F46"/>
+                </a:solidFill>
+                <a:latin typeface="Arial"/>
+              </a:rPr>
+              <a:t>Zeroth nautical mile</a:t>
+            </a:r>
+          </a:p>
+        </p:txBody>
+      </p:sp>
+      <p:sp>
+        <p:nvSpPr>
+          <p:cNvPr id="69" name="Timeline rule: Slow drives on the water"/>
+          <p:cNvSpPr/>
+          <p:nvPr/>
+        </p:nvSpPr>
+        <p:spPr>
+          <a:xfrm>
+            <a:off x="4023360" y="8412480"/>
+            <a:ext cx="3364992" cy="9144"/>
+          </a:xfrm>
+          <a:prstGeom prst="rect">
+            <a:avLst/>
+          </a:prstGeom>
+          <a:solidFill>
+            <a:srgbClr val="E4E4E7"/>
+          </a:solidFill>
+          <a:ln>
+            <a:noFill/>
+          </a:ln>
+          <a:effectLst/>
+        </p:spPr>
+        <p:style>
+          <a:lnRef idx="1">
+            <a:schemeClr val="accent1"/>
+          </a:lnRef>
+          <a:fillRef idx="3">
+            <a:schemeClr val="accent1"/>
+          </a:fillRef>
+          <a:effectRef idx="2">
+            <a:schemeClr val="accent1"/>
+          </a:effectRef>
+          <a:fontRef idx="minor">
+            <a:schemeClr val="lt1"/>
+          </a:fontRef>
+        </p:style>
+        <p:txBody>
+          <a:bodyPr rtlCol="0" anchor="ctr"/>
+          <a:lstStyle/>
+          <a:p>
+            <a:pPr algn="ctr"/>
+          </a:p>
+        </p:txBody>
+      </p:sp>
+      <p:sp>
+        <p:nvSpPr>
+          <p:cNvPr id="70" name="Timeline date: Slow drives on the water"/>
+          <p:cNvSpPr txBox="1"/>
+          <p:nvPr/>
+        </p:nvSpPr>
+        <p:spPr>
+          <a:xfrm>
+            <a:off x="4023360" y="8453628"/>
+            <a:ext cx="1051560" cy="146304"/>
+          </a:xfrm>
+          <a:prstGeom prst="rect">
+            <a:avLst/>
+          </a:prstGeom>
+          <a:noFill/>
+        </p:spPr>
+        <p:txBody>
+          <a:bodyPr wrap="square" lIns="0" rIns="0" tIns="0" bIns="0" anchor="t">
+            <a:spAutoFit/>
+          </a:bodyPr>
+          <a:lstStyle/>
+          <a:p>
+            <a:pPr algn="l"/>
+            <a:r>
+              <a:rPr sz="800" b="1">
+                <a:solidFill>
+                  <a:srgbClr val="C5050C"/>
+                </a:solidFill>
+                <a:latin typeface="Arial"/>
+              </a:rPr>
+              <a:t>Early February</a:t>
+            </a:r>
+          </a:p>
+        </p:txBody>
+      </p:sp>
+      <p:sp>
+        <p:nvSpPr>
+          <p:cNvPr id="71" name="Timeline label: Slow drives on the water"/>
+          <p:cNvSpPr txBox="1"/>
+          <p:nvPr/>
+        </p:nvSpPr>
+        <p:spPr>
+          <a:xfrm>
+            <a:off x="5120640" y="8453628"/>
+            <a:ext cx="2267712" cy="146304"/>
+          </a:xfrm>
+          <a:prstGeom prst="rect">
+            <a:avLst/>
+          </a:prstGeom>
+          <a:noFill/>
+        </p:spPr>
+        <p:txBody>
+          <a:bodyPr wrap="square" lIns="0" rIns="0" tIns="0" bIns="0" anchor="t">
+            <a:spAutoFit/>
+          </a:bodyPr>
+          <a:lstStyle/>
+          <a:p>
+            <a:pPr algn="l"/>
+            <a:r>
+              <a:rPr sz="800" b="0">
+                <a:solidFill>
+                  <a:srgbClr val="3F3F46"/>
+                </a:solidFill>
+                <a:latin typeface="Arial"/>
+              </a:rPr>
+              <a:t>Slow drives on the water</a:t>
+            </a:r>
+          </a:p>
+        </p:txBody>
+      </p:sp>
+      <p:sp>
+        <p:nvSpPr>
+          <p:cNvPr id="72" name="Timeline rule: Start increasing speed"/>
+          <p:cNvSpPr/>
+          <p:nvPr/>
+        </p:nvSpPr>
+        <p:spPr>
+          <a:xfrm>
+            <a:off x="4023360" y="8613648"/>
+            <a:ext cx="3364992" cy="9144"/>
+          </a:xfrm>
+          <a:prstGeom prst="rect">
+            <a:avLst/>
+          </a:prstGeom>
+          <a:solidFill>
+            <a:srgbClr val="E4E4E7"/>
+          </a:solidFill>
+          <a:ln>
+            <a:noFill/>
+          </a:ln>
+          <a:effectLst/>
+        </p:spPr>
+        <p:style>
+          <a:lnRef idx="1">
+            <a:schemeClr val="accent1"/>
+          </a:lnRef>
+          <a:fillRef idx="3">
+            <a:schemeClr val="accent1"/>
+          </a:fillRef>
+          <a:effectRef idx="2">
+            <a:schemeClr val="accent1"/>
+          </a:effectRef>
+          <a:fontRef idx="minor">
+            <a:schemeClr val="lt1"/>
+          </a:fontRef>
+        </p:style>
+        <p:txBody>
+          <a:bodyPr rtlCol="0" anchor="ctr"/>
+          <a:lstStyle/>
+          <a:p>
+            <a:pPr algn="ctr"/>
+          </a:p>
+        </p:txBody>
+      </p:sp>
+      <p:sp>
+        <p:nvSpPr>
+          <p:cNvPr id="73" name="Timeline date: Start increasing speed"/>
+          <p:cNvSpPr txBox="1"/>
+          <p:nvPr/>
+        </p:nvSpPr>
+        <p:spPr>
+          <a:xfrm>
+            <a:off x="4023360" y="8654796"/>
+            <a:ext cx="1051560" cy="146304"/>
+          </a:xfrm>
+          <a:prstGeom prst="rect">
+            <a:avLst/>
+          </a:prstGeom>
+          <a:noFill/>
+        </p:spPr>
+        <p:txBody>
+          <a:bodyPr wrap="square" lIns="0" rIns="0" tIns="0" bIns="0" anchor="t">
+            <a:spAutoFit/>
+          </a:bodyPr>
+          <a:lstStyle/>
+          <a:p>
+            <a:pPr algn="l"/>
+            <a:r>
+              <a:rPr sz="800" b="1">
+                <a:solidFill>
+                  <a:srgbClr val="C5050C"/>
+                </a:solidFill>
+                <a:latin typeface="Arial"/>
+              </a:rPr>
+              <a:t>Mid February</a:t>
+            </a:r>
+          </a:p>
+        </p:txBody>
+      </p:sp>
+      <p:sp>
+        <p:nvSpPr>
+          <p:cNvPr id="74" name="Timeline label: Start increasing speed"/>
+          <p:cNvSpPr txBox="1"/>
+          <p:nvPr/>
+        </p:nvSpPr>
+        <p:spPr>
+          <a:xfrm>
+            <a:off x="5120640" y="8654796"/>
+            <a:ext cx="2267712" cy="146304"/>
+          </a:xfrm>
+          <a:prstGeom prst="rect">
+            <a:avLst/>
+          </a:prstGeom>
+          <a:noFill/>
+        </p:spPr>
+        <p:txBody>
+          <a:bodyPr wrap="square" lIns="0" rIns="0" tIns="0" bIns="0" anchor="t">
+            <a:spAutoFit/>
+          </a:bodyPr>
+          <a:lstStyle/>
+          <a:p>
+            <a:pPr algn="l"/>
+            <a:r>
+              <a:rPr sz="800" b="0">
+                <a:solidFill>
+                  <a:srgbClr val="3F3F46"/>
+                </a:solidFill>
+                <a:latin typeface="Arial"/>
+              </a:rPr>
+              <a:t>Start increasing speed</a:t>
+            </a:r>
+          </a:p>
+        </p:txBody>
+      </p:sp>
+      <p:sp>
+        <p:nvSpPr>
+          <p:cNvPr id="75" name="Timeline rule: Test as much as possible"/>
+          <p:cNvSpPr/>
+          <p:nvPr/>
+        </p:nvSpPr>
+        <p:spPr>
+          <a:xfrm>
+            <a:off x="4023360" y="8814816"/>
+            <a:ext cx="3364992" cy="9144"/>
+          </a:xfrm>
+          <a:prstGeom prst="rect">
+            <a:avLst/>
+          </a:prstGeom>
+          <a:solidFill>
+            <a:srgbClr val="E4E4E7"/>
+          </a:solidFill>
+          <a:ln>
+            <a:noFill/>
+          </a:ln>
+          <a:effectLst/>
+        </p:spPr>
+        <p:style>
+          <a:lnRef idx="1">
+            <a:schemeClr val="accent1"/>
+          </a:lnRef>
+          <a:fillRef idx="3">
+            <a:schemeClr val="accent1"/>
+          </a:fillRef>
+          <a:effectRef idx="2">
+            <a:schemeClr val="accent1"/>
+          </a:effectRef>
+          <a:fontRef idx="minor">
+            <a:schemeClr val="lt1"/>
+          </a:fontRef>
+        </p:style>
+        <p:txBody>
+          <a:bodyPr rtlCol="0" anchor="ctr"/>
+          <a:lstStyle/>
+          <a:p>
+            <a:pPr algn="ctr"/>
+          </a:p>
+        </p:txBody>
+      </p:sp>
+      <p:sp>
+        <p:nvSpPr>
+          <p:cNvPr id="76" name="Timeline date: Test as much as possible"/>
+          <p:cNvSpPr txBox="1"/>
+          <p:nvPr/>
+        </p:nvSpPr>
+        <p:spPr>
+          <a:xfrm>
+            <a:off x="4023360" y="8855964"/>
+            <a:ext cx="1051560" cy="146304"/>
+          </a:xfrm>
+          <a:prstGeom prst="rect">
+            <a:avLst/>
+          </a:prstGeom>
+          <a:noFill/>
+        </p:spPr>
+        <p:txBody>
+          <a:bodyPr wrap="square" lIns="0" rIns="0" tIns="0" bIns="0" anchor="t">
+            <a:spAutoFit/>
+          </a:bodyPr>
+          <a:lstStyle/>
+          <a:p>
+            <a:pPr algn="l"/>
+            <a:r>
+              <a:rPr sz="800" b="1">
+                <a:solidFill>
+                  <a:srgbClr val="C5050C"/>
+                </a:solidFill>
+                <a:latin typeface="Arial"/>
+              </a:rPr>
+              <a:t>Until competition</a:t>
+            </a:r>
+          </a:p>
+        </p:txBody>
+      </p:sp>
+      <p:sp>
+        <p:nvSpPr>
+          <p:cNvPr id="77" name="Timeline label: Test as much as possible"/>
+          <p:cNvSpPr txBox="1"/>
+          <p:nvPr/>
+        </p:nvSpPr>
+        <p:spPr>
+          <a:xfrm>
+            <a:off x="5120640" y="8855964"/>
+            <a:ext cx="2267712" cy="146304"/>
+          </a:xfrm>
+          <a:prstGeom prst="rect">
+            <a:avLst/>
+          </a:prstGeom>
+          <a:noFill/>
+        </p:spPr>
+        <p:txBody>
+          <a:bodyPr wrap="square" lIns="0" rIns="0" tIns="0" bIns="0" anchor="t">
+            <a:spAutoFit/>
+          </a:bodyPr>
+          <a:lstStyle/>
+          <a:p>
+            <a:pPr algn="l"/>
+            <a:r>
+              <a:rPr sz="800" b="0">
+                <a:solidFill>
+                  <a:srgbClr val="3F3F46"/>
+                </a:solidFill>
+                <a:latin typeface="Arial"/>
+              </a:rPr>
+              <a:t>Test as much as possible</a:t>
+            </a:r>
+          </a:p>
+        </p:txBody>
+      </p:sp>
+      <p:sp>
+        <p:nvSpPr>
+          <p:cNvPr id="78" name="Footer band"/>
           <p:cNvSpPr/>
           <p:nvPr/>
         </p:nvSpPr>
@@ -5686,7 +6256,7 @@
       </p:sp>
       <p:sp>
         <p:nvSpPr>
-          <p:cNvPr id="64" name="Footer title"/>
+          <p:cNvPr id="79" name="Footer title"/>
           <p:cNvSpPr txBox="1"/>
           <p:nvPr/>
         </p:nvSpPr>
@@ -5721,7 +6291,7 @@
       </p:sp>
       <p:sp>
         <p:nvSpPr>
-          <p:cNvPr id="65" name="Footer tagline"/>
+          <p:cNvPr id="80" name="Footer tagline"/>
           <p:cNvSpPr txBox="1"/>
           <p:nvPr/>
         </p:nvSpPr>
@@ -5756,7 +6326,7 @@
       </p:sp>
       <p:sp>
         <p:nvSpPr>
-          <p:cNvPr id="66" name="Footer link label"/>
+          <p:cNvPr id="81" name="Footer link label"/>
           <p:cNvSpPr txBox="1"/>
           <p:nvPr/>
         </p:nvSpPr>
@@ -5791,7 +6361,7 @@
       </p:sp>
       <p:sp>
         <p:nvSpPr>
-          <p:cNvPr id="67" name="Footer link"/>
+          <p:cNvPr id="82" name="Footer link"/>
           <p:cNvSpPr txBox="1"/>
           <p:nvPr/>
         </p:nvSpPr>
@@ -5826,7 +6396,7 @@
       </p:sp>
       <p:sp>
         <p:nvSpPr>
-          <p:cNvPr id="68" name="Footer contact label"/>
+          <p:cNvPr id="83" name="Footer contact label"/>
           <p:cNvSpPr txBox="1"/>
           <p:nvPr/>
         </p:nvSpPr>
@@ -5861,7 +6431,7 @@
       </p:sp>
       <p:sp>
         <p:nvSpPr>
-          <p:cNvPr id="69" name="Footer contact name"/>
+          <p:cNvPr id="84" name="Footer contact name"/>
           <p:cNvSpPr txBox="1"/>
           <p:nvPr/>
         </p:nvSpPr>
@@ -5896,7 +6466,7 @@
       </p:sp>
       <p:sp>
         <p:nvSpPr>
-          <p:cNvPr id="70" name="Footer contact email"/>
+          <p:cNvPr id="85" name="Footer contact email"/>
           <p:cNvSpPr txBox="1"/>
           <p:nvPr/>
         </p:nvSpPr>

</xml_diff>

<commit_message>
Timeline: hard dates for every milestone, drop early January
Co-Authored-By: Claude Sonnet 5.5 <noreply@anthropic.com>
</commit_message>
<xml_diff>
--- a/dashboard/public/haav-handout.pptx
+++ b/dashboard/public/haav-handout.pptx
@@ -5372,7 +5372,7 @@
                 </a:solidFill>
                 <a:latin typeface="Arial"/>
               </a:rPr>
-              <a:t>December</a:t>
+              <a:t>Dec 1–31</a:t>
             </a:r>
           </a:p>
         </p:txBody>
@@ -5414,7 +5414,7 @@
       </p:sp>
       <p:sp>
         <p:nvSpPr>
-          <p:cNvPr id="57" name="Timeline rule: First float and tow test"/>
+          <p:cNvPr id="57" name="Timeline rule: Manufacture and assemble everything"/>
           <p:cNvSpPr/>
           <p:nvPr/>
         </p:nvSpPr>
@@ -5458,7 +5458,7 @@
       </p:sp>
       <p:sp>
         <p:nvSpPr>
-          <p:cNvPr id="58" name="Timeline date: First float and tow test"/>
+          <p:cNvPr id="58" name="Timeline date: Manufacture and assemble everything"/>
           <p:cNvSpPr txBox="1"/>
           <p:nvPr/>
         </p:nvSpPr>
@@ -5486,14 +5486,14 @@
                 </a:solidFill>
                 <a:latin typeface="Arial"/>
               </a:rPr>
-              <a:t>Early January</a:t>
-            </a:r>
-          </a:p>
-        </p:txBody>
-      </p:sp>
-      <p:sp>
-        <p:nvSpPr>
-          <p:cNvPr id="59" name="Timeline label: First float and tow test"/>
+              <a:t>Jan 11–28</a:t>
+            </a:r>
+          </a:p>
+        </p:txBody>
+      </p:sp>
+      <p:sp>
+        <p:nvSpPr>
+          <p:cNvPr id="59" name="Timeline label: Manufacture and assemble everything"/>
           <p:cNvSpPr txBox="1"/>
           <p:nvPr/>
         </p:nvSpPr>
@@ -5521,20 +5521,20 @@
                 </a:solidFill>
                 <a:latin typeface="Arial"/>
               </a:rPr>
-              <a:t>First float and tow test</a:t>
-            </a:r>
-          </a:p>
-        </p:txBody>
-      </p:sp>
-      <p:sp>
-        <p:nvSpPr>
-          <p:cNvPr id="60" name="Timeline rule: Manufacture and assemble everything"/>
+              <a:t>Manufacture and assemble everything</a:t>
+            </a:r>
+          </a:p>
+        </p:txBody>
+      </p:sp>
+      <p:sp>
+        <p:nvSpPr>
+          <p:cNvPr id="60" name="Timeline rule: Build likely spare parts, in parallel"/>
           <p:cNvSpPr/>
           <p:nvPr/>
         </p:nvSpPr>
         <p:spPr>
           <a:xfrm>
-            <a:off x="384048" y="9015984"/>
+            <a:off x="4023360" y="8010144"/>
             <a:ext cx="3364992" cy="9144"/>
           </a:xfrm>
           <a:prstGeom prst="rect">
@@ -5572,13 +5572,13 @@
       </p:sp>
       <p:sp>
         <p:nvSpPr>
-          <p:cNvPr id="61" name="Timeline date: Manufacture and assemble everything"/>
+          <p:cNvPr id="61" name="Timeline date: Build likely spare parts, in parallel"/>
           <p:cNvSpPr txBox="1"/>
           <p:nvPr/>
         </p:nvSpPr>
         <p:spPr>
           <a:xfrm>
-            <a:off x="384048" y="9057132"/>
+            <a:off x="4023360" y="8051292"/>
             <a:ext cx="1051560" cy="146304"/>
           </a:xfrm>
           <a:prstGeom prst="rect">
@@ -5600,20 +5600,20 @@
                 </a:solidFill>
                 <a:latin typeface="Arial"/>
               </a:rPr>
-              <a:t>January</a:t>
-            </a:r>
-          </a:p>
-        </p:txBody>
-      </p:sp>
-      <p:sp>
-        <p:nvSpPr>
-          <p:cNvPr id="62" name="Timeline label: Manufacture and assemble everything"/>
+              <a:t>Jan 11–Feb 26</a:t>
+            </a:r>
+          </a:p>
+        </p:txBody>
+      </p:sp>
+      <p:sp>
+        <p:nvSpPr>
+          <p:cNvPr id="62" name="Timeline label: Build likely spare parts, in parallel"/>
           <p:cNvSpPr txBox="1"/>
           <p:nvPr/>
         </p:nvSpPr>
         <p:spPr>
           <a:xfrm>
-            <a:off x="1481328" y="9057132"/>
+            <a:off x="5120640" y="8051292"/>
             <a:ext cx="2267712" cy="146304"/>
           </a:xfrm>
           <a:prstGeom prst="rect">
@@ -5635,20 +5635,20 @@
                 </a:solidFill>
                 <a:latin typeface="Arial"/>
               </a:rPr>
-              <a:t>Manufacture and assemble everything</a:t>
-            </a:r>
-          </a:p>
-        </p:txBody>
-      </p:sp>
-      <p:sp>
-        <p:nvSpPr>
-          <p:cNvPr id="63" name="Timeline rule: Build likely spare parts, in parallel"/>
+              <a:t>Build likely spare parts, in parallel</a:t>
+            </a:r>
+          </a:p>
+        </p:txBody>
+      </p:sp>
+      <p:sp>
+        <p:nvSpPr>
+          <p:cNvPr id="63" name="Timeline rule: Zeroth nautical mile"/>
           <p:cNvSpPr/>
           <p:nvPr/>
         </p:nvSpPr>
         <p:spPr>
           <a:xfrm>
-            <a:off x="4023360" y="8010144"/>
+            <a:off x="4023360" y="8211312"/>
             <a:ext cx="3364992" cy="9144"/>
           </a:xfrm>
           <a:prstGeom prst="rect">
@@ -5686,13 +5686,13 @@
       </p:sp>
       <p:sp>
         <p:nvSpPr>
-          <p:cNvPr id="64" name="Timeline date: Build likely spare parts, in parallel"/>
+          <p:cNvPr id="64" name="Timeline date: Zeroth nautical mile"/>
           <p:cNvSpPr txBox="1"/>
           <p:nvPr/>
         </p:nvSpPr>
         <p:spPr>
           <a:xfrm>
-            <a:off x="4023360" y="8051292"/>
+            <a:off x="4023360" y="8252460"/>
             <a:ext cx="1051560" cy="146304"/>
           </a:xfrm>
           <a:prstGeom prst="rect">
@@ -5714,20 +5714,20 @@
                 </a:solidFill>
                 <a:latin typeface="Arial"/>
               </a:rPr>
-              <a:t>Jan–Feb</a:t>
-            </a:r>
-          </a:p>
-        </p:txBody>
-      </p:sp>
-      <p:sp>
-        <p:nvSpPr>
-          <p:cNvPr id="65" name="Timeline label: Build likely spare parts, in parallel"/>
+              <a:t>Jan 29</a:t>
+            </a:r>
+          </a:p>
+        </p:txBody>
+      </p:sp>
+      <p:sp>
+        <p:nvSpPr>
+          <p:cNvPr id="65" name="Timeline label: Zeroth nautical mile"/>
           <p:cNvSpPr txBox="1"/>
           <p:nvPr/>
         </p:nvSpPr>
         <p:spPr>
           <a:xfrm>
-            <a:off x="5120640" y="8051292"/>
+            <a:off x="5120640" y="8252460"/>
             <a:ext cx="2267712" cy="146304"/>
           </a:xfrm>
           <a:prstGeom prst="rect">
@@ -5749,20 +5749,20 @@
                 </a:solidFill>
                 <a:latin typeface="Arial"/>
               </a:rPr>
-              <a:t>Build likely spare parts, in parallel</a:t>
-            </a:r>
-          </a:p>
-        </p:txBody>
-      </p:sp>
-      <p:sp>
-        <p:nvSpPr>
-          <p:cNvPr id="66" name="Timeline rule: Zeroth nautical mile"/>
+              <a:t>Zeroth nautical mile</a:t>
+            </a:r>
+          </a:p>
+        </p:txBody>
+      </p:sp>
+      <p:sp>
+        <p:nvSpPr>
+          <p:cNvPr id="66" name="Timeline rule: Slow drives on the water"/>
           <p:cNvSpPr/>
           <p:nvPr/>
         </p:nvSpPr>
         <p:spPr>
           <a:xfrm>
-            <a:off x="4023360" y="8211312"/>
+            <a:off x="4023360" y="8412480"/>
             <a:ext cx="3364992" cy="9144"/>
           </a:xfrm>
           <a:prstGeom prst="rect">
@@ -5800,13 +5800,13 @@
       </p:sp>
       <p:sp>
         <p:nvSpPr>
-          <p:cNvPr id="67" name="Timeline date: Zeroth nautical mile"/>
+          <p:cNvPr id="67" name="Timeline date: Slow drives on the water"/>
           <p:cNvSpPr txBox="1"/>
           <p:nvPr/>
         </p:nvSpPr>
         <p:spPr>
           <a:xfrm>
-            <a:off x="4023360" y="8252460"/>
+            <a:off x="4023360" y="8453628"/>
             <a:ext cx="1051560" cy="146304"/>
           </a:xfrm>
           <a:prstGeom prst="rect">
@@ -5828,20 +5828,20 @@
                 </a:solidFill>
                 <a:latin typeface="Arial"/>
               </a:rPr>
-              <a:t>End of January</a:t>
-            </a:r>
-          </a:p>
-        </p:txBody>
-      </p:sp>
-      <p:sp>
-        <p:nvSpPr>
-          <p:cNvPr id="68" name="Timeline label: Zeroth nautical mile"/>
+              <a:t>Feb 1–14</a:t>
+            </a:r>
+          </a:p>
+        </p:txBody>
+      </p:sp>
+      <p:sp>
+        <p:nvSpPr>
+          <p:cNvPr id="68" name="Timeline label: Slow drives on the water"/>
           <p:cNvSpPr txBox="1"/>
           <p:nvPr/>
         </p:nvSpPr>
         <p:spPr>
           <a:xfrm>
-            <a:off x="5120640" y="8252460"/>
+            <a:off x="5120640" y="8453628"/>
             <a:ext cx="2267712" cy="146304"/>
           </a:xfrm>
           <a:prstGeom prst="rect">
@@ -5863,20 +5863,20 @@
                 </a:solidFill>
                 <a:latin typeface="Arial"/>
               </a:rPr>
-              <a:t>Zeroth nautical mile</a:t>
-            </a:r>
-          </a:p>
-        </p:txBody>
-      </p:sp>
-      <p:sp>
-        <p:nvSpPr>
-          <p:cNvPr id="69" name="Timeline rule: Slow drives on the water"/>
+              <a:t>Slow drives on the water</a:t>
+            </a:r>
+          </a:p>
+        </p:txBody>
+      </p:sp>
+      <p:sp>
+        <p:nvSpPr>
+          <p:cNvPr id="69" name="Timeline rule: Start increasing speed"/>
           <p:cNvSpPr/>
           <p:nvPr/>
         </p:nvSpPr>
         <p:spPr>
           <a:xfrm>
-            <a:off x="4023360" y="8412480"/>
+            <a:off x="4023360" y="8613648"/>
             <a:ext cx="3364992" cy="9144"/>
           </a:xfrm>
           <a:prstGeom prst="rect">
@@ -5914,13 +5914,13 @@
       </p:sp>
       <p:sp>
         <p:nvSpPr>
-          <p:cNvPr id="70" name="Timeline date: Slow drives on the water"/>
+          <p:cNvPr id="70" name="Timeline date: Start increasing speed"/>
           <p:cNvSpPr txBox="1"/>
           <p:nvPr/>
         </p:nvSpPr>
         <p:spPr>
           <a:xfrm>
-            <a:off x="4023360" y="8453628"/>
+            <a:off x="4023360" y="8654796"/>
             <a:ext cx="1051560" cy="146304"/>
           </a:xfrm>
           <a:prstGeom prst="rect">
@@ -5942,20 +5942,20 @@
                 </a:solidFill>
                 <a:latin typeface="Arial"/>
               </a:rPr>
-              <a:t>Early February</a:t>
-            </a:r>
-          </a:p>
-        </p:txBody>
-      </p:sp>
-      <p:sp>
-        <p:nvSpPr>
-          <p:cNvPr id="71" name="Timeline label: Slow drives on the water"/>
+              <a:t>Feb 15</a:t>
+            </a:r>
+          </a:p>
+        </p:txBody>
+      </p:sp>
+      <p:sp>
+        <p:nvSpPr>
+          <p:cNvPr id="71" name="Timeline label: Start increasing speed"/>
           <p:cNvSpPr txBox="1"/>
           <p:nvPr/>
         </p:nvSpPr>
         <p:spPr>
           <a:xfrm>
-            <a:off x="5120640" y="8453628"/>
+            <a:off x="5120640" y="8654796"/>
             <a:ext cx="2267712" cy="146304"/>
           </a:xfrm>
           <a:prstGeom prst="rect">
@@ -5977,20 +5977,20 @@
                 </a:solidFill>
                 <a:latin typeface="Arial"/>
               </a:rPr>
-              <a:t>Slow drives on the water</a:t>
-            </a:r>
-          </a:p>
-        </p:txBody>
-      </p:sp>
-      <p:sp>
-        <p:nvSpPr>
-          <p:cNvPr id="72" name="Timeline rule: Start increasing speed"/>
+              <a:t>Start increasing speed</a:t>
+            </a:r>
+          </a:p>
+        </p:txBody>
+      </p:sp>
+      <p:sp>
+        <p:nvSpPr>
+          <p:cNvPr id="72" name="Timeline rule: Test as much as possible until the competition"/>
           <p:cNvSpPr/>
           <p:nvPr/>
         </p:nvSpPr>
         <p:spPr>
           <a:xfrm>
-            <a:off x="4023360" y="8613648"/>
+            <a:off x="4023360" y="8814816"/>
             <a:ext cx="3364992" cy="9144"/>
           </a:xfrm>
           <a:prstGeom prst="rect">
@@ -6028,13 +6028,13 @@
       </p:sp>
       <p:sp>
         <p:nvSpPr>
-          <p:cNvPr id="73" name="Timeline date: Start increasing speed"/>
+          <p:cNvPr id="73" name="Timeline date: Test as much as possible until the competition"/>
           <p:cNvSpPr txBox="1"/>
           <p:nvPr/>
         </p:nvSpPr>
         <p:spPr>
           <a:xfrm>
-            <a:off x="4023360" y="8654796"/>
+            <a:off x="4023360" y="8855964"/>
             <a:ext cx="1051560" cy="146304"/>
           </a:xfrm>
           <a:prstGeom prst="rect">
@@ -6056,20 +6056,20 @@
                 </a:solidFill>
                 <a:latin typeface="Arial"/>
               </a:rPr>
-              <a:t>Mid February</a:t>
-            </a:r>
-          </a:p>
-        </p:txBody>
-      </p:sp>
-      <p:sp>
-        <p:nvSpPr>
-          <p:cNvPr id="74" name="Timeline label: Start increasing speed"/>
+              <a:t>From Feb 15</a:t>
+            </a:r>
+          </a:p>
+        </p:txBody>
+      </p:sp>
+      <p:sp>
+        <p:nvSpPr>
+          <p:cNvPr id="74" name="Timeline label: Test as much as possible until the competition"/>
           <p:cNvSpPr txBox="1"/>
           <p:nvPr/>
         </p:nvSpPr>
         <p:spPr>
           <a:xfrm>
-            <a:off x="5120640" y="8654796"/>
+            <a:off x="5120640" y="8855964"/>
             <a:ext cx="2267712" cy="146304"/>
           </a:xfrm>
           <a:prstGeom prst="rect">
@@ -6091,128 +6091,14 @@
                 </a:solidFill>
                 <a:latin typeface="Arial"/>
               </a:rPr>
-              <a:t>Start increasing speed</a:t>
-            </a:r>
-          </a:p>
-        </p:txBody>
-      </p:sp>
-      <p:sp>
-        <p:nvSpPr>
-          <p:cNvPr id="75" name="Timeline rule: Test as much as possible"/>
-          <p:cNvSpPr/>
-          <p:nvPr/>
-        </p:nvSpPr>
-        <p:spPr>
-          <a:xfrm>
-            <a:off x="4023360" y="8814816"/>
-            <a:ext cx="3364992" cy="9144"/>
-          </a:xfrm>
-          <a:prstGeom prst="rect">
-            <a:avLst/>
-          </a:prstGeom>
-          <a:solidFill>
-            <a:srgbClr val="E4E4E7"/>
-          </a:solidFill>
-          <a:ln>
-            <a:noFill/>
-          </a:ln>
-          <a:effectLst/>
-        </p:spPr>
-        <p:style>
-          <a:lnRef idx="1">
-            <a:schemeClr val="accent1"/>
-          </a:lnRef>
-          <a:fillRef idx="3">
-            <a:schemeClr val="accent1"/>
-          </a:fillRef>
-          <a:effectRef idx="2">
-            <a:schemeClr val="accent1"/>
-          </a:effectRef>
-          <a:fontRef idx="minor">
-            <a:schemeClr val="lt1"/>
-          </a:fontRef>
-        </p:style>
-        <p:txBody>
-          <a:bodyPr rtlCol="0" anchor="ctr"/>
-          <a:lstStyle/>
-          <a:p>
-            <a:pPr algn="ctr"/>
-          </a:p>
-        </p:txBody>
-      </p:sp>
-      <p:sp>
-        <p:nvSpPr>
-          <p:cNvPr id="76" name="Timeline date: Test as much as possible"/>
-          <p:cNvSpPr txBox="1"/>
-          <p:nvPr/>
-        </p:nvSpPr>
-        <p:spPr>
-          <a:xfrm>
-            <a:off x="4023360" y="8855964"/>
-            <a:ext cx="1051560" cy="146304"/>
-          </a:xfrm>
-          <a:prstGeom prst="rect">
-            <a:avLst/>
-          </a:prstGeom>
-          <a:noFill/>
-        </p:spPr>
-        <p:txBody>
-          <a:bodyPr wrap="square" lIns="0" rIns="0" tIns="0" bIns="0" anchor="t">
-            <a:spAutoFit/>
-          </a:bodyPr>
-          <a:lstStyle/>
-          <a:p>
-            <a:pPr algn="l"/>
-            <a:r>
-              <a:rPr sz="800" b="1">
-                <a:solidFill>
-                  <a:srgbClr val="C5050C"/>
-                </a:solidFill>
-                <a:latin typeface="Arial"/>
-              </a:rPr>
-              <a:t>Until competition</a:t>
-            </a:r>
-          </a:p>
-        </p:txBody>
-      </p:sp>
-      <p:sp>
-        <p:nvSpPr>
-          <p:cNvPr id="77" name="Timeline label: Test as much as possible"/>
-          <p:cNvSpPr txBox="1"/>
-          <p:nvPr/>
-        </p:nvSpPr>
-        <p:spPr>
-          <a:xfrm>
-            <a:off x="5120640" y="8855964"/>
-            <a:ext cx="2267712" cy="146304"/>
-          </a:xfrm>
-          <a:prstGeom prst="rect">
-            <a:avLst/>
-          </a:prstGeom>
-          <a:noFill/>
-        </p:spPr>
-        <p:txBody>
-          <a:bodyPr wrap="square" lIns="0" rIns="0" tIns="0" bIns="0" anchor="t">
-            <a:spAutoFit/>
-          </a:bodyPr>
-          <a:lstStyle/>
-          <a:p>
-            <a:pPr algn="l"/>
-            <a:r>
-              <a:rPr sz="800" b="0">
-                <a:solidFill>
-                  <a:srgbClr val="3F3F46"/>
-                </a:solidFill>
-                <a:latin typeface="Arial"/>
-              </a:rPr>
-              <a:t>Test as much as possible</a:t>
-            </a:r>
-          </a:p>
-        </p:txBody>
-      </p:sp>
-      <p:sp>
-        <p:nvSpPr>
-          <p:cNvPr id="78" name="Footer band"/>
+              <a:t>Test as much as possible until the competition</a:t>
+            </a:r>
+          </a:p>
+        </p:txBody>
+      </p:sp>
+      <p:sp>
+        <p:nvSpPr>
+          <p:cNvPr id="75" name="Footer band"/>
           <p:cNvSpPr/>
           <p:nvPr/>
         </p:nvSpPr>
@@ -6256,7 +6142,7 @@
       </p:sp>
       <p:sp>
         <p:nvSpPr>
-          <p:cNvPr id="79" name="Footer title"/>
+          <p:cNvPr id="76" name="Footer title"/>
           <p:cNvSpPr txBox="1"/>
           <p:nvPr/>
         </p:nvSpPr>
@@ -6291,7 +6177,7 @@
       </p:sp>
       <p:sp>
         <p:nvSpPr>
-          <p:cNvPr id="80" name="Footer tagline"/>
+          <p:cNvPr id="77" name="Footer tagline"/>
           <p:cNvSpPr txBox="1"/>
           <p:nvPr/>
         </p:nvSpPr>
@@ -6326,7 +6212,7 @@
       </p:sp>
       <p:sp>
         <p:nvSpPr>
-          <p:cNvPr id="81" name="Footer link label"/>
+          <p:cNvPr id="78" name="Footer link label"/>
           <p:cNvSpPr txBox="1"/>
           <p:nvPr/>
         </p:nvSpPr>
@@ -6361,7 +6247,7 @@
       </p:sp>
       <p:sp>
         <p:nvSpPr>
-          <p:cNvPr id="82" name="Footer link"/>
+          <p:cNvPr id="79" name="Footer link"/>
           <p:cNvSpPr txBox="1"/>
           <p:nvPr/>
         </p:nvSpPr>
@@ -6396,7 +6282,7 @@
       </p:sp>
       <p:sp>
         <p:nvSpPr>
-          <p:cNvPr id="83" name="Footer contact label"/>
+          <p:cNvPr id="80" name="Footer contact label"/>
           <p:cNvSpPr txBox="1"/>
           <p:nvPr/>
         </p:nvSpPr>
@@ -6431,7 +6317,7 @@
       </p:sp>
       <p:sp>
         <p:nvSpPr>
-          <p:cNvPr id="84" name="Footer contact name"/>
+          <p:cNvPr id="81" name="Footer contact name"/>
           <p:cNvSpPr txBox="1"/>
           <p:nvPr/>
         </p:nvSpPr>
@@ -6466,7 +6352,7 @@
       </p:sp>
       <p:sp>
         <p:nvSpPr>
-          <p:cNvPr id="85" name="Footer contact email"/>
+          <p:cNvPr id="82" name="Footer contact email"/>
           <p:cNvSpPr txBox="1"/>
           <p:nvPr/>
         </p:nvSpPr>

</xml_diff>

<commit_message>
Timeline: add the first float and tow test in late January
Co-Authored-By: Claude Sonnet 5.5 <noreply@anthropic.com>
</commit_message>
<xml_diff>
--- a/dashboard/public/haav-handout.pptx
+++ b/dashboard/public/haav-handout.pptx
@@ -5534,7 +5534,7 @@
         </p:nvSpPr>
         <p:spPr>
           <a:xfrm>
-            <a:off x="4023360" y="8010144"/>
+            <a:off x="384048" y="9015984"/>
             <a:ext cx="3364992" cy="9144"/>
           </a:xfrm>
           <a:prstGeom prst="rect">
@@ -5578,7 +5578,7 @@
         </p:nvSpPr>
         <p:spPr>
           <a:xfrm>
-            <a:off x="4023360" y="8051292"/>
+            <a:off x="384048" y="9057132"/>
             <a:ext cx="1051560" cy="146304"/>
           </a:xfrm>
           <a:prstGeom prst="rect">
@@ -5613,7 +5613,7 @@
         </p:nvSpPr>
         <p:spPr>
           <a:xfrm>
-            <a:off x="5120640" y="8051292"/>
+            <a:off x="1481328" y="9057132"/>
             <a:ext cx="2267712" cy="146304"/>
           </a:xfrm>
           <a:prstGeom prst="rect">
@@ -5642,13 +5642,13 @@
       </p:sp>
       <p:sp>
         <p:nvSpPr>
-          <p:cNvPr id="63" name="Timeline rule: Zeroth nautical mile"/>
+          <p:cNvPr id="63" name="Timeline rule: First float and tow test"/>
           <p:cNvSpPr/>
           <p:nvPr/>
         </p:nvSpPr>
         <p:spPr>
           <a:xfrm>
-            <a:off x="4023360" y="8211312"/>
+            <a:off x="4023360" y="8010144"/>
             <a:ext cx="3364992" cy="9144"/>
           </a:xfrm>
           <a:prstGeom prst="rect">
@@ -5686,13 +5686,13 @@
       </p:sp>
       <p:sp>
         <p:nvSpPr>
-          <p:cNvPr id="64" name="Timeline date: Zeroth nautical mile"/>
+          <p:cNvPr id="64" name="Timeline date: First float and tow test"/>
           <p:cNvSpPr txBox="1"/>
           <p:nvPr/>
         </p:nvSpPr>
         <p:spPr>
           <a:xfrm>
-            <a:off x="4023360" y="8252460"/>
+            <a:off x="4023360" y="8051292"/>
             <a:ext cx="1051560" cy="146304"/>
           </a:xfrm>
           <a:prstGeom prst="rect">
@@ -5714,20 +5714,20 @@
                 </a:solidFill>
                 <a:latin typeface="Arial"/>
               </a:rPr>
-              <a:t>Jan 29</a:t>
-            </a:r>
-          </a:p>
-        </p:txBody>
-      </p:sp>
-      <p:sp>
-        <p:nvSpPr>
-          <p:cNvPr id="65" name="Timeline label: Zeroth nautical mile"/>
+              <a:t>Jan 22</a:t>
+            </a:r>
+          </a:p>
+        </p:txBody>
+      </p:sp>
+      <p:sp>
+        <p:nvSpPr>
+          <p:cNvPr id="65" name="Timeline label: First float and tow test"/>
           <p:cNvSpPr txBox="1"/>
           <p:nvPr/>
         </p:nvSpPr>
         <p:spPr>
           <a:xfrm>
-            <a:off x="5120640" y="8252460"/>
+            <a:off x="5120640" y="8051292"/>
             <a:ext cx="2267712" cy="146304"/>
           </a:xfrm>
           <a:prstGeom prst="rect">
@@ -5749,20 +5749,20 @@
                 </a:solidFill>
                 <a:latin typeface="Arial"/>
               </a:rPr>
-              <a:t>Zeroth nautical mile</a:t>
-            </a:r>
-          </a:p>
-        </p:txBody>
-      </p:sp>
-      <p:sp>
-        <p:nvSpPr>
-          <p:cNvPr id="66" name="Timeline rule: Slow drives on the water"/>
+              <a:t>First float and tow test</a:t>
+            </a:r>
+          </a:p>
+        </p:txBody>
+      </p:sp>
+      <p:sp>
+        <p:nvSpPr>
+          <p:cNvPr id="66" name="Timeline rule: Zeroth nautical mile"/>
           <p:cNvSpPr/>
           <p:nvPr/>
         </p:nvSpPr>
         <p:spPr>
           <a:xfrm>
-            <a:off x="4023360" y="8412480"/>
+            <a:off x="4023360" y="8211312"/>
             <a:ext cx="3364992" cy="9144"/>
           </a:xfrm>
           <a:prstGeom prst="rect">
@@ -5800,13 +5800,13 @@
       </p:sp>
       <p:sp>
         <p:nvSpPr>
-          <p:cNvPr id="67" name="Timeline date: Slow drives on the water"/>
+          <p:cNvPr id="67" name="Timeline date: Zeroth nautical mile"/>
           <p:cNvSpPr txBox="1"/>
           <p:nvPr/>
         </p:nvSpPr>
         <p:spPr>
           <a:xfrm>
-            <a:off x="4023360" y="8453628"/>
+            <a:off x="4023360" y="8252460"/>
             <a:ext cx="1051560" cy="146304"/>
           </a:xfrm>
           <a:prstGeom prst="rect">
@@ -5828,20 +5828,20 @@
                 </a:solidFill>
                 <a:latin typeface="Arial"/>
               </a:rPr>
-              <a:t>Feb 1–14</a:t>
-            </a:r>
-          </a:p>
-        </p:txBody>
-      </p:sp>
-      <p:sp>
-        <p:nvSpPr>
-          <p:cNvPr id="68" name="Timeline label: Slow drives on the water"/>
+              <a:t>Jan 29</a:t>
+            </a:r>
+          </a:p>
+        </p:txBody>
+      </p:sp>
+      <p:sp>
+        <p:nvSpPr>
+          <p:cNvPr id="68" name="Timeline label: Zeroth nautical mile"/>
           <p:cNvSpPr txBox="1"/>
           <p:nvPr/>
         </p:nvSpPr>
         <p:spPr>
           <a:xfrm>
-            <a:off x="5120640" y="8453628"/>
+            <a:off x="5120640" y="8252460"/>
             <a:ext cx="2267712" cy="146304"/>
           </a:xfrm>
           <a:prstGeom prst="rect">
@@ -5863,20 +5863,20 @@
                 </a:solidFill>
                 <a:latin typeface="Arial"/>
               </a:rPr>
-              <a:t>Slow drives on the water</a:t>
-            </a:r>
-          </a:p>
-        </p:txBody>
-      </p:sp>
-      <p:sp>
-        <p:nvSpPr>
-          <p:cNvPr id="69" name="Timeline rule: Start increasing speed"/>
+              <a:t>Zeroth nautical mile</a:t>
+            </a:r>
+          </a:p>
+        </p:txBody>
+      </p:sp>
+      <p:sp>
+        <p:nvSpPr>
+          <p:cNvPr id="69" name="Timeline rule: Slow drives on the water"/>
           <p:cNvSpPr/>
           <p:nvPr/>
         </p:nvSpPr>
         <p:spPr>
           <a:xfrm>
-            <a:off x="4023360" y="8613648"/>
+            <a:off x="4023360" y="8412480"/>
             <a:ext cx="3364992" cy="9144"/>
           </a:xfrm>
           <a:prstGeom prst="rect">
@@ -5914,13 +5914,13 @@
       </p:sp>
       <p:sp>
         <p:nvSpPr>
-          <p:cNvPr id="70" name="Timeline date: Start increasing speed"/>
+          <p:cNvPr id="70" name="Timeline date: Slow drives on the water"/>
           <p:cNvSpPr txBox="1"/>
           <p:nvPr/>
         </p:nvSpPr>
         <p:spPr>
           <a:xfrm>
-            <a:off x="4023360" y="8654796"/>
+            <a:off x="4023360" y="8453628"/>
             <a:ext cx="1051560" cy="146304"/>
           </a:xfrm>
           <a:prstGeom prst="rect">
@@ -5942,20 +5942,20 @@
                 </a:solidFill>
                 <a:latin typeface="Arial"/>
               </a:rPr>
-              <a:t>Feb 15</a:t>
-            </a:r>
-          </a:p>
-        </p:txBody>
-      </p:sp>
-      <p:sp>
-        <p:nvSpPr>
-          <p:cNvPr id="71" name="Timeline label: Start increasing speed"/>
+              <a:t>Feb 1–14</a:t>
+            </a:r>
+          </a:p>
+        </p:txBody>
+      </p:sp>
+      <p:sp>
+        <p:nvSpPr>
+          <p:cNvPr id="71" name="Timeline label: Slow drives on the water"/>
           <p:cNvSpPr txBox="1"/>
           <p:nvPr/>
         </p:nvSpPr>
         <p:spPr>
           <a:xfrm>
-            <a:off x="5120640" y="8654796"/>
+            <a:off x="5120640" y="8453628"/>
             <a:ext cx="2267712" cy="146304"/>
           </a:xfrm>
           <a:prstGeom prst="rect">
@@ -5977,20 +5977,20 @@
                 </a:solidFill>
                 <a:latin typeface="Arial"/>
               </a:rPr>
-              <a:t>Start increasing speed</a:t>
-            </a:r>
-          </a:p>
-        </p:txBody>
-      </p:sp>
-      <p:sp>
-        <p:nvSpPr>
-          <p:cNvPr id="72" name="Timeline rule: Test as much as possible until the competition"/>
+              <a:t>Slow drives on the water</a:t>
+            </a:r>
+          </a:p>
+        </p:txBody>
+      </p:sp>
+      <p:sp>
+        <p:nvSpPr>
+          <p:cNvPr id="72" name="Timeline rule: Start increasing speed"/>
           <p:cNvSpPr/>
           <p:nvPr/>
         </p:nvSpPr>
         <p:spPr>
           <a:xfrm>
-            <a:off x="4023360" y="8814816"/>
+            <a:off x="4023360" y="8613648"/>
             <a:ext cx="3364992" cy="9144"/>
           </a:xfrm>
           <a:prstGeom prst="rect">
@@ -6028,13 +6028,13 @@
       </p:sp>
       <p:sp>
         <p:nvSpPr>
-          <p:cNvPr id="73" name="Timeline date: Test as much as possible until the competition"/>
+          <p:cNvPr id="73" name="Timeline date: Start increasing speed"/>
           <p:cNvSpPr txBox="1"/>
           <p:nvPr/>
         </p:nvSpPr>
         <p:spPr>
           <a:xfrm>
-            <a:off x="4023360" y="8855964"/>
+            <a:off x="4023360" y="8654796"/>
             <a:ext cx="1051560" cy="146304"/>
           </a:xfrm>
           <a:prstGeom prst="rect">
@@ -6056,20 +6056,20 @@
                 </a:solidFill>
                 <a:latin typeface="Arial"/>
               </a:rPr>
-              <a:t>From Feb 15</a:t>
-            </a:r>
-          </a:p>
-        </p:txBody>
-      </p:sp>
-      <p:sp>
-        <p:nvSpPr>
-          <p:cNvPr id="74" name="Timeline label: Test as much as possible until the competition"/>
+              <a:t>Feb 15</a:t>
+            </a:r>
+          </a:p>
+        </p:txBody>
+      </p:sp>
+      <p:sp>
+        <p:nvSpPr>
+          <p:cNvPr id="74" name="Timeline label: Start increasing speed"/>
           <p:cNvSpPr txBox="1"/>
           <p:nvPr/>
         </p:nvSpPr>
         <p:spPr>
           <a:xfrm>
-            <a:off x="5120640" y="8855964"/>
+            <a:off x="5120640" y="8654796"/>
             <a:ext cx="2267712" cy="146304"/>
           </a:xfrm>
           <a:prstGeom prst="rect">
@@ -6091,14 +6091,128 @@
                 </a:solidFill>
                 <a:latin typeface="Arial"/>
               </a:rPr>
-              <a:t>Test as much as possible until the competition</a:t>
-            </a:r>
-          </a:p>
-        </p:txBody>
-      </p:sp>
-      <p:sp>
-        <p:nvSpPr>
-          <p:cNvPr id="75" name="Footer band"/>
+              <a:t>Start increasing speed</a:t>
+            </a:r>
+          </a:p>
+        </p:txBody>
+      </p:sp>
+      <p:sp>
+        <p:nvSpPr>
+          <p:cNvPr id="75" name="Timeline rule: Keep testing until the competition"/>
+          <p:cNvSpPr/>
+          <p:nvPr/>
+        </p:nvSpPr>
+        <p:spPr>
+          <a:xfrm>
+            <a:off x="4023360" y="8814816"/>
+            <a:ext cx="3364992" cy="9144"/>
+          </a:xfrm>
+          <a:prstGeom prst="rect">
+            <a:avLst/>
+          </a:prstGeom>
+          <a:solidFill>
+            <a:srgbClr val="E4E4E7"/>
+          </a:solidFill>
+          <a:ln>
+            <a:noFill/>
+          </a:ln>
+          <a:effectLst/>
+        </p:spPr>
+        <p:style>
+          <a:lnRef idx="1">
+            <a:schemeClr val="accent1"/>
+          </a:lnRef>
+          <a:fillRef idx="3">
+            <a:schemeClr val="accent1"/>
+          </a:fillRef>
+          <a:effectRef idx="2">
+            <a:schemeClr val="accent1"/>
+          </a:effectRef>
+          <a:fontRef idx="minor">
+            <a:schemeClr val="lt1"/>
+          </a:fontRef>
+        </p:style>
+        <p:txBody>
+          <a:bodyPr rtlCol="0" anchor="ctr"/>
+          <a:lstStyle/>
+          <a:p>
+            <a:pPr algn="ctr"/>
+          </a:p>
+        </p:txBody>
+      </p:sp>
+      <p:sp>
+        <p:nvSpPr>
+          <p:cNvPr id="76" name="Timeline date: Keep testing until the competition"/>
+          <p:cNvSpPr txBox="1"/>
+          <p:nvPr/>
+        </p:nvSpPr>
+        <p:spPr>
+          <a:xfrm>
+            <a:off x="4023360" y="8855964"/>
+            <a:ext cx="1051560" cy="146304"/>
+          </a:xfrm>
+          <a:prstGeom prst="rect">
+            <a:avLst/>
+          </a:prstGeom>
+          <a:noFill/>
+        </p:spPr>
+        <p:txBody>
+          <a:bodyPr wrap="square" lIns="0" rIns="0" tIns="0" bIns="0" anchor="t">
+            <a:spAutoFit/>
+          </a:bodyPr>
+          <a:lstStyle/>
+          <a:p>
+            <a:pPr algn="l"/>
+            <a:r>
+              <a:rPr sz="800" b="1">
+                <a:solidFill>
+                  <a:srgbClr val="C5050C"/>
+                </a:solidFill>
+                <a:latin typeface="Arial"/>
+              </a:rPr>
+              <a:t>From Feb 15</a:t>
+            </a:r>
+          </a:p>
+        </p:txBody>
+      </p:sp>
+      <p:sp>
+        <p:nvSpPr>
+          <p:cNvPr id="77" name="Timeline label: Keep testing until the competition"/>
+          <p:cNvSpPr txBox="1"/>
+          <p:nvPr/>
+        </p:nvSpPr>
+        <p:spPr>
+          <a:xfrm>
+            <a:off x="5120640" y="8855964"/>
+            <a:ext cx="2267712" cy="146304"/>
+          </a:xfrm>
+          <a:prstGeom prst="rect">
+            <a:avLst/>
+          </a:prstGeom>
+          <a:noFill/>
+        </p:spPr>
+        <p:txBody>
+          <a:bodyPr wrap="square" lIns="0" rIns="0" tIns="0" bIns="0" anchor="t">
+            <a:spAutoFit/>
+          </a:bodyPr>
+          <a:lstStyle/>
+          <a:p>
+            <a:pPr algn="l"/>
+            <a:r>
+              <a:rPr sz="800" b="0">
+                <a:solidFill>
+                  <a:srgbClr val="3F3F46"/>
+                </a:solidFill>
+                <a:latin typeface="Arial"/>
+              </a:rPr>
+              <a:t>Keep testing until the competition</a:t>
+            </a:r>
+          </a:p>
+        </p:txBody>
+      </p:sp>
+      <p:sp>
+        <p:nvSpPr>
+          <p:cNvPr id="78" name="Footer band"/>
           <p:cNvSpPr/>
           <p:nvPr/>
         </p:nvSpPr>
@@ -6142,7 +6256,7 @@
       </p:sp>
       <p:sp>
         <p:nvSpPr>
-          <p:cNvPr id="76" name="Footer title"/>
+          <p:cNvPr id="79" name="Footer title"/>
           <p:cNvSpPr txBox="1"/>
           <p:nvPr/>
         </p:nvSpPr>
@@ -6177,7 +6291,7 @@
       </p:sp>
       <p:sp>
         <p:nvSpPr>
-          <p:cNvPr id="77" name="Footer tagline"/>
+          <p:cNvPr id="80" name="Footer tagline"/>
           <p:cNvSpPr txBox="1"/>
           <p:nvPr/>
         </p:nvSpPr>
@@ -6212,7 +6326,7 @@
       </p:sp>
       <p:sp>
         <p:nvSpPr>
-          <p:cNvPr id="78" name="Footer link label"/>
+          <p:cNvPr id="81" name="Footer link label"/>
           <p:cNvSpPr txBox="1"/>
           <p:nvPr/>
         </p:nvSpPr>
@@ -6247,7 +6361,7 @@
       </p:sp>
       <p:sp>
         <p:nvSpPr>
-          <p:cNvPr id="79" name="Footer link"/>
+          <p:cNvPr id="82" name="Footer link"/>
           <p:cNvSpPr txBox="1"/>
           <p:nvPr/>
         </p:nvSpPr>
@@ -6282,7 +6396,7 @@
       </p:sp>
       <p:sp>
         <p:nvSpPr>
-          <p:cNvPr id="80" name="Footer contact label"/>
+          <p:cNvPr id="83" name="Footer contact label"/>
           <p:cNvSpPr txBox="1"/>
           <p:nvPr/>
         </p:nvSpPr>
@@ -6317,7 +6431,7 @@
       </p:sp>
       <p:sp>
         <p:nvSpPr>
-          <p:cNvPr id="81" name="Footer contact name"/>
+          <p:cNvPr id="84" name="Footer contact name"/>
           <p:cNvSpPr txBox="1"/>
           <p:nvPr/>
         </p:nvSpPr>
@@ -6352,7 +6466,7 @@
       </p:sp>
       <p:sp>
         <p:nvSpPr>
-          <p:cNvPr id="82" name="Footer contact email"/>
+          <p:cNvPr id="85" name="Footer contact email"/>
           <p:cNvSpPr txBox="1"/>
           <p:nvPr/>
         </p:nvSpPr>

</xml_diff>

<commit_message>
Timeline: keep the full detail on the site, handout and PowerPoint
Co-Authored-By: Claude Sonnet 5.5 <noreply@anthropic.com>
</commit_message>
<xml_diff>
--- a/dashboard/public/haav-handout.pptx
+++ b/dashboard/public/haav-handout.pptx
@@ -3280,8 +3280,8 @@
         </p:nvSpPr>
         <p:spPr>
           <a:xfrm>
-            <a:off x="384048" y="1115568"/>
-            <a:ext cx="4023360" cy="1188720"/>
+            <a:off x="384048" y="1005840"/>
+            <a:ext cx="4023360" cy="914400"/>
           </a:xfrm>
           <a:prstGeom prst="rect">
             <a:avLst/>
@@ -3300,7 +3300,7 @@
               </a:lnSpc>
             </a:pPr>
             <a:r>
-              <a:rPr sz="2100" b="1">
+              <a:rPr sz="2000" b="1">
                 <a:solidFill>
                   <a:srgbClr val="18181B"/>
                 </a:solidFill>
@@ -3319,12 +3319,12 @@
         </p:nvSpPr>
         <p:spPr>
           <a:xfrm>
-            <a:off x="4663440" y="1069848"/>
-            <a:ext cx="2724912" cy="1335024"/>
+            <a:off x="4663440" y="1024128"/>
+            <a:ext cx="2724912" cy="1005840"/>
           </a:xfrm>
           <a:prstGeom prst="roundRect">
             <a:avLst>
-              <a:gd name="adj" fmla="val 6849"/>
+              <a:gd name="adj" fmla="val 9090"/>
             </a:avLst>
           </a:prstGeom>
           <a:solidFill>
@@ -3375,8 +3375,8 @@
         </p:blipFill>
         <p:spPr>
           <a:xfrm>
-            <a:off x="4846320" y="1097280"/>
-            <a:ext cx="1526540" cy="1280160"/>
+            <a:off x="5074920" y="1051560"/>
+            <a:ext cx="1134001" cy="950976"/>
           </a:xfrm>
           <a:prstGeom prst="rect">
             <a:avLst/>
@@ -3391,7 +3391,7 @@
         </p:nvSpPr>
         <p:spPr>
           <a:xfrm>
-            <a:off x="384048" y="2651760"/>
+            <a:off x="384048" y="2157984"/>
             <a:ext cx="3657600" cy="182880"/>
           </a:xfrm>
           <a:prstGeom prst="rect">
@@ -3426,12 +3426,12 @@
         </p:nvSpPr>
         <p:spPr>
           <a:xfrm>
-            <a:off x="384048" y="2852928"/>
-            <a:ext cx="7004304" cy="1216152"/>
+            <a:off x="384048" y="2340864"/>
+            <a:ext cx="7004304" cy="987552"/>
           </a:xfrm>
           <a:prstGeom prst="roundRect">
             <a:avLst>
-              <a:gd name="adj" fmla="val 7518"/>
+              <a:gd name="adj" fmla="val 9259"/>
             </a:avLst>
           </a:prstGeom>
           <a:solidFill>
@@ -3472,7 +3472,7 @@
         </p:nvSpPr>
         <p:spPr>
           <a:xfrm>
-            <a:off x="548640" y="2990088"/>
+            <a:off x="548640" y="2414016"/>
             <a:ext cx="6675120" cy="274320"/>
           </a:xfrm>
           <a:prstGeom prst="rect">
@@ -3488,7 +3488,7 @@
           <a:p>
             <a:pPr algn="l"/>
             <a:r>
-              <a:rPr sz="1300" b="1">
+              <a:rPr sz="1250" b="1">
                 <a:solidFill>
                   <a:srgbClr val="18181B"/>
                 </a:solidFill>
@@ -3507,8 +3507,8 @@
         </p:nvSpPr>
         <p:spPr>
           <a:xfrm>
-            <a:off x="548640" y="3310128"/>
-            <a:ext cx="6675120" cy="685800"/>
+            <a:off x="548640" y="2688336"/>
+            <a:ext cx="6675120" cy="640080"/>
           </a:xfrm>
           <a:prstGeom prst="rect">
             <a:avLst/>
@@ -3523,11 +3523,11 @@
           <a:p>
             <a:pPr algn="l">
               <a:lnSpc>
-                <a:spcPct val="120000"/>
+                <a:spcPct val="115000"/>
               </a:lnSpc>
             </a:pPr>
             <a:r>
-              <a:rPr sz="1000" b="0">
+              <a:rPr sz="900" b="0">
                 <a:solidFill>
                   <a:srgbClr val="3F3F46"/>
                 </a:solidFill>
@@ -3536,7 +3536,7 @@
               <a:t>We build the model from physics up. Each constraint cuts the space of possible boats, and the optimizer finds the fastest one left. Hull resistance comes from </a:t>
             </a:r>
             <a:r>
-              <a:rPr sz="1000" b="1">
+              <a:rPr sz="900" b="1">
                 <a:solidFill>
                   <a:srgbClr val="3F3F46"/>
                 </a:solidFill>
@@ -3545,7 +3545,7 @@
               <a:t>Savitsky's planing-hull model</a:t>
             </a:r>
             <a:r>
-              <a:rPr sz="1000" b="0">
+              <a:rPr sz="900" b="0">
                 <a:solidFill>
                   <a:srgbClr val="3F3F46"/>
                 </a:solidFill>
@@ -3564,8 +3564,8 @@
         </p:nvSpPr>
         <p:spPr>
           <a:xfrm>
-            <a:off x="384048" y="4389120"/>
-            <a:ext cx="4572000" cy="182880"/>
+            <a:off x="384048" y="3474720"/>
+            <a:ext cx="4114800" cy="182880"/>
           </a:xfrm>
           <a:prstGeom prst="rect">
             <a:avLst/>
@@ -3599,8 +3599,8 @@
         </p:nvSpPr>
         <p:spPr>
           <a:xfrm>
-            <a:off x="384048" y="4572000"/>
-            <a:ext cx="7004304" cy="182880"/>
+            <a:off x="3566160" y="3474720"/>
+            <a:ext cx="3822191" cy="164592"/>
           </a:xfrm>
           <a:prstGeom prst="rect">
             <a:avLst/>
@@ -3613,15 +3613,15 @@
           </a:bodyPr>
           <a:lstStyle/>
           <a:p>
-            <a:pPr algn="l"/>
-            <a:r>
-              <a:rPr sz="900" b="0">
+            <a:pPr algn="r"/>
+            <a:r>
+              <a:rPr sz="750" b="0">
                 <a:solidFill>
                   <a:srgbClr val="3F3F46"/>
                 </a:solidFill>
                 <a:latin typeface="Arial"/>
               </a:rPr>
-              <a:t>Each segment of the boat is covered, and members have worked at Tesla, Northrop Grumman, Xcel Energy and Milwaukee Tool.</a:t>
+              <a:t>Experience at Tesla, Northrop Grumman, Xcel Energy and Milwaukee Tool</a:t>
             </a:r>
           </a:p>
         </p:txBody>
@@ -3634,12 +3634,12 @@
         </p:nvSpPr>
         <p:spPr>
           <a:xfrm>
-            <a:off x="384048" y="4828032"/>
-            <a:ext cx="1655064" cy="713232"/>
+            <a:off x="384048" y="3675887"/>
+            <a:ext cx="1655064" cy="640080"/>
           </a:xfrm>
           <a:prstGeom prst="roundRect">
             <a:avLst>
-              <a:gd name="adj" fmla="val 8974"/>
+              <a:gd name="adj" fmla="val 10000"/>
             </a:avLst>
           </a:prstGeom>
           <a:solidFill>
@@ -3680,7 +3680,7 @@
         </p:nvSpPr>
         <p:spPr>
           <a:xfrm>
-            <a:off x="484632" y="4892040"/>
+            <a:off x="484632" y="3730752"/>
             <a:ext cx="1472184" cy="182880"/>
           </a:xfrm>
           <a:prstGeom prst="rect">
@@ -3696,7 +3696,7 @@
           <a:p>
             <a:pPr algn="l"/>
             <a:r>
-              <a:rPr sz="1100" b="1">
+              <a:rPr sz="1050" b="1">
                 <a:solidFill>
                   <a:srgbClr val="C5050C"/>
                 </a:solidFill>
@@ -3715,8 +3715,8 @@
         </p:nvSpPr>
         <p:spPr>
           <a:xfrm>
-            <a:off x="484632" y="5102352"/>
-            <a:ext cx="1472184" cy="411480"/>
+            <a:off x="484632" y="3931920"/>
+            <a:ext cx="1472184" cy="365760"/>
           </a:xfrm>
           <a:prstGeom prst="rect">
             <a:avLst/>
@@ -3735,7 +3735,7 @@
               </a:lnSpc>
             </a:pPr>
             <a:r>
-              <a:rPr sz="900" b="0">
+              <a:rPr sz="850" b="0">
                 <a:solidFill>
                   <a:srgbClr val="3F3F46"/>
                 </a:solidFill>
@@ -3754,12 +3754,12 @@
         </p:nvSpPr>
         <p:spPr>
           <a:xfrm>
-            <a:off x="2157984" y="4828032"/>
-            <a:ext cx="1655064" cy="713232"/>
+            <a:off x="2157984" y="3675887"/>
+            <a:ext cx="1655064" cy="640080"/>
           </a:xfrm>
           <a:prstGeom prst="roundRect">
             <a:avLst>
-              <a:gd name="adj" fmla="val 8974"/>
+              <a:gd name="adj" fmla="val 10000"/>
             </a:avLst>
           </a:prstGeom>
           <a:solidFill>
@@ -3800,7 +3800,7 @@
         </p:nvSpPr>
         <p:spPr>
           <a:xfrm>
-            <a:off x="2258568" y="4892040"/>
+            <a:off x="2258568" y="3730752"/>
             <a:ext cx="1472184" cy="182880"/>
           </a:xfrm>
           <a:prstGeom prst="rect">
@@ -3816,7 +3816,7 @@
           <a:p>
             <a:pPr algn="l"/>
             <a:r>
-              <a:rPr sz="1100" b="1">
+              <a:rPr sz="1050" b="1">
                 <a:solidFill>
                   <a:srgbClr val="C5050C"/>
                 </a:solidFill>
@@ -3835,8 +3835,8 @@
         </p:nvSpPr>
         <p:spPr>
           <a:xfrm>
-            <a:off x="2258568" y="5102352"/>
-            <a:ext cx="1472184" cy="411480"/>
+            <a:off x="2258568" y="3931920"/>
+            <a:ext cx="1472184" cy="365760"/>
           </a:xfrm>
           <a:prstGeom prst="rect">
             <a:avLst/>
@@ -3855,7 +3855,7 @@
               </a:lnSpc>
             </a:pPr>
             <a:r>
-              <a:rPr sz="900" b="0">
+              <a:rPr sz="850" b="0">
                 <a:solidFill>
                   <a:srgbClr val="3F3F46"/>
                 </a:solidFill>
@@ -3874,12 +3874,12 @@
         </p:nvSpPr>
         <p:spPr>
           <a:xfrm>
-            <a:off x="3931920" y="4828032"/>
-            <a:ext cx="1655064" cy="713232"/>
+            <a:off x="3931920" y="3675887"/>
+            <a:ext cx="1655064" cy="640080"/>
           </a:xfrm>
           <a:prstGeom prst="roundRect">
             <a:avLst>
-              <a:gd name="adj" fmla="val 8974"/>
+              <a:gd name="adj" fmla="val 10000"/>
             </a:avLst>
           </a:prstGeom>
           <a:solidFill>
@@ -3920,7 +3920,7 @@
         </p:nvSpPr>
         <p:spPr>
           <a:xfrm>
-            <a:off x="4032504" y="4892040"/>
+            <a:off x="4032504" y="3730752"/>
             <a:ext cx="1472184" cy="182880"/>
           </a:xfrm>
           <a:prstGeom prst="rect">
@@ -3936,7 +3936,7 @@
           <a:p>
             <a:pPr algn="l"/>
             <a:r>
-              <a:rPr sz="1100" b="1">
+              <a:rPr sz="1050" b="1">
                 <a:solidFill>
                   <a:srgbClr val="C5050C"/>
                 </a:solidFill>
@@ -3955,8 +3955,8 @@
         </p:nvSpPr>
         <p:spPr>
           <a:xfrm>
-            <a:off x="4032504" y="5102352"/>
-            <a:ext cx="1472184" cy="411480"/>
+            <a:off x="4032504" y="3931920"/>
+            <a:ext cx="1472184" cy="365760"/>
           </a:xfrm>
           <a:prstGeom prst="rect">
             <a:avLst/>
@@ -3975,7 +3975,7 @@
               </a:lnSpc>
             </a:pPr>
             <a:r>
-              <a:rPr sz="900" b="0">
+              <a:rPr sz="850" b="0">
                 <a:solidFill>
                   <a:srgbClr val="3F3F46"/>
                 </a:solidFill>
@@ -3994,12 +3994,12 @@
         </p:nvSpPr>
         <p:spPr>
           <a:xfrm>
-            <a:off x="5705856" y="4828032"/>
-            <a:ext cx="1655064" cy="713232"/>
+            <a:off x="5705856" y="3675887"/>
+            <a:ext cx="1655064" cy="640080"/>
           </a:xfrm>
           <a:prstGeom prst="roundRect">
             <a:avLst>
-              <a:gd name="adj" fmla="val 8974"/>
+              <a:gd name="adj" fmla="val 10000"/>
             </a:avLst>
           </a:prstGeom>
           <a:solidFill>
@@ -4040,7 +4040,7 @@
         </p:nvSpPr>
         <p:spPr>
           <a:xfrm>
-            <a:off x="5806440" y="4892040"/>
+            <a:off x="5806440" y="3730752"/>
             <a:ext cx="1472184" cy="182880"/>
           </a:xfrm>
           <a:prstGeom prst="rect">
@@ -4056,7 +4056,7 @@
           <a:p>
             <a:pPr algn="l"/>
             <a:r>
-              <a:rPr sz="1100" b="1">
+              <a:rPr sz="1050" b="1">
                 <a:solidFill>
                   <a:srgbClr val="C5050C"/>
                 </a:solidFill>
@@ -4075,8 +4075,8 @@
         </p:nvSpPr>
         <p:spPr>
           <a:xfrm>
-            <a:off x="5806440" y="5102352"/>
-            <a:ext cx="1472184" cy="411480"/>
+            <a:off x="5806440" y="3931920"/>
+            <a:ext cx="1472184" cy="365760"/>
           </a:xfrm>
           <a:prstGeom prst="rect">
             <a:avLst/>
@@ -4095,7 +4095,7 @@
               </a:lnSpc>
             </a:pPr>
             <a:r>
-              <a:rPr sz="900" b="0">
+              <a:rPr sz="850" b="0">
                 <a:solidFill>
                   <a:srgbClr val="3F3F46"/>
                 </a:solidFill>
@@ -4114,7 +4114,7 @@
         </p:nvSpPr>
         <p:spPr>
           <a:xfrm>
-            <a:off x="384048" y="5852160"/>
+            <a:off x="384048" y="4480560"/>
             <a:ext cx="3657600" cy="182880"/>
           </a:xfrm>
           <a:prstGeom prst="rect">
@@ -4149,12 +4149,12 @@
         </p:nvSpPr>
         <p:spPr>
           <a:xfrm>
-            <a:off x="384048" y="6062472"/>
-            <a:ext cx="2240280" cy="1600200"/>
+            <a:off x="384048" y="4681728"/>
+            <a:ext cx="2240280" cy="1389888"/>
           </a:xfrm>
           <a:prstGeom prst="roundRect">
             <a:avLst>
-              <a:gd name="adj" fmla="val 5714"/>
+              <a:gd name="adj" fmla="val 6578"/>
             </a:avLst>
           </a:prstGeom>
           <a:solidFill>
@@ -4197,7 +4197,7 @@
         </p:nvSpPr>
         <p:spPr>
           <a:xfrm>
-            <a:off x="521207" y="6172200"/>
+            <a:off x="521207" y="4736592"/>
             <a:ext cx="1965960" cy="274320"/>
           </a:xfrm>
           <a:prstGeom prst="rect">
@@ -4213,7 +4213,7 @@
           <a:p>
             <a:pPr algn="l"/>
             <a:r>
-              <a:rPr sz="1500" b="1">
+              <a:rPr sz="1400" b="1">
                 <a:solidFill>
                   <a:srgbClr val="18181B"/>
                 </a:solidFill>
@@ -4232,7 +4232,7 @@
         </p:nvSpPr>
         <p:spPr>
           <a:xfrm>
-            <a:off x="521207" y="6510528"/>
+            <a:off x="521207" y="5029200"/>
             <a:ext cx="1965960" cy="228600"/>
           </a:xfrm>
           <a:prstGeom prst="rect">
@@ -4248,7 +4248,7 @@
           <a:p>
             <a:pPr algn="l"/>
             <a:r>
-              <a:rPr sz="1050" b="1">
+              <a:rPr sz="1000" b="1">
                 <a:solidFill>
                   <a:srgbClr val="18181B"/>
                 </a:solidFill>
@@ -4267,7 +4267,7 @@
         </p:nvSpPr>
         <p:spPr>
           <a:xfrm>
-            <a:off x="521207" y="6821424"/>
+            <a:off x="521207" y="5285232"/>
             <a:ext cx="1965960" cy="9144"/>
           </a:xfrm>
           <a:prstGeom prst="rect">
@@ -4311,8 +4311,8 @@
         </p:nvSpPr>
         <p:spPr>
           <a:xfrm>
-            <a:off x="521207" y="6931152"/>
-            <a:ext cx="1965960" cy="822960"/>
+            <a:off x="521207" y="5358384"/>
+            <a:ext cx="1965960" cy="685800"/>
           </a:xfrm>
           <a:prstGeom prst="rect">
             <a:avLst/>
@@ -4327,7 +4327,7 @@
           <a:p>
             <a:pPr algn="l">
               <a:lnSpc>
-                <a:spcPct val="155000"/>
+                <a:spcPct val="150000"/>
               </a:lnSpc>
             </a:pPr>
             <a:r>
@@ -4340,7 +4340,7 @@
               <a:t>●  </a:t>
             </a:r>
             <a:r>
-              <a:rPr sz="900" b="0">
+              <a:rPr sz="850" b="0">
                 <a:solidFill>
                   <a:srgbClr val="3F3F46"/>
                 </a:solidFill>
@@ -4352,7 +4352,7 @@
           <a:p>
             <a:pPr algn="l">
               <a:lnSpc>
-                <a:spcPct val="155000"/>
+                <a:spcPct val="150000"/>
               </a:lnSpc>
             </a:pPr>
             <a:r>
@@ -4365,7 +4365,7 @@
               <a:t>●  </a:t>
             </a:r>
             <a:r>
-              <a:rPr sz="900" b="0">
+              <a:rPr sz="850" b="0">
                 <a:solidFill>
                   <a:srgbClr val="3F3F46"/>
                 </a:solidFill>
@@ -4377,7 +4377,7 @@
           <a:p>
             <a:pPr algn="l">
               <a:lnSpc>
-                <a:spcPct val="155000"/>
+                <a:spcPct val="150000"/>
               </a:lnSpc>
             </a:pPr>
             <a:r>
@@ -4390,7 +4390,7 @@
               <a:t>●  </a:t>
             </a:r>
             <a:r>
-              <a:rPr sz="900" b="0">
+              <a:rPr sz="850" b="0">
                 <a:solidFill>
                   <a:srgbClr val="3F3F46"/>
                 </a:solidFill>
@@ -4409,12 +4409,12 @@
         </p:nvSpPr>
         <p:spPr>
           <a:xfrm>
-            <a:off x="2743200" y="6062472"/>
-            <a:ext cx="2240280" cy="1600200"/>
+            <a:off x="2743200" y="4681728"/>
+            <a:ext cx="2240280" cy="1389888"/>
           </a:xfrm>
           <a:prstGeom prst="roundRect">
             <a:avLst>
-              <a:gd name="adj" fmla="val 5714"/>
+              <a:gd name="adj" fmla="val 6578"/>
             </a:avLst>
           </a:prstGeom>
           <a:solidFill>
@@ -4457,7 +4457,7 @@
         </p:nvSpPr>
         <p:spPr>
           <a:xfrm>
-            <a:off x="2880360" y="6172200"/>
+            <a:off x="2880360" y="4736592"/>
             <a:ext cx="1965960" cy="274320"/>
           </a:xfrm>
           <a:prstGeom prst="rect">
@@ -4473,7 +4473,7 @@
           <a:p>
             <a:pPr algn="l"/>
             <a:r>
-              <a:rPr sz="1500" b="1">
+              <a:rPr sz="1400" b="1">
                 <a:solidFill>
                   <a:srgbClr val="18181B"/>
                 </a:solidFill>
@@ -4492,7 +4492,7 @@
         </p:nvSpPr>
         <p:spPr>
           <a:xfrm>
-            <a:off x="2880360" y="6510528"/>
+            <a:off x="2880360" y="5029200"/>
             <a:ext cx="1965960" cy="228600"/>
           </a:xfrm>
           <a:prstGeom prst="rect">
@@ -4508,7 +4508,7 @@
           <a:p>
             <a:pPr algn="l"/>
             <a:r>
-              <a:rPr sz="1050" b="1">
+              <a:rPr sz="1000" b="1">
                 <a:solidFill>
                   <a:srgbClr val="18181B"/>
                 </a:solidFill>
@@ -4527,7 +4527,7 @@
         </p:nvSpPr>
         <p:spPr>
           <a:xfrm>
-            <a:off x="2880360" y="6821424"/>
+            <a:off x="2880360" y="5285232"/>
             <a:ext cx="1965960" cy="9144"/>
           </a:xfrm>
           <a:prstGeom prst="rect">
@@ -4571,8 +4571,8 @@
         </p:nvSpPr>
         <p:spPr>
           <a:xfrm>
-            <a:off x="2880360" y="6931152"/>
-            <a:ext cx="1965960" cy="822960"/>
+            <a:off x="2880360" y="5358384"/>
+            <a:ext cx="1965960" cy="685800"/>
           </a:xfrm>
           <a:prstGeom prst="rect">
             <a:avLst/>
@@ -4587,7 +4587,7 @@
           <a:p>
             <a:pPr algn="l">
               <a:lnSpc>
-                <a:spcPct val="155000"/>
+                <a:spcPct val="150000"/>
               </a:lnSpc>
             </a:pPr>
             <a:r>
@@ -4600,7 +4600,7 @@
               <a:t>●  </a:t>
             </a:r>
             <a:r>
-              <a:rPr sz="900" b="0">
+              <a:rPr sz="850" b="0">
                 <a:solidFill>
                   <a:srgbClr val="3F3F46"/>
                 </a:solidFill>
@@ -4612,7 +4612,7 @@
           <a:p>
             <a:pPr algn="l">
               <a:lnSpc>
-                <a:spcPct val="155000"/>
+                <a:spcPct val="150000"/>
               </a:lnSpc>
             </a:pPr>
             <a:r>
@@ -4625,7 +4625,7 @@
               <a:t>●  </a:t>
             </a:r>
             <a:r>
-              <a:rPr sz="900" b="0">
+              <a:rPr sz="850" b="0">
                 <a:solidFill>
                   <a:srgbClr val="3F3F46"/>
                 </a:solidFill>
@@ -4637,7 +4637,7 @@
           <a:p>
             <a:pPr algn="l">
               <a:lnSpc>
-                <a:spcPct val="155000"/>
+                <a:spcPct val="150000"/>
               </a:lnSpc>
             </a:pPr>
             <a:r>
@@ -4650,7 +4650,7 @@
               <a:t>●  </a:t>
             </a:r>
             <a:r>
-              <a:rPr sz="900" b="0">
+              <a:rPr sz="850" b="0">
                 <a:solidFill>
                   <a:srgbClr val="3F3F46"/>
                 </a:solidFill>
@@ -4669,12 +4669,12 @@
         </p:nvSpPr>
         <p:spPr>
           <a:xfrm>
-            <a:off x="5102352" y="6062472"/>
-            <a:ext cx="2240280" cy="1600200"/>
+            <a:off x="5102352" y="4681728"/>
+            <a:ext cx="2240280" cy="1389888"/>
           </a:xfrm>
           <a:prstGeom prst="roundRect">
             <a:avLst>
-              <a:gd name="adj" fmla="val 5714"/>
+              <a:gd name="adj" fmla="val 6578"/>
             </a:avLst>
           </a:prstGeom>
           <a:solidFill>
@@ -4717,7 +4717,7 @@
         </p:nvSpPr>
         <p:spPr>
           <a:xfrm>
-            <a:off x="5239512" y="6172200"/>
+            <a:off x="5239512" y="4736592"/>
             <a:ext cx="1965960" cy="274320"/>
           </a:xfrm>
           <a:prstGeom prst="rect">
@@ -4733,7 +4733,7 @@
           <a:p>
             <a:pPr algn="l"/>
             <a:r>
-              <a:rPr sz="1500" b="1">
+              <a:rPr sz="1400" b="1">
                 <a:solidFill>
                   <a:srgbClr val="18181B"/>
                 </a:solidFill>
@@ -4752,7 +4752,7 @@
         </p:nvSpPr>
         <p:spPr>
           <a:xfrm>
-            <a:off x="5239512" y="6510528"/>
+            <a:off x="5239512" y="5029200"/>
             <a:ext cx="1965960" cy="228600"/>
           </a:xfrm>
           <a:prstGeom prst="rect">
@@ -4768,7 +4768,7 @@
           <a:p>
             <a:pPr algn="l"/>
             <a:r>
-              <a:rPr sz="1050" b="1">
+              <a:rPr sz="1000" b="1">
                 <a:solidFill>
                   <a:srgbClr val="18181B"/>
                 </a:solidFill>
@@ -4787,7 +4787,7 @@
         </p:nvSpPr>
         <p:spPr>
           <a:xfrm>
-            <a:off x="5239512" y="6821424"/>
+            <a:off x="5239512" y="5285232"/>
             <a:ext cx="1965960" cy="9144"/>
           </a:xfrm>
           <a:prstGeom prst="rect">
@@ -4831,8 +4831,8 @@
         </p:nvSpPr>
         <p:spPr>
           <a:xfrm>
-            <a:off x="5239512" y="6931152"/>
-            <a:ext cx="1965960" cy="822960"/>
+            <a:off x="5239512" y="5358384"/>
+            <a:ext cx="1965960" cy="685800"/>
           </a:xfrm>
           <a:prstGeom prst="rect">
             <a:avLst/>
@@ -4847,7 +4847,7 @@
           <a:p>
             <a:pPr algn="l">
               <a:lnSpc>
-                <a:spcPct val="155000"/>
+                <a:spcPct val="150000"/>
               </a:lnSpc>
             </a:pPr>
             <a:r>
@@ -4860,7 +4860,7 @@
               <a:t>●  </a:t>
             </a:r>
             <a:r>
-              <a:rPr sz="900" b="0">
+              <a:rPr sz="850" b="0">
                 <a:solidFill>
                   <a:srgbClr val="3F3F46"/>
                 </a:solidFill>
@@ -4872,7 +4872,7 @@
           <a:p>
             <a:pPr algn="l">
               <a:lnSpc>
-                <a:spcPct val="155000"/>
+                <a:spcPct val="150000"/>
               </a:lnSpc>
             </a:pPr>
             <a:r>
@@ -4885,7 +4885,7 @@
               <a:t>●  </a:t>
             </a:r>
             <a:r>
-              <a:rPr sz="900" b="0">
+              <a:rPr sz="850" b="0">
                 <a:solidFill>
                   <a:srgbClr val="3F3F46"/>
                 </a:solidFill>
@@ -4897,7 +4897,7 @@
           <a:p>
             <a:pPr algn="l">
               <a:lnSpc>
-                <a:spcPct val="155000"/>
+                <a:spcPct val="150000"/>
               </a:lnSpc>
             </a:pPr>
             <a:r>
@@ -4910,7 +4910,7 @@
               <a:t>●  </a:t>
             </a:r>
             <a:r>
-              <a:rPr sz="900" b="0">
+              <a:rPr sz="850" b="0">
                 <a:solidFill>
                   <a:srgbClr val="3F3F46"/>
                 </a:solidFill>
@@ -4929,7 +4929,7 @@
         </p:nvSpPr>
         <p:spPr>
           <a:xfrm>
-            <a:off x="384048" y="7790688"/>
+            <a:off x="384048" y="6254496"/>
             <a:ext cx="3657600" cy="182880"/>
           </a:xfrm>
           <a:prstGeom prst="rect">
@@ -4964,7 +4964,7 @@
         </p:nvSpPr>
         <p:spPr>
           <a:xfrm>
-            <a:off x="384048" y="8010144"/>
+            <a:off x="384048" y="6455664"/>
             <a:ext cx="3364992" cy="9144"/>
           </a:xfrm>
           <a:prstGeom prst="rect">
@@ -5008,8 +5008,8 @@
         </p:nvSpPr>
         <p:spPr>
           <a:xfrm>
-            <a:off x="384048" y="8051292"/>
-            <a:ext cx="1051560" cy="146304"/>
+            <a:off x="384048" y="6501383"/>
+            <a:ext cx="868680" cy="146304"/>
           </a:xfrm>
           <a:prstGeom prst="rect">
             <a:avLst/>
@@ -5037,14 +5037,14 @@
       </p:sp>
       <p:sp>
         <p:nvSpPr>
-          <p:cNvPr id="47" name="Timeline label: Current hull design frozen"/>
+          <p:cNvPr id="47" name="Timeline: Current hull design frozen"/>
           <p:cNvSpPr txBox="1"/>
           <p:nvPr/>
         </p:nvSpPr>
         <p:spPr>
           <a:xfrm>
-            <a:off x="1481328" y="8051292"/>
-            <a:ext cx="2267712" cy="146304"/>
+            <a:off x="1298448" y="6501383"/>
+            <a:ext cx="2450592" cy="182880"/>
           </a:xfrm>
           <a:prstGeom prst="rect">
             <a:avLst/>
@@ -5057,11 +5057,15 @@
           </a:bodyPr>
           <a:lstStyle/>
           <a:p>
-            <a:pPr algn="l"/>
-            <a:r>
-              <a:rPr sz="800" b="0">
-                <a:solidFill>
-                  <a:srgbClr val="3F3F46"/>
+            <a:pPr algn="l">
+              <a:lnSpc>
+                <a:spcPct val="100000"/>
+              </a:lnSpc>
+            </a:pPr>
+            <a:r>
+              <a:rPr sz="850" b="1">
+                <a:solidFill>
+                  <a:srgbClr val="18181B"/>
                 </a:solidFill>
                 <a:latin typeface="Arial"/>
               </a:rPr>
@@ -5078,7 +5082,7 @@
         </p:nvSpPr>
         <p:spPr>
           <a:xfrm>
-            <a:off x="384048" y="8211312"/>
+            <a:off x="384048" y="6684264"/>
             <a:ext cx="3364992" cy="9144"/>
           </a:xfrm>
           <a:prstGeom prst="rect">
@@ -5122,8 +5126,8 @@
         </p:nvSpPr>
         <p:spPr>
           <a:xfrm>
-            <a:off x="384048" y="8252460"/>
-            <a:ext cx="1051560" cy="146304"/>
+            <a:off x="384048" y="6729983"/>
+            <a:ext cx="868680" cy="146304"/>
           </a:xfrm>
           <a:prstGeom prst="rect">
             <a:avLst/>
@@ -5151,14 +5155,14 @@
       </p:sp>
       <p:sp>
         <p:nvSpPr>
-          <p:cNvPr id="50" name="Timeline label: Preliminary design review"/>
+          <p:cNvPr id="50" name="Timeline: Preliminary design review"/>
           <p:cNvSpPr txBox="1"/>
           <p:nvPr/>
         </p:nvSpPr>
         <p:spPr>
           <a:xfrm>
-            <a:off x="1481328" y="8252460"/>
-            <a:ext cx="2267712" cy="146304"/>
+            <a:off x="1298448" y="6729983"/>
+            <a:ext cx="2450592" cy="740664"/>
           </a:xfrm>
           <a:prstGeom prst="rect">
             <a:avLst/>
@@ -5171,15 +5175,35 @@
           </a:bodyPr>
           <a:lstStyle/>
           <a:p>
-            <a:pPr algn="l"/>
-            <a:r>
-              <a:rPr sz="800" b="0">
+            <a:pPr algn="l">
+              <a:lnSpc>
+                <a:spcPct val="100000"/>
+              </a:lnSpc>
+            </a:pPr>
+            <a:r>
+              <a:rPr sz="850" b="1">
+                <a:solidFill>
+                  <a:srgbClr val="18181B"/>
+                </a:solidFill>
+                <a:latin typeface="Arial"/>
+              </a:rPr>
+              <a:t>Preliminary design review</a:t>
+            </a:r>
+          </a:p>
+          <a:p>
+            <a:pPr algn="l">
+              <a:lnSpc>
+                <a:spcPct val="100000"/>
+              </a:lnSpc>
+            </a:pPr>
+            <a:r>
+              <a:rPr sz="750" b="0">
                 <a:solidFill>
                   <a:srgbClr val="3F3F46"/>
                 </a:solidFill>
                 <a:latin typeface="Arial"/>
               </a:rPr>
-              <a:t>Preliminary design review</a:t>
+              <a:t>Full CAD and circuit design, plus a rough proof of concept, even a cardboard boat with boxes for the components, to visually check dimensions and catch issues. Critical and long-lead components are ordered.</a:t>
             </a:r>
           </a:p>
         </p:txBody>
@@ -5192,7 +5216,7 @@
         </p:nvSpPr>
         <p:spPr>
           <a:xfrm>
-            <a:off x="384048" y="8412480"/>
+            <a:off x="384048" y="7470648"/>
             <a:ext cx="3364992" cy="9144"/>
           </a:xfrm>
           <a:prstGeom prst="rect">
@@ -5236,8 +5260,8 @@
         </p:nvSpPr>
         <p:spPr>
           <a:xfrm>
-            <a:off x="384048" y="8453628"/>
-            <a:ext cx="1051560" cy="146304"/>
+            <a:off x="384048" y="7516368"/>
+            <a:ext cx="868680" cy="146304"/>
           </a:xfrm>
           <a:prstGeom prst="rect">
             <a:avLst/>
@@ -5265,14 +5289,14 @@
       </p:sp>
       <p:sp>
         <p:nvSpPr>
-          <p:cNvPr id="53" name="Timeline label: Mechanical and electrical design frozen"/>
+          <p:cNvPr id="53" name="Timeline: Mechanical and electrical design frozen"/>
           <p:cNvSpPr txBox="1"/>
           <p:nvPr/>
         </p:nvSpPr>
         <p:spPr>
           <a:xfrm>
-            <a:off x="1481328" y="8453628"/>
-            <a:ext cx="2267712" cy="146304"/>
+            <a:off x="1298448" y="7516368"/>
+            <a:ext cx="2450592" cy="294436"/>
           </a:xfrm>
           <a:prstGeom prst="rect">
             <a:avLst/>
@@ -5285,15 +5309,35 @@
           </a:bodyPr>
           <a:lstStyle/>
           <a:p>
-            <a:pPr algn="l"/>
-            <a:r>
-              <a:rPr sz="800" b="0">
+            <a:pPr algn="l">
+              <a:lnSpc>
+                <a:spcPct val="100000"/>
+              </a:lnSpc>
+            </a:pPr>
+            <a:r>
+              <a:rPr sz="850" b="1">
+                <a:solidFill>
+                  <a:srgbClr val="18181B"/>
+                </a:solidFill>
+                <a:latin typeface="Arial"/>
+              </a:rPr>
+              <a:t>Mechanical and electrical design frozen</a:t>
+            </a:r>
+          </a:p>
+          <a:p>
+            <a:pPr algn="l">
+              <a:lnSpc>
+                <a:spcPct val="100000"/>
+              </a:lnSpc>
+            </a:pPr>
+            <a:r>
+              <a:rPr sz="750" b="0">
                 <a:solidFill>
                   <a:srgbClr val="3F3F46"/>
                 </a:solidFill>
                 <a:latin typeface="Arial"/>
               </a:rPr>
-              <a:t>Mechanical and electrical design frozen</a:t>
+              <a:t>With the full BOM and the order.</a:t>
             </a:r>
           </a:p>
         </p:txBody>
@@ -5306,7 +5350,7 @@
         </p:nvSpPr>
         <p:spPr>
           <a:xfrm>
-            <a:off x="384048" y="8613648"/>
+            <a:off x="384048" y="7810804"/>
             <a:ext cx="3364992" cy="9144"/>
           </a:xfrm>
           <a:prstGeom prst="rect">
@@ -5350,8 +5394,8 @@
         </p:nvSpPr>
         <p:spPr>
           <a:xfrm>
-            <a:off x="384048" y="8654796"/>
-            <a:ext cx="1051560" cy="146304"/>
+            <a:off x="384048" y="7856524"/>
+            <a:ext cx="868680" cy="146304"/>
           </a:xfrm>
           <a:prstGeom prst="rect">
             <a:avLst/>
@@ -5379,14 +5423,14 @@
       </p:sp>
       <p:sp>
         <p:nvSpPr>
-          <p:cNvPr id="56" name="Timeline label: Build the hull and composite parts"/>
+          <p:cNvPr id="56" name="Timeline: Build the hull and composite parts"/>
           <p:cNvSpPr txBox="1"/>
           <p:nvPr/>
         </p:nvSpPr>
         <p:spPr>
           <a:xfrm>
-            <a:off x="1481328" y="8654796"/>
-            <a:ext cx="2267712" cy="146304"/>
+            <a:off x="1298448" y="7856524"/>
+            <a:ext cx="2450592" cy="294436"/>
           </a:xfrm>
           <a:prstGeom prst="rect">
             <a:avLst/>
@@ -5399,15 +5443,35 @@
           </a:bodyPr>
           <a:lstStyle/>
           <a:p>
-            <a:pPr algn="l"/>
-            <a:r>
-              <a:rPr sz="800" b="0">
+            <a:pPr algn="l">
+              <a:lnSpc>
+                <a:spcPct val="100000"/>
+              </a:lnSpc>
+            </a:pPr>
+            <a:r>
+              <a:rPr sz="850" b="1">
+                <a:solidFill>
+                  <a:srgbClr val="18181B"/>
+                </a:solidFill>
+                <a:latin typeface="Arial"/>
+              </a:rPr>
+              <a:t>Build the hull and composite parts</a:t>
+            </a:r>
+          </a:p>
+          <a:p>
+            <a:pPr algn="l">
+              <a:lnSpc>
+                <a:spcPct val="100000"/>
+              </a:lnSpc>
+            </a:pPr>
+            <a:r>
+              <a:rPr sz="750" b="0">
                 <a:solidFill>
                   <a:srgbClr val="3F3F46"/>
                 </a:solidFill>
                 <a:latin typeface="Arial"/>
               </a:rPr>
-              <a:t>Build the hull and composite parts</a:t>
+              <a:t>Plus any custom-milled parts.</a:t>
             </a:r>
           </a:p>
         </p:txBody>
@@ -5420,7 +5484,7 @@
         </p:nvSpPr>
         <p:spPr>
           <a:xfrm>
-            <a:off x="384048" y="8814816"/>
+            <a:off x="384048" y="8150961"/>
             <a:ext cx="3364992" cy="9144"/>
           </a:xfrm>
           <a:prstGeom prst="rect">
@@ -5464,8 +5528,8 @@
         </p:nvSpPr>
         <p:spPr>
           <a:xfrm>
-            <a:off x="384048" y="8855964"/>
-            <a:ext cx="1051560" cy="146304"/>
+            <a:off x="384048" y="8196681"/>
+            <a:ext cx="868680" cy="146304"/>
           </a:xfrm>
           <a:prstGeom prst="rect">
             <a:avLst/>
@@ -5493,14 +5557,14 @@
       </p:sp>
       <p:sp>
         <p:nvSpPr>
-          <p:cNvPr id="59" name="Timeline label: Manufacture and assemble everything"/>
+          <p:cNvPr id="59" name="Timeline: Manufacture and assemble everything"/>
           <p:cNvSpPr txBox="1"/>
           <p:nvPr/>
         </p:nvSpPr>
         <p:spPr>
           <a:xfrm>
-            <a:off x="1481328" y="8855964"/>
-            <a:ext cx="2267712" cy="146304"/>
+            <a:off x="1298448" y="8196681"/>
+            <a:ext cx="2450592" cy="517550"/>
           </a:xfrm>
           <a:prstGeom prst="rect">
             <a:avLst/>
@@ -5513,15 +5577,35 @@
           </a:bodyPr>
           <a:lstStyle/>
           <a:p>
-            <a:pPr algn="l"/>
-            <a:r>
-              <a:rPr sz="800" b="0">
+            <a:pPr algn="l">
+              <a:lnSpc>
+                <a:spcPct val="100000"/>
+              </a:lnSpc>
+            </a:pPr>
+            <a:r>
+              <a:rPr sz="850" b="1">
+                <a:solidFill>
+                  <a:srgbClr val="18181B"/>
+                </a:solidFill>
+                <a:latin typeface="Arial"/>
+              </a:rPr>
+              <a:t>Manufacture and assemble everything</a:t>
+            </a:r>
+          </a:p>
+          <a:p>
+            <a:pPr algn="l">
+              <a:lnSpc>
+                <a:spcPct val="100000"/>
+              </a:lnSpc>
+            </a:pPr>
+            <a:r>
+              <a:rPr sz="750" b="0">
                 <a:solidFill>
                   <a:srgbClr val="3F3F46"/>
                 </a:solidFill>
                 <a:latin typeface="Arial"/>
               </a:rPr>
-              <a:t>Manufacture and assemble everything</a:t>
+              <a:t>All mechanical and electrical components, with dry fits, electrical assembly out of the boat first, and debugging.</a:t>
             </a:r>
           </a:p>
         </p:txBody>
@@ -5534,7 +5618,7 @@
         </p:nvSpPr>
         <p:spPr>
           <a:xfrm>
-            <a:off x="384048" y="9015984"/>
+            <a:off x="384048" y="8714232"/>
             <a:ext cx="3364992" cy="9144"/>
           </a:xfrm>
           <a:prstGeom prst="rect">
@@ -5578,8 +5662,8 @@
         </p:nvSpPr>
         <p:spPr>
           <a:xfrm>
-            <a:off x="384048" y="9057132"/>
-            <a:ext cx="1051560" cy="146304"/>
+            <a:off x="384048" y="8759952"/>
+            <a:ext cx="868680" cy="146304"/>
           </a:xfrm>
           <a:prstGeom prst="rect">
             <a:avLst/>
@@ -5607,14 +5691,14 @@
       </p:sp>
       <p:sp>
         <p:nvSpPr>
-          <p:cNvPr id="62" name="Timeline label: Build likely spare parts, in parallel"/>
+          <p:cNvPr id="62" name="Timeline: Build likely spare parts, in parallel"/>
           <p:cNvSpPr txBox="1"/>
           <p:nvPr/>
         </p:nvSpPr>
         <p:spPr>
           <a:xfrm>
-            <a:off x="1481328" y="9057132"/>
-            <a:ext cx="2267712" cy="146304"/>
+            <a:off x="1298448" y="8759952"/>
+            <a:ext cx="2450592" cy="294436"/>
           </a:xfrm>
           <a:prstGeom prst="rect">
             <a:avLst/>
@@ -5627,15 +5711,35 @@
           </a:bodyPr>
           <a:lstStyle/>
           <a:p>
-            <a:pPr algn="l"/>
-            <a:r>
-              <a:rPr sz="800" b="0">
+            <a:pPr algn="l">
+              <a:lnSpc>
+                <a:spcPct val="100000"/>
+              </a:lnSpc>
+            </a:pPr>
+            <a:r>
+              <a:rPr sz="850" b="1">
+                <a:solidFill>
+                  <a:srgbClr val="18181B"/>
+                </a:solidFill>
+                <a:latin typeface="Arial"/>
+              </a:rPr>
+              <a:t>Build likely spare parts, in parallel</a:t>
+            </a:r>
+          </a:p>
+          <a:p>
+            <a:pPr algn="l">
+              <a:lnSpc>
+                <a:spcPct val="100000"/>
+              </a:lnSpc>
+            </a:pPr>
+            <a:r>
+              <a:rPr sz="750" b="0">
                 <a:solidFill>
                   <a:srgbClr val="3F3F46"/>
                 </a:solidFill>
                 <a:latin typeface="Arial"/>
               </a:rPr>
-              <a:t>Build likely spare parts, in parallel</a:t>
+              <a:t>Spares for the parts most likely to be used.</a:t>
             </a:r>
           </a:p>
         </p:txBody>
@@ -5648,7 +5752,7 @@
         </p:nvSpPr>
         <p:spPr>
           <a:xfrm>
-            <a:off x="4023360" y="8010144"/>
+            <a:off x="4023360" y="6455664"/>
             <a:ext cx="3364992" cy="9144"/>
           </a:xfrm>
           <a:prstGeom prst="rect">
@@ -5692,8 +5796,8 @@
         </p:nvSpPr>
         <p:spPr>
           <a:xfrm>
-            <a:off x="4023360" y="8051292"/>
-            <a:ext cx="1051560" cy="146304"/>
+            <a:off x="4023360" y="6501383"/>
+            <a:ext cx="868680" cy="146304"/>
           </a:xfrm>
           <a:prstGeom prst="rect">
             <a:avLst/>
@@ -5721,14 +5825,14 @@
       </p:sp>
       <p:sp>
         <p:nvSpPr>
-          <p:cNvPr id="65" name="Timeline label: First float and tow test"/>
+          <p:cNvPr id="65" name="Timeline: First float and tow test"/>
           <p:cNvSpPr txBox="1"/>
           <p:nvPr/>
         </p:nvSpPr>
         <p:spPr>
           <a:xfrm>
-            <a:off x="5120640" y="8051292"/>
-            <a:ext cx="2267712" cy="146304"/>
+            <a:off x="4937760" y="6501383"/>
+            <a:ext cx="2450592" cy="517550"/>
           </a:xfrm>
           <a:prstGeom prst="rect">
             <a:avLst/>
@@ -5741,15 +5845,35 @@
           </a:bodyPr>
           <a:lstStyle/>
           <a:p>
-            <a:pPr algn="l"/>
-            <a:r>
-              <a:rPr sz="800" b="0">
+            <a:pPr algn="l">
+              <a:lnSpc>
+                <a:spcPct val="100000"/>
+              </a:lnSpc>
+            </a:pPr>
+            <a:r>
+              <a:rPr sz="850" b="1">
+                <a:solidFill>
+                  <a:srgbClr val="18181B"/>
+                </a:solidFill>
+                <a:latin typeface="Arial"/>
+              </a:rPr>
+              <a:t>First float and tow test</a:t>
+            </a:r>
+          </a:p>
+          <a:p>
+            <a:pPr algn="l">
+              <a:lnSpc>
+                <a:spcPct val="100000"/>
+              </a:lnSpc>
+            </a:pPr>
+            <a:r>
+              <a:rPr sz="750" b="0">
                 <a:solidFill>
                   <a:srgbClr val="3F3F46"/>
                 </a:solidFill>
                 <a:latin typeface="Arial"/>
               </a:rPr>
-              <a:t>First float and tow test</a:t>
+              <a:t>The hull floats with deadweight for the real weight, and is towed behind a motorized boat to validate the hull design and quality.</a:t>
             </a:r>
           </a:p>
         </p:txBody>
@@ -5762,7 +5886,7 @@
         </p:nvSpPr>
         <p:spPr>
           <a:xfrm>
-            <a:off x="4023360" y="8211312"/>
+            <a:off x="4023360" y="7018934"/>
             <a:ext cx="3364992" cy="9144"/>
           </a:xfrm>
           <a:prstGeom prst="rect">
@@ -5806,8 +5930,8 @@
         </p:nvSpPr>
         <p:spPr>
           <a:xfrm>
-            <a:off x="4023360" y="8252460"/>
-            <a:ext cx="1051560" cy="146304"/>
+            <a:off x="4023360" y="7064654"/>
+            <a:ext cx="868680" cy="146304"/>
           </a:xfrm>
           <a:prstGeom prst="rect">
             <a:avLst/>
@@ -5835,14 +5959,14 @@
       </p:sp>
       <p:sp>
         <p:nvSpPr>
-          <p:cNvPr id="68" name="Timeline label: Zeroth nautical mile"/>
+          <p:cNvPr id="68" name="Timeline: Zeroth nautical mile"/>
           <p:cNvSpPr txBox="1"/>
           <p:nvPr/>
         </p:nvSpPr>
         <p:spPr>
           <a:xfrm>
-            <a:off x="5120640" y="8252460"/>
-            <a:ext cx="2267712" cy="146304"/>
+            <a:off x="4937760" y="7064654"/>
+            <a:ext cx="2450592" cy="852220"/>
           </a:xfrm>
           <a:prstGeom prst="rect">
             <a:avLst/>
@@ -5855,15 +5979,35 @@
           </a:bodyPr>
           <a:lstStyle/>
           <a:p>
-            <a:pPr algn="l"/>
-            <a:r>
-              <a:rPr sz="800" b="0">
+            <a:pPr algn="l">
+              <a:lnSpc>
+                <a:spcPct val="100000"/>
+              </a:lnSpc>
+            </a:pPr>
+            <a:r>
+              <a:rPr sz="850" b="1">
+                <a:solidFill>
+                  <a:srgbClr val="18181B"/>
+                </a:solidFill>
+                <a:latin typeface="Arial"/>
+              </a:rPr>
+              <a:t>Zeroth nautical mile</a:t>
+            </a:r>
+          </a:p>
+          <a:p>
+            <a:pPr algn="l">
+              <a:lnSpc>
+                <a:spcPct val="100000"/>
+              </a:lnSpc>
+            </a:pPr>
+            <a:r>
+              <a:rPr sz="750" b="0">
                 <a:solidFill>
                   <a:srgbClr val="3F3F46"/>
                 </a:solidFill>
                 <a:latin typeface="Arial"/>
               </a:rPr>
-              <a:t>Zeroth nautical mile</a:t>
+              <a:t>The first time everything is powered on in the hull: all microcontrollers, sensors and actuators. The first motor and propeller spin with the boat lifted in the air, and the first propulsion and navigation test commanded by the autonomous pipeline.</a:t>
             </a:r>
           </a:p>
         </p:txBody>
@@ -5876,7 +6020,7 @@
         </p:nvSpPr>
         <p:spPr>
           <a:xfrm>
-            <a:off x="4023360" y="8412480"/>
+            <a:off x="4023360" y="7916875"/>
             <a:ext cx="3364992" cy="9144"/>
           </a:xfrm>
           <a:prstGeom prst="rect">
@@ -5920,8 +6064,8 @@
         </p:nvSpPr>
         <p:spPr>
           <a:xfrm>
-            <a:off x="4023360" y="8453628"/>
-            <a:ext cx="1051560" cy="146304"/>
+            <a:off x="4023360" y="7962595"/>
+            <a:ext cx="868680" cy="146304"/>
           </a:xfrm>
           <a:prstGeom prst="rect">
             <a:avLst/>
@@ -5949,14 +6093,14 @@
       </p:sp>
       <p:sp>
         <p:nvSpPr>
-          <p:cNvPr id="71" name="Timeline label: Slow drives on the water"/>
+          <p:cNvPr id="71" name="Timeline: Slow drives on the water"/>
           <p:cNvSpPr txBox="1"/>
           <p:nvPr/>
         </p:nvSpPr>
         <p:spPr>
           <a:xfrm>
-            <a:off x="5120640" y="8453628"/>
-            <a:ext cx="2267712" cy="146304"/>
+            <a:off x="4937760" y="7962595"/>
+            <a:ext cx="2450592" cy="405993"/>
           </a:xfrm>
           <a:prstGeom prst="rect">
             <a:avLst/>
@@ -5969,15 +6113,35 @@
           </a:bodyPr>
           <a:lstStyle/>
           <a:p>
-            <a:pPr algn="l"/>
-            <a:r>
-              <a:rPr sz="800" b="0">
+            <a:pPr algn="l">
+              <a:lnSpc>
+                <a:spcPct val="100000"/>
+              </a:lnSpc>
+            </a:pPr>
+            <a:r>
+              <a:rPr sz="850" b="1">
+                <a:solidFill>
+                  <a:srgbClr val="18181B"/>
+                </a:solidFill>
+                <a:latin typeface="Arial"/>
+              </a:rPr>
+              <a:t>Slow drives on the water</a:t>
+            </a:r>
+          </a:p>
+          <a:p>
+            <a:pPr algn="l">
+              <a:lnSpc>
+                <a:spcPct val="100000"/>
+              </a:lnSpc>
+            </a:pPr>
+            <a:r>
+              <a:rPr sz="750" b="0">
                 <a:solidFill>
                   <a:srgbClr val="3F3F46"/>
                 </a:solidFill>
                 <a:latin typeface="Arial"/>
               </a:rPr>
-              <a:t>Slow drives on the water</a:t>
+              <a:t>Fully manual first, by remote command, then adding autonomy over time.</a:t>
             </a:r>
           </a:p>
         </p:txBody>
@@ -5990,7 +6154,7 @@
         </p:nvSpPr>
         <p:spPr>
           <a:xfrm>
-            <a:off x="4023360" y="8613648"/>
+            <a:off x="4023360" y="8368588"/>
             <a:ext cx="3364992" cy="9144"/>
           </a:xfrm>
           <a:prstGeom prst="rect">
@@ -6034,8 +6198,8 @@
         </p:nvSpPr>
         <p:spPr>
           <a:xfrm>
-            <a:off x="4023360" y="8654796"/>
-            <a:ext cx="1051560" cy="146304"/>
+            <a:off x="4023360" y="8414308"/>
+            <a:ext cx="868680" cy="146304"/>
           </a:xfrm>
           <a:prstGeom prst="rect">
             <a:avLst/>
@@ -6063,14 +6227,14 @@
       </p:sp>
       <p:sp>
         <p:nvSpPr>
-          <p:cNvPr id="74" name="Timeline label: Start increasing speed"/>
+          <p:cNvPr id="74" name="Timeline: Start increasing speed"/>
           <p:cNvSpPr txBox="1"/>
           <p:nvPr/>
         </p:nvSpPr>
         <p:spPr>
           <a:xfrm>
-            <a:off x="5120640" y="8654796"/>
-            <a:ext cx="2267712" cy="146304"/>
+            <a:off x="4937760" y="8414308"/>
+            <a:ext cx="2450592" cy="182880"/>
           </a:xfrm>
           <a:prstGeom prst="rect">
             <a:avLst/>
@@ -6083,11 +6247,15 @@
           </a:bodyPr>
           <a:lstStyle/>
           <a:p>
-            <a:pPr algn="l"/>
-            <a:r>
-              <a:rPr sz="800" b="0">
-                <a:solidFill>
-                  <a:srgbClr val="3F3F46"/>
+            <a:pPr algn="l">
+              <a:lnSpc>
+                <a:spcPct val="100000"/>
+              </a:lnSpc>
+            </a:pPr>
+            <a:r>
+              <a:rPr sz="850" b="1">
+                <a:solidFill>
+                  <a:srgbClr val="18181B"/>
                 </a:solidFill>
                 <a:latin typeface="Arial"/>
               </a:rPr>
@@ -6098,13 +6266,13 @@
       </p:sp>
       <p:sp>
         <p:nvSpPr>
-          <p:cNvPr id="75" name="Timeline rule: Keep testing until the competition"/>
+          <p:cNvPr id="75" name="Timeline rule: Test as much as possible"/>
           <p:cNvSpPr/>
           <p:nvPr/>
         </p:nvSpPr>
         <p:spPr>
           <a:xfrm>
-            <a:off x="4023360" y="8814816"/>
+            <a:off x="4023360" y="8597188"/>
             <a:ext cx="3364992" cy="9144"/>
           </a:xfrm>
           <a:prstGeom prst="rect">
@@ -6142,14 +6310,14 @@
       </p:sp>
       <p:sp>
         <p:nvSpPr>
-          <p:cNvPr id="76" name="Timeline date: Keep testing until the competition"/>
+          <p:cNvPr id="76" name="Timeline date: Test as much as possible"/>
           <p:cNvSpPr txBox="1"/>
           <p:nvPr/>
         </p:nvSpPr>
         <p:spPr>
           <a:xfrm>
-            <a:off x="4023360" y="8855964"/>
-            <a:ext cx="1051560" cy="146304"/>
+            <a:off x="4023360" y="8642908"/>
+            <a:ext cx="868680" cy="146304"/>
           </a:xfrm>
           <a:prstGeom prst="rect">
             <a:avLst/>
@@ -6177,14 +6345,14 @@
       </p:sp>
       <p:sp>
         <p:nvSpPr>
-          <p:cNvPr id="77" name="Timeline label: Keep testing until the competition"/>
+          <p:cNvPr id="77" name="Timeline: Test as much as possible"/>
           <p:cNvSpPr txBox="1"/>
           <p:nvPr/>
         </p:nvSpPr>
         <p:spPr>
           <a:xfrm>
-            <a:off x="5120640" y="8855964"/>
-            <a:ext cx="2267712" cy="146304"/>
+            <a:off x="4937760" y="8642908"/>
+            <a:ext cx="2450592" cy="405993"/>
           </a:xfrm>
           <a:prstGeom prst="rect">
             <a:avLst/>
@@ -6197,15 +6365,35 @@
           </a:bodyPr>
           <a:lstStyle/>
           <a:p>
-            <a:pPr algn="l"/>
-            <a:r>
-              <a:rPr sz="800" b="0">
+            <a:pPr algn="l">
+              <a:lnSpc>
+                <a:spcPct val="100000"/>
+              </a:lnSpc>
+            </a:pPr>
+            <a:r>
+              <a:rPr sz="850" b="1">
+                <a:solidFill>
+                  <a:srgbClr val="18181B"/>
+                </a:solidFill>
+                <a:latin typeface="Arial"/>
+              </a:rPr>
+              <a:t>Test as much as possible</a:t>
+            </a:r>
+          </a:p>
+          <a:p>
+            <a:pPr algn="l">
+              <a:lnSpc>
+                <a:spcPct val="100000"/>
+              </a:lnSpc>
+            </a:pPr>
+            <a:r>
+              <a:rPr sz="750" b="0">
                 <a:solidFill>
                   <a:srgbClr val="3F3F46"/>
                 </a:solidFill>
                 <a:latin typeface="Arial"/>
               </a:rPr>
-              <a:t>Keep testing until the competition</a:t>
+              <a:t>Right up to the competition, working through the hardware and software issues that come up.</a:t>
             </a:r>
           </a:p>
         </p:txBody>

</xml_diff>

<commit_message>
Handout: back to a short timeline; full detail stays on the site and in timeline.txt
Co-Authored-By: Claude Sonnet 5.5 <noreply@anthropic.com>
</commit_message>
<xml_diff>
--- a/dashboard/public/haav-handout.pptx
+++ b/dashboard/public/haav-handout.pptx
@@ -3280,8 +3280,8 @@
         </p:nvSpPr>
         <p:spPr>
           <a:xfrm>
-            <a:off x="384048" y="1005840"/>
-            <a:ext cx="4023360" cy="914400"/>
+            <a:off x="384048" y="1115568"/>
+            <a:ext cx="4023360" cy="1188720"/>
           </a:xfrm>
           <a:prstGeom prst="rect">
             <a:avLst/>
@@ -3300,7 +3300,7 @@
               </a:lnSpc>
             </a:pPr>
             <a:r>
-              <a:rPr sz="2000" b="1">
+              <a:rPr sz="2100" b="1">
                 <a:solidFill>
                   <a:srgbClr val="18181B"/>
                 </a:solidFill>
@@ -3319,12 +3319,12 @@
         </p:nvSpPr>
         <p:spPr>
           <a:xfrm>
-            <a:off x="4663440" y="1024128"/>
-            <a:ext cx="2724912" cy="1005840"/>
+            <a:off x="4663440" y="1069848"/>
+            <a:ext cx="2724912" cy="1335024"/>
           </a:xfrm>
           <a:prstGeom prst="roundRect">
             <a:avLst>
-              <a:gd name="adj" fmla="val 9090"/>
+              <a:gd name="adj" fmla="val 6849"/>
             </a:avLst>
           </a:prstGeom>
           <a:solidFill>
@@ -3375,8 +3375,8 @@
         </p:blipFill>
         <p:spPr>
           <a:xfrm>
-            <a:off x="5074920" y="1051560"/>
-            <a:ext cx="1134001" cy="950976"/>
+            <a:off x="4846320" y="1097280"/>
+            <a:ext cx="1526540" cy="1280160"/>
           </a:xfrm>
           <a:prstGeom prst="rect">
             <a:avLst/>
@@ -3391,7 +3391,7 @@
         </p:nvSpPr>
         <p:spPr>
           <a:xfrm>
-            <a:off x="384048" y="2157984"/>
+            <a:off x="384048" y="2651760"/>
             <a:ext cx="3657600" cy="182880"/>
           </a:xfrm>
           <a:prstGeom prst="rect">
@@ -3426,12 +3426,12 @@
         </p:nvSpPr>
         <p:spPr>
           <a:xfrm>
-            <a:off x="384048" y="2340864"/>
-            <a:ext cx="7004304" cy="987552"/>
+            <a:off x="384048" y="2852928"/>
+            <a:ext cx="7004304" cy="1216152"/>
           </a:xfrm>
           <a:prstGeom prst="roundRect">
             <a:avLst>
-              <a:gd name="adj" fmla="val 9259"/>
+              <a:gd name="adj" fmla="val 7518"/>
             </a:avLst>
           </a:prstGeom>
           <a:solidFill>
@@ -3472,7 +3472,7 @@
         </p:nvSpPr>
         <p:spPr>
           <a:xfrm>
-            <a:off x="548640" y="2414016"/>
+            <a:off x="548640" y="2990088"/>
             <a:ext cx="6675120" cy="274320"/>
           </a:xfrm>
           <a:prstGeom prst="rect">
@@ -3488,7 +3488,7 @@
           <a:p>
             <a:pPr algn="l"/>
             <a:r>
-              <a:rPr sz="1250" b="1">
+              <a:rPr sz="1300" b="1">
                 <a:solidFill>
                   <a:srgbClr val="18181B"/>
                 </a:solidFill>
@@ -3507,8 +3507,8 @@
         </p:nvSpPr>
         <p:spPr>
           <a:xfrm>
-            <a:off x="548640" y="2688336"/>
-            <a:ext cx="6675120" cy="640080"/>
+            <a:off x="548640" y="3310128"/>
+            <a:ext cx="6675120" cy="685800"/>
           </a:xfrm>
           <a:prstGeom prst="rect">
             <a:avLst/>
@@ -3523,11 +3523,11 @@
           <a:p>
             <a:pPr algn="l">
               <a:lnSpc>
-                <a:spcPct val="115000"/>
+                <a:spcPct val="120000"/>
               </a:lnSpc>
             </a:pPr>
             <a:r>
-              <a:rPr sz="900" b="0">
+              <a:rPr sz="1000" b="0">
                 <a:solidFill>
                   <a:srgbClr val="3F3F46"/>
                 </a:solidFill>
@@ -3536,7 +3536,7 @@
               <a:t>We build the model from physics up. Each constraint cuts the space of possible boats, and the optimizer finds the fastest one left. Hull resistance comes from </a:t>
             </a:r>
             <a:r>
-              <a:rPr sz="900" b="1">
+              <a:rPr sz="1000" b="1">
                 <a:solidFill>
                   <a:srgbClr val="3F3F46"/>
                 </a:solidFill>
@@ -3545,7 +3545,7 @@
               <a:t>Savitsky's planing-hull model</a:t>
             </a:r>
             <a:r>
-              <a:rPr sz="900" b="0">
+              <a:rPr sz="1000" b="0">
                 <a:solidFill>
                   <a:srgbClr val="3F3F46"/>
                 </a:solidFill>
@@ -3564,8 +3564,8 @@
         </p:nvSpPr>
         <p:spPr>
           <a:xfrm>
-            <a:off x="384048" y="3474720"/>
-            <a:ext cx="4114800" cy="182880"/>
+            <a:off x="384048" y="4389120"/>
+            <a:ext cx="4572000" cy="182880"/>
           </a:xfrm>
           <a:prstGeom prst="rect">
             <a:avLst/>
@@ -3599,8 +3599,8 @@
         </p:nvSpPr>
         <p:spPr>
           <a:xfrm>
-            <a:off x="3566160" y="3474720"/>
-            <a:ext cx="3822191" cy="164592"/>
+            <a:off x="384048" y="4572000"/>
+            <a:ext cx="7004304" cy="182880"/>
           </a:xfrm>
           <a:prstGeom prst="rect">
             <a:avLst/>
@@ -3613,15 +3613,15 @@
           </a:bodyPr>
           <a:lstStyle/>
           <a:p>
-            <a:pPr algn="r"/>
-            <a:r>
-              <a:rPr sz="750" b="0">
+            <a:pPr algn="l"/>
+            <a:r>
+              <a:rPr sz="900" b="0">
                 <a:solidFill>
                   <a:srgbClr val="3F3F46"/>
                 </a:solidFill>
                 <a:latin typeface="Arial"/>
               </a:rPr>
-              <a:t>Experience at Tesla, Northrop Grumman, Xcel Energy and Milwaukee Tool</a:t>
+              <a:t>Each segment of the boat is covered, and members have worked at Tesla, Northrop Grumman, Xcel Energy and Milwaukee Tool.</a:t>
             </a:r>
           </a:p>
         </p:txBody>
@@ -3634,12 +3634,12 @@
         </p:nvSpPr>
         <p:spPr>
           <a:xfrm>
-            <a:off x="384048" y="3675887"/>
-            <a:ext cx="1655064" cy="640080"/>
+            <a:off x="384048" y="4828032"/>
+            <a:ext cx="1655064" cy="713232"/>
           </a:xfrm>
           <a:prstGeom prst="roundRect">
             <a:avLst>
-              <a:gd name="adj" fmla="val 10000"/>
+              <a:gd name="adj" fmla="val 8974"/>
             </a:avLst>
           </a:prstGeom>
           <a:solidFill>
@@ -3680,7 +3680,7 @@
         </p:nvSpPr>
         <p:spPr>
           <a:xfrm>
-            <a:off x="484632" y="3730752"/>
+            <a:off x="484632" y="4892040"/>
             <a:ext cx="1472184" cy="182880"/>
           </a:xfrm>
           <a:prstGeom prst="rect">
@@ -3696,7 +3696,7 @@
           <a:p>
             <a:pPr algn="l"/>
             <a:r>
-              <a:rPr sz="1050" b="1">
+              <a:rPr sz="1100" b="1">
                 <a:solidFill>
                   <a:srgbClr val="C5050C"/>
                 </a:solidFill>
@@ -3715,8 +3715,8 @@
         </p:nvSpPr>
         <p:spPr>
           <a:xfrm>
-            <a:off x="484632" y="3931920"/>
-            <a:ext cx="1472184" cy="365760"/>
+            <a:off x="484632" y="5102352"/>
+            <a:ext cx="1472184" cy="411480"/>
           </a:xfrm>
           <a:prstGeom prst="rect">
             <a:avLst/>
@@ -3735,7 +3735,7 @@
               </a:lnSpc>
             </a:pPr>
             <a:r>
-              <a:rPr sz="850" b="0">
+              <a:rPr sz="900" b="0">
                 <a:solidFill>
                   <a:srgbClr val="3F3F46"/>
                 </a:solidFill>
@@ -3754,12 +3754,12 @@
         </p:nvSpPr>
         <p:spPr>
           <a:xfrm>
-            <a:off x="2157984" y="3675887"/>
-            <a:ext cx="1655064" cy="640080"/>
+            <a:off x="2157984" y="4828032"/>
+            <a:ext cx="1655064" cy="713232"/>
           </a:xfrm>
           <a:prstGeom prst="roundRect">
             <a:avLst>
-              <a:gd name="adj" fmla="val 10000"/>
+              <a:gd name="adj" fmla="val 8974"/>
             </a:avLst>
           </a:prstGeom>
           <a:solidFill>
@@ -3800,7 +3800,7 @@
         </p:nvSpPr>
         <p:spPr>
           <a:xfrm>
-            <a:off x="2258568" y="3730752"/>
+            <a:off x="2258568" y="4892040"/>
             <a:ext cx="1472184" cy="182880"/>
           </a:xfrm>
           <a:prstGeom prst="rect">
@@ -3816,7 +3816,7 @@
           <a:p>
             <a:pPr algn="l"/>
             <a:r>
-              <a:rPr sz="1050" b="1">
+              <a:rPr sz="1100" b="1">
                 <a:solidFill>
                   <a:srgbClr val="C5050C"/>
                 </a:solidFill>
@@ -3835,8 +3835,8 @@
         </p:nvSpPr>
         <p:spPr>
           <a:xfrm>
-            <a:off x="2258568" y="3931920"/>
-            <a:ext cx="1472184" cy="365760"/>
+            <a:off x="2258568" y="5102352"/>
+            <a:ext cx="1472184" cy="411480"/>
           </a:xfrm>
           <a:prstGeom prst="rect">
             <a:avLst/>
@@ -3855,7 +3855,7 @@
               </a:lnSpc>
             </a:pPr>
             <a:r>
-              <a:rPr sz="850" b="0">
+              <a:rPr sz="900" b="0">
                 <a:solidFill>
                   <a:srgbClr val="3F3F46"/>
                 </a:solidFill>
@@ -3874,12 +3874,12 @@
         </p:nvSpPr>
         <p:spPr>
           <a:xfrm>
-            <a:off x="3931920" y="3675887"/>
-            <a:ext cx="1655064" cy="640080"/>
+            <a:off x="3931920" y="4828032"/>
+            <a:ext cx="1655064" cy="713232"/>
           </a:xfrm>
           <a:prstGeom prst="roundRect">
             <a:avLst>
-              <a:gd name="adj" fmla="val 10000"/>
+              <a:gd name="adj" fmla="val 8974"/>
             </a:avLst>
           </a:prstGeom>
           <a:solidFill>
@@ -3920,7 +3920,7 @@
         </p:nvSpPr>
         <p:spPr>
           <a:xfrm>
-            <a:off x="4032504" y="3730752"/>
+            <a:off x="4032504" y="4892040"/>
             <a:ext cx="1472184" cy="182880"/>
           </a:xfrm>
           <a:prstGeom prst="rect">
@@ -3936,7 +3936,7 @@
           <a:p>
             <a:pPr algn="l"/>
             <a:r>
-              <a:rPr sz="1050" b="1">
+              <a:rPr sz="1100" b="1">
                 <a:solidFill>
                   <a:srgbClr val="C5050C"/>
                 </a:solidFill>
@@ -3955,8 +3955,8 @@
         </p:nvSpPr>
         <p:spPr>
           <a:xfrm>
-            <a:off x="4032504" y="3931920"/>
-            <a:ext cx="1472184" cy="365760"/>
+            <a:off x="4032504" y="5102352"/>
+            <a:ext cx="1472184" cy="411480"/>
           </a:xfrm>
           <a:prstGeom prst="rect">
             <a:avLst/>
@@ -3975,7 +3975,7 @@
               </a:lnSpc>
             </a:pPr>
             <a:r>
-              <a:rPr sz="850" b="0">
+              <a:rPr sz="900" b="0">
                 <a:solidFill>
                   <a:srgbClr val="3F3F46"/>
                 </a:solidFill>
@@ -3994,12 +3994,12 @@
         </p:nvSpPr>
         <p:spPr>
           <a:xfrm>
-            <a:off x="5705856" y="3675887"/>
-            <a:ext cx="1655064" cy="640080"/>
+            <a:off x="5705856" y="4828032"/>
+            <a:ext cx="1655064" cy="713232"/>
           </a:xfrm>
           <a:prstGeom prst="roundRect">
             <a:avLst>
-              <a:gd name="adj" fmla="val 10000"/>
+              <a:gd name="adj" fmla="val 8974"/>
             </a:avLst>
           </a:prstGeom>
           <a:solidFill>
@@ -4040,7 +4040,7 @@
         </p:nvSpPr>
         <p:spPr>
           <a:xfrm>
-            <a:off x="5806440" y="3730752"/>
+            <a:off x="5806440" y="4892040"/>
             <a:ext cx="1472184" cy="182880"/>
           </a:xfrm>
           <a:prstGeom prst="rect">
@@ -4056,7 +4056,7 @@
           <a:p>
             <a:pPr algn="l"/>
             <a:r>
-              <a:rPr sz="1050" b="1">
+              <a:rPr sz="1100" b="1">
                 <a:solidFill>
                   <a:srgbClr val="C5050C"/>
                 </a:solidFill>
@@ -4075,8 +4075,8 @@
         </p:nvSpPr>
         <p:spPr>
           <a:xfrm>
-            <a:off x="5806440" y="3931920"/>
-            <a:ext cx="1472184" cy="365760"/>
+            <a:off x="5806440" y="5102352"/>
+            <a:ext cx="1472184" cy="411480"/>
           </a:xfrm>
           <a:prstGeom prst="rect">
             <a:avLst/>
@@ -4095,7 +4095,7 @@
               </a:lnSpc>
             </a:pPr>
             <a:r>
-              <a:rPr sz="850" b="0">
+              <a:rPr sz="900" b="0">
                 <a:solidFill>
                   <a:srgbClr val="3F3F46"/>
                 </a:solidFill>
@@ -4114,7 +4114,7 @@
         </p:nvSpPr>
         <p:spPr>
           <a:xfrm>
-            <a:off x="384048" y="4480560"/>
+            <a:off x="384048" y="5852160"/>
             <a:ext cx="3657600" cy="182880"/>
           </a:xfrm>
           <a:prstGeom prst="rect">
@@ -4149,12 +4149,12 @@
         </p:nvSpPr>
         <p:spPr>
           <a:xfrm>
-            <a:off x="384048" y="4681728"/>
-            <a:ext cx="2240280" cy="1389888"/>
+            <a:off x="384048" y="6062472"/>
+            <a:ext cx="2240280" cy="1600200"/>
           </a:xfrm>
           <a:prstGeom prst="roundRect">
             <a:avLst>
-              <a:gd name="adj" fmla="val 6578"/>
+              <a:gd name="adj" fmla="val 5714"/>
             </a:avLst>
           </a:prstGeom>
           <a:solidFill>
@@ -4197,7 +4197,7 @@
         </p:nvSpPr>
         <p:spPr>
           <a:xfrm>
-            <a:off x="521207" y="4736592"/>
+            <a:off x="521207" y="6172200"/>
             <a:ext cx="1965960" cy="274320"/>
           </a:xfrm>
           <a:prstGeom prst="rect">
@@ -4213,7 +4213,7 @@
           <a:p>
             <a:pPr algn="l"/>
             <a:r>
-              <a:rPr sz="1400" b="1">
+              <a:rPr sz="1500" b="1">
                 <a:solidFill>
                   <a:srgbClr val="18181B"/>
                 </a:solidFill>
@@ -4232,7 +4232,7 @@
         </p:nvSpPr>
         <p:spPr>
           <a:xfrm>
-            <a:off x="521207" y="5029200"/>
+            <a:off x="521207" y="6510528"/>
             <a:ext cx="1965960" cy="228600"/>
           </a:xfrm>
           <a:prstGeom prst="rect">
@@ -4248,7 +4248,7 @@
           <a:p>
             <a:pPr algn="l"/>
             <a:r>
-              <a:rPr sz="1000" b="1">
+              <a:rPr sz="1050" b="1">
                 <a:solidFill>
                   <a:srgbClr val="18181B"/>
                 </a:solidFill>
@@ -4267,7 +4267,7 @@
         </p:nvSpPr>
         <p:spPr>
           <a:xfrm>
-            <a:off x="521207" y="5285232"/>
+            <a:off x="521207" y="6821424"/>
             <a:ext cx="1965960" cy="9144"/>
           </a:xfrm>
           <a:prstGeom prst="rect">
@@ -4311,8 +4311,8 @@
         </p:nvSpPr>
         <p:spPr>
           <a:xfrm>
-            <a:off x="521207" y="5358384"/>
-            <a:ext cx="1965960" cy="685800"/>
+            <a:off x="521207" y="6931152"/>
+            <a:ext cx="1965960" cy="822960"/>
           </a:xfrm>
           <a:prstGeom prst="rect">
             <a:avLst/>
@@ -4327,7 +4327,7 @@
           <a:p>
             <a:pPr algn="l">
               <a:lnSpc>
-                <a:spcPct val="150000"/>
+                <a:spcPct val="155000"/>
               </a:lnSpc>
             </a:pPr>
             <a:r>
@@ -4340,7 +4340,7 @@
               <a:t>●  </a:t>
             </a:r>
             <a:r>
-              <a:rPr sz="850" b="0">
+              <a:rPr sz="900" b="0">
                 <a:solidFill>
                   <a:srgbClr val="3F3F46"/>
                 </a:solidFill>
@@ -4352,7 +4352,7 @@
           <a:p>
             <a:pPr algn="l">
               <a:lnSpc>
-                <a:spcPct val="150000"/>
+                <a:spcPct val="155000"/>
               </a:lnSpc>
             </a:pPr>
             <a:r>
@@ -4365,7 +4365,7 @@
               <a:t>●  </a:t>
             </a:r>
             <a:r>
-              <a:rPr sz="850" b="0">
+              <a:rPr sz="900" b="0">
                 <a:solidFill>
                   <a:srgbClr val="3F3F46"/>
                 </a:solidFill>
@@ -4377,7 +4377,7 @@
           <a:p>
             <a:pPr algn="l">
               <a:lnSpc>
-                <a:spcPct val="150000"/>
+                <a:spcPct val="155000"/>
               </a:lnSpc>
             </a:pPr>
             <a:r>
@@ -4390,7 +4390,7 @@
               <a:t>●  </a:t>
             </a:r>
             <a:r>
-              <a:rPr sz="850" b="0">
+              <a:rPr sz="900" b="0">
                 <a:solidFill>
                   <a:srgbClr val="3F3F46"/>
                 </a:solidFill>
@@ -4409,12 +4409,12 @@
         </p:nvSpPr>
         <p:spPr>
           <a:xfrm>
-            <a:off x="2743200" y="4681728"/>
-            <a:ext cx="2240280" cy="1389888"/>
+            <a:off x="2743200" y="6062472"/>
+            <a:ext cx="2240280" cy="1600200"/>
           </a:xfrm>
           <a:prstGeom prst="roundRect">
             <a:avLst>
-              <a:gd name="adj" fmla="val 6578"/>
+              <a:gd name="adj" fmla="val 5714"/>
             </a:avLst>
           </a:prstGeom>
           <a:solidFill>
@@ -4457,7 +4457,7 @@
         </p:nvSpPr>
         <p:spPr>
           <a:xfrm>
-            <a:off x="2880360" y="4736592"/>
+            <a:off x="2880360" y="6172200"/>
             <a:ext cx="1965960" cy="274320"/>
           </a:xfrm>
           <a:prstGeom prst="rect">
@@ -4473,7 +4473,7 @@
           <a:p>
             <a:pPr algn="l"/>
             <a:r>
-              <a:rPr sz="1400" b="1">
+              <a:rPr sz="1500" b="1">
                 <a:solidFill>
                   <a:srgbClr val="18181B"/>
                 </a:solidFill>
@@ -4492,7 +4492,7 @@
         </p:nvSpPr>
         <p:spPr>
           <a:xfrm>
-            <a:off x="2880360" y="5029200"/>
+            <a:off x="2880360" y="6510528"/>
             <a:ext cx="1965960" cy="228600"/>
           </a:xfrm>
           <a:prstGeom prst="rect">
@@ -4508,7 +4508,7 @@
           <a:p>
             <a:pPr algn="l"/>
             <a:r>
-              <a:rPr sz="1000" b="1">
+              <a:rPr sz="1050" b="1">
                 <a:solidFill>
                   <a:srgbClr val="18181B"/>
                 </a:solidFill>
@@ -4527,7 +4527,7 @@
         </p:nvSpPr>
         <p:spPr>
           <a:xfrm>
-            <a:off x="2880360" y="5285232"/>
+            <a:off x="2880360" y="6821424"/>
             <a:ext cx="1965960" cy="9144"/>
           </a:xfrm>
           <a:prstGeom prst="rect">
@@ -4571,8 +4571,8 @@
         </p:nvSpPr>
         <p:spPr>
           <a:xfrm>
-            <a:off x="2880360" y="5358384"/>
-            <a:ext cx="1965960" cy="685800"/>
+            <a:off x="2880360" y="6931152"/>
+            <a:ext cx="1965960" cy="822960"/>
           </a:xfrm>
           <a:prstGeom prst="rect">
             <a:avLst/>
@@ -4587,7 +4587,7 @@
           <a:p>
             <a:pPr algn="l">
               <a:lnSpc>
-                <a:spcPct val="150000"/>
+                <a:spcPct val="155000"/>
               </a:lnSpc>
             </a:pPr>
             <a:r>
@@ -4600,7 +4600,7 @@
               <a:t>●  </a:t>
             </a:r>
             <a:r>
-              <a:rPr sz="850" b="0">
+              <a:rPr sz="900" b="0">
                 <a:solidFill>
                   <a:srgbClr val="3F3F46"/>
                 </a:solidFill>
@@ -4612,7 +4612,7 @@
           <a:p>
             <a:pPr algn="l">
               <a:lnSpc>
-                <a:spcPct val="150000"/>
+                <a:spcPct val="155000"/>
               </a:lnSpc>
             </a:pPr>
             <a:r>
@@ -4625,7 +4625,7 @@
               <a:t>●  </a:t>
             </a:r>
             <a:r>
-              <a:rPr sz="850" b="0">
+              <a:rPr sz="900" b="0">
                 <a:solidFill>
                   <a:srgbClr val="3F3F46"/>
                 </a:solidFill>
@@ -4637,7 +4637,7 @@
           <a:p>
             <a:pPr algn="l">
               <a:lnSpc>
-                <a:spcPct val="150000"/>
+                <a:spcPct val="155000"/>
               </a:lnSpc>
             </a:pPr>
             <a:r>
@@ -4650,7 +4650,7 @@
               <a:t>●  </a:t>
             </a:r>
             <a:r>
-              <a:rPr sz="850" b="0">
+              <a:rPr sz="900" b="0">
                 <a:solidFill>
                   <a:srgbClr val="3F3F46"/>
                 </a:solidFill>
@@ -4669,12 +4669,12 @@
         </p:nvSpPr>
         <p:spPr>
           <a:xfrm>
-            <a:off x="5102352" y="4681728"/>
-            <a:ext cx="2240280" cy="1389888"/>
+            <a:off x="5102352" y="6062472"/>
+            <a:ext cx="2240280" cy="1600200"/>
           </a:xfrm>
           <a:prstGeom prst="roundRect">
             <a:avLst>
-              <a:gd name="adj" fmla="val 6578"/>
+              <a:gd name="adj" fmla="val 5714"/>
             </a:avLst>
           </a:prstGeom>
           <a:solidFill>
@@ -4717,7 +4717,7 @@
         </p:nvSpPr>
         <p:spPr>
           <a:xfrm>
-            <a:off x="5239512" y="4736592"/>
+            <a:off x="5239512" y="6172200"/>
             <a:ext cx="1965960" cy="274320"/>
           </a:xfrm>
           <a:prstGeom prst="rect">
@@ -4733,7 +4733,7 @@
           <a:p>
             <a:pPr algn="l"/>
             <a:r>
-              <a:rPr sz="1400" b="1">
+              <a:rPr sz="1500" b="1">
                 <a:solidFill>
                   <a:srgbClr val="18181B"/>
                 </a:solidFill>
@@ -4752,7 +4752,7 @@
         </p:nvSpPr>
         <p:spPr>
           <a:xfrm>
-            <a:off x="5239512" y="5029200"/>
+            <a:off x="5239512" y="6510528"/>
             <a:ext cx="1965960" cy="228600"/>
           </a:xfrm>
           <a:prstGeom prst="rect">
@@ -4768,7 +4768,7 @@
           <a:p>
             <a:pPr algn="l"/>
             <a:r>
-              <a:rPr sz="1000" b="1">
+              <a:rPr sz="1050" b="1">
                 <a:solidFill>
                   <a:srgbClr val="18181B"/>
                 </a:solidFill>
@@ -4787,7 +4787,7 @@
         </p:nvSpPr>
         <p:spPr>
           <a:xfrm>
-            <a:off x="5239512" y="5285232"/>
+            <a:off x="5239512" y="6821424"/>
             <a:ext cx="1965960" cy="9144"/>
           </a:xfrm>
           <a:prstGeom prst="rect">
@@ -4831,8 +4831,8 @@
         </p:nvSpPr>
         <p:spPr>
           <a:xfrm>
-            <a:off x="5239512" y="5358384"/>
-            <a:ext cx="1965960" cy="685800"/>
+            <a:off x="5239512" y="6931152"/>
+            <a:ext cx="1965960" cy="822960"/>
           </a:xfrm>
           <a:prstGeom prst="rect">
             <a:avLst/>
@@ -4847,7 +4847,7 @@
           <a:p>
             <a:pPr algn="l">
               <a:lnSpc>
-                <a:spcPct val="150000"/>
+                <a:spcPct val="155000"/>
               </a:lnSpc>
             </a:pPr>
             <a:r>
@@ -4860,7 +4860,7 @@
               <a:t>●  </a:t>
             </a:r>
             <a:r>
-              <a:rPr sz="850" b="0">
+              <a:rPr sz="900" b="0">
                 <a:solidFill>
                   <a:srgbClr val="3F3F46"/>
                 </a:solidFill>
@@ -4872,7 +4872,7 @@
           <a:p>
             <a:pPr algn="l">
               <a:lnSpc>
-                <a:spcPct val="150000"/>
+                <a:spcPct val="155000"/>
               </a:lnSpc>
             </a:pPr>
             <a:r>
@@ -4885,7 +4885,7 @@
               <a:t>●  </a:t>
             </a:r>
             <a:r>
-              <a:rPr sz="850" b="0">
+              <a:rPr sz="900" b="0">
                 <a:solidFill>
                   <a:srgbClr val="3F3F46"/>
                 </a:solidFill>
@@ -4897,7 +4897,7 @@
           <a:p>
             <a:pPr algn="l">
               <a:lnSpc>
-                <a:spcPct val="150000"/>
+                <a:spcPct val="155000"/>
               </a:lnSpc>
             </a:pPr>
             <a:r>
@@ -4910,7 +4910,7 @@
               <a:t>●  </a:t>
             </a:r>
             <a:r>
-              <a:rPr sz="850" b="0">
+              <a:rPr sz="900" b="0">
                 <a:solidFill>
                   <a:srgbClr val="3F3F46"/>
                 </a:solidFill>
@@ -4929,7 +4929,7 @@
         </p:nvSpPr>
         <p:spPr>
           <a:xfrm>
-            <a:off x="384048" y="6254496"/>
+            <a:off x="384048" y="7790688"/>
             <a:ext cx="3657600" cy="182880"/>
           </a:xfrm>
           <a:prstGeom prst="rect">
@@ -4964,7 +4964,7 @@
         </p:nvSpPr>
         <p:spPr>
           <a:xfrm>
-            <a:off x="384048" y="6455664"/>
+            <a:off x="384048" y="8010144"/>
             <a:ext cx="3364992" cy="9144"/>
           </a:xfrm>
           <a:prstGeom prst="rect">
@@ -5008,8 +5008,8 @@
         </p:nvSpPr>
         <p:spPr>
           <a:xfrm>
-            <a:off x="384048" y="6501383"/>
-            <a:ext cx="868680" cy="146304"/>
+            <a:off x="384048" y="8051292"/>
+            <a:ext cx="1051560" cy="146304"/>
           </a:xfrm>
           <a:prstGeom prst="rect">
             <a:avLst/>
@@ -5037,14 +5037,14 @@
       </p:sp>
       <p:sp>
         <p:nvSpPr>
-          <p:cNvPr id="47" name="Timeline: Current hull design frozen"/>
+          <p:cNvPr id="47" name="Timeline label: Current hull design frozen"/>
           <p:cNvSpPr txBox="1"/>
           <p:nvPr/>
         </p:nvSpPr>
         <p:spPr>
           <a:xfrm>
-            <a:off x="1298448" y="6501383"/>
-            <a:ext cx="2450592" cy="182880"/>
+            <a:off x="1481328" y="8051292"/>
+            <a:ext cx="2267712" cy="146304"/>
           </a:xfrm>
           <a:prstGeom prst="rect">
             <a:avLst/>
@@ -5057,15 +5057,11 @@
           </a:bodyPr>
           <a:lstStyle/>
           <a:p>
-            <a:pPr algn="l">
-              <a:lnSpc>
-                <a:spcPct val="100000"/>
-              </a:lnSpc>
-            </a:pPr>
-            <a:r>
-              <a:rPr sz="850" b="1">
-                <a:solidFill>
-                  <a:srgbClr val="18181B"/>
+            <a:pPr algn="l"/>
+            <a:r>
+              <a:rPr sz="800" b="0">
+                <a:solidFill>
+                  <a:srgbClr val="3F3F46"/>
                 </a:solidFill>
                 <a:latin typeface="Arial"/>
               </a:rPr>
@@ -5082,7 +5078,7 @@
         </p:nvSpPr>
         <p:spPr>
           <a:xfrm>
-            <a:off x="384048" y="6684264"/>
+            <a:off x="384048" y="8211312"/>
             <a:ext cx="3364992" cy="9144"/>
           </a:xfrm>
           <a:prstGeom prst="rect">
@@ -5126,8 +5122,8 @@
         </p:nvSpPr>
         <p:spPr>
           <a:xfrm>
-            <a:off x="384048" y="6729983"/>
-            <a:ext cx="868680" cy="146304"/>
+            <a:off x="384048" y="8252460"/>
+            <a:ext cx="1051560" cy="146304"/>
           </a:xfrm>
           <a:prstGeom prst="rect">
             <a:avLst/>
@@ -5155,14 +5151,14 @@
       </p:sp>
       <p:sp>
         <p:nvSpPr>
-          <p:cNvPr id="50" name="Timeline: Preliminary design review"/>
+          <p:cNvPr id="50" name="Timeline label: Preliminary design review"/>
           <p:cNvSpPr txBox="1"/>
           <p:nvPr/>
         </p:nvSpPr>
         <p:spPr>
           <a:xfrm>
-            <a:off x="1298448" y="6729983"/>
-            <a:ext cx="2450592" cy="740664"/>
+            <a:off x="1481328" y="8252460"/>
+            <a:ext cx="2267712" cy="146304"/>
           </a:xfrm>
           <a:prstGeom prst="rect">
             <a:avLst/>
@@ -5175,35 +5171,15 @@
           </a:bodyPr>
           <a:lstStyle/>
           <a:p>
-            <a:pPr algn="l">
-              <a:lnSpc>
-                <a:spcPct val="100000"/>
-              </a:lnSpc>
-            </a:pPr>
-            <a:r>
-              <a:rPr sz="850" b="1">
-                <a:solidFill>
-                  <a:srgbClr val="18181B"/>
+            <a:pPr algn="l"/>
+            <a:r>
+              <a:rPr sz="800" b="0">
+                <a:solidFill>
+                  <a:srgbClr val="3F3F46"/>
                 </a:solidFill>
                 <a:latin typeface="Arial"/>
               </a:rPr>
               <a:t>Preliminary design review</a:t>
-            </a:r>
-          </a:p>
-          <a:p>
-            <a:pPr algn="l">
-              <a:lnSpc>
-                <a:spcPct val="100000"/>
-              </a:lnSpc>
-            </a:pPr>
-            <a:r>
-              <a:rPr sz="750" b="0">
-                <a:solidFill>
-                  <a:srgbClr val="3F3F46"/>
-                </a:solidFill>
-                <a:latin typeface="Arial"/>
-              </a:rPr>
-              <a:t>Full CAD and circuit design, plus a rough proof of concept, even a cardboard boat with boxes for the components, to visually check dimensions and catch issues. Critical and long-lead components are ordered.</a:t>
             </a:r>
           </a:p>
         </p:txBody>
@@ -5216,7 +5192,7 @@
         </p:nvSpPr>
         <p:spPr>
           <a:xfrm>
-            <a:off x="384048" y="7470648"/>
+            <a:off x="384048" y="8412480"/>
             <a:ext cx="3364992" cy="9144"/>
           </a:xfrm>
           <a:prstGeom prst="rect">
@@ -5260,8 +5236,8 @@
         </p:nvSpPr>
         <p:spPr>
           <a:xfrm>
-            <a:off x="384048" y="7516368"/>
-            <a:ext cx="868680" cy="146304"/>
+            <a:off x="384048" y="8453628"/>
+            <a:ext cx="1051560" cy="146304"/>
           </a:xfrm>
           <a:prstGeom prst="rect">
             <a:avLst/>
@@ -5289,14 +5265,14 @@
       </p:sp>
       <p:sp>
         <p:nvSpPr>
-          <p:cNvPr id="53" name="Timeline: Mechanical and electrical design frozen"/>
+          <p:cNvPr id="53" name="Timeline label: Mechanical and electrical design frozen"/>
           <p:cNvSpPr txBox="1"/>
           <p:nvPr/>
         </p:nvSpPr>
         <p:spPr>
           <a:xfrm>
-            <a:off x="1298448" y="7516368"/>
-            <a:ext cx="2450592" cy="294436"/>
+            <a:off x="1481328" y="8453628"/>
+            <a:ext cx="2267712" cy="146304"/>
           </a:xfrm>
           <a:prstGeom prst="rect">
             <a:avLst/>
@@ -5309,35 +5285,15 @@
           </a:bodyPr>
           <a:lstStyle/>
           <a:p>
-            <a:pPr algn="l">
-              <a:lnSpc>
-                <a:spcPct val="100000"/>
-              </a:lnSpc>
-            </a:pPr>
-            <a:r>
-              <a:rPr sz="850" b="1">
-                <a:solidFill>
-                  <a:srgbClr val="18181B"/>
+            <a:pPr algn="l"/>
+            <a:r>
+              <a:rPr sz="800" b="0">
+                <a:solidFill>
+                  <a:srgbClr val="3F3F46"/>
                 </a:solidFill>
                 <a:latin typeface="Arial"/>
               </a:rPr>
               <a:t>Mechanical and electrical design frozen</a:t>
-            </a:r>
-          </a:p>
-          <a:p>
-            <a:pPr algn="l">
-              <a:lnSpc>
-                <a:spcPct val="100000"/>
-              </a:lnSpc>
-            </a:pPr>
-            <a:r>
-              <a:rPr sz="750" b="0">
-                <a:solidFill>
-                  <a:srgbClr val="3F3F46"/>
-                </a:solidFill>
-                <a:latin typeface="Arial"/>
-              </a:rPr>
-              <a:t>With the full BOM and the order.</a:t>
             </a:r>
           </a:p>
         </p:txBody>
@@ -5350,7 +5306,7 @@
         </p:nvSpPr>
         <p:spPr>
           <a:xfrm>
-            <a:off x="384048" y="7810804"/>
+            <a:off x="384048" y="8613648"/>
             <a:ext cx="3364992" cy="9144"/>
           </a:xfrm>
           <a:prstGeom prst="rect">
@@ -5394,8 +5350,8 @@
         </p:nvSpPr>
         <p:spPr>
           <a:xfrm>
-            <a:off x="384048" y="7856524"/>
-            <a:ext cx="868680" cy="146304"/>
+            <a:off x="384048" y="8654796"/>
+            <a:ext cx="1051560" cy="146304"/>
           </a:xfrm>
           <a:prstGeom prst="rect">
             <a:avLst/>
@@ -5423,14 +5379,14 @@
       </p:sp>
       <p:sp>
         <p:nvSpPr>
-          <p:cNvPr id="56" name="Timeline: Build the hull and composite parts"/>
+          <p:cNvPr id="56" name="Timeline label: Build the hull and composite parts"/>
           <p:cNvSpPr txBox="1"/>
           <p:nvPr/>
         </p:nvSpPr>
         <p:spPr>
           <a:xfrm>
-            <a:off x="1298448" y="7856524"/>
-            <a:ext cx="2450592" cy="294436"/>
+            <a:off x="1481328" y="8654796"/>
+            <a:ext cx="2267712" cy="146304"/>
           </a:xfrm>
           <a:prstGeom prst="rect">
             <a:avLst/>
@@ -5443,35 +5399,15 @@
           </a:bodyPr>
           <a:lstStyle/>
           <a:p>
-            <a:pPr algn="l">
-              <a:lnSpc>
-                <a:spcPct val="100000"/>
-              </a:lnSpc>
-            </a:pPr>
-            <a:r>
-              <a:rPr sz="850" b="1">
-                <a:solidFill>
-                  <a:srgbClr val="18181B"/>
+            <a:pPr algn="l"/>
+            <a:r>
+              <a:rPr sz="800" b="0">
+                <a:solidFill>
+                  <a:srgbClr val="3F3F46"/>
                 </a:solidFill>
                 <a:latin typeface="Arial"/>
               </a:rPr>
               <a:t>Build the hull and composite parts</a:t>
-            </a:r>
-          </a:p>
-          <a:p>
-            <a:pPr algn="l">
-              <a:lnSpc>
-                <a:spcPct val="100000"/>
-              </a:lnSpc>
-            </a:pPr>
-            <a:r>
-              <a:rPr sz="750" b="0">
-                <a:solidFill>
-                  <a:srgbClr val="3F3F46"/>
-                </a:solidFill>
-                <a:latin typeface="Arial"/>
-              </a:rPr>
-              <a:t>Plus any custom-milled parts.</a:t>
             </a:r>
           </a:p>
         </p:txBody>
@@ -5484,7 +5420,7 @@
         </p:nvSpPr>
         <p:spPr>
           <a:xfrm>
-            <a:off x="384048" y="8150961"/>
+            <a:off x="384048" y="8814816"/>
             <a:ext cx="3364992" cy="9144"/>
           </a:xfrm>
           <a:prstGeom prst="rect">
@@ -5528,8 +5464,8 @@
         </p:nvSpPr>
         <p:spPr>
           <a:xfrm>
-            <a:off x="384048" y="8196681"/>
-            <a:ext cx="868680" cy="146304"/>
+            <a:off x="384048" y="8855964"/>
+            <a:ext cx="1051560" cy="146304"/>
           </a:xfrm>
           <a:prstGeom prst="rect">
             <a:avLst/>
@@ -5557,14 +5493,14 @@
       </p:sp>
       <p:sp>
         <p:nvSpPr>
-          <p:cNvPr id="59" name="Timeline: Manufacture and assemble everything"/>
+          <p:cNvPr id="59" name="Timeline label: Manufacture and assemble everything"/>
           <p:cNvSpPr txBox="1"/>
           <p:nvPr/>
         </p:nvSpPr>
         <p:spPr>
           <a:xfrm>
-            <a:off x="1298448" y="8196681"/>
-            <a:ext cx="2450592" cy="517550"/>
+            <a:off x="1481328" y="8855964"/>
+            <a:ext cx="2267712" cy="146304"/>
           </a:xfrm>
           <a:prstGeom prst="rect">
             <a:avLst/>
@@ -5577,35 +5513,15 @@
           </a:bodyPr>
           <a:lstStyle/>
           <a:p>
-            <a:pPr algn="l">
-              <a:lnSpc>
-                <a:spcPct val="100000"/>
-              </a:lnSpc>
-            </a:pPr>
-            <a:r>
-              <a:rPr sz="850" b="1">
-                <a:solidFill>
-                  <a:srgbClr val="18181B"/>
+            <a:pPr algn="l"/>
+            <a:r>
+              <a:rPr sz="800" b="0">
+                <a:solidFill>
+                  <a:srgbClr val="3F3F46"/>
                 </a:solidFill>
                 <a:latin typeface="Arial"/>
               </a:rPr>
               <a:t>Manufacture and assemble everything</a:t>
-            </a:r>
-          </a:p>
-          <a:p>
-            <a:pPr algn="l">
-              <a:lnSpc>
-                <a:spcPct val="100000"/>
-              </a:lnSpc>
-            </a:pPr>
-            <a:r>
-              <a:rPr sz="750" b="0">
-                <a:solidFill>
-                  <a:srgbClr val="3F3F46"/>
-                </a:solidFill>
-                <a:latin typeface="Arial"/>
-              </a:rPr>
-              <a:t>All mechanical and electrical components, with dry fits, electrical assembly out of the boat first, and debugging.</a:t>
             </a:r>
           </a:p>
         </p:txBody>
@@ -5618,7 +5534,7 @@
         </p:nvSpPr>
         <p:spPr>
           <a:xfrm>
-            <a:off x="384048" y="8714232"/>
+            <a:off x="384048" y="9015984"/>
             <a:ext cx="3364992" cy="9144"/>
           </a:xfrm>
           <a:prstGeom prst="rect">
@@ -5662,8 +5578,8 @@
         </p:nvSpPr>
         <p:spPr>
           <a:xfrm>
-            <a:off x="384048" y="8759952"/>
-            <a:ext cx="868680" cy="146304"/>
+            <a:off x="384048" y="9057132"/>
+            <a:ext cx="1051560" cy="146304"/>
           </a:xfrm>
           <a:prstGeom prst="rect">
             <a:avLst/>
@@ -5691,14 +5607,14 @@
       </p:sp>
       <p:sp>
         <p:nvSpPr>
-          <p:cNvPr id="62" name="Timeline: Build likely spare parts, in parallel"/>
+          <p:cNvPr id="62" name="Timeline label: Build likely spare parts, in parallel"/>
           <p:cNvSpPr txBox="1"/>
           <p:nvPr/>
         </p:nvSpPr>
         <p:spPr>
           <a:xfrm>
-            <a:off x="1298448" y="8759952"/>
-            <a:ext cx="2450592" cy="294436"/>
+            <a:off x="1481328" y="9057132"/>
+            <a:ext cx="2267712" cy="146304"/>
           </a:xfrm>
           <a:prstGeom prst="rect">
             <a:avLst/>
@@ -5711,35 +5627,15 @@
           </a:bodyPr>
           <a:lstStyle/>
           <a:p>
-            <a:pPr algn="l">
-              <a:lnSpc>
-                <a:spcPct val="100000"/>
-              </a:lnSpc>
-            </a:pPr>
-            <a:r>
-              <a:rPr sz="850" b="1">
-                <a:solidFill>
-                  <a:srgbClr val="18181B"/>
+            <a:pPr algn="l"/>
+            <a:r>
+              <a:rPr sz="800" b="0">
+                <a:solidFill>
+                  <a:srgbClr val="3F3F46"/>
                 </a:solidFill>
                 <a:latin typeface="Arial"/>
               </a:rPr>
               <a:t>Build likely spare parts, in parallel</a:t>
-            </a:r>
-          </a:p>
-          <a:p>
-            <a:pPr algn="l">
-              <a:lnSpc>
-                <a:spcPct val="100000"/>
-              </a:lnSpc>
-            </a:pPr>
-            <a:r>
-              <a:rPr sz="750" b="0">
-                <a:solidFill>
-                  <a:srgbClr val="3F3F46"/>
-                </a:solidFill>
-                <a:latin typeface="Arial"/>
-              </a:rPr>
-              <a:t>Spares for the parts most likely to be used.</a:t>
             </a:r>
           </a:p>
         </p:txBody>
@@ -5752,7 +5648,7 @@
         </p:nvSpPr>
         <p:spPr>
           <a:xfrm>
-            <a:off x="4023360" y="6455664"/>
+            <a:off x="4023360" y="8010144"/>
             <a:ext cx="3364992" cy="9144"/>
           </a:xfrm>
           <a:prstGeom prst="rect">
@@ -5796,8 +5692,8 @@
         </p:nvSpPr>
         <p:spPr>
           <a:xfrm>
-            <a:off x="4023360" y="6501383"/>
-            <a:ext cx="868680" cy="146304"/>
+            <a:off x="4023360" y="8051292"/>
+            <a:ext cx="1051560" cy="146304"/>
           </a:xfrm>
           <a:prstGeom prst="rect">
             <a:avLst/>
@@ -5825,14 +5721,14 @@
       </p:sp>
       <p:sp>
         <p:nvSpPr>
-          <p:cNvPr id="65" name="Timeline: First float and tow test"/>
+          <p:cNvPr id="65" name="Timeline label: First float and tow test"/>
           <p:cNvSpPr txBox="1"/>
           <p:nvPr/>
         </p:nvSpPr>
         <p:spPr>
           <a:xfrm>
-            <a:off x="4937760" y="6501383"/>
-            <a:ext cx="2450592" cy="517550"/>
+            <a:off x="5120640" y="8051292"/>
+            <a:ext cx="2267712" cy="146304"/>
           </a:xfrm>
           <a:prstGeom prst="rect">
             <a:avLst/>
@@ -5845,35 +5741,15 @@
           </a:bodyPr>
           <a:lstStyle/>
           <a:p>
-            <a:pPr algn="l">
-              <a:lnSpc>
-                <a:spcPct val="100000"/>
-              </a:lnSpc>
-            </a:pPr>
-            <a:r>
-              <a:rPr sz="850" b="1">
-                <a:solidFill>
-                  <a:srgbClr val="18181B"/>
+            <a:pPr algn="l"/>
+            <a:r>
+              <a:rPr sz="800" b="0">
+                <a:solidFill>
+                  <a:srgbClr val="3F3F46"/>
                 </a:solidFill>
                 <a:latin typeface="Arial"/>
               </a:rPr>
               <a:t>First float and tow test</a:t>
-            </a:r>
-          </a:p>
-          <a:p>
-            <a:pPr algn="l">
-              <a:lnSpc>
-                <a:spcPct val="100000"/>
-              </a:lnSpc>
-            </a:pPr>
-            <a:r>
-              <a:rPr sz="750" b="0">
-                <a:solidFill>
-                  <a:srgbClr val="3F3F46"/>
-                </a:solidFill>
-                <a:latin typeface="Arial"/>
-              </a:rPr>
-              <a:t>The hull floats with deadweight for the real weight, and is towed behind a motorized boat to validate the hull design and quality.</a:t>
             </a:r>
           </a:p>
         </p:txBody>
@@ -5886,7 +5762,7 @@
         </p:nvSpPr>
         <p:spPr>
           <a:xfrm>
-            <a:off x="4023360" y="7018934"/>
+            <a:off x="4023360" y="8211312"/>
             <a:ext cx="3364992" cy="9144"/>
           </a:xfrm>
           <a:prstGeom prst="rect">
@@ -5930,8 +5806,8 @@
         </p:nvSpPr>
         <p:spPr>
           <a:xfrm>
-            <a:off x="4023360" y="7064654"/>
-            <a:ext cx="868680" cy="146304"/>
+            <a:off x="4023360" y="8252460"/>
+            <a:ext cx="1051560" cy="146304"/>
           </a:xfrm>
           <a:prstGeom prst="rect">
             <a:avLst/>
@@ -5959,14 +5835,14 @@
       </p:sp>
       <p:sp>
         <p:nvSpPr>
-          <p:cNvPr id="68" name="Timeline: Zeroth nautical mile"/>
+          <p:cNvPr id="68" name="Timeline label: Zeroth nautical mile"/>
           <p:cNvSpPr txBox="1"/>
           <p:nvPr/>
         </p:nvSpPr>
         <p:spPr>
           <a:xfrm>
-            <a:off x="4937760" y="7064654"/>
-            <a:ext cx="2450592" cy="852220"/>
+            <a:off x="5120640" y="8252460"/>
+            <a:ext cx="2267712" cy="146304"/>
           </a:xfrm>
           <a:prstGeom prst="rect">
             <a:avLst/>
@@ -5979,35 +5855,15 @@
           </a:bodyPr>
           <a:lstStyle/>
           <a:p>
-            <a:pPr algn="l">
-              <a:lnSpc>
-                <a:spcPct val="100000"/>
-              </a:lnSpc>
-            </a:pPr>
-            <a:r>
-              <a:rPr sz="850" b="1">
-                <a:solidFill>
-                  <a:srgbClr val="18181B"/>
+            <a:pPr algn="l"/>
+            <a:r>
+              <a:rPr sz="800" b="0">
+                <a:solidFill>
+                  <a:srgbClr val="3F3F46"/>
                 </a:solidFill>
                 <a:latin typeface="Arial"/>
               </a:rPr>
               <a:t>Zeroth nautical mile</a:t>
-            </a:r>
-          </a:p>
-          <a:p>
-            <a:pPr algn="l">
-              <a:lnSpc>
-                <a:spcPct val="100000"/>
-              </a:lnSpc>
-            </a:pPr>
-            <a:r>
-              <a:rPr sz="750" b="0">
-                <a:solidFill>
-                  <a:srgbClr val="3F3F46"/>
-                </a:solidFill>
-                <a:latin typeface="Arial"/>
-              </a:rPr>
-              <a:t>The first time everything is powered on in the hull: all microcontrollers, sensors and actuators. The first motor and propeller spin with the boat lifted in the air, and the first propulsion and navigation test commanded by the autonomous pipeline.</a:t>
             </a:r>
           </a:p>
         </p:txBody>
@@ -6020,7 +5876,7 @@
         </p:nvSpPr>
         <p:spPr>
           <a:xfrm>
-            <a:off x="4023360" y="7916875"/>
+            <a:off x="4023360" y="8412480"/>
             <a:ext cx="3364992" cy="9144"/>
           </a:xfrm>
           <a:prstGeom prst="rect">
@@ -6064,8 +5920,8 @@
         </p:nvSpPr>
         <p:spPr>
           <a:xfrm>
-            <a:off x="4023360" y="7962595"/>
-            <a:ext cx="868680" cy="146304"/>
+            <a:off x="4023360" y="8453628"/>
+            <a:ext cx="1051560" cy="146304"/>
           </a:xfrm>
           <a:prstGeom prst="rect">
             <a:avLst/>
@@ -6093,14 +5949,14 @@
       </p:sp>
       <p:sp>
         <p:nvSpPr>
-          <p:cNvPr id="71" name="Timeline: Slow drives on the water"/>
+          <p:cNvPr id="71" name="Timeline label: Slow drives on the water"/>
           <p:cNvSpPr txBox="1"/>
           <p:nvPr/>
         </p:nvSpPr>
         <p:spPr>
           <a:xfrm>
-            <a:off x="4937760" y="7962595"/>
-            <a:ext cx="2450592" cy="405993"/>
+            <a:off x="5120640" y="8453628"/>
+            <a:ext cx="2267712" cy="146304"/>
           </a:xfrm>
           <a:prstGeom prst="rect">
             <a:avLst/>
@@ -6113,35 +5969,15 @@
           </a:bodyPr>
           <a:lstStyle/>
           <a:p>
-            <a:pPr algn="l">
-              <a:lnSpc>
-                <a:spcPct val="100000"/>
-              </a:lnSpc>
-            </a:pPr>
-            <a:r>
-              <a:rPr sz="850" b="1">
-                <a:solidFill>
-                  <a:srgbClr val="18181B"/>
+            <a:pPr algn="l"/>
+            <a:r>
+              <a:rPr sz="800" b="0">
+                <a:solidFill>
+                  <a:srgbClr val="3F3F46"/>
                 </a:solidFill>
                 <a:latin typeface="Arial"/>
               </a:rPr>
               <a:t>Slow drives on the water</a:t>
-            </a:r>
-          </a:p>
-          <a:p>
-            <a:pPr algn="l">
-              <a:lnSpc>
-                <a:spcPct val="100000"/>
-              </a:lnSpc>
-            </a:pPr>
-            <a:r>
-              <a:rPr sz="750" b="0">
-                <a:solidFill>
-                  <a:srgbClr val="3F3F46"/>
-                </a:solidFill>
-                <a:latin typeface="Arial"/>
-              </a:rPr>
-              <a:t>Fully manual first, by remote command, then adding autonomy over time.</a:t>
             </a:r>
           </a:p>
         </p:txBody>
@@ -6154,7 +5990,7 @@
         </p:nvSpPr>
         <p:spPr>
           <a:xfrm>
-            <a:off x="4023360" y="8368588"/>
+            <a:off x="4023360" y="8613648"/>
             <a:ext cx="3364992" cy="9144"/>
           </a:xfrm>
           <a:prstGeom prst="rect">
@@ -6198,8 +6034,8 @@
         </p:nvSpPr>
         <p:spPr>
           <a:xfrm>
-            <a:off x="4023360" y="8414308"/>
-            <a:ext cx="868680" cy="146304"/>
+            <a:off x="4023360" y="8654796"/>
+            <a:ext cx="1051560" cy="146304"/>
           </a:xfrm>
           <a:prstGeom prst="rect">
             <a:avLst/>
@@ -6227,14 +6063,14 @@
       </p:sp>
       <p:sp>
         <p:nvSpPr>
-          <p:cNvPr id="74" name="Timeline: Start increasing speed"/>
+          <p:cNvPr id="74" name="Timeline label: Start increasing speed"/>
           <p:cNvSpPr txBox="1"/>
           <p:nvPr/>
         </p:nvSpPr>
         <p:spPr>
           <a:xfrm>
-            <a:off x="4937760" y="8414308"/>
-            <a:ext cx="2450592" cy="182880"/>
+            <a:off x="5120640" y="8654796"/>
+            <a:ext cx="2267712" cy="146304"/>
           </a:xfrm>
           <a:prstGeom prst="rect">
             <a:avLst/>
@@ -6247,15 +6083,11 @@
           </a:bodyPr>
           <a:lstStyle/>
           <a:p>
-            <a:pPr algn="l">
-              <a:lnSpc>
-                <a:spcPct val="100000"/>
-              </a:lnSpc>
-            </a:pPr>
-            <a:r>
-              <a:rPr sz="850" b="1">
-                <a:solidFill>
-                  <a:srgbClr val="18181B"/>
+            <a:pPr algn="l"/>
+            <a:r>
+              <a:rPr sz="800" b="0">
+                <a:solidFill>
+                  <a:srgbClr val="3F3F46"/>
                 </a:solidFill>
                 <a:latin typeface="Arial"/>
               </a:rPr>
@@ -6272,7 +6104,7 @@
         </p:nvSpPr>
         <p:spPr>
           <a:xfrm>
-            <a:off x="4023360" y="8597188"/>
+            <a:off x="4023360" y="8814816"/>
             <a:ext cx="3364992" cy="9144"/>
           </a:xfrm>
           <a:prstGeom prst="rect">
@@ -6316,8 +6148,8 @@
         </p:nvSpPr>
         <p:spPr>
           <a:xfrm>
-            <a:off x="4023360" y="8642908"/>
-            <a:ext cx="868680" cy="146304"/>
+            <a:off x="4023360" y="8855964"/>
+            <a:ext cx="1051560" cy="146304"/>
           </a:xfrm>
           <a:prstGeom prst="rect">
             <a:avLst/>
@@ -6345,14 +6177,14 @@
       </p:sp>
       <p:sp>
         <p:nvSpPr>
-          <p:cNvPr id="77" name="Timeline: Test as much as possible"/>
+          <p:cNvPr id="77" name="Timeline label: Test as much as possible"/>
           <p:cNvSpPr txBox="1"/>
           <p:nvPr/>
         </p:nvSpPr>
         <p:spPr>
           <a:xfrm>
-            <a:off x="4937760" y="8642908"/>
-            <a:ext cx="2450592" cy="405993"/>
+            <a:off x="5120640" y="8855964"/>
+            <a:ext cx="2267712" cy="146304"/>
           </a:xfrm>
           <a:prstGeom prst="rect">
             <a:avLst/>
@@ -6365,35 +6197,15 @@
           </a:bodyPr>
           <a:lstStyle/>
           <a:p>
-            <a:pPr algn="l">
-              <a:lnSpc>
-                <a:spcPct val="100000"/>
-              </a:lnSpc>
-            </a:pPr>
-            <a:r>
-              <a:rPr sz="850" b="1">
-                <a:solidFill>
-                  <a:srgbClr val="18181B"/>
+            <a:pPr algn="l"/>
+            <a:r>
+              <a:rPr sz="800" b="0">
+                <a:solidFill>
+                  <a:srgbClr val="3F3F46"/>
                 </a:solidFill>
                 <a:latin typeface="Arial"/>
               </a:rPr>
               <a:t>Test as much as possible</a:t>
-            </a:r>
-          </a:p>
-          <a:p>
-            <a:pPr algn="l">
-              <a:lnSpc>
-                <a:spcPct val="100000"/>
-              </a:lnSpc>
-            </a:pPr>
-            <a:r>
-              <a:rPr sz="750" b="0">
-                <a:solidFill>
-                  <a:srgbClr val="3F3F46"/>
-                </a:solidFill>
-                <a:latin typeface="Arial"/>
-              </a:rPr>
-              <a:t>Right up to the competition, working through the hardware and software issues that come up.</a:t>
             </a:r>
           </a:p>
         </p:txBody>

</xml_diff>

<commit_message>
Timeline: new dates and wording from the team plan, hard dates throughout
Co-Authored-By: Claude Sonnet 5.5 <noreply@anthropic.com>
</commit_message>
<xml_diff>
--- a/dashboard/public/haav-handout.pptx
+++ b/dashboard/public/haav-handout.pptx
@@ -4958,7 +4958,7 @@
       </p:sp>
       <p:sp>
         <p:nvSpPr>
-          <p:cNvPr id="45" name="Timeline rule: Current hull design frozen"/>
+          <p:cNvPr id="45" name="Timeline rule: Hull design frozen"/>
           <p:cNvSpPr/>
           <p:nvPr/>
         </p:nvSpPr>
@@ -5002,7 +5002,7 @@
       </p:sp>
       <p:sp>
         <p:nvSpPr>
-          <p:cNvPr id="46" name="Timeline date: Current hull design frozen"/>
+          <p:cNvPr id="46" name="Timeline date: Hull design frozen"/>
           <p:cNvSpPr txBox="1"/>
           <p:nvPr/>
         </p:nvSpPr>
@@ -5037,7 +5037,7 @@
       </p:sp>
       <p:sp>
         <p:nvSpPr>
-          <p:cNvPr id="47" name="Timeline label: Current hull design frozen"/>
+          <p:cNvPr id="47" name="Timeline label: Hull design frozen"/>
           <p:cNvSpPr txBox="1"/>
           <p:nvPr/>
         </p:nvSpPr>
@@ -5065,7 +5065,7 @@
                 </a:solidFill>
                 <a:latin typeface="Arial"/>
               </a:rPr>
-              <a:t>Current hull design frozen</a:t>
+              <a:t>Hull design frozen</a:t>
             </a:r>
           </a:p>
         </p:txBody>
@@ -5144,7 +5144,7 @@
                 </a:solidFill>
                 <a:latin typeface="Arial"/>
               </a:rPr>
-              <a:t>Nov 15</a:t>
+              <a:t>Nov 1</a:t>
             </a:r>
           </a:p>
         </p:txBody>
@@ -5186,7 +5186,7 @@
       </p:sp>
       <p:sp>
         <p:nvSpPr>
-          <p:cNvPr id="51" name="Timeline rule: Mechanical and electrical design frozen"/>
+          <p:cNvPr id="51" name="Timeline rule: Critical and long-lead parts ordered"/>
           <p:cNvSpPr/>
           <p:nvPr/>
         </p:nvSpPr>
@@ -5230,7 +5230,7 @@
       </p:sp>
       <p:sp>
         <p:nvSpPr>
-          <p:cNvPr id="52" name="Timeline date: Mechanical and electrical design frozen"/>
+          <p:cNvPr id="52" name="Timeline date: Critical and long-lead parts ordered"/>
           <p:cNvSpPr txBox="1"/>
           <p:nvPr/>
         </p:nvSpPr>
@@ -5258,14 +5258,14 @@
                 </a:solidFill>
                 <a:latin typeface="Arial"/>
               </a:rPr>
-              <a:t>Dec 1</a:t>
-            </a:r>
-          </a:p>
-        </p:txBody>
-      </p:sp>
-      <p:sp>
-        <p:nvSpPr>
-          <p:cNvPr id="53" name="Timeline label: Mechanical and electrical design frozen"/>
+              <a:t>Nov 10</a:t>
+            </a:r>
+          </a:p>
+        </p:txBody>
+      </p:sp>
+      <p:sp>
+        <p:nvSpPr>
+          <p:cNvPr id="53" name="Timeline label: Critical and long-lead parts ordered"/>
           <p:cNvSpPr txBox="1"/>
           <p:nvPr/>
         </p:nvSpPr>
@@ -5293,14 +5293,14 @@
                 </a:solidFill>
                 <a:latin typeface="Arial"/>
               </a:rPr>
-              <a:t>Mechanical and electrical design frozen</a:t>
-            </a:r>
-          </a:p>
-        </p:txBody>
-      </p:sp>
-      <p:sp>
-        <p:nvSpPr>
-          <p:cNvPr id="54" name="Timeline rule: Build the hull and composite parts"/>
+              <a:t>Critical and long-lead parts ordered</a:t>
+            </a:r>
+          </a:p>
+        </p:txBody>
+      </p:sp>
+      <p:sp>
+        <p:nvSpPr>
+          <p:cNvPr id="54" name="Timeline rule: Mechanical and electrical design frozen"/>
           <p:cNvSpPr/>
           <p:nvPr/>
         </p:nvSpPr>
@@ -5344,7 +5344,7 @@
       </p:sp>
       <p:sp>
         <p:nvSpPr>
-          <p:cNvPr id="55" name="Timeline date: Build the hull and composite parts"/>
+          <p:cNvPr id="55" name="Timeline date: Mechanical and electrical design frozen"/>
           <p:cNvSpPr txBox="1"/>
           <p:nvPr/>
         </p:nvSpPr>
@@ -5372,14 +5372,14 @@
                 </a:solidFill>
                 <a:latin typeface="Arial"/>
               </a:rPr>
-              <a:t>Dec 1–31</a:t>
-            </a:r>
-          </a:p>
-        </p:txBody>
-      </p:sp>
-      <p:sp>
-        <p:nvSpPr>
-          <p:cNvPr id="56" name="Timeline label: Build the hull and composite parts"/>
+              <a:t>Nov 20</a:t>
+            </a:r>
+          </a:p>
+        </p:txBody>
+      </p:sp>
+      <p:sp>
+        <p:nvSpPr>
+          <p:cNvPr id="56" name="Timeline label: Mechanical and electrical design frozen"/>
           <p:cNvSpPr txBox="1"/>
           <p:nvPr/>
         </p:nvSpPr>
@@ -5407,14 +5407,14 @@
                 </a:solidFill>
                 <a:latin typeface="Arial"/>
               </a:rPr>
-              <a:t>Build the hull and composite parts</a:t>
-            </a:r>
-          </a:p>
-        </p:txBody>
-      </p:sp>
-      <p:sp>
-        <p:nvSpPr>
-          <p:cNvPr id="57" name="Timeline rule: Manufacture and assemble everything"/>
+              <a:t>Mechanical and electrical design frozen</a:t>
+            </a:r>
+          </a:p>
+        </p:txBody>
+      </p:sp>
+      <p:sp>
+        <p:nvSpPr>
+          <p:cNvPr id="57" name="Timeline rule: Build the hull and composite parts"/>
           <p:cNvSpPr/>
           <p:nvPr/>
         </p:nvSpPr>
@@ -5458,7 +5458,7 @@
       </p:sp>
       <p:sp>
         <p:nvSpPr>
-          <p:cNvPr id="58" name="Timeline date: Manufacture and assemble everything"/>
+          <p:cNvPr id="58" name="Timeline date: Build the hull and composite parts"/>
           <p:cNvSpPr txBox="1"/>
           <p:nvPr/>
         </p:nvSpPr>
@@ -5486,14 +5486,14 @@
                 </a:solidFill>
                 <a:latin typeface="Arial"/>
               </a:rPr>
-              <a:t>Jan 11–28</a:t>
-            </a:r>
-          </a:p>
-        </p:txBody>
-      </p:sp>
-      <p:sp>
-        <p:nvSpPr>
-          <p:cNvPr id="59" name="Timeline label: Manufacture and assemble everything"/>
+              <a:t>Nov 20–Dec 20</a:t>
+            </a:r>
+          </a:p>
+        </p:txBody>
+      </p:sp>
+      <p:sp>
+        <p:nvSpPr>
+          <p:cNvPr id="59" name="Timeline label: Build the hull and composite parts"/>
           <p:cNvSpPr txBox="1"/>
           <p:nvPr/>
         </p:nvSpPr>
@@ -5521,14 +5521,14 @@
                 </a:solidFill>
                 <a:latin typeface="Arial"/>
               </a:rPr>
-              <a:t>Manufacture and assemble everything</a:t>
-            </a:r>
-          </a:p>
-        </p:txBody>
-      </p:sp>
-      <p:sp>
-        <p:nvSpPr>
-          <p:cNvPr id="60" name="Timeline rule: Build likely spare parts, in parallel"/>
+              <a:t>Build the hull and composite parts</a:t>
+            </a:r>
+          </a:p>
+        </p:txBody>
+      </p:sp>
+      <p:sp>
+        <p:nvSpPr>
+          <p:cNvPr id="60" name="Timeline rule: First float and tow test"/>
           <p:cNvSpPr/>
           <p:nvPr/>
         </p:nvSpPr>
@@ -5572,7 +5572,7 @@
       </p:sp>
       <p:sp>
         <p:nvSpPr>
-          <p:cNvPr id="61" name="Timeline date: Build likely spare parts, in parallel"/>
+          <p:cNvPr id="61" name="Timeline date: First float and tow test"/>
           <p:cNvSpPr txBox="1"/>
           <p:nvPr/>
         </p:nvSpPr>
@@ -5600,14 +5600,14 @@
                 </a:solidFill>
                 <a:latin typeface="Arial"/>
               </a:rPr>
-              <a:t>Jan 11–Feb 26</a:t>
-            </a:r>
-          </a:p>
-        </p:txBody>
-      </p:sp>
-      <p:sp>
-        <p:nvSpPr>
-          <p:cNvPr id="62" name="Timeline label: Build likely spare parts, in parallel"/>
+              <a:t>Jan 8</a:t>
+            </a:r>
+          </a:p>
+        </p:txBody>
+      </p:sp>
+      <p:sp>
+        <p:nvSpPr>
+          <p:cNvPr id="62" name="Timeline label: First float and tow test"/>
           <p:cNvSpPr txBox="1"/>
           <p:nvPr/>
         </p:nvSpPr>
@@ -5635,14 +5635,14 @@
                 </a:solidFill>
                 <a:latin typeface="Arial"/>
               </a:rPr>
-              <a:t>Build likely spare parts, in parallel</a:t>
-            </a:r>
-          </a:p>
-        </p:txBody>
-      </p:sp>
-      <p:sp>
-        <p:nvSpPr>
-          <p:cNvPr id="63" name="Timeline rule: First float and tow test"/>
+              <a:t>First float and tow test</a:t>
+            </a:r>
+          </a:p>
+        </p:txBody>
+      </p:sp>
+      <p:sp>
+        <p:nvSpPr>
+          <p:cNvPr id="63" name="Timeline rule: Manufacture and assemble everything"/>
           <p:cNvSpPr/>
           <p:nvPr/>
         </p:nvSpPr>
@@ -5686,7 +5686,7 @@
       </p:sp>
       <p:sp>
         <p:nvSpPr>
-          <p:cNvPr id="64" name="Timeline date: First float and tow test"/>
+          <p:cNvPr id="64" name="Timeline date: Manufacture and assemble everything"/>
           <p:cNvSpPr txBox="1"/>
           <p:nvPr/>
         </p:nvSpPr>
@@ -5714,14 +5714,14 @@
                 </a:solidFill>
                 <a:latin typeface="Arial"/>
               </a:rPr>
-              <a:t>Jan 22</a:t>
-            </a:r>
-          </a:p>
-        </p:txBody>
-      </p:sp>
-      <p:sp>
-        <p:nvSpPr>
-          <p:cNvPr id="65" name="Timeline label: First float and tow test"/>
+              <a:t>Jan 8–30</a:t>
+            </a:r>
+          </a:p>
+        </p:txBody>
+      </p:sp>
+      <p:sp>
+        <p:nvSpPr>
+          <p:cNvPr id="65" name="Timeline label: Manufacture and assemble everything"/>
           <p:cNvSpPr txBox="1"/>
           <p:nvPr/>
         </p:nvSpPr>
@@ -5749,14 +5749,14 @@
                 </a:solidFill>
                 <a:latin typeface="Arial"/>
               </a:rPr>
-              <a:t>First float and tow test</a:t>
-            </a:r>
-          </a:p>
-        </p:txBody>
-      </p:sp>
-      <p:sp>
-        <p:nvSpPr>
-          <p:cNvPr id="66" name="Timeline rule: Zeroth nautical mile"/>
+              <a:t>Manufacture and assemble everything</a:t>
+            </a:r>
+          </a:p>
+        </p:txBody>
+      </p:sp>
+      <p:sp>
+        <p:nvSpPr>
+          <p:cNvPr id="66" name="Timeline rule: Build likely spare parts, in parallel"/>
           <p:cNvSpPr/>
           <p:nvPr/>
         </p:nvSpPr>
@@ -5800,7 +5800,7 @@
       </p:sp>
       <p:sp>
         <p:nvSpPr>
-          <p:cNvPr id="67" name="Timeline date: Zeroth nautical mile"/>
+          <p:cNvPr id="67" name="Timeline date: Build likely spare parts, in parallel"/>
           <p:cNvSpPr txBox="1"/>
           <p:nvPr/>
         </p:nvSpPr>
@@ -5828,14 +5828,14 @@
                 </a:solidFill>
                 <a:latin typeface="Arial"/>
               </a:rPr>
-              <a:t>Jan 29</a:t>
-            </a:r>
-          </a:p>
-        </p:txBody>
-      </p:sp>
-      <p:sp>
-        <p:nvSpPr>
-          <p:cNvPr id="68" name="Timeline label: Zeroth nautical mile"/>
+              <a:t>Jan 8–30</a:t>
+            </a:r>
+          </a:p>
+        </p:txBody>
+      </p:sp>
+      <p:sp>
+        <p:nvSpPr>
+          <p:cNvPr id="68" name="Timeline label: Build likely spare parts, in parallel"/>
           <p:cNvSpPr txBox="1"/>
           <p:nvPr/>
         </p:nvSpPr>
@@ -5863,14 +5863,14 @@
                 </a:solidFill>
                 <a:latin typeface="Arial"/>
               </a:rPr>
-              <a:t>Zeroth nautical mile</a:t>
-            </a:r>
-          </a:p>
-        </p:txBody>
-      </p:sp>
-      <p:sp>
-        <p:nvSpPr>
-          <p:cNvPr id="69" name="Timeline rule: Slow drives on the water"/>
+              <a:t>Build likely spare parts, in parallel</a:t>
+            </a:r>
+          </a:p>
+        </p:txBody>
+      </p:sp>
+      <p:sp>
+        <p:nvSpPr>
+          <p:cNvPr id="69" name="Timeline rule: First nautical mile"/>
           <p:cNvSpPr/>
           <p:nvPr/>
         </p:nvSpPr>
@@ -5914,7 +5914,7 @@
       </p:sp>
       <p:sp>
         <p:nvSpPr>
-          <p:cNvPr id="70" name="Timeline date: Slow drives on the water"/>
+          <p:cNvPr id="70" name="Timeline date: First nautical mile"/>
           <p:cNvSpPr txBox="1"/>
           <p:nvPr/>
         </p:nvSpPr>
@@ -5942,14 +5942,14 @@
                 </a:solidFill>
                 <a:latin typeface="Arial"/>
               </a:rPr>
-              <a:t>Feb 1–14</a:t>
-            </a:r>
-          </a:p>
-        </p:txBody>
-      </p:sp>
-      <p:sp>
-        <p:nvSpPr>
-          <p:cNvPr id="71" name="Timeline label: Slow drives on the water"/>
+              <a:t>Jan 31</a:t>
+            </a:r>
+          </a:p>
+        </p:txBody>
+      </p:sp>
+      <p:sp>
+        <p:nvSpPr>
+          <p:cNvPr id="71" name="Timeline label: First nautical mile"/>
           <p:cNvSpPr txBox="1"/>
           <p:nvPr/>
         </p:nvSpPr>
@@ -5977,14 +5977,14 @@
                 </a:solidFill>
                 <a:latin typeface="Arial"/>
               </a:rPr>
-              <a:t>Slow drives on the water</a:t>
-            </a:r>
-          </a:p>
-        </p:txBody>
-      </p:sp>
-      <p:sp>
-        <p:nvSpPr>
-          <p:cNvPr id="72" name="Timeline rule: Start increasing speed"/>
+              <a:t>First nautical mile</a:t>
+            </a:r>
+          </a:p>
+        </p:txBody>
+      </p:sp>
+      <p:sp>
+        <p:nvSpPr>
+          <p:cNvPr id="72" name="Timeline rule: Slow drives on the water"/>
           <p:cNvSpPr/>
           <p:nvPr/>
         </p:nvSpPr>
@@ -6028,7 +6028,7 @@
       </p:sp>
       <p:sp>
         <p:nvSpPr>
-          <p:cNvPr id="73" name="Timeline date: Start increasing speed"/>
+          <p:cNvPr id="73" name="Timeline date: Slow drives on the water"/>
           <p:cNvSpPr txBox="1"/>
           <p:nvPr/>
         </p:nvSpPr>
@@ -6056,14 +6056,14 @@
                 </a:solidFill>
                 <a:latin typeface="Arial"/>
               </a:rPr>
-              <a:t>Feb 15</a:t>
-            </a:r>
-          </a:p>
-        </p:txBody>
-      </p:sp>
-      <p:sp>
-        <p:nvSpPr>
-          <p:cNvPr id="74" name="Timeline label: Start increasing speed"/>
+              <a:t>Feb 1–14</a:t>
+            </a:r>
+          </a:p>
+        </p:txBody>
+      </p:sp>
+      <p:sp>
+        <p:nvSpPr>
+          <p:cNvPr id="74" name="Timeline label: Slow drives on the water"/>
           <p:cNvSpPr txBox="1"/>
           <p:nvPr/>
         </p:nvSpPr>
@@ -6091,14 +6091,14 @@
                 </a:solidFill>
                 <a:latin typeface="Arial"/>
               </a:rPr>
-              <a:t>Start increasing speed</a:t>
-            </a:r>
-          </a:p>
-        </p:txBody>
-      </p:sp>
-      <p:sp>
-        <p:nvSpPr>
-          <p:cNvPr id="75" name="Timeline rule: Test as much as possible"/>
+              <a:t>Slow drives on the water</a:t>
+            </a:r>
+          </a:p>
+        </p:txBody>
+      </p:sp>
+      <p:sp>
+        <p:nvSpPr>
+          <p:cNvPr id="75" name="Timeline rule: Start increasing speed"/>
           <p:cNvSpPr/>
           <p:nvPr/>
         </p:nvSpPr>
@@ -6142,7 +6142,7 @@
       </p:sp>
       <p:sp>
         <p:nvSpPr>
-          <p:cNvPr id="76" name="Timeline date: Test as much as possible"/>
+          <p:cNvPr id="76" name="Timeline date: Start increasing speed"/>
           <p:cNvSpPr txBox="1"/>
           <p:nvPr/>
         </p:nvSpPr>
@@ -6170,14 +6170,14 @@
                 </a:solidFill>
                 <a:latin typeface="Arial"/>
               </a:rPr>
-              <a:t>From Feb 15</a:t>
-            </a:r>
-          </a:p>
-        </p:txBody>
-      </p:sp>
-      <p:sp>
-        <p:nvSpPr>
-          <p:cNvPr id="77" name="Timeline label: Test as much as possible"/>
+              <a:t>Feb 15</a:t>
+            </a:r>
+          </a:p>
+        </p:txBody>
+      </p:sp>
+      <p:sp>
+        <p:nvSpPr>
+          <p:cNvPr id="77" name="Timeline label: Start increasing speed"/>
           <p:cNvSpPr txBox="1"/>
           <p:nvPr/>
         </p:nvSpPr>
@@ -6205,14 +6205,128 @@
                 </a:solidFill>
                 <a:latin typeface="Arial"/>
               </a:rPr>
-              <a:t>Test as much as possible</a:t>
-            </a:r>
-          </a:p>
-        </p:txBody>
-      </p:sp>
-      <p:sp>
-        <p:nvSpPr>
-          <p:cNvPr id="78" name="Footer band"/>
+              <a:t>Start increasing speed</a:t>
+            </a:r>
+          </a:p>
+        </p:txBody>
+      </p:sp>
+      <p:sp>
+        <p:nvSpPr>
+          <p:cNvPr id="78" name="Timeline rule: Testing and tuning"/>
+          <p:cNvSpPr/>
+          <p:nvPr/>
+        </p:nvSpPr>
+        <p:spPr>
+          <a:xfrm>
+            <a:off x="4023360" y="9015984"/>
+            <a:ext cx="3364992" cy="9144"/>
+          </a:xfrm>
+          <a:prstGeom prst="rect">
+            <a:avLst/>
+          </a:prstGeom>
+          <a:solidFill>
+            <a:srgbClr val="E4E4E7"/>
+          </a:solidFill>
+          <a:ln>
+            <a:noFill/>
+          </a:ln>
+          <a:effectLst/>
+        </p:spPr>
+        <p:style>
+          <a:lnRef idx="1">
+            <a:schemeClr val="accent1"/>
+          </a:lnRef>
+          <a:fillRef idx="3">
+            <a:schemeClr val="accent1"/>
+          </a:fillRef>
+          <a:effectRef idx="2">
+            <a:schemeClr val="accent1"/>
+          </a:effectRef>
+          <a:fontRef idx="minor">
+            <a:schemeClr val="lt1"/>
+          </a:fontRef>
+        </p:style>
+        <p:txBody>
+          <a:bodyPr rtlCol="0" anchor="ctr"/>
+          <a:lstStyle/>
+          <a:p>
+            <a:pPr algn="ctr"/>
+          </a:p>
+        </p:txBody>
+      </p:sp>
+      <p:sp>
+        <p:nvSpPr>
+          <p:cNvPr id="79" name="Timeline date: Testing and tuning"/>
+          <p:cNvSpPr txBox="1"/>
+          <p:nvPr/>
+        </p:nvSpPr>
+        <p:spPr>
+          <a:xfrm>
+            <a:off x="4023360" y="9057132"/>
+            <a:ext cx="1051560" cy="146304"/>
+          </a:xfrm>
+          <a:prstGeom prst="rect">
+            <a:avLst/>
+          </a:prstGeom>
+          <a:noFill/>
+        </p:spPr>
+        <p:txBody>
+          <a:bodyPr wrap="square" lIns="0" rIns="0" tIns="0" bIns="0" anchor="t">
+            <a:spAutoFit/>
+          </a:bodyPr>
+          <a:lstStyle/>
+          <a:p>
+            <a:pPr algn="l"/>
+            <a:r>
+              <a:rPr sz="800" b="1">
+                <a:solidFill>
+                  <a:srgbClr val="C5050C"/>
+                </a:solidFill>
+                <a:latin typeface="Arial"/>
+              </a:rPr>
+              <a:t>Until April</a:t>
+            </a:r>
+          </a:p>
+        </p:txBody>
+      </p:sp>
+      <p:sp>
+        <p:nvSpPr>
+          <p:cNvPr id="80" name="Timeline label: Testing and tuning"/>
+          <p:cNvSpPr txBox="1"/>
+          <p:nvPr/>
+        </p:nvSpPr>
+        <p:spPr>
+          <a:xfrm>
+            <a:off x="5120640" y="9057132"/>
+            <a:ext cx="2267712" cy="146304"/>
+          </a:xfrm>
+          <a:prstGeom prst="rect">
+            <a:avLst/>
+          </a:prstGeom>
+          <a:noFill/>
+        </p:spPr>
+        <p:txBody>
+          <a:bodyPr wrap="square" lIns="0" rIns="0" tIns="0" bIns="0" anchor="t">
+            <a:spAutoFit/>
+          </a:bodyPr>
+          <a:lstStyle/>
+          <a:p>
+            <a:pPr algn="l"/>
+            <a:r>
+              <a:rPr sz="800" b="0">
+                <a:solidFill>
+                  <a:srgbClr val="3F3F46"/>
+                </a:solidFill>
+                <a:latin typeface="Arial"/>
+              </a:rPr>
+              <a:t>Testing and tuning</a:t>
+            </a:r>
+          </a:p>
+        </p:txBody>
+      </p:sp>
+      <p:sp>
+        <p:nvSpPr>
+          <p:cNvPr id="81" name="Footer band"/>
           <p:cNvSpPr/>
           <p:nvPr/>
         </p:nvSpPr>
@@ -6256,7 +6370,7 @@
       </p:sp>
       <p:sp>
         <p:nvSpPr>
-          <p:cNvPr id="79" name="Footer title"/>
+          <p:cNvPr id="82" name="Footer title"/>
           <p:cNvSpPr txBox="1"/>
           <p:nvPr/>
         </p:nvSpPr>
@@ -6291,7 +6405,7 @@
       </p:sp>
       <p:sp>
         <p:nvSpPr>
-          <p:cNvPr id="80" name="Footer tagline"/>
+          <p:cNvPr id="83" name="Footer tagline"/>
           <p:cNvSpPr txBox="1"/>
           <p:nvPr/>
         </p:nvSpPr>
@@ -6326,7 +6440,7 @@
       </p:sp>
       <p:sp>
         <p:nvSpPr>
-          <p:cNvPr id="81" name="Footer link label"/>
+          <p:cNvPr id="84" name="Footer link label"/>
           <p:cNvSpPr txBox="1"/>
           <p:nvPr/>
         </p:nvSpPr>
@@ -6361,7 +6475,7 @@
       </p:sp>
       <p:sp>
         <p:nvSpPr>
-          <p:cNvPr id="82" name="Footer link"/>
+          <p:cNvPr id="85" name="Footer link"/>
           <p:cNvSpPr txBox="1"/>
           <p:nvPr/>
         </p:nvSpPr>
@@ -6396,7 +6510,7 @@
       </p:sp>
       <p:sp>
         <p:nvSpPr>
-          <p:cNvPr id="83" name="Footer contact label"/>
+          <p:cNvPr id="86" name="Footer contact label"/>
           <p:cNvSpPr txBox="1"/>
           <p:nvPr/>
         </p:nvSpPr>
@@ -6431,7 +6545,7 @@
       </p:sp>
       <p:sp>
         <p:nvSpPr>
-          <p:cNvPr id="84" name="Footer contact name"/>
+          <p:cNvPr id="87" name="Footer contact name"/>
           <p:cNvSpPr txBox="1"/>
           <p:nvPr/>
         </p:nvSpPr>
@@ -6466,7 +6580,7 @@
       </p:sp>
       <p:sp>
         <p:nvSpPr>
-          <p:cNvPr id="85" name="Footer contact email"/>
+          <p:cNvPr id="88" name="Footer contact email"/>
           <p:cNvSpPr txBox="1"/>
           <p:nvPr/>
         </p:nvSpPr>

</xml_diff>

<commit_message>
Timeline: the team's exact wording with hard dates
Co-Authored-By: Claude Sonnet 5.5 <noreply@anthropic.com>
</commit_message>
<xml_diff>
--- a/dashboard/public/haav-handout.pptx
+++ b/dashboard/public/haav-handout.pptx
@@ -5078,7 +5078,7 @@
         </p:nvSpPr>
         <p:spPr>
           <a:xfrm>
-            <a:off x="384048" y="8211312"/>
+            <a:off x="384048" y="8193023"/>
             <a:ext cx="3364992" cy="9144"/>
           </a:xfrm>
           <a:prstGeom prst="rect">
@@ -5122,7 +5122,7 @@
         </p:nvSpPr>
         <p:spPr>
           <a:xfrm>
-            <a:off x="384048" y="8252460"/>
+            <a:off x="384048" y="8234171"/>
             <a:ext cx="1051560" cy="146304"/>
           </a:xfrm>
           <a:prstGeom prst="rect">
@@ -5157,7 +5157,7 @@
         </p:nvSpPr>
         <p:spPr>
           <a:xfrm>
-            <a:off x="1481328" y="8252460"/>
+            <a:off x="1481328" y="8234171"/>
             <a:ext cx="2267712" cy="146304"/>
           </a:xfrm>
           <a:prstGeom prst="rect">
@@ -5186,13 +5186,13 @@
       </p:sp>
       <p:sp>
         <p:nvSpPr>
-          <p:cNvPr id="51" name="Timeline rule: Critical and long-lead parts ordered"/>
+          <p:cNvPr id="51" name="Timeline rule: Critical and long-lead parts are ordered"/>
           <p:cNvSpPr/>
           <p:nvPr/>
         </p:nvSpPr>
         <p:spPr>
           <a:xfrm>
-            <a:off x="384048" y="8412480"/>
+            <a:off x="384048" y="8375903"/>
             <a:ext cx="3364992" cy="9144"/>
           </a:xfrm>
           <a:prstGeom prst="rect">
@@ -5230,13 +5230,13 @@
       </p:sp>
       <p:sp>
         <p:nvSpPr>
-          <p:cNvPr id="52" name="Timeline date: Critical and long-lead parts ordered"/>
+          <p:cNvPr id="52" name="Timeline date: Critical and long-lead parts are ordered"/>
           <p:cNvSpPr txBox="1"/>
           <p:nvPr/>
         </p:nvSpPr>
         <p:spPr>
           <a:xfrm>
-            <a:off x="384048" y="8453628"/>
+            <a:off x="384048" y="8417051"/>
             <a:ext cx="1051560" cy="146304"/>
           </a:xfrm>
           <a:prstGeom prst="rect">
@@ -5265,13 +5265,13 @@
       </p:sp>
       <p:sp>
         <p:nvSpPr>
-          <p:cNvPr id="53" name="Timeline label: Critical and long-lead parts ordered"/>
+          <p:cNvPr id="53" name="Timeline label: Critical and long-lead parts are ordered"/>
           <p:cNvSpPr txBox="1"/>
           <p:nvPr/>
         </p:nvSpPr>
         <p:spPr>
           <a:xfrm>
-            <a:off x="1481328" y="8453628"/>
+            <a:off x="1481328" y="8417051"/>
             <a:ext cx="2267712" cy="146304"/>
           </a:xfrm>
           <a:prstGeom prst="rect">
@@ -5293,7 +5293,7 @@
                 </a:solidFill>
                 <a:latin typeface="Arial"/>
               </a:rPr>
-              <a:t>Critical and long-lead parts ordered</a:t>
+              <a:t>Critical and long-lead parts are ordered</a:t>
             </a:r>
           </a:p>
         </p:txBody>
@@ -5306,7 +5306,7 @@
         </p:nvSpPr>
         <p:spPr>
           <a:xfrm>
-            <a:off x="384048" y="8613648"/>
+            <a:off x="384048" y="8558783"/>
             <a:ext cx="3364992" cy="9144"/>
           </a:xfrm>
           <a:prstGeom prst="rect">
@@ -5350,7 +5350,7 @@
         </p:nvSpPr>
         <p:spPr>
           <a:xfrm>
-            <a:off x="384048" y="8654796"/>
+            <a:off x="384048" y="8599931"/>
             <a:ext cx="1051560" cy="146304"/>
           </a:xfrm>
           <a:prstGeom prst="rect">
@@ -5385,7 +5385,7 @@
         </p:nvSpPr>
         <p:spPr>
           <a:xfrm>
-            <a:off x="1481328" y="8654796"/>
+            <a:off x="1481328" y="8599931"/>
             <a:ext cx="2267712" cy="146304"/>
           </a:xfrm>
           <a:prstGeom prst="rect">
@@ -5414,13 +5414,13 @@
       </p:sp>
       <p:sp>
         <p:nvSpPr>
-          <p:cNvPr id="57" name="Timeline rule: Build the hull and composite parts"/>
+          <p:cNvPr id="57" name="Timeline rule: Build the hull, composite parts and any custom-milled parts"/>
           <p:cNvSpPr/>
           <p:nvPr/>
         </p:nvSpPr>
         <p:spPr>
           <a:xfrm>
-            <a:off x="384048" y="8814816"/>
+            <a:off x="384048" y="8741663"/>
             <a:ext cx="3364992" cy="9144"/>
           </a:xfrm>
           <a:prstGeom prst="rect">
@@ -5458,13 +5458,13 @@
       </p:sp>
       <p:sp>
         <p:nvSpPr>
-          <p:cNvPr id="58" name="Timeline date: Build the hull and composite parts"/>
+          <p:cNvPr id="58" name="Timeline date: Build the hull, composite parts and any custom-milled parts"/>
           <p:cNvSpPr txBox="1"/>
           <p:nvPr/>
         </p:nvSpPr>
         <p:spPr>
           <a:xfrm>
-            <a:off x="384048" y="8855964"/>
+            <a:off x="384048" y="8782811"/>
             <a:ext cx="1051560" cy="146304"/>
           </a:xfrm>
           <a:prstGeom prst="rect">
@@ -5493,14 +5493,14 @@
       </p:sp>
       <p:sp>
         <p:nvSpPr>
-          <p:cNvPr id="59" name="Timeline label: Build the hull and composite parts"/>
+          <p:cNvPr id="59" name="Timeline label: Build the hull, composite parts and any custom-milled parts"/>
           <p:cNvSpPr txBox="1"/>
           <p:nvPr/>
         </p:nvSpPr>
         <p:spPr>
           <a:xfrm>
-            <a:off x="1481328" y="8855964"/>
-            <a:ext cx="2267712" cy="146304"/>
+            <a:off x="1481328" y="8782811"/>
+            <a:ext cx="2267712" cy="265176"/>
           </a:xfrm>
           <a:prstGeom prst="rect">
             <a:avLst/>
@@ -5521,7 +5521,7 @@
                 </a:solidFill>
                 <a:latin typeface="Arial"/>
               </a:rPr>
-              <a:t>Build the hull and composite parts</a:t>
+              <a:t>Build the hull, composite parts and any custom-milled parts</a:t>
             </a:r>
           </a:p>
         </p:txBody>
@@ -5534,7 +5534,7 @@
         </p:nvSpPr>
         <p:spPr>
           <a:xfrm>
-            <a:off x="384048" y="9015984"/>
+            <a:off x="384048" y="9043415"/>
             <a:ext cx="3364992" cy="9144"/>
           </a:xfrm>
           <a:prstGeom prst="rect">
@@ -5578,7 +5578,7 @@
         </p:nvSpPr>
         <p:spPr>
           <a:xfrm>
-            <a:off x="384048" y="9057132"/>
+            <a:off x="384048" y="9084563"/>
             <a:ext cx="1051560" cy="146304"/>
           </a:xfrm>
           <a:prstGeom prst="rect">
@@ -5613,7 +5613,7 @@
         </p:nvSpPr>
         <p:spPr>
           <a:xfrm>
-            <a:off x="1481328" y="9057132"/>
+            <a:off x="1481328" y="9084563"/>
             <a:ext cx="2267712" cy="146304"/>
           </a:xfrm>
           <a:prstGeom prst="rect">
@@ -5762,7 +5762,7 @@
         </p:nvSpPr>
         <p:spPr>
           <a:xfrm>
-            <a:off x="4023360" y="8211312"/>
+            <a:off x="4023360" y="8193023"/>
             <a:ext cx="3364992" cy="9144"/>
           </a:xfrm>
           <a:prstGeom prst="rect">
@@ -5806,7 +5806,7 @@
         </p:nvSpPr>
         <p:spPr>
           <a:xfrm>
-            <a:off x="4023360" y="8252460"/>
+            <a:off x="4023360" y="8234171"/>
             <a:ext cx="1051560" cy="146304"/>
           </a:xfrm>
           <a:prstGeom prst="rect">
@@ -5841,7 +5841,7 @@
         </p:nvSpPr>
         <p:spPr>
           <a:xfrm>
-            <a:off x="5120640" y="8252460"/>
+            <a:off x="5120640" y="8234171"/>
             <a:ext cx="2267712" cy="146304"/>
           </a:xfrm>
           <a:prstGeom prst="rect">
@@ -5876,7 +5876,7 @@
         </p:nvSpPr>
         <p:spPr>
           <a:xfrm>
-            <a:off x="4023360" y="8412480"/>
+            <a:off x="4023360" y="8375903"/>
             <a:ext cx="3364992" cy="9144"/>
           </a:xfrm>
           <a:prstGeom prst="rect">
@@ -5920,7 +5920,7 @@
         </p:nvSpPr>
         <p:spPr>
           <a:xfrm>
-            <a:off x="4023360" y="8453628"/>
+            <a:off x="4023360" y="8417051"/>
             <a:ext cx="1051560" cy="146304"/>
           </a:xfrm>
           <a:prstGeom prst="rect">
@@ -5955,7 +5955,7 @@
         </p:nvSpPr>
         <p:spPr>
           <a:xfrm>
-            <a:off x="5120640" y="8453628"/>
+            <a:off x="5120640" y="8417051"/>
             <a:ext cx="2267712" cy="146304"/>
           </a:xfrm>
           <a:prstGeom prst="rect">
@@ -5990,7 +5990,7 @@
         </p:nvSpPr>
         <p:spPr>
           <a:xfrm>
-            <a:off x="4023360" y="8613648"/>
+            <a:off x="4023360" y="8558783"/>
             <a:ext cx="3364992" cy="9144"/>
           </a:xfrm>
           <a:prstGeom prst="rect">
@@ -6034,7 +6034,7 @@
         </p:nvSpPr>
         <p:spPr>
           <a:xfrm>
-            <a:off x="4023360" y="8654796"/>
+            <a:off x="4023360" y="8599931"/>
             <a:ext cx="1051560" cy="146304"/>
           </a:xfrm>
           <a:prstGeom prst="rect">
@@ -6069,7 +6069,7 @@
         </p:nvSpPr>
         <p:spPr>
           <a:xfrm>
-            <a:off x="5120640" y="8654796"/>
+            <a:off x="5120640" y="8599931"/>
             <a:ext cx="2267712" cy="146304"/>
           </a:xfrm>
           <a:prstGeom prst="rect">
@@ -6104,7 +6104,7 @@
         </p:nvSpPr>
         <p:spPr>
           <a:xfrm>
-            <a:off x="4023360" y="8814816"/>
+            <a:off x="4023360" y="8741663"/>
             <a:ext cx="3364992" cy="9144"/>
           </a:xfrm>
           <a:prstGeom prst="rect">
@@ -6148,7 +6148,7 @@
         </p:nvSpPr>
         <p:spPr>
           <a:xfrm>
-            <a:off x="4023360" y="8855964"/>
+            <a:off x="4023360" y="8782811"/>
             <a:ext cx="1051560" cy="146304"/>
           </a:xfrm>
           <a:prstGeom prst="rect">
@@ -6183,7 +6183,7 @@
         </p:nvSpPr>
         <p:spPr>
           <a:xfrm>
-            <a:off x="5120640" y="8855964"/>
+            <a:off x="5120640" y="8782811"/>
             <a:ext cx="2267712" cy="146304"/>
           </a:xfrm>
           <a:prstGeom prst="rect">
@@ -6212,13 +6212,13 @@
       </p:sp>
       <p:sp>
         <p:nvSpPr>
-          <p:cNvPr id="78" name="Timeline rule: Testing and tuning"/>
+          <p:cNvPr id="78" name="Timeline rule: Testing / Tuning"/>
           <p:cNvSpPr/>
           <p:nvPr/>
         </p:nvSpPr>
         <p:spPr>
           <a:xfrm>
-            <a:off x="4023360" y="9015984"/>
+            <a:off x="4023360" y="8924543"/>
             <a:ext cx="3364992" cy="9144"/>
           </a:xfrm>
           <a:prstGeom prst="rect">
@@ -6256,13 +6256,13 @@
       </p:sp>
       <p:sp>
         <p:nvSpPr>
-          <p:cNvPr id="79" name="Timeline date: Testing and tuning"/>
+          <p:cNvPr id="79" name="Timeline date: Testing / Tuning"/>
           <p:cNvSpPr txBox="1"/>
           <p:nvPr/>
         </p:nvSpPr>
         <p:spPr>
           <a:xfrm>
-            <a:off x="4023360" y="9057132"/>
+            <a:off x="4023360" y="8965691"/>
             <a:ext cx="1051560" cy="146304"/>
           </a:xfrm>
           <a:prstGeom prst="rect">
@@ -6291,13 +6291,13 @@
       </p:sp>
       <p:sp>
         <p:nvSpPr>
-          <p:cNvPr id="80" name="Timeline label: Testing and tuning"/>
+          <p:cNvPr id="80" name="Timeline label: Testing / Tuning"/>
           <p:cNvSpPr txBox="1"/>
           <p:nvPr/>
         </p:nvSpPr>
         <p:spPr>
           <a:xfrm>
-            <a:off x="5120640" y="9057132"/>
+            <a:off x="5120640" y="8965691"/>
             <a:ext cx="2267712" cy="146304"/>
           </a:xfrm>
           <a:prstGeom prst="rect">
@@ -6319,7 +6319,7 @@
                 </a:solidFill>
                 <a:latin typeface="Arial"/>
               </a:rPr>
-              <a:t>Testing and tuning</a:t>
+              <a:t>Testing / Tuning</a:t>
             </a:r>
           </a:p>
         </p:txBody>

</xml_diff>

<commit_message>
style(design): cards back in, normal font, text UW-Madison mark
Co-Authored-By: Claude Sonnet 5.5 <noreply@anthropic.com>
</commit_message>
<xml_diff>
--- a/dashboard/public/haav-handout.pptx
+++ b/dashboard/public/haav-handout.pptx
@@ -3140,7 +3140,7 @@
         </p:nvSpPr>
         <p:spPr>
           <a:xfrm>
-            <a:off x="548640" y="329184"/>
+            <a:off x="502920" y="329184"/>
             <a:ext cx="2743200" cy="640080"/>
           </a:xfrm>
           <a:prstGeom prst="rect">
@@ -3156,7 +3156,7 @@
           <a:p>
             <a:pPr algn="l"/>
             <a:r>
-              <a:rPr sz="3900" b="1">
+              <a:rPr sz="3600" b="1">
                 <a:solidFill>
                   <a:srgbClr val="2B2620"/>
                 </a:solidFill>
@@ -3175,7 +3175,7 @@
         </p:nvSpPr>
         <p:spPr>
           <a:xfrm>
-            <a:off x="548640" y="969264"/>
+            <a:off x="502920" y="950976"/>
             <a:ext cx="3657600" cy="201168"/>
           </a:xfrm>
           <a:prstGeom prst="rect">
@@ -3202,9 +3202,118 @@
           </a:p>
         </p:txBody>
       </p:sp>
+      <p:sp>
+        <p:nvSpPr>
+          <p:cNvPr id="5" name="UW-Madison"/>
+          <p:cNvSpPr txBox="1"/>
+          <p:nvPr/>
+        </p:nvSpPr>
+        <p:spPr>
+          <a:xfrm>
+            <a:off x="4069080" y="365760"/>
+            <a:ext cx="3200400" cy="365760"/>
+          </a:xfrm>
+          <a:prstGeom prst="rect">
+            <a:avLst/>
+          </a:prstGeom>
+          <a:noFill/>
+        </p:spPr>
+        <p:txBody>
+          <a:bodyPr wrap="square" lIns="0" rIns="0" tIns="0" bIns="0" anchor="t">
+            <a:spAutoFit/>
+          </a:bodyPr>
+          <a:lstStyle/>
+          <a:p>
+            <a:pPr algn="r"/>
+            <a:r>
+              <a:rPr sz="1950" b="1">
+                <a:solidFill>
+                  <a:srgbClr val="C5050C"/>
+                </a:solidFill>
+                <a:latin typeface="Arial"/>
+              </a:rPr>
+              <a:t>UW–Madison</a:t>
+            </a:r>
+          </a:p>
+        </p:txBody>
+      </p:sp>
+      <p:sp>
+        <p:nvSpPr>
+          <p:cNvPr id="6" name="College of Engineering"/>
+          <p:cNvSpPr txBox="1"/>
+          <p:nvPr/>
+        </p:nvSpPr>
+        <p:spPr>
+          <a:xfrm>
+            <a:off x="4069080" y="731520"/>
+            <a:ext cx="3200400" cy="201168"/>
+          </a:xfrm>
+          <a:prstGeom prst="rect">
+            <a:avLst/>
+          </a:prstGeom>
+          <a:noFill/>
+        </p:spPr>
+        <p:txBody>
+          <a:bodyPr wrap="square" lIns="0" rIns="0" tIns="0" bIns="0" anchor="t">
+            <a:spAutoFit/>
+          </a:bodyPr>
+          <a:lstStyle/>
+          <a:p>
+            <a:pPr algn="r"/>
+            <a:r>
+              <a:rPr sz="975" b="0">
+                <a:solidFill>
+                  <a:srgbClr val="5A5249"/>
+                </a:solidFill>
+                <a:latin typeface="Arial"/>
+              </a:rPr>
+              <a:t>College of Engineering</a:t>
+            </a:r>
+          </a:p>
+        </p:txBody>
+      </p:sp>
+      <p:sp>
+        <p:nvSpPr>
+          <p:cNvPr id="7" name="Headline"/>
+          <p:cNvSpPr txBox="1"/>
+          <p:nvPr/>
+        </p:nvSpPr>
+        <p:spPr>
+          <a:xfrm>
+            <a:off x="502920" y="1572768"/>
+            <a:ext cx="3931920" cy="1188720"/>
+          </a:xfrm>
+          <a:prstGeom prst="rect">
+            <a:avLst/>
+          </a:prstGeom>
+          <a:noFill/>
+        </p:spPr>
+        <p:txBody>
+          <a:bodyPr wrap="square" lIns="0" rIns="0" tIns="0" bIns="0" anchor="t">
+            <a:spAutoFit/>
+          </a:bodyPr>
+          <a:lstStyle/>
+          <a:p>
+            <a:pPr algn="l">
+              <a:lnSpc>
+                <a:spcPct val="100000"/>
+              </a:lnSpc>
+            </a:pPr>
+            <a:r>
+              <a:rPr sz="2400" b="1">
+                <a:solidFill>
+                  <a:srgbClr val="2B2620"/>
+                </a:solidFill>
+                <a:latin typeface="Arial"/>
+              </a:rPr>
+              <a:t>A student team building an autonomous boat from the ground up.</a:t>
+            </a:r>
+          </a:p>
+        </p:txBody>
+      </p:sp>
       <p:pic>
         <p:nvPicPr>
-          <p:cNvPr id="5" name="UW-Madison logo" descr="uw-logo-horizontal.png"/>
+          <p:cNvPr id="8" name="Hull render" descr="haav-hull-paper.png"/>
           <p:cNvPicPr>
             <a:picLocks noChangeAspect="1"/>
           </p:cNvPicPr>
@@ -3217,9 +3326,9 @@
           </a:stretch>
         </p:blipFill>
         <p:spPr>
-          <a:xfrm>
-            <a:off x="5565038" y="475488"/>
-            <a:ext cx="1658829" cy="566928"/>
+          <a:xfrm rot="21420000">
+            <a:off x="4983480" y="1298448"/>
+            <a:ext cx="2286000" cy="1917045"/>
           </a:xfrm>
           <a:prstGeom prst="rect">
             <a:avLst/>
@@ -3228,14 +3337,62 @@
       </p:pic>
       <p:sp>
         <p:nvSpPr>
-          <p:cNvPr id="6" name="Headline"/>
+          <p:cNvPr id="9" name="Model card"/>
+          <p:cNvSpPr/>
+          <p:nvPr/>
+        </p:nvSpPr>
+        <p:spPr>
+          <a:xfrm>
+            <a:off x="502920" y="3227832"/>
+            <a:ext cx="6766560" cy="978408"/>
+          </a:xfrm>
+          <a:prstGeom prst="roundRect">
+            <a:avLst>
+              <a:gd name="adj" fmla="val 14953"/>
+            </a:avLst>
+          </a:prstGeom>
+          <a:solidFill>
+            <a:srgbClr val="FFFDF8"/>
+          </a:solidFill>
+          <a:ln w="9525">
+            <a:solidFill>
+              <a:srgbClr val="E7DECE"/>
+            </a:solidFill>
+          </a:ln>
+          <a:effectLst/>
+        </p:spPr>
+        <p:style>
+          <a:lnRef idx="1">
+            <a:schemeClr val="accent1"/>
+          </a:lnRef>
+          <a:fillRef idx="3">
+            <a:schemeClr val="accent1"/>
+          </a:fillRef>
+          <a:effectRef idx="2">
+            <a:schemeClr val="accent1"/>
+          </a:effectRef>
+          <a:fontRef idx="minor">
+            <a:schemeClr val="lt1"/>
+          </a:fontRef>
+        </p:style>
+        <p:txBody>
+          <a:bodyPr rtlCol="0" anchor="ctr"/>
+          <a:lstStyle/>
+          <a:p>
+            <a:pPr algn="ctr"/>
+          </a:p>
+        </p:txBody>
+      </p:sp>
+      <p:sp>
+        <p:nvSpPr>
+          <p:cNvPr id="10" name="Model title"/>
           <p:cNvSpPr txBox="1"/>
           <p:nvPr/>
         </p:nvSpPr>
         <p:spPr>
           <a:xfrm>
-            <a:off x="548640" y="1600200"/>
-            <a:ext cx="3840480" cy="1280160"/>
+            <a:off x="658368" y="3319272"/>
+            <a:ext cx="6455664" cy="274320"/>
           </a:xfrm>
           <a:prstGeom prst="rect">
             <a:avLst/>
@@ -3248,57 +3405,29 @@
           </a:bodyPr>
           <a:lstStyle/>
           <a:p>
-            <a:pPr algn="l">
-              <a:lnSpc>
-                <a:spcPct val="98000"/>
-              </a:lnSpc>
-            </a:pPr>
-            <a:r>
-              <a:rPr sz="2550" b="1">
+            <a:pPr algn="l"/>
+            <a:r>
+              <a:rPr sz="1275" b="1">
                 <a:solidFill>
                   <a:srgbClr val="2B2620"/>
                 </a:solidFill>
                 <a:latin typeface="Arial"/>
               </a:rPr>
-              <a:t>A student team building an autonomous boat from the ground up.</a:t>
-            </a:r>
-          </a:p>
-        </p:txBody>
-      </p:sp>
-      <p:pic>
-        <p:nvPicPr>
-          <p:cNvPr id="7" name="Hull render" descr="haav-hull-paper.png"/>
-          <p:cNvPicPr>
-            <a:picLocks noChangeAspect="1"/>
-          </p:cNvPicPr>
-          <p:nvPr/>
-        </p:nvPicPr>
-        <p:blipFill>
-          <a:blip r:embed="rId3"/>
-          <a:stretch>
-            <a:fillRect/>
-          </a:stretch>
-        </p:blipFill>
-        <p:spPr>
-          <a:xfrm rot="21420000">
-            <a:off x="4846320" y="1371600"/>
-            <a:ext cx="2377440" cy="1993727"/>
-          </a:xfrm>
-          <a:prstGeom prst="rect">
-            <a:avLst/>
-          </a:prstGeom>
-        </p:spPr>
-      </p:pic>
-      <p:sp>
-        <p:nvSpPr>
-          <p:cNvPr id="8" name="Heading: First-principles mixed-integer linear programming"/>
+              <a:t>First-principles mixed-integer linear programming</a:t>
+            </a:r>
+          </a:p>
+        </p:txBody>
+      </p:sp>
+      <p:sp>
+        <p:nvSpPr>
+          <p:cNvPr id="11" name="Model text"/>
           <p:cNvSpPr txBox="1"/>
           <p:nvPr/>
         </p:nvSpPr>
         <p:spPr>
           <a:xfrm>
-            <a:off x="548640" y="3401568"/>
-            <a:ext cx="6583680" cy="274320"/>
+            <a:off x="658368" y="3584448"/>
+            <a:ext cx="6455664" cy="594360"/>
           </a:xfrm>
           <a:prstGeom prst="rect">
             <a:avLst/>
@@ -3311,29 +3440,51 @@
           </a:bodyPr>
           <a:lstStyle/>
           <a:p>
-            <a:pPr algn="l"/>
-            <a:r>
-              <a:rPr sz="1400" b="1">
+            <a:pPr algn="l">
+              <a:lnSpc>
+                <a:spcPct val="120000"/>
+              </a:lnSpc>
+            </a:pPr>
+            <a:r>
+              <a:rPr sz="900" b="0">
+                <a:solidFill>
+                  <a:srgbClr val="5A5249"/>
+                </a:solidFill>
+                <a:latin typeface="Arial"/>
+              </a:rPr>
+              <a:t>We build the model from physics up. Each constraint cuts the space of possible boats, and the optimizer finds the fastest one left. Hull resistance comes from </a:t>
+            </a:r>
+            <a:r>
+              <a:rPr sz="900" b="1">
                 <a:solidFill>
                   <a:srgbClr val="2B2620"/>
                 </a:solidFill>
                 <a:latin typeface="Arial"/>
               </a:rPr>
-              <a:t>First-principles mixed-integer linear programming</a:t>
-            </a:r>
-          </a:p>
-        </p:txBody>
-      </p:sp>
-      <p:sp>
-        <p:nvSpPr>
-          <p:cNvPr id="9" name="Model text"/>
+              <a:t>Savitsky's planing-hull model</a:t>
+            </a:r>
+            <a:r>
+              <a:rPr sz="900" b="0">
+                <a:solidFill>
+                  <a:srgbClr val="5A5249"/>
+                </a:solidFill>
+                <a:latin typeface="Arial"/>
+              </a:rPr>
+              <a:t>. As we build and test, we keep updating the model and adding constraints: a hybrid of simulation and empirical data.</a:t>
+            </a:r>
+          </a:p>
+        </p:txBody>
+      </p:sp>
+      <p:sp>
+        <p:nvSpPr>
+          <p:cNvPr id="12" name="Heading: Engineers from across UW–Madison"/>
           <p:cNvSpPr txBox="1"/>
           <p:nvPr/>
         </p:nvSpPr>
         <p:spPr>
           <a:xfrm>
-            <a:off x="548640" y="3694176"/>
-            <a:ext cx="6035040" cy="731520"/>
+            <a:off x="502920" y="4434840"/>
+            <a:ext cx="6583680" cy="274320"/>
           </a:xfrm>
           <a:prstGeom prst="rect">
             <a:avLst/>
@@ -3346,51 +3497,29 @@
           </a:bodyPr>
           <a:lstStyle/>
           <a:p>
-            <a:pPr algn="l">
-              <a:lnSpc>
-                <a:spcPct val="125000"/>
-              </a:lnSpc>
-            </a:pPr>
-            <a:r>
-              <a:rPr sz="950" b="0">
-                <a:solidFill>
-                  <a:srgbClr val="5A5249"/>
-                </a:solidFill>
-                <a:latin typeface="Arial"/>
-              </a:rPr>
-              <a:t>We build the model from physics up. Each constraint cuts the space of possible boats, and the optimizer finds the fastest one left. Hull resistance comes from </a:t>
-            </a:r>
-            <a:r>
-              <a:rPr sz="950" b="1">
+            <a:pPr algn="l"/>
+            <a:r>
+              <a:rPr sz="1275" b="1">
                 <a:solidFill>
                   <a:srgbClr val="2B2620"/>
                 </a:solidFill>
                 <a:latin typeface="Arial"/>
               </a:rPr>
-              <a:t>Savitsky's planing-hull model</a:t>
-            </a:r>
-            <a:r>
-              <a:rPr sz="950" b="0">
-                <a:solidFill>
-                  <a:srgbClr val="5A5249"/>
-                </a:solidFill>
-                <a:latin typeface="Arial"/>
-              </a:rPr>
-              <a:t>. As we build and test, we keep updating the model and adding constraints: a hybrid of simulation and empirical data.</a:t>
-            </a:r>
-          </a:p>
-        </p:txBody>
-      </p:sp>
-      <p:sp>
-        <p:nvSpPr>
-          <p:cNvPr id="10" name="Heading: Engineers from across UW–Madison"/>
+              <a:t>Engineers from across UW–Madison</a:t>
+            </a:r>
+          </a:p>
+        </p:txBody>
+      </p:sp>
+      <p:sp>
+        <p:nvSpPr>
+          <p:cNvPr id="13" name="Engineers text"/>
           <p:cNvSpPr txBox="1"/>
           <p:nvPr/>
         </p:nvSpPr>
         <p:spPr>
           <a:xfrm>
-            <a:off x="548640" y="4407408"/>
-            <a:ext cx="6583680" cy="274320"/>
+            <a:off x="502920" y="4690872"/>
+            <a:ext cx="6766560" cy="182880"/>
           </a:xfrm>
           <a:prstGeom prst="rect">
             <a:avLst/>
@@ -3405,27 +3534,27 @@
           <a:p>
             <a:pPr algn="l"/>
             <a:r>
-              <a:rPr sz="1400" b="1">
-                <a:solidFill>
-                  <a:srgbClr val="2B2620"/>
-                </a:solidFill>
-                <a:latin typeface="Arial"/>
-              </a:rPr>
-              <a:t>Engineers from across UW–Madison</a:t>
-            </a:r>
-          </a:p>
-        </p:txBody>
-      </p:sp>
-      <p:sp>
-        <p:nvSpPr>
-          <p:cNvPr id="11" name="Engineers text"/>
+              <a:rPr sz="900" b="0">
+                <a:solidFill>
+                  <a:srgbClr val="5A5249"/>
+                </a:solidFill>
+                <a:latin typeface="Arial"/>
+              </a:rPr>
+              <a:t>Each segment of the boat is covered, and members have worked at Tesla, Northrop Grumman, Xcel Energy and Milwaukee Tool.</a:t>
+            </a:r>
+          </a:p>
+        </p:txBody>
+      </p:sp>
+      <p:sp>
+        <p:nvSpPr>
+          <p:cNvPr id="14" name="Discipline: Industrial"/>
           <p:cNvSpPr txBox="1"/>
           <p:nvPr/>
         </p:nvSpPr>
         <p:spPr>
           <a:xfrm>
-            <a:off x="548640" y="4681728"/>
-            <a:ext cx="4754880" cy="365760"/>
+            <a:off x="502920" y="4937760"/>
+            <a:ext cx="1565910" cy="182880"/>
           </a:xfrm>
           <a:prstGeom prst="rect">
             <a:avLst/>
@@ -3438,33 +3567,29 @@
           </a:bodyPr>
           <a:lstStyle/>
           <a:p>
-            <a:pPr algn="l">
-              <a:lnSpc>
-                <a:spcPct val="125000"/>
-              </a:lnSpc>
-            </a:pPr>
-            <a:r>
-              <a:rPr sz="950" b="0">
-                <a:solidFill>
-                  <a:srgbClr val="5A5249"/>
-                </a:solidFill>
-                <a:latin typeface="Arial"/>
-              </a:rPr>
-              <a:t>Each segment of the boat is covered, and members have worked at Tesla, Northrop Grumman, Xcel Energy and Milwaukee Tool.</a:t>
-            </a:r>
-          </a:p>
-        </p:txBody>
-      </p:sp>
-      <p:sp>
-        <p:nvSpPr>
-          <p:cNvPr id="12" name="Discipline: Industrial"/>
+            <a:pPr algn="l"/>
+            <a:r>
+              <a:rPr sz="950" b="1">
+                <a:solidFill>
+                  <a:srgbClr val="2B2620"/>
+                </a:solidFill>
+                <a:latin typeface="Arial"/>
+              </a:rPr>
+              <a:t>Industrial</a:t>
+            </a:r>
+          </a:p>
+        </p:txBody>
+      </p:sp>
+      <p:sp>
+        <p:nvSpPr>
+          <p:cNvPr id="15" name="Discipline text: Industrial"/>
           <p:cNvSpPr txBox="1"/>
           <p:nvPr/>
         </p:nvSpPr>
         <p:spPr>
           <a:xfrm>
-            <a:off x="548640" y="5166360"/>
-            <a:ext cx="1543050" cy="182880"/>
+            <a:off x="502920" y="5120640"/>
+            <a:ext cx="1474470" cy="365760"/>
           </a:xfrm>
           <a:prstGeom prst="rect">
             <a:avLst/>
@@ -3477,29 +3602,408 @@
           </a:bodyPr>
           <a:lstStyle/>
           <a:p>
+            <a:pPr algn="l">
+              <a:lnSpc>
+                <a:spcPct val="110000"/>
+              </a:lnSpc>
+            </a:pPr>
+            <a:r>
+              <a:rPr sz="860" b="0">
+                <a:solidFill>
+                  <a:srgbClr val="5A5249"/>
+                </a:solidFill>
+                <a:latin typeface="Arial"/>
+              </a:rPr>
+              <a:t>optimization, composites and manufacturing</a:t>
+            </a:r>
+          </a:p>
+        </p:txBody>
+      </p:sp>
+      <p:sp>
+        <p:nvSpPr>
+          <p:cNvPr id="16" name="Discipline: Mechanical"/>
+          <p:cNvSpPr txBox="1"/>
+          <p:nvPr/>
+        </p:nvSpPr>
+        <p:spPr>
+          <a:xfrm>
+            <a:off x="2251710" y="4937760"/>
+            <a:ext cx="1565910" cy="182880"/>
+          </a:xfrm>
+          <a:prstGeom prst="rect">
+            <a:avLst/>
+          </a:prstGeom>
+          <a:noFill/>
+        </p:spPr>
+        <p:txBody>
+          <a:bodyPr wrap="square" lIns="0" rIns="0" tIns="0" bIns="0" anchor="t">
+            <a:spAutoFit/>
+          </a:bodyPr>
+          <a:lstStyle/>
+          <a:p>
             <a:pPr algn="l"/>
             <a:r>
-              <a:rPr sz="1000" b="1">
+              <a:rPr sz="950" b="1">
                 <a:solidFill>
                   <a:srgbClr val="2B2620"/>
                 </a:solidFill>
                 <a:latin typeface="Arial"/>
               </a:rPr>
-              <a:t>Industrial</a:t>
-            </a:r>
-          </a:p>
-        </p:txBody>
-      </p:sp>
-      <p:sp>
-        <p:nvSpPr>
-          <p:cNvPr id="13" name="Discipline text: Industrial"/>
+              <a:t>Mechanical</a:t>
+            </a:r>
+          </a:p>
+        </p:txBody>
+      </p:sp>
+      <p:sp>
+        <p:nvSpPr>
+          <p:cNvPr id="17" name="Discipline text: Mechanical"/>
           <p:cNvSpPr txBox="1"/>
           <p:nvPr/>
         </p:nvSpPr>
         <p:spPr>
           <a:xfrm>
-            <a:off x="548640" y="5349240"/>
-            <a:ext cx="1451610" cy="411480"/>
+            <a:off x="2251710" y="5120640"/>
+            <a:ext cx="1474470" cy="365760"/>
+          </a:xfrm>
+          <a:prstGeom prst="rect">
+            <a:avLst/>
+          </a:prstGeom>
+          <a:noFill/>
+        </p:spPr>
+        <p:txBody>
+          <a:bodyPr wrap="square" lIns="0" rIns="0" tIns="0" bIns="0" anchor="t">
+            <a:spAutoFit/>
+          </a:bodyPr>
+          <a:lstStyle/>
+          <a:p>
+            <a:pPr algn="l">
+              <a:lnSpc>
+                <a:spcPct val="110000"/>
+              </a:lnSpc>
+            </a:pPr>
+            <a:r>
+              <a:rPr sz="860" b="0">
+                <a:solidFill>
+                  <a:srgbClr val="5A5249"/>
+                </a:solidFill>
+                <a:latin typeface="Arial"/>
+              </a:rPr>
+              <a:t>structures, CAD and fabrication</a:t>
+            </a:r>
+          </a:p>
+        </p:txBody>
+      </p:sp>
+      <p:sp>
+        <p:nvSpPr>
+          <p:cNvPr id="18" name="Discipline: Electrical"/>
+          <p:cNvSpPr txBox="1"/>
+          <p:nvPr/>
+        </p:nvSpPr>
+        <p:spPr>
+          <a:xfrm>
+            <a:off x="4000500" y="4937760"/>
+            <a:ext cx="1565910" cy="182880"/>
+          </a:xfrm>
+          <a:prstGeom prst="rect">
+            <a:avLst/>
+          </a:prstGeom>
+          <a:noFill/>
+        </p:spPr>
+        <p:txBody>
+          <a:bodyPr wrap="square" lIns="0" rIns="0" tIns="0" bIns="0" anchor="t">
+            <a:spAutoFit/>
+          </a:bodyPr>
+          <a:lstStyle/>
+          <a:p>
+            <a:pPr algn="l"/>
+            <a:r>
+              <a:rPr sz="950" b="1">
+                <a:solidFill>
+                  <a:srgbClr val="2B2620"/>
+                </a:solidFill>
+                <a:latin typeface="Arial"/>
+              </a:rPr>
+              <a:t>Electrical</a:t>
+            </a:r>
+          </a:p>
+        </p:txBody>
+      </p:sp>
+      <p:sp>
+        <p:nvSpPr>
+          <p:cNvPr id="19" name="Discipline text: Electrical"/>
+          <p:cNvSpPr txBox="1"/>
+          <p:nvPr/>
+        </p:nvSpPr>
+        <p:spPr>
+          <a:xfrm>
+            <a:off x="4000500" y="5120640"/>
+            <a:ext cx="1474470" cy="365760"/>
+          </a:xfrm>
+          <a:prstGeom prst="rect">
+            <a:avLst/>
+          </a:prstGeom>
+          <a:noFill/>
+        </p:spPr>
+        <p:txBody>
+          <a:bodyPr wrap="square" lIns="0" rIns="0" tIns="0" bIns="0" anchor="t">
+            <a:spAutoFit/>
+          </a:bodyPr>
+          <a:lstStyle/>
+          <a:p>
+            <a:pPr algn="l">
+              <a:lnSpc>
+                <a:spcPct val="110000"/>
+              </a:lnSpc>
+            </a:pPr>
+            <a:r>
+              <a:rPr sz="860" b="0">
+                <a:solidFill>
+                  <a:srgbClr val="5A5249"/>
+                </a:solidFill>
+                <a:latin typeface="Arial"/>
+              </a:rPr>
+              <a:t>power, battery and high voltage</a:t>
+            </a:r>
+          </a:p>
+        </p:txBody>
+      </p:sp>
+      <p:sp>
+        <p:nvSpPr>
+          <p:cNvPr id="20" name="Discipline: Computer"/>
+          <p:cNvSpPr txBox="1"/>
+          <p:nvPr/>
+        </p:nvSpPr>
+        <p:spPr>
+          <a:xfrm>
+            <a:off x="5749290" y="4937760"/>
+            <a:ext cx="1565910" cy="182880"/>
+          </a:xfrm>
+          <a:prstGeom prst="rect">
+            <a:avLst/>
+          </a:prstGeom>
+          <a:noFill/>
+        </p:spPr>
+        <p:txBody>
+          <a:bodyPr wrap="square" lIns="0" rIns="0" tIns="0" bIns="0" anchor="t">
+            <a:spAutoFit/>
+          </a:bodyPr>
+          <a:lstStyle/>
+          <a:p>
+            <a:pPr algn="l"/>
+            <a:r>
+              <a:rPr sz="950" b="1">
+                <a:solidFill>
+                  <a:srgbClr val="2B2620"/>
+                </a:solidFill>
+                <a:latin typeface="Arial"/>
+              </a:rPr>
+              <a:t>Computer</a:t>
+            </a:r>
+          </a:p>
+        </p:txBody>
+      </p:sp>
+      <p:sp>
+        <p:nvSpPr>
+          <p:cNvPr id="21" name="Discipline text: Computer"/>
+          <p:cNvSpPr txBox="1"/>
+          <p:nvPr/>
+        </p:nvSpPr>
+        <p:spPr>
+          <a:xfrm>
+            <a:off x="5749290" y="5120640"/>
+            <a:ext cx="1474470" cy="365760"/>
+          </a:xfrm>
+          <a:prstGeom prst="rect">
+            <a:avLst/>
+          </a:prstGeom>
+          <a:noFill/>
+        </p:spPr>
+        <p:txBody>
+          <a:bodyPr wrap="square" lIns="0" rIns="0" tIns="0" bIns="0" anchor="t">
+            <a:spAutoFit/>
+          </a:bodyPr>
+          <a:lstStyle/>
+          <a:p>
+            <a:pPr algn="l">
+              <a:lnSpc>
+                <a:spcPct val="110000"/>
+              </a:lnSpc>
+            </a:pPr>
+            <a:r>
+              <a:rPr sz="860" b="0">
+                <a:solidFill>
+                  <a:srgbClr val="5A5249"/>
+                </a:solidFill>
+                <a:latin typeface="Arial"/>
+              </a:rPr>
+              <a:t>embedded, firmware and software</a:t>
+            </a:r>
+          </a:p>
+        </p:txBody>
+      </p:sp>
+      <p:sp>
+        <p:nvSpPr>
+          <p:cNvPr id="22" name="Heading: Our approach"/>
+          <p:cNvSpPr txBox="1"/>
+          <p:nvPr/>
+        </p:nvSpPr>
+        <p:spPr>
+          <a:xfrm>
+            <a:off x="502920" y="5577840"/>
+            <a:ext cx="6583680" cy="274320"/>
+          </a:xfrm>
+          <a:prstGeom prst="rect">
+            <a:avLst/>
+          </a:prstGeom>
+          <a:noFill/>
+        </p:spPr>
+        <p:txBody>
+          <a:bodyPr wrap="square" lIns="0" rIns="0" tIns="0" bIns="0" anchor="t">
+            <a:spAutoFit/>
+          </a:bodyPr>
+          <a:lstStyle/>
+          <a:p>
+            <a:pPr algn="l"/>
+            <a:r>
+              <a:rPr sz="1275" b="1">
+                <a:solidFill>
+                  <a:srgbClr val="2B2620"/>
+                </a:solidFill>
+                <a:latin typeface="Arial"/>
+              </a:rPr>
+              <a:t>Our approach</a:t>
+            </a:r>
+          </a:p>
+        </p:txBody>
+      </p:sp>
+      <p:sp>
+        <p:nvSpPr>
+          <p:cNvPr id="23" name="Card: Hull"/>
+          <p:cNvSpPr/>
+          <p:nvPr/>
+        </p:nvSpPr>
+        <p:spPr>
+          <a:xfrm>
+            <a:off x="502920" y="5824728"/>
+            <a:ext cx="2179320" cy="1143000"/>
+          </a:xfrm>
+          <a:prstGeom prst="roundRect">
+            <a:avLst>
+              <a:gd name="adj" fmla="val 12800"/>
+            </a:avLst>
+          </a:prstGeom>
+          <a:solidFill>
+            <a:srgbClr val="FFFDF8"/>
+          </a:solidFill>
+          <a:ln w="9525">
+            <a:solidFill>
+              <a:srgbClr val="E7DECE"/>
+            </a:solidFill>
+          </a:ln>
+          <a:effectLst/>
+        </p:spPr>
+        <p:style>
+          <a:lnRef idx="1">
+            <a:schemeClr val="accent1"/>
+          </a:lnRef>
+          <a:fillRef idx="3">
+            <a:schemeClr val="accent1"/>
+          </a:fillRef>
+          <a:effectRef idx="2">
+            <a:schemeClr val="accent1"/>
+          </a:effectRef>
+          <a:fontRef idx="minor">
+            <a:schemeClr val="lt1"/>
+          </a:fontRef>
+        </p:style>
+        <p:txBody>
+          <a:bodyPr rtlCol="0" anchor="ctr"/>
+          <a:lstStyle/>
+          <a:p>
+            <a:pPr algn="ctr"/>
+          </a:p>
+        </p:txBody>
+      </p:sp>
+      <p:sp>
+        <p:nvSpPr>
+          <p:cNvPr id="24" name="Part: Hull"/>
+          <p:cNvSpPr txBox="1"/>
+          <p:nvPr/>
+        </p:nvSpPr>
+        <p:spPr>
+          <a:xfrm>
+            <a:off x="640080" y="5897880"/>
+            <a:ext cx="1905000" cy="228600"/>
+          </a:xfrm>
+          <a:prstGeom prst="rect">
+            <a:avLst/>
+          </a:prstGeom>
+          <a:noFill/>
+        </p:spPr>
+        <p:txBody>
+          <a:bodyPr wrap="square" lIns="0" rIns="0" tIns="0" bIns="0" anchor="t">
+            <a:spAutoFit/>
+          </a:bodyPr>
+          <a:lstStyle/>
+          <a:p>
+            <a:pPr algn="l"/>
+            <a:r>
+              <a:rPr sz="1125" b="1">
+                <a:solidFill>
+                  <a:srgbClr val="2B2620"/>
+                </a:solidFill>
+                <a:latin typeface="Arial"/>
+              </a:rPr>
+              <a:t>Hull</a:t>
+            </a:r>
+          </a:p>
+        </p:txBody>
+      </p:sp>
+      <p:sp>
+        <p:nvSpPr>
+          <p:cNvPr id="25" name="Part tagline: Hull"/>
+          <p:cNvSpPr txBox="1"/>
+          <p:nvPr/>
+        </p:nvSpPr>
+        <p:spPr>
+          <a:xfrm>
+            <a:off x="640080" y="6108192"/>
+            <a:ext cx="1905000" cy="182880"/>
+          </a:xfrm>
+          <a:prstGeom prst="rect">
+            <a:avLst/>
+          </a:prstGeom>
+          <a:noFill/>
+        </p:spPr>
+        <p:txBody>
+          <a:bodyPr wrap="square" lIns="0" rIns="0" tIns="0" bIns="0" anchor="t">
+            <a:spAutoFit/>
+          </a:bodyPr>
+          <a:lstStyle/>
+          <a:p>
+            <a:pPr algn="l"/>
+            <a:r>
+              <a:rPr sz="900" b="1">
+                <a:solidFill>
+                  <a:srgbClr val="C5050C"/>
+                </a:solidFill>
+                <a:latin typeface="Arial"/>
+              </a:rPr>
+              <a:t>Plane well and stay light.</a:t>
+            </a:r>
+          </a:p>
+        </p:txBody>
+      </p:sp>
+      <p:sp>
+        <p:nvSpPr>
+          <p:cNvPr id="26" name="Part points: Hull"/>
+          <p:cNvSpPr txBox="1"/>
+          <p:nvPr/>
+        </p:nvSpPr>
+        <p:spPr>
+          <a:xfrm>
+            <a:off x="640080" y="6327648"/>
+            <a:ext cx="1905000" cy="548640"/>
           </a:xfrm>
           <a:prstGeom prst="rect">
             <a:avLst/>
@@ -3518,73 +4022,15 @@
               </a:lnSpc>
             </a:pPr>
             <a:r>
-              <a:rPr sz="900" b="0">
+              <a:rPr sz="860" b="0">
                 <a:solidFill>
                   <a:srgbClr val="5A5249"/>
                 </a:solidFill>
                 <a:latin typeface="Arial"/>
               </a:rPr>
-              <a:t>optimization, composites and manufacturing</a:t>
-            </a:r>
-          </a:p>
-        </p:txBody>
-      </p:sp>
-      <p:sp>
-        <p:nvSpPr>
-          <p:cNvPr id="14" name="Discipline: Mechanical"/>
-          <p:cNvSpPr txBox="1"/>
-          <p:nvPr/>
-        </p:nvSpPr>
-        <p:spPr>
-          <a:xfrm>
-            <a:off x="2274570" y="5166360"/>
-            <a:ext cx="1543050" cy="182880"/>
-          </a:xfrm>
-          <a:prstGeom prst="rect">
-            <a:avLst/>
-          </a:prstGeom>
-          <a:noFill/>
-        </p:spPr>
-        <p:txBody>
-          <a:bodyPr wrap="square" lIns="0" rIns="0" tIns="0" bIns="0" anchor="t">
-            <a:spAutoFit/>
-          </a:bodyPr>
-          <a:lstStyle/>
-          <a:p>
-            <a:pPr algn="l"/>
-            <a:r>
-              <a:rPr sz="1000" b="1">
-                <a:solidFill>
-                  <a:srgbClr val="2B2620"/>
-                </a:solidFill>
-                <a:latin typeface="Arial"/>
-              </a:rPr>
-              <a:t>Mechanical</a:t>
-            </a:r>
-          </a:p>
-        </p:txBody>
-      </p:sp>
-      <p:sp>
-        <p:nvSpPr>
-          <p:cNvPr id="15" name="Discipline text: Mechanical"/>
-          <p:cNvSpPr txBox="1"/>
-          <p:nvPr/>
-        </p:nvSpPr>
-        <p:spPr>
-          <a:xfrm>
-            <a:off x="2274570" y="5349240"/>
-            <a:ext cx="1451610" cy="411480"/>
-          </a:xfrm>
-          <a:prstGeom prst="rect">
-            <a:avLst/>
-          </a:prstGeom>
-          <a:noFill/>
-        </p:spPr>
-        <p:txBody>
-          <a:bodyPr wrap="square" lIns="0" rIns="0" tIns="0" bIns="0" anchor="t">
-            <a:spAutoFit/>
-          </a:bodyPr>
-          <a:lstStyle/>
+              <a:t>Hybrid planing composite hull</a:t>
+            </a:r>
+          </a:p>
           <a:p>
             <a:pPr algn="l">
               <a:lnSpc>
@@ -3592,73 +4038,15 @@
               </a:lnSpc>
             </a:pPr>
             <a:r>
-              <a:rPr sz="900" b="0">
+              <a:rPr sz="860" b="0">
                 <a:solidFill>
                   <a:srgbClr val="5A5249"/>
                 </a:solidFill>
                 <a:latin typeface="Arial"/>
               </a:rPr>
-              <a:t>structures, CAD and fabrication</a:t>
-            </a:r>
-          </a:p>
-        </p:txBody>
-      </p:sp>
-      <p:sp>
-        <p:nvSpPr>
-          <p:cNvPr id="16" name="Discipline: Electrical"/>
-          <p:cNvSpPr txBox="1"/>
-          <p:nvPr/>
-        </p:nvSpPr>
-        <p:spPr>
-          <a:xfrm>
-            <a:off x="4000500" y="5166360"/>
-            <a:ext cx="1543050" cy="182880"/>
-          </a:xfrm>
-          <a:prstGeom prst="rect">
-            <a:avLst/>
-          </a:prstGeom>
-          <a:noFill/>
-        </p:spPr>
-        <p:txBody>
-          <a:bodyPr wrap="square" lIns="0" rIns="0" tIns="0" bIns="0" anchor="t">
-            <a:spAutoFit/>
-          </a:bodyPr>
-          <a:lstStyle/>
-          <a:p>
-            <a:pPr algn="l"/>
-            <a:r>
-              <a:rPr sz="1000" b="1">
-                <a:solidFill>
-                  <a:srgbClr val="2B2620"/>
-                </a:solidFill>
-                <a:latin typeface="Arial"/>
-              </a:rPr>
-              <a:t>Electrical</a:t>
-            </a:r>
-          </a:p>
-        </p:txBody>
-      </p:sp>
-      <p:sp>
-        <p:nvSpPr>
-          <p:cNvPr id="17" name="Discipline text: Electrical"/>
-          <p:cNvSpPr txBox="1"/>
-          <p:nvPr/>
-        </p:nvSpPr>
-        <p:spPr>
-          <a:xfrm>
-            <a:off x="4000500" y="5349240"/>
-            <a:ext cx="1451610" cy="411480"/>
-          </a:xfrm>
-          <a:prstGeom prst="rect">
-            <a:avLst/>
-          </a:prstGeom>
-          <a:noFill/>
-        </p:spPr>
-        <p:txBody>
-          <a:bodyPr wrap="square" lIns="0" rIns="0" tIns="0" bIns="0" anchor="t">
-            <a:spAutoFit/>
-          </a:bodyPr>
-          <a:lstStyle/>
+              <a:t>Shape tuned by optimization</a:t>
+            </a:r>
+          </a:p>
           <a:p>
             <a:pPr algn="l">
               <a:lnSpc>
@@ -3666,27 +4054,75 @@
               </a:lnSpc>
             </a:pPr>
             <a:r>
-              <a:rPr sz="900" b="0">
+              <a:rPr sz="860" b="0">
                 <a:solidFill>
                   <a:srgbClr val="5A5249"/>
                 </a:solidFill>
                 <a:latin typeface="Arial"/>
               </a:rPr>
-              <a:t>power, battery and high voltage</a:t>
-            </a:r>
-          </a:p>
-        </p:txBody>
-      </p:sp>
-      <p:sp>
-        <p:nvSpPr>
-          <p:cNvPr id="18" name="Discipline: Computer"/>
+              <a:t>Resistance checked in CFD first</a:t>
+            </a:r>
+          </a:p>
+        </p:txBody>
+      </p:sp>
+      <p:sp>
+        <p:nvSpPr>
+          <p:cNvPr id="27" name="Card: Electric"/>
+          <p:cNvSpPr/>
+          <p:nvPr/>
+        </p:nvSpPr>
+        <p:spPr>
+          <a:xfrm>
+            <a:off x="2796540" y="5824728"/>
+            <a:ext cx="2179320" cy="1143000"/>
+          </a:xfrm>
+          <a:prstGeom prst="roundRect">
+            <a:avLst>
+              <a:gd name="adj" fmla="val 12800"/>
+            </a:avLst>
+          </a:prstGeom>
+          <a:solidFill>
+            <a:srgbClr val="FFFDF8"/>
+          </a:solidFill>
+          <a:ln w="9525">
+            <a:solidFill>
+              <a:srgbClr val="E7DECE"/>
+            </a:solidFill>
+          </a:ln>
+          <a:effectLst/>
+        </p:spPr>
+        <p:style>
+          <a:lnRef idx="1">
+            <a:schemeClr val="accent1"/>
+          </a:lnRef>
+          <a:fillRef idx="3">
+            <a:schemeClr val="accent1"/>
+          </a:fillRef>
+          <a:effectRef idx="2">
+            <a:schemeClr val="accent1"/>
+          </a:effectRef>
+          <a:fontRef idx="minor">
+            <a:schemeClr val="lt1"/>
+          </a:fontRef>
+        </p:style>
+        <p:txBody>
+          <a:bodyPr rtlCol="0" anchor="ctr"/>
+          <a:lstStyle/>
+          <a:p>
+            <a:pPr algn="ctr"/>
+          </a:p>
+        </p:txBody>
+      </p:sp>
+      <p:sp>
+        <p:nvSpPr>
+          <p:cNvPr id="28" name="Part: Electric"/>
           <p:cNvSpPr txBox="1"/>
           <p:nvPr/>
         </p:nvSpPr>
         <p:spPr>
           <a:xfrm>
-            <a:off x="5726429" y="5166360"/>
-            <a:ext cx="1543050" cy="182880"/>
+            <a:off x="2933700" y="5897880"/>
+            <a:ext cx="1905000" cy="228600"/>
           </a:xfrm>
           <a:prstGeom prst="rect">
             <a:avLst/>
@@ -3701,27 +4137,62 @@
           <a:p>
             <a:pPr algn="l"/>
             <a:r>
-              <a:rPr sz="1000" b="1">
+              <a:rPr sz="1125" b="1">
                 <a:solidFill>
                   <a:srgbClr val="2B2620"/>
                 </a:solidFill>
                 <a:latin typeface="Arial"/>
               </a:rPr>
-              <a:t>Computer</a:t>
-            </a:r>
-          </a:p>
-        </p:txBody>
-      </p:sp>
-      <p:sp>
-        <p:nvSpPr>
-          <p:cNvPr id="19" name="Discipline text: Computer"/>
+              <a:t>Electric</a:t>
+            </a:r>
+          </a:p>
+        </p:txBody>
+      </p:sp>
+      <p:sp>
+        <p:nvSpPr>
+          <p:cNvPr id="29" name="Part tagline: Electric"/>
           <p:cNvSpPr txBox="1"/>
           <p:nvPr/>
         </p:nvSpPr>
         <p:spPr>
           <a:xfrm>
-            <a:off x="5726429" y="5349240"/>
-            <a:ext cx="1451610" cy="411480"/>
+            <a:off x="2933700" y="6108192"/>
+            <a:ext cx="1905000" cy="182880"/>
+          </a:xfrm>
+          <a:prstGeom prst="rect">
+            <a:avLst/>
+          </a:prstGeom>
+          <a:noFill/>
+        </p:spPr>
+        <p:txBody>
+          <a:bodyPr wrap="square" lIns="0" rIns="0" tIns="0" bIns="0" anchor="t">
+            <a:spAutoFit/>
+          </a:bodyPr>
+          <a:lstStyle/>
+          <a:p>
+            <a:pPr algn="l"/>
+            <a:r>
+              <a:rPr sz="900" b="1">
+                <a:solidFill>
+                  <a:srgbClr val="C5050C"/>
+                </a:solidFill>
+                <a:latin typeface="Arial"/>
+              </a:rPr>
+              <a:t>Every watt-hour to speed.</a:t>
+            </a:r>
+          </a:p>
+        </p:txBody>
+      </p:sp>
+      <p:sp>
+        <p:nvSpPr>
+          <p:cNvPr id="30" name="Part points: Electric"/>
+          <p:cNvSpPr txBox="1"/>
+          <p:nvPr/>
+        </p:nvSpPr>
+        <p:spPr>
+          <a:xfrm>
+            <a:off x="2933700" y="6327648"/>
+            <a:ext cx="1905000" cy="548640"/>
           </a:xfrm>
           <a:prstGeom prst="rect">
             <a:avLst/>
@@ -3740,27 +4211,107 @@
               </a:lnSpc>
             </a:pPr>
             <a:r>
-              <a:rPr sz="900" b="0">
+              <a:rPr sz="860" b="0">
                 <a:solidFill>
                   <a:srgbClr val="5A5249"/>
                 </a:solidFill>
                 <a:latin typeface="Arial"/>
               </a:rPr>
-              <a:t>embedded, firmware and software</a:t>
-            </a:r>
-          </a:p>
-        </p:txBody>
-      </p:sp>
-      <p:sp>
-        <p:nvSpPr>
-          <p:cNvPr id="20" name="Heading: Our approach"/>
+              <a:t>High-voltage battery storage</a:t>
+            </a:r>
+          </a:p>
+          <a:p>
+            <a:pPr algn="l">
+              <a:lnSpc>
+                <a:spcPct val="115000"/>
+              </a:lnSpc>
+            </a:pPr>
+            <a:r>
+              <a:rPr sz="860" b="0">
+                <a:solidFill>
+                  <a:srgbClr val="5A5249"/>
+                </a:solidFill>
+                <a:latin typeface="Arial"/>
+              </a:rPr>
+              <a:t>Propulsion sized by the model</a:t>
+            </a:r>
+          </a:p>
+          <a:p>
+            <a:pPr algn="l">
+              <a:lnSpc>
+                <a:spcPct val="115000"/>
+              </a:lnSpc>
+            </a:pPr>
+            <a:r>
+              <a:rPr sz="860" b="0">
+                <a:solidFill>
+                  <a:srgbClr val="5A5249"/>
+                </a:solidFill>
+                <a:latin typeface="Arial"/>
+              </a:rPr>
+              <a:t>Propulsion and cooling co-designed</a:t>
+            </a:r>
+          </a:p>
+        </p:txBody>
+      </p:sp>
+      <p:sp>
+        <p:nvSpPr>
+          <p:cNvPr id="31" name="Card: Autonomous"/>
+          <p:cNvSpPr/>
+          <p:nvPr/>
+        </p:nvSpPr>
+        <p:spPr>
+          <a:xfrm>
+            <a:off x="5090160" y="5824728"/>
+            <a:ext cx="2179320" cy="1143000"/>
+          </a:xfrm>
+          <a:prstGeom prst="roundRect">
+            <a:avLst>
+              <a:gd name="adj" fmla="val 12800"/>
+            </a:avLst>
+          </a:prstGeom>
+          <a:solidFill>
+            <a:srgbClr val="FFFDF8"/>
+          </a:solidFill>
+          <a:ln w="9525">
+            <a:solidFill>
+              <a:srgbClr val="E7DECE"/>
+            </a:solidFill>
+          </a:ln>
+          <a:effectLst/>
+        </p:spPr>
+        <p:style>
+          <a:lnRef idx="1">
+            <a:schemeClr val="accent1"/>
+          </a:lnRef>
+          <a:fillRef idx="3">
+            <a:schemeClr val="accent1"/>
+          </a:fillRef>
+          <a:effectRef idx="2">
+            <a:schemeClr val="accent1"/>
+          </a:effectRef>
+          <a:fontRef idx="minor">
+            <a:schemeClr val="lt1"/>
+          </a:fontRef>
+        </p:style>
+        <p:txBody>
+          <a:bodyPr rtlCol="0" anchor="ctr"/>
+          <a:lstStyle/>
+          <a:p>
+            <a:pPr algn="ctr"/>
+          </a:p>
+        </p:txBody>
+      </p:sp>
+      <p:sp>
+        <p:nvSpPr>
+          <p:cNvPr id="32" name="Part: Autonomous"/>
           <p:cNvSpPr txBox="1"/>
           <p:nvPr/>
         </p:nvSpPr>
         <p:spPr>
           <a:xfrm>
-            <a:off x="548640" y="5852160"/>
-            <a:ext cx="6583680" cy="274320"/>
+            <a:off x="5227320" y="5897880"/>
+            <a:ext cx="1905000" cy="228600"/>
           </a:xfrm>
           <a:prstGeom prst="rect">
             <a:avLst/>
@@ -3775,27 +4326,27 @@
           <a:p>
             <a:pPr algn="l"/>
             <a:r>
-              <a:rPr sz="1400" b="1">
+              <a:rPr sz="1125" b="1">
                 <a:solidFill>
                   <a:srgbClr val="2B2620"/>
                 </a:solidFill>
                 <a:latin typeface="Arial"/>
               </a:rPr>
-              <a:t>Our approach</a:t>
-            </a:r>
-          </a:p>
-        </p:txBody>
-      </p:sp>
-      <p:sp>
-        <p:nvSpPr>
-          <p:cNvPr id="21" name="Part: Hull"/>
+              <a:t>Autonomous</a:t>
+            </a:r>
+          </a:p>
+        </p:txBody>
+      </p:sp>
+      <p:sp>
+        <p:nvSpPr>
+          <p:cNvPr id="33" name="Part tagline: Autonomous"/>
           <p:cNvSpPr txBox="1"/>
           <p:nvPr/>
         </p:nvSpPr>
         <p:spPr>
           <a:xfrm>
-            <a:off x="548640" y="6181344"/>
-            <a:ext cx="2052218" cy="228600"/>
+            <a:off x="5227320" y="6108192"/>
+            <a:ext cx="1905000" cy="182880"/>
           </a:xfrm>
           <a:prstGeom prst="rect">
             <a:avLst/>
@@ -3810,27 +4361,27 @@
           <a:p>
             <a:pPr algn="l"/>
             <a:r>
-              <a:rPr sz="1200" b="1">
-                <a:solidFill>
-                  <a:srgbClr val="2B2620"/>
-                </a:solidFill>
-                <a:latin typeface="Arial"/>
-              </a:rPr>
-              <a:t>Hull</a:t>
-            </a:r>
-          </a:p>
-        </p:txBody>
-      </p:sp>
-      <p:sp>
-        <p:nvSpPr>
-          <p:cNvPr id="22" name="Part tagline: Hull"/>
+              <a:rPr sz="900" b="1">
+                <a:solidFill>
+                  <a:srgbClr val="C5050C"/>
+                </a:solidFill>
+                <a:latin typeface="Arial"/>
+              </a:rPr>
+              <a:t>Manage drift and controls.</a:t>
+            </a:r>
+          </a:p>
+        </p:txBody>
+      </p:sp>
+      <p:sp>
+        <p:nvSpPr>
+          <p:cNvPr id="34" name="Part points: Autonomous"/>
           <p:cNvSpPr txBox="1"/>
           <p:nvPr/>
         </p:nvSpPr>
         <p:spPr>
           <a:xfrm>
-            <a:off x="548640" y="6382512"/>
-            <a:ext cx="2052218" cy="201168"/>
+            <a:off x="5227320" y="6327648"/>
+            <a:ext cx="1905000" cy="548640"/>
           </a:xfrm>
           <a:prstGeom prst="rect">
             <a:avLst/>
@@ -3843,29 +4394,65 @@
           </a:bodyPr>
           <a:lstStyle/>
           <a:p>
-            <a:pPr algn="l"/>
-            <a:r>
-              <a:rPr sz="950" b="1">
-                <a:solidFill>
-                  <a:srgbClr val="2B2620"/>
-                </a:solidFill>
-                <a:latin typeface="Arial"/>
-              </a:rPr>
-              <a:t>Plane well and stay light.</a:t>
-            </a:r>
-          </a:p>
-        </p:txBody>
-      </p:sp>
-      <p:sp>
-        <p:nvSpPr>
-          <p:cNvPr id="23" name="Part points: Hull"/>
+            <a:pPr algn="l">
+              <a:lnSpc>
+                <a:spcPct val="115000"/>
+              </a:lnSpc>
+            </a:pPr>
+            <a:r>
+              <a:rPr sz="860" b="0">
+                <a:solidFill>
+                  <a:srgbClr val="5A5249"/>
+                </a:solidFill>
+                <a:latin typeface="Arial"/>
+              </a:rPr>
+              <a:t>GPS, IMU and LIDAR sensing</a:t>
+            </a:r>
+          </a:p>
+          <a:p>
+            <a:pPr algn="l">
+              <a:lnSpc>
+                <a:spcPct val="115000"/>
+              </a:lnSpc>
+            </a:pPr>
+            <a:r>
+              <a:rPr sz="860" b="0">
+                <a:solidFill>
+                  <a:srgbClr val="5A5249"/>
+                </a:solidFill>
+                <a:latin typeface="Arial"/>
+              </a:rPr>
+              <a:t>Firmware protects the battery</a:t>
+            </a:r>
+          </a:p>
+          <a:p>
+            <a:pPr algn="l">
+              <a:lnSpc>
+                <a:spcPct val="115000"/>
+              </a:lnSpc>
+            </a:pPr>
+            <a:r>
+              <a:rPr sz="860" b="0">
+                <a:solidFill>
+                  <a:srgbClr val="5A5249"/>
+                </a:solidFill>
+                <a:latin typeface="Arial"/>
+              </a:rPr>
+              <a:t>Software plans the route</a:t>
+            </a:r>
+          </a:p>
+        </p:txBody>
+      </p:sp>
+      <p:sp>
+        <p:nvSpPr>
+          <p:cNvPr id="35" name="Heading: Timeline"/>
           <p:cNvSpPr txBox="1"/>
           <p:nvPr/>
         </p:nvSpPr>
         <p:spPr>
           <a:xfrm>
-            <a:off x="548640" y="6601968"/>
-            <a:ext cx="2052218" cy="548640"/>
+            <a:off x="502920" y="7132320"/>
+            <a:ext cx="6583680" cy="274320"/>
           </a:xfrm>
           <a:prstGeom prst="rect">
             <a:avLst/>
@@ -3878,65 +4465,29 @@
           </a:bodyPr>
           <a:lstStyle/>
           <a:p>
-            <a:pPr algn="l">
-              <a:lnSpc>
-                <a:spcPct val="120000"/>
-              </a:lnSpc>
-            </a:pPr>
-            <a:r>
-              <a:rPr sz="900" b="0">
-                <a:solidFill>
-                  <a:srgbClr val="5A5249"/>
-                </a:solidFill>
-                <a:latin typeface="Arial"/>
-              </a:rPr>
-              <a:t>Hybrid planing composite hull</a:t>
-            </a:r>
-          </a:p>
-          <a:p>
-            <a:pPr algn="l">
-              <a:lnSpc>
-                <a:spcPct val="120000"/>
-              </a:lnSpc>
-            </a:pPr>
-            <a:r>
-              <a:rPr sz="900" b="0">
-                <a:solidFill>
-                  <a:srgbClr val="5A5249"/>
-                </a:solidFill>
-                <a:latin typeface="Arial"/>
-              </a:rPr>
-              <a:t>Shape tuned by optimization</a:t>
-            </a:r>
-          </a:p>
-          <a:p>
-            <a:pPr algn="l">
-              <a:lnSpc>
-                <a:spcPct val="120000"/>
-              </a:lnSpc>
-            </a:pPr>
-            <a:r>
-              <a:rPr sz="900" b="0">
-                <a:solidFill>
-                  <a:srgbClr val="5A5249"/>
-                </a:solidFill>
-                <a:latin typeface="Arial"/>
-              </a:rPr>
-              <a:t>Resistance checked in CFD first</a:t>
-            </a:r>
-          </a:p>
-        </p:txBody>
-      </p:sp>
-      <p:sp>
-        <p:nvSpPr>
-          <p:cNvPr id="24" name="Part: Electric"/>
+            <a:pPr algn="l"/>
+            <a:r>
+              <a:rPr sz="1275" b="1">
+                <a:solidFill>
+                  <a:srgbClr val="2B2620"/>
+                </a:solidFill>
+                <a:latin typeface="Arial"/>
+              </a:rPr>
+              <a:t>Timeline</a:t>
+            </a:r>
+          </a:p>
+        </p:txBody>
+      </p:sp>
+      <p:sp>
+        <p:nvSpPr>
+          <p:cNvPr id="36" name="Timeline date: Hull design frozen"/>
           <p:cNvSpPr txBox="1"/>
           <p:nvPr/>
         </p:nvSpPr>
         <p:spPr>
           <a:xfrm>
-            <a:off x="2875178" y="6181344"/>
-            <a:ext cx="2052218" cy="228600"/>
+            <a:off x="502920" y="7406640"/>
+            <a:ext cx="1005840" cy="164592"/>
           </a:xfrm>
           <a:prstGeom prst="rect">
             <a:avLst/>
@@ -3951,27 +4502,27 @@
           <a:p>
             <a:pPr algn="l"/>
             <a:r>
-              <a:rPr sz="1200" b="1">
-                <a:solidFill>
-                  <a:srgbClr val="2B2620"/>
-                </a:solidFill>
-                <a:latin typeface="Arial"/>
-              </a:rPr>
-              <a:t>Electric</a:t>
-            </a:r>
-          </a:p>
-        </p:txBody>
-      </p:sp>
-      <p:sp>
-        <p:nvSpPr>
-          <p:cNvPr id="25" name="Part tagline: Electric"/>
+              <a:rPr sz="819" b="1">
+                <a:solidFill>
+                  <a:srgbClr val="C5050C"/>
+                </a:solidFill>
+                <a:latin typeface="Arial"/>
+              </a:rPr>
+              <a:t>Oct 25</a:t>
+            </a:r>
+          </a:p>
+        </p:txBody>
+      </p:sp>
+      <p:sp>
+        <p:nvSpPr>
+          <p:cNvPr id="37" name="Timeline label: Hull design frozen"/>
           <p:cNvSpPr txBox="1"/>
           <p:nvPr/>
         </p:nvSpPr>
         <p:spPr>
           <a:xfrm>
-            <a:off x="2875178" y="6382512"/>
-            <a:ext cx="2052218" cy="201168"/>
+            <a:off x="1600200" y="7406640"/>
+            <a:ext cx="2133752" cy="169164"/>
           </a:xfrm>
           <a:prstGeom prst="rect">
             <a:avLst/>
@@ -3986,27 +4537,27 @@
           <a:p>
             <a:pPr algn="l"/>
             <a:r>
-              <a:rPr sz="950" b="1">
-                <a:solidFill>
-                  <a:srgbClr val="2B2620"/>
-                </a:solidFill>
-                <a:latin typeface="Arial"/>
-              </a:rPr>
-              <a:t>Every watt-hour to speed.</a:t>
-            </a:r>
-          </a:p>
-        </p:txBody>
-      </p:sp>
-      <p:sp>
-        <p:nvSpPr>
-          <p:cNvPr id="26" name="Part points: Electric"/>
+              <a:rPr sz="819" b="0">
+                <a:solidFill>
+                  <a:srgbClr val="5A5249"/>
+                </a:solidFill>
+                <a:latin typeface="Arial"/>
+              </a:rPr>
+              <a:t>Hull design frozen</a:t>
+            </a:r>
+          </a:p>
+        </p:txBody>
+      </p:sp>
+      <p:sp>
+        <p:nvSpPr>
+          <p:cNvPr id="38" name="Timeline date: Preliminary design review"/>
           <p:cNvSpPr txBox="1"/>
           <p:nvPr/>
         </p:nvSpPr>
         <p:spPr>
           <a:xfrm>
-            <a:off x="2875178" y="6601968"/>
-            <a:ext cx="2052218" cy="548640"/>
+            <a:off x="502920" y="7575804"/>
+            <a:ext cx="1005840" cy="164592"/>
           </a:xfrm>
           <a:prstGeom prst="rect">
             <a:avLst/>
@@ -4019,65 +4570,29 @@
           </a:bodyPr>
           <a:lstStyle/>
           <a:p>
-            <a:pPr algn="l">
-              <a:lnSpc>
-                <a:spcPct val="120000"/>
-              </a:lnSpc>
-            </a:pPr>
-            <a:r>
-              <a:rPr sz="900" b="0">
-                <a:solidFill>
-                  <a:srgbClr val="5A5249"/>
-                </a:solidFill>
-                <a:latin typeface="Arial"/>
-              </a:rPr>
-              <a:t>High-voltage battery storage</a:t>
-            </a:r>
-          </a:p>
-          <a:p>
-            <a:pPr algn="l">
-              <a:lnSpc>
-                <a:spcPct val="120000"/>
-              </a:lnSpc>
-            </a:pPr>
-            <a:r>
-              <a:rPr sz="900" b="0">
-                <a:solidFill>
-                  <a:srgbClr val="5A5249"/>
-                </a:solidFill>
-                <a:latin typeface="Arial"/>
-              </a:rPr>
-              <a:t>Propulsion sized by the model</a:t>
-            </a:r>
-          </a:p>
-          <a:p>
-            <a:pPr algn="l">
-              <a:lnSpc>
-                <a:spcPct val="120000"/>
-              </a:lnSpc>
-            </a:pPr>
-            <a:r>
-              <a:rPr sz="900" b="0">
-                <a:solidFill>
-                  <a:srgbClr val="5A5249"/>
-                </a:solidFill>
-                <a:latin typeface="Arial"/>
-              </a:rPr>
-              <a:t>Propulsion and cooling co-designed</a:t>
-            </a:r>
-          </a:p>
-        </p:txBody>
-      </p:sp>
-      <p:sp>
-        <p:nvSpPr>
-          <p:cNvPr id="27" name="Part: Autonomous"/>
+            <a:pPr algn="l"/>
+            <a:r>
+              <a:rPr sz="819" b="1">
+                <a:solidFill>
+                  <a:srgbClr val="C5050C"/>
+                </a:solidFill>
+                <a:latin typeface="Arial"/>
+              </a:rPr>
+              <a:t>Nov 1</a:t>
+            </a:r>
+          </a:p>
+        </p:txBody>
+      </p:sp>
+      <p:sp>
+        <p:nvSpPr>
+          <p:cNvPr id="39" name="Timeline label: Preliminary design review"/>
           <p:cNvSpPr txBox="1"/>
           <p:nvPr/>
         </p:nvSpPr>
         <p:spPr>
           <a:xfrm>
-            <a:off x="5201716" y="6181344"/>
-            <a:ext cx="2052218" cy="228600"/>
+            <a:off x="1600200" y="7575804"/>
+            <a:ext cx="2133752" cy="169164"/>
           </a:xfrm>
           <a:prstGeom prst="rect">
             <a:avLst/>
@@ -4092,27 +4607,27 @@
           <a:p>
             <a:pPr algn="l"/>
             <a:r>
-              <a:rPr sz="1200" b="1">
-                <a:solidFill>
-                  <a:srgbClr val="2B2620"/>
-                </a:solidFill>
-                <a:latin typeface="Arial"/>
-              </a:rPr>
-              <a:t>Autonomous</a:t>
-            </a:r>
-          </a:p>
-        </p:txBody>
-      </p:sp>
-      <p:sp>
-        <p:nvSpPr>
-          <p:cNvPr id="28" name="Part tagline: Autonomous"/>
+              <a:rPr sz="819" b="0">
+                <a:solidFill>
+                  <a:srgbClr val="5A5249"/>
+                </a:solidFill>
+                <a:latin typeface="Arial"/>
+              </a:rPr>
+              <a:t>Preliminary design review</a:t>
+            </a:r>
+          </a:p>
+        </p:txBody>
+      </p:sp>
+      <p:sp>
+        <p:nvSpPr>
+          <p:cNvPr id="40" name="Timeline date: Critical and long-lead parts are ordered"/>
           <p:cNvSpPr txBox="1"/>
           <p:nvPr/>
         </p:nvSpPr>
         <p:spPr>
           <a:xfrm>
-            <a:off x="5201716" y="6382512"/>
-            <a:ext cx="2052218" cy="201168"/>
+            <a:off x="502920" y="7744968"/>
+            <a:ext cx="1005840" cy="164592"/>
           </a:xfrm>
           <a:prstGeom prst="rect">
             <a:avLst/>
@@ -4127,27 +4642,27 @@
           <a:p>
             <a:pPr algn="l"/>
             <a:r>
-              <a:rPr sz="950" b="1">
-                <a:solidFill>
-                  <a:srgbClr val="2B2620"/>
-                </a:solidFill>
-                <a:latin typeface="Arial"/>
-              </a:rPr>
-              <a:t>Manage drift and controls.</a:t>
-            </a:r>
-          </a:p>
-        </p:txBody>
-      </p:sp>
-      <p:sp>
-        <p:nvSpPr>
-          <p:cNvPr id="29" name="Part points: Autonomous"/>
+              <a:rPr sz="819" b="1">
+                <a:solidFill>
+                  <a:srgbClr val="C5050C"/>
+                </a:solidFill>
+                <a:latin typeface="Arial"/>
+              </a:rPr>
+              <a:t>Nov 10</a:t>
+            </a:r>
+          </a:p>
+        </p:txBody>
+      </p:sp>
+      <p:sp>
+        <p:nvSpPr>
+          <p:cNvPr id="41" name="Timeline label: Critical and long-lead parts are ordered"/>
           <p:cNvSpPr txBox="1"/>
           <p:nvPr/>
         </p:nvSpPr>
         <p:spPr>
           <a:xfrm>
-            <a:off x="5201716" y="6601968"/>
-            <a:ext cx="2052218" cy="548640"/>
+            <a:off x="1600200" y="7744968"/>
+            <a:ext cx="2133752" cy="169164"/>
           </a:xfrm>
           <a:prstGeom prst="rect">
             <a:avLst/>
@@ -4160,65 +4675,29 @@
           </a:bodyPr>
           <a:lstStyle/>
           <a:p>
-            <a:pPr algn="l">
-              <a:lnSpc>
-                <a:spcPct val="120000"/>
-              </a:lnSpc>
-            </a:pPr>
-            <a:r>
-              <a:rPr sz="900" b="0">
+            <a:pPr algn="l"/>
+            <a:r>
+              <a:rPr sz="819" b="0">
                 <a:solidFill>
                   <a:srgbClr val="5A5249"/>
                 </a:solidFill>
                 <a:latin typeface="Arial"/>
               </a:rPr>
-              <a:t>GPS, IMU and LIDAR sensing</a:t>
-            </a:r>
-          </a:p>
-          <a:p>
-            <a:pPr algn="l">
-              <a:lnSpc>
-                <a:spcPct val="120000"/>
-              </a:lnSpc>
-            </a:pPr>
-            <a:r>
-              <a:rPr sz="900" b="0">
-                <a:solidFill>
-                  <a:srgbClr val="5A5249"/>
-                </a:solidFill>
-                <a:latin typeface="Arial"/>
-              </a:rPr>
-              <a:t>Firmware protects the battery</a:t>
-            </a:r>
-          </a:p>
-          <a:p>
-            <a:pPr algn="l">
-              <a:lnSpc>
-                <a:spcPct val="120000"/>
-              </a:lnSpc>
-            </a:pPr>
-            <a:r>
-              <a:rPr sz="900" b="0">
-                <a:solidFill>
-                  <a:srgbClr val="5A5249"/>
-                </a:solidFill>
-                <a:latin typeface="Arial"/>
-              </a:rPr>
-              <a:t>Software plans the route</a:t>
-            </a:r>
-          </a:p>
-        </p:txBody>
-      </p:sp>
-      <p:sp>
-        <p:nvSpPr>
-          <p:cNvPr id="30" name="Heading: Timeline"/>
+              <a:t>Critical and long-lead parts are ordered</a:t>
+            </a:r>
+          </a:p>
+        </p:txBody>
+      </p:sp>
+      <p:sp>
+        <p:nvSpPr>
+          <p:cNvPr id="42" name="Timeline date: Mechanical and electrical design frozen"/>
           <p:cNvSpPr txBox="1"/>
           <p:nvPr/>
         </p:nvSpPr>
         <p:spPr>
           <a:xfrm>
-            <a:off x="548640" y="7150608"/>
-            <a:ext cx="6583680" cy="274320"/>
+            <a:off x="502920" y="7914132"/>
+            <a:ext cx="1005840" cy="164592"/>
           </a:xfrm>
           <a:prstGeom prst="rect">
             <a:avLst/>
@@ -4233,27 +4712,27 @@
           <a:p>
             <a:pPr algn="l"/>
             <a:r>
-              <a:rPr sz="1400" b="1">
-                <a:solidFill>
-                  <a:srgbClr val="2B2620"/>
-                </a:solidFill>
-                <a:latin typeface="Arial"/>
-              </a:rPr>
-              <a:t>Timeline</a:t>
-            </a:r>
-          </a:p>
-        </p:txBody>
-      </p:sp>
-      <p:sp>
-        <p:nvSpPr>
-          <p:cNvPr id="31" name="Timeline date: Hull design frozen"/>
+              <a:rPr sz="819" b="1">
+                <a:solidFill>
+                  <a:srgbClr val="C5050C"/>
+                </a:solidFill>
+                <a:latin typeface="Arial"/>
+              </a:rPr>
+              <a:t>Nov 20</a:t>
+            </a:r>
+          </a:p>
+        </p:txBody>
+      </p:sp>
+      <p:sp>
+        <p:nvSpPr>
+          <p:cNvPr id="43" name="Timeline label: Mechanical and electrical design frozen"/>
           <p:cNvSpPr txBox="1"/>
           <p:nvPr/>
         </p:nvSpPr>
         <p:spPr>
           <a:xfrm>
-            <a:off x="548640" y="7488936"/>
-            <a:ext cx="1051560" cy="164592"/>
+            <a:off x="1600200" y="7914132"/>
+            <a:ext cx="2133752" cy="169164"/>
           </a:xfrm>
           <a:prstGeom prst="rect">
             <a:avLst/>
@@ -4268,27 +4747,27 @@
           <a:p>
             <a:pPr algn="l"/>
             <a:r>
-              <a:rPr sz="860" b="1">
-                <a:solidFill>
-                  <a:srgbClr val="C5050C"/>
-                </a:solidFill>
-                <a:latin typeface="Arial"/>
-              </a:rPr>
-              <a:t>Oct 25</a:t>
-            </a:r>
-          </a:p>
-        </p:txBody>
-      </p:sp>
-      <p:sp>
-        <p:nvSpPr>
-          <p:cNvPr id="32" name="Timeline label: Hull design frozen"/>
+              <a:rPr sz="819" b="0">
+                <a:solidFill>
+                  <a:srgbClr val="5A5249"/>
+                </a:solidFill>
+                <a:latin typeface="Arial"/>
+              </a:rPr>
+              <a:t>Mechanical and electrical design frozen</a:t>
+            </a:r>
+          </a:p>
+        </p:txBody>
+      </p:sp>
+      <p:sp>
+        <p:nvSpPr>
+          <p:cNvPr id="44" name="Timeline date: Build the hull, composite parts and any custom-milled parts"/>
           <p:cNvSpPr txBox="1"/>
           <p:nvPr/>
         </p:nvSpPr>
         <p:spPr>
           <a:xfrm>
-            <a:off x="1709928" y="7488936"/>
-            <a:ext cx="2024024" cy="182880"/>
+            <a:off x="502920" y="8083296"/>
+            <a:ext cx="1005840" cy="164592"/>
           </a:xfrm>
           <a:prstGeom prst="rect">
             <a:avLst/>
@@ -4303,27 +4782,27 @@
           <a:p>
             <a:pPr algn="l"/>
             <a:r>
-              <a:rPr sz="860" b="0">
-                <a:solidFill>
-                  <a:srgbClr val="5A5249"/>
-                </a:solidFill>
-                <a:latin typeface="Arial"/>
-              </a:rPr>
-              <a:t>Hull design frozen</a:t>
-            </a:r>
-          </a:p>
-        </p:txBody>
-      </p:sp>
-      <p:sp>
-        <p:nvSpPr>
-          <p:cNvPr id="33" name="Timeline date: Preliminary design review"/>
+              <a:rPr sz="819" b="1">
+                <a:solidFill>
+                  <a:srgbClr val="C5050C"/>
+                </a:solidFill>
+                <a:latin typeface="Arial"/>
+              </a:rPr>
+              <a:t>Nov 20–Dec 20</a:t>
+            </a:r>
+          </a:p>
+        </p:txBody>
+      </p:sp>
+      <p:sp>
+        <p:nvSpPr>
+          <p:cNvPr id="45" name="Timeline label: Build the hull, composite parts and any custom-milled parts"/>
           <p:cNvSpPr txBox="1"/>
           <p:nvPr/>
         </p:nvSpPr>
         <p:spPr>
           <a:xfrm>
-            <a:off x="548640" y="7671815"/>
-            <a:ext cx="1051560" cy="164592"/>
+            <a:off x="1600200" y="8083296"/>
+            <a:ext cx="2133752" cy="288036"/>
           </a:xfrm>
           <a:prstGeom prst="rect">
             <a:avLst/>
@@ -4338,27 +4817,27 @@
           <a:p>
             <a:pPr algn="l"/>
             <a:r>
-              <a:rPr sz="860" b="1">
-                <a:solidFill>
-                  <a:srgbClr val="C5050C"/>
-                </a:solidFill>
-                <a:latin typeface="Arial"/>
-              </a:rPr>
-              <a:t>Nov 1</a:t>
-            </a:r>
-          </a:p>
-        </p:txBody>
-      </p:sp>
-      <p:sp>
-        <p:nvSpPr>
-          <p:cNvPr id="34" name="Timeline label: Preliminary design review"/>
+              <a:rPr sz="819" b="0">
+                <a:solidFill>
+                  <a:srgbClr val="5A5249"/>
+                </a:solidFill>
+                <a:latin typeface="Arial"/>
+              </a:rPr>
+              <a:t>Build the hull, composite parts and any custom-milled parts</a:t>
+            </a:r>
+          </a:p>
+        </p:txBody>
+      </p:sp>
+      <p:sp>
+        <p:nvSpPr>
+          <p:cNvPr id="46" name="Timeline date: First float and tow test"/>
           <p:cNvSpPr txBox="1"/>
           <p:nvPr/>
         </p:nvSpPr>
         <p:spPr>
           <a:xfrm>
-            <a:off x="1709928" y="7671815"/>
-            <a:ext cx="2024024" cy="182880"/>
+            <a:off x="502920" y="8371332"/>
+            <a:ext cx="1005840" cy="164592"/>
           </a:xfrm>
           <a:prstGeom prst="rect">
             <a:avLst/>
@@ -4373,27 +4852,27 @@
           <a:p>
             <a:pPr algn="l"/>
             <a:r>
-              <a:rPr sz="860" b="0">
-                <a:solidFill>
-                  <a:srgbClr val="5A5249"/>
-                </a:solidFill>
-                <a:latin typeface="Arial"/>
-              </a:rPr>
-              <a:t>Preliminary design review</a:t>
-            </a:r>
-          </a:p>
-        </p:txBody>
-      </p:sp>
-      <p:sp>
-        <p:nvSpPr>
-          <p:cNvPr id="35" name="Timeline date: Critical and long-lead parts are ordered"/>
+              <a:rPr sz="819" b="1">
+                <a:solidFill>
+                  <a:srgbClr val="C5050C"/>
+                </a:solidFill>
+                <a:latin typeface="Arial"/>
+              </a:rPr>
+              <a:t>Jan 8</a:t>
+            </a:r>
+          </a:p>
+        </p:txBody>
+      </p:sp>
+      <p:sp>
+        <p:nvSpPr>
+          <p:cNvPr id="47" name="Timeline label: First float and tow test"/>
           <p:cNvSpPr txBox="1"/>
           <p:nvPr/>
         </p:nvSpPr>
         <p:spPr>
           <a:xfrm>
-            <a:off x="548640" y="7854695"/>
-            <a:ext cx="1051560" cy="164592"/>
+            <a:off x="1600200" y="8371332"/>
+            <a:ext cx="2133752" cy="169164"/>
           </a:xfrm>
           <a:prstGeom prst="rect">
             <a:avLst/>
@@ -4408,27 +4887,27 @@
           <a:p>
             <a:pPr algn="l"/>
             <a:r>
-              <a:rPr sz="860" b="1">
-                <a:solidFill>
-                  <a:srgbClr val="C5050C"/>
-                </a:solidFill>
-                <a:latin typeface="Arial"/>
-              </a:rPr>
-              <a:t>Nov 10</a:t>
-            </a:r>
-          </a:p>
-        </p:txBody>
-      </p:sp>
-      <p:sp>
-        <p:nvSpPr>
-          <p:cNvPr id="36" name="Timeline label: Critical and long-lead parts are ordered"/>
+              <a:rPr sz="819" b="0">
+                <a:solidFill>
+                  <a:srgbClr val="5A5249"/>
+                </a:solidFill>
+                <a:latin typeface="Arial"/>
+              </a:rPr>
+              <a:t>First float and tow test</a:t>
+            </a:r>
+          </a:p>
+        </p:txBody>
+      </p:sp>
+      <p:sp>
+        <p:nvSpPr>
+          <p:cNvPr id="48" name="Timeline date: Manufacture and assemble everything"/>
           <p:cNvSpPr txBox="1"/>
           <p:nvPr/>
         </p:nvSpPr>
         <p:spPr>
           <a:xfrm>
-            <a:off x="1709928" y="7854695"/>
-            <a:ext cx="2024024" cy="182880"/>
+            <a:off x="4038447" y="7406640"/>
+            <a:ext cx="1005840" cy="164592"/>
           </a:xfrm>
           <a:prstGeom prst="rect">
             <a:avLst/>
@@ -4443,27 +4922,27 @@
           <a:p>
             <a:pPr algn="l"/>
             <a:r>
-              <a:rPr sz="860" b="0">
-                <a:solidFill>
-                  <a:srgbClr val="5A5249"/>
-                </a:solidFill>
-                <a:latin typeface="Arial"/>
-              </a:rPr>
-              <a:t>Critical and long-lead parts are ordered</a:t>
-            </a:r>
-          </a:p>
-        </p:txBody>
-      </p:sp>
-      <p:sp>
-        <p:nvSpPr>
-          <p:cNvPr id="37" name="Timeline date: Mechanical and electrical design frozen"/>
+              <a:rPr sz="819" b="1">
+                <a:solidFill>
+                  <a:srgbClr val="C5050C"/>
+                </a:solidFill>
+                <a:latin typeface="Arial"/>
+              </a:rPr>
+              <a:t>Jan 8–30</a:t>
+            </a:r>
+          </a:p>
+        </p:txBody>
+      </p:sp>
+      <p:sp>
+        <p:nvSpPr>
+          <p:cNvPr id="49" name="Timeline label: Manufacture and assemble everything"/>
           <p:cNvSpPr txBox="1"/>
           <p:nvPr/>
         </p:nvSpPr>
         <p:spPr>
           <a:xfrm>
-            <a:off x="548640" y="8037575"/>
-            <a:ext cx="1051560" cy="164592"/>
+            <a:off x="5135727" y="7406640"/>
+            <a:ext cx="2133752" cy="169164"/>
           </a:xfrm>
           <a:prstGeom prst="rect">
             <a:avLst/>
@@ -4478,27 +4957,27 @@
           <a:p>
             <a:pPr algn="l"/>
             <a:r>
-              <a:rPr sz="860" b="1">
-                <a:solidFill>
-                  <a:srgbClr val="C5050C"/>
-                </a:solidFill>
-                <a:latin typeface="Arial"/>
-              </a:rPr>
-              <a:t>Nov 20</a:t>
-            </a:r>
-          </a:p>
-        </p:txBody>
-      </p:sp>
-      <p:sp>
-        <p:nvSpPr>
-          <p:cNvPr id="38" name="Timeline label: Mechanical and electrical design frozen"/>
+              <a:rPr sz="819" b="0">
+                <a:solidFill>
+                  <a:srgbClr val="5A5249"/>
+                </a:solidFill>
+                <a:latin typeface="Arial"/>
+              </a:rPr>
+              <a:t>Manufacture and assemble everything</a:t>
+            </a:r>
+          </a:p>
+        </p:txBody>
+      </p:sp>
+      <p:sp>
+        <p:nvSpPr>
+          <p:cNvPr id="50" name="Timeline date: Build likely spare parts, in parallel"/>
           <p:cNvSpPr txBox="1"/>
           <p:nvPr/>
         </p:nvSpPr>
         <p:spPr>
           <a:xfrm>
-            <a:off x="1709928" y="8037575"/>
-            <a:ext cx="2024024" cy="182880"/>
+            <a:off x="4038447" y="7575804"/>
+            <a:ext cx="1005840" cy="164592"/>
           </a:xfrm>
           <a:prstGeom prst="rect">
             <a:avLst/>
@@ -4513,27 +4992,27 @@
           <a:p>
             <a:pPr algn="l"/>
             <a:r>
-              <a:rPr sz="860" b="0">
-                <a:solidFill>
-                  <a:srgbClr val="5A5249"/>
-                </a:solidFill>
-                <a:latin typeface="Arial"/>
-              </a:rPr>
-              <a:t>Mechanical and electrical design frozen</a:t>
-            </a:r>
-          </a:p>
-        </p:txBody>
-      </p:sp>
-      <p:sp>
-        <p:nvSpPr>
-          <p:cNvPr id="39" name="Timeline date: Build the hull, composite parts and any custom-milled parts"/>
+              <a:rPr sz="819" b="1">
+                <a:solidFill>
+                  <a:srgbClr val="C5050C"/>
+                </a:solidFill>
+                <a:latin typeface="Arial"/>
+              </a:rPr>
+              <a:t>Jan 8–30</a:t>
+            </a:r>
+          </a:p>
+        </p:txBody>
+      </p:sp>
+      <p:sp>
+        <p:nvSpPr>
+          <p:cNvPr id="51" name="Timeline label: Build likely spare parts, in parallel"/>
           <p:cNvSpPr txBox="1"/>
           <p:nvPr/>
         </p:nvSpPr>
         <p:spPr>
           <a:xfrm>
-            <a:off x="548640" y="8220455"/>
-            <a:ext cx="1051560" cy="164592"/>
+            <a:off x="5135727" y="7575804"/>
+            <a:ext cx="2133752" cy="169164"/>
           </a:xfrm>
           <a:prstGeom prst="rect">
             <a:avLst/>
@@ -4548,27 +5027,27 @@
           <a:p>
             <a:pPr algn="l"/>
             <a:r>
-              <a:rPr sz="860" b="1">
-                <a:solidFill>
-                  <a:srgbClr val="C5050C"/>
-                </a:solidFill>
-                <a:latin typeface="Arial"/>
-              </a:rPr>
-              <a:t>Nov 20–Dec 20</a:t>
-            </a:r>
-          </a:p>
-        </p:txBody>
-      </p:sp>
-      <p:sp>
-        <p:nvSpPr>
-          <p:cNvPr id="40" name="Timeline label: Build the hull, composite parts and any custom-milled parts"/>
+              <a:rPr sz="819" b="0">
+                <a:solidFill>
+                  <a:srgbClr val="5A5249"/>
+                </a:solidFill>
+                <a:latin typeface="Arial"/>
+              </a:rPr>
+              <a:t>Build likely spare parts, in parallel</a:t>
+            </a:r>
+          </a:p>
+        </p:txBody>
+      </p:sp>
+      <p:sp>
+        <p:nvSpPr>
+          <p:cNvPr id="52" name="Timeline date: First nautical mile"/>
           <p:cNvSpPr txBox="1"/>
           <p:nvPr/>
         </p:nvSpPr>
         <p:spPr>
           <a:xfrm>
-            <a:off x="1709928" y="8220455"/>
-            <a:ext cx="2024024" cy="310896"/>
+            <a:off x="4038447" y="7744968"/>
+            <a:ext cx="1005840" cy="164592"/>
           </a:xfrm>
           <a:prstGeom prst="rect">
             <a:avLst/>
@@ -4583,27 +5062,27 @@
           <a:p>
             <a:pPr algn="l"/>
             <a:r>
-              <a:rPr sz="860" b="0">
-                <a:solidFill>
-                  <a:srgbClr val="5A5249"/>
-                </a:solidFill>
-                <a:latin typeface="Arial"/>
-              </a:rPr>
-              <a:t>Build the hull, composite parts and any custom-milled parts</a:t>
-            </a:r>
-          </a:p>
-        </p:txBody>
-      </p:sp>
-      <p:sp>
-        <p:nvSpPr>
-          <p:cNvPr id="41" name="Timeline date: First float and tow test"/>
+              <a:rPr sz="819" b="1">
+                <a:solidFill>
+                  <a:srgbClr val="C5050C"/>
+                </a:solidFill>
+                <a:latin typeface="Arial"/>
+              </a:rPr>
+              <a:t>Jan 31</a:t>
+            </a:r>
+          </a:p>
+        </p:txBody>
+      </p:sp>
+      <p:sp>
+        <p:nvSpPr>
+          <p:cNvPr id="53" name="Timeline label: First nautical mile"/>
           <p:cNvSpPr txBox="1"/>
           <p:nvPr/>
         </p:nvSpPr>
         <p:spPr>
           <a:xfrm>
-            <a:off x="548640" y="8531351"/>
-            <a:ext cx="1051560" cy="164592"/>
+            <a:off x="5135727" y="7744968"/>
+            <a:ext cx="2133752" cy="169164"/>
           </a:xfrm>
           <a:prstGeom prst="rect">
             <a:avLst/>
@@ -4618,27 +5097,27 @@
           <a:p>
             <a:pPr algn="l"/>
             <a:r>
-              <a:rPr sz="860" b="1">
-                <a:solidFill>
-                  <a:srgbClr val="C5050C"/>
-                </a:solidFill>
-                <a:latin typeface="Arial"/>
-              </a:rPr>
-              <a:t>Jan 8</a:t>
-            </a:r>
-          </a:p>
-        </p:txBody>
-      </p:sp>
-      <p:sp>
-        <p:nvSpPr>
-          <p:cNvPr id="42" name="Timeline label: First float and tow test"/>
+              <a:rPr sz="819" b="0">
+                <a:solidFill>
+                  <a:srgbClr val="5A5249"/>
+                </a:solidFill>
+                <a:latin typeface="Arial"/>
+              </a:rPr>
+              <a:t>First nautical mile</a:t>
+            </a:r>
+          </a:p>
+        </p:txBody>
+      </p:sp>
+      <p:sp>
+        <p:nvSpPr>
+          <p:cNvPr id="54" name="Timeline date: Slow drives on the water"/>
           <p:cNvSpPr txBox="1"/>
           <p:nvPr/>
         </p:nvSpPr>
         <p:spPr>
           <a:xfrm>
-            <a:off x="1709928" y="8531351"/>
-            <a:ext cx="2024024" cy="182880"/>
+            <a:off x="4038447" y="7914132"/>
+            <a:ext cx="1005840" cy="164592"/>
           </a:xfrm>
           <a:prstGeom prst="rect">
             <a:avLst/>
@@ -4653,27 +5132,27 @@
           <a:p>
             <a:pPr algn="l"/>
             <a:r>
-              <a:rPr sz="860" b="0">
-                <a:solidFill>
-                  <a:srgbClr val="5A5249"/>
-                </a:solidFill>
-                <a:latin typeface="Arial"/>
-              </a:rPr>
-              <a:t>First float and tow test</a:t>
-            </a:r>
-          </a:p>
-        </p:txBody>
-      </p:sp>
-      <p:sp>
-        <p:nvSpPr>
-          <p:cNvPr id="43" name="Timeline date: Manufacture and assemble everything"/>
+              <a:rPr sz="819" b="1">
+                <a:solidFill>
+                  <a:srgbClr val="C5050C"/>
+                </a:solidFill>
+                <a:latin typeface="Arial"/>
+              </a:rPr>
+              <a:t>Feb 1–14</a:t>
+            </a:r>
+          </a:p>
+        </p:txBody>
+      </p:sp>
+      <p:sp>
+        <p:nvSpPr>
+          <p:cNvPr id="55" name="Timeline label: Slow drives on the water"/>
           <p:cNvSpPr txBox="1"/>
           <p:nvPr/>
         </p:nvSpPr>
         <p:spPr>
           <a:xfrm>
-            <a:off x="4038447" y="7488936"/>
-            <a:ext cx="1051560" cy="164592"/>
+            <a:off x="5135727" y="7914132"/>
+            <a:ext cx="2133752" cy="169164"/>
           </a:xfrm>
           <a:prstGeom prst="rect">
             <a:avLst/>
@@ -4688,27 +5167,27 @@
           <a:p>
             <a:pPr algn="l"/>
             <a:r>
-              <a:rPr sz="860" b="1">
-                <a:solidFill>
-                  <a:srgbClr val="C5050C"/>
-                </a:solidFill>
-                <a:latin typeface="Arial"/>
-              </a:rPr>
-              <a:t>Jan 8–30</a:t>
-            </a:r>
-          </a:p>
-        </p:txBody>
-      </p:sp>
-      <p:sp>
-        <p:nvSpPr>
-          <p:cNvPr id="44" name="Timeline label: Manufacture and assemble everything"/>
+              <a:rPr sz="819" b="0">
+                <a:solidFill>
+                  <a:srgbClr val="5A5249"/>
+                </a:solidFill>
+                <a:latin typeface="Arial"/>
+              </a:rPr>
+              <a:t>Slow drives on the water</a:t>
+            </a:r>
+          </a:p>
+        </p:txBody>
+      </p:sp>
+      <p:sp>
+        <p:nvSpPr>
+          <p:cNvPr id="56" name="Timeline date: Start increasing speed"/>
           <p:cNvSpPr txBox="1"/>
           <p:nvPr/>
         </p:nvSpPr>
         <p:spPr>
           <a:xfrm>
-            <a:off x="5199735" y="7488936"/>
-            <a:ext cx="2024024" cy="182880"/>
+            <a:off x="4038447" y="8083296"/>
+            <a:ext cx="1005840" cy="164592"/>
           </a:xfrm>
           <a:prstGeom prst="rect">
             <a:avLst/>
@@ -4723,27 +5202,27 @@
           <a:p>
             <a:pPr algn="l"/>
             <a:r>
-              <a:rPr sz="860" b="0">
-                <a:solidFill>
-                  <a:srgbClr val="5A5249"/>
-                </a:solidFill>
-                <a:latin typeface="Arial"/>
-              </a:rPr>
-              <a:t>Manufacture and assemble everything</a:t>
-            </a:r>
-          </a:p>
-        </p:txBody>
-      </p:sp>
-      <p:sp>
-        <p:nvSpPr>
-          <p:cNvPr id="45" name="Timeline date: Build likely spare parts, in parallel"/>
+              <a:rPr sz="819" b="1">
+                <a:solidFill>
+                  <a:srgbClr val="C5050C"/>
+                </a:solidFill>
+                <a:latin typeface="Arial"/>
+              </a:rPr>
+              <a:t>Feb 15</a:t>
+            </a:r>
+          </a:p>
+        </p:txBody>
+      </p:sp>
+      <p:sp>
+        <p:nvSpPr>
+          <p:cNvPr id="57" name="Timeline label: Start increasing speed"/>
           <p:cNvSpPr txBox="1"/>
           <p:nvPr/>
         </p:nvSpPr>
         <p:spPr>
           <a:xfrm>
-            <a:off x="4038447" y="7671815"/>
-            <a:ext cx="1051560" cy="164592"/>
+            <a:off x="5135727" y="8083296"/>
+            <a:ext cx="2133752" cy="169164"/>
           </a:xfrm>
           <a:prstGeom prst="rect">
             <a:avLst/>
@@ -4758,27 +5237,27 @@
           <a:p>
             <a:pPr algn="l"/>
             <a:r>
-              <a:rPr sz="860" b="1">
-                <a:solidFill>
-                  <a:srgbClr val="C5050C"/>
-                </a:solidFill>
-                <a:latin typeface="Arial"/>
-              </a:rPr>
-              <a:t>Jan 8–30</a:t>
-            </a:r>
-          </a:p>
-        </p:txBody>
-      </p:sp>
-      <p:sp>
-        <p:nvSpPr>
-          <p:cNvPr id="46" name="Timeline label: Build likely spare parts, in parallel"/>
+              <a:rPr sz="819" b="0">
+                <a:solidFill>
+                  <a:srgbClr val="5A5249"/>
+                </a:solidFill>
+                <a:latin typeface="Arial"/>
+              </a:rPr>
+              <a:t>Start increasing speed</a:t>
+            </a:r>
+          </a:p>
+        </p:txBody>
+      </p:sp>
+      <p:sp>
+        <p:nvSpPr>
+          <p:cNvPr id="58" name="Timeline date: Testing / Tuning"/>
           <p:cNvSpPr txBox="1"/>
           <p:nvPr/>
         </p:nvSpPr>
         <p:spPr>
           <a:xfrm>
-            <a:off x="5199735" y="7671815"/>
-            <a:ext cx="2024024" cy="182880"/>
+            <a:off x="4038447" y="8252460"/>
+            <a:ext cx="1005840" cy="164592"/>
           </a:xfrm>
           <a:prstGeom prst="rect">
             <a:avLst/>
@@ -4793,27 +5272,27 @@
           <a:p>
             <a:pPr algn="l"/>
             <a:r>
-              <a:rPr sz="860" b="0">
-                <a:solidFill>
-                  <a:srgbClr val="5A5249"/>
-                </a:solidFill>
-                <a:latin typeface="Arial"/>
-              </a:rPr>
-              <a:t>Build likely spare parts, in parallel</a:t>
-            </a:r>
-          </a:p>
-        </p:txBody>
-      </p:sp>
-      <p:sp>
-        <p:nvSpPr>
-          <p:cNvPr id="47" name="Timeline date: First nautical mile"/>
+              <a:rPr sz="819" b="1">
+                <a:solidFill>
+                  <a:srgbClr val="C5050C"/>
+                </a:solidFill>
+                <a:latin typeface="Arial"/>
+              </a:rPr>
+              <a:t>Until April</a:t>
+            </a:r>
+          </a:p>
+        </p:txBody>
+      </p:sp>
+      <p:sp>
+        <p:nvSpPr>
+          <p:cNvPr id="59" name="Timeline label: Testing / Tuning"/>
           <p:cNvSpPr txBox="1"/>
           <p:nvPr/>
         </p:nvSpPr>
         <p:spPr>
           <a:xfrm>
-            <a:off x="4038447" y="7854695"/>
-            <a:ext cx="1051560" cy="164592"/>
+            <a:off x="5135727" y="8252460"/>
+            <a:ext cx="2133752" cy="169164"/>
           </a:xfrm>
           <a:prstGeom prst="rect">
             <a:avLst/>
@@ -4828,27 +5307,73 @@
           <a:p>
             <a:pPr algn="l"/>
             <a:r>
-              <a:rPr sz="860" b="1">
-                <a:solidFill>
-                  <a:srgbClr val="C5050C"/>
-                </a:solidFill>
-                <a:latin typeface="Arial"/>
-              </a:rPr>
-              <a:t>Jan 31</a:t>
-            </a:r>
-          </a:p>
-        </p:txBody>
-      </p:sp>
-      <p:sp>
-        <p:nvSpPr>
-          <p:cNvPr id="48" name="Timeline label: First nautical mile"/>
+              <a:rPr sz="819" b="0">
+                <a:solidFill>
+                  <a:srgbClr val="5A5249"/>
+                </a:solidFill>
+                <a:latin typeface="Arial"/>
+              </a:rPr>
+              <a:t>Testing / Tuning</a:t>
+            </a:r>
+          </a:p>
+        </p:txBody>
+      </p:sp>
+      <p:sp>
+        <p:nvSpPr>
+          <p:cNvPr id="60" name="Footer card"/>
+          <p:cNvSpPr/>
+          <p:nvPr/>
+        </p:nvSpPr>
+        <p:spPr>
+          <a:xfrm>
+            <a:off x="502920" y="8823960"/>
+            <a:ext cx="6766560" cy="822960"/>
+          </a:xfrm>
+          <a:prstGeom prst="roundRect">
+            <a:avLst>
+              <a:gd name="adj" fmla="val 17777"/>
+            </a:avLst>
+          </a:prstGeom>
+          <a:solidFill>
+            <a:srgbClr val="2B2620"/>
+          </a:solidFill>
+          <a:ln>
+            <a:noFill/>
+          </a:ln>
+          <a:effectLst/>
+        </p:spPr>
+        <p:style>
+          <a:lnRef idx="1">
+            <a:schemeClr val="accent1"/>
+          </a:lnRef>
+          <a:fillRef idx="3">
+            <a:schemeClr val="accent1"/>
+          </a:fillRef>
+          <a:effectRef idx="2">
+            <a:schemeClr val="accent1"/>
+          </a:effectRef>
+          <a:fontRef idx="minor">
+            <a:schemeClr val="lt1"/>
+          </a:fontRef>
+        </p:style>
+        <p:txBody>
+          <a:bodyPr rtlCol="0" anchor="ctr"/>
+          <a:lstStyle/>
+          <a:p>
+            <a:pPr algn="ctr"/>
+          </a:p>
+        </p:txBody>
+      </p:sp>
+      <p:sp>
+        <p:nvSpPr>
+          <p:cNvPr id="61" name="Footer title"/>
           <p:cNvSpPr txBox="1"/>
           <p:nvPr/>
         </p:nvSpPr>
         <p:spPr>
           <a:xfrm>
-            <a:off x="5199735" y="7854695"/>
-            <a:ext cx="2024024" cy="182880"/>
+            <a:off x="685800" y="8961120"/>
+            <a:ext cx="3474720" cy="274320"/>
           </a:xfrm>
           <a:prstGeom prst="rect">
             <a:avLst/>
@@ -4863,27 +5388,27 @@
           <a:p>
             <a:pPr algn="l"/>
             <a:r>
-              <a:rPr sz="860" b="0">
-                <a:solidFill>
-                  <a:srgbClr val="5A5249"/>
-                </a:solidFill>
-                <a:latin typeface="Arial"/>
-              </a:rPr>
-              <a:t>First nautical mile</a:t>
-            </a:r>
-          </a:p>
-        </p:txBody>
-      </p:sp>
-      <p:sp>
-        <p:nvSpPr>
-          <p:cNvPr id="49" name="Timeline date: Slow drives on the water"/>
+              <a:rPr sz="1425" b="1">
+                <a:solidFill>
+                  <a:srgbClr val="F8F3EA"/>
+                </a:solidFill>
+                <a:latin typeface="Arial"/>
+              </a:rPr>
+              <a:t>Want to help build it?</a:t>
+            </a:r>
+          </a:p>
+        </p:txBody>
+      </p:sp>
+      <p:sp>
+        <p:nvSpPr>
+          <p:cNvPr id="62" name="Footer text"/>
           <p:cNvSpPr txBox="1"/>
           <p:nvPr/>
         </p:nvSpPr>
         <p:spPr>
           <a:xfrm>
-            <a:off x="4038447" y="8037575"/>
-            <a:ext cx="1051560" cy="164592"/>
+            <a:off x="685800" y="9235440"/>
+            <a:ext cx="3291840" cy="365760"/>
           </a:xfrm>
           <a:prstGeom prst="rect">
             <a:avLst/>
@@ -4896,29 +5421,33 @@
           </a:bodyPr>
           <a:lstStyle/>
           <a:p>
-            <a:pPr algn="l"/>
-            <a:r>
-              <a:rPr sz="860" b="1">
-                <a:solidFill>
-                  <a:srgbClr val="C5050C"/>
-                </a:solidFill>
-                <a:latin typeface="Arial"/>
-              </a:rPr>
-              <a:t>Feb 1–14</a:t>
-            </a:r>
-          </a:p>
-        </p:txBody>
-      </p:sp>
-      <p:sp>
-        <p:nvSpPr>
-          <p:cNvPr id="50" name="Timeline label: Slow drives on the water"/>
+            <a:pPr algn="l">
+              <a:lnSpc>
+                <a:spcPct val="115000"/>
+              </a:lnSpc>
+            </a:pPr>
+            <a:r>
+              <a:rPr sz="900" b="0">
+                <a:solidFill>
+                  <a:srgbClr val="BDB7AD"/>
+                </a:solidFill>
+                <a:latin typeface="Arial"/>
+              </a:rPr>
+              <a:t>We are looking for funds, parts, advisors and people to build our BOM as we design.</a:t>
+            </a:r>
+          </a:p>
+        </p:txBody>
+      </p:sp>
+      <p:sp>
+        <p:nvSpPr>
+          <p:cNvPr id="63" name="Footer link"/>
           <p:cNvSpPr txBox="1"/>
           <p:nvPr/>
         </p:nvSpPr>
         <p:spPr>
           <a:xfrm>
-            <a:off x="5199735" y="8037575"/>
-            <a:ext cx="2024024" cy="182880"/>
+            <a:off x="4160520" y="8942832"/>
+            <a:ext cx="2926080" cy="274320"/>
           </a:xfrm>
           <a:prstGeom prst="rect">
             <a:avLst/>
@@ -4931,29 +5460,29 @@
           </a:bodyPr>
           <a:lstStyle/>
           <a:p>
-            <a:pPr algn="l"/>
-            <a:r>
-              <a:rPr sz="860" b="0">
-                <a:solidFill>
-                  <a:srgbClr val="5A5249"/>
-                </a:solidFill>
-                <a:latin typeface="Arial"/>
-              </a:rPr>
-              <a:t>Slow drives on the water</a:t>
-            </a:r>
-          </a:p>
-        </p:txBody>
-      </p:sp>
-      <p:sp>
-        <p:nvSpPr>
-          <p:cNvPr id="51" name="Timeline date: Start increasing speed"/>
+            <a:pPr algn="r"/>
+            <a:r>
+              <a:rPr sz="1425" b="1">
+                <a:solidFill>
+                  <a:srgbClr val="F8F3EA"/>
+                </a:solidFill>
+                <a:latin typeface="Arial"/>
+              </a:rPr>
+              <a:t>bit.ly/haav</a:t>
+            </a:r>
+          </a:p>
+        </p:txBody>
+      </p:sp>
+      <p:sp>
+        <p:nvSpPr>
+          <p:cNvPr id="64" name="Footer contact name"/>
           <p:cNvSpPr txBox="1"/>
           <p:nvPr/>
         </p:nvSpPr>
         <p:spPr>
           <a:xfrm>
-            <a:off x="4038447" y="8220455"/>
-            <a:ext cx="1051560" cy="164592"/>
+            <a:off x="4160520" y="9235440"/>
+            <a:ext cx="2926080" cy="182880"/>
           </a:xfrm>
           <a:prstGeom prst="rect">
             <a:avLst/>
@@ -4966,29 +5495,29 @@
           </a:bodyPr>
           <a:lstStyle/>
           <a:p>
-            <a:pPr algn="l"/>
-            <a:r>
-              <a:rPr sz="860" b="1">
-                <a:solidFill>
-                  <a:srgbClr val="C5050C"/>
-                </a:solidFill>
-                <a:latin typeface="Arial"/>
-              </a:rPr>
-              <a:t>Feb 15</a:t>
-            </a:r>
-          </a:p>
-        </p:txBody>
-      </p:sp>
-      <p:sp>
-        <p:nvSpPr>
-          <p:cNvPr id="52" name="Timeline label: Start increasing speed"/>
+            <a:pPr algn="r"/>
+            <a:r>
+              <a:rPr sz="900" b="1">
+                <a:solidFill>
+                  <a:srgbClr val="F8F3EA"/>
+                </a:solidFill>
+                <a:latin typeface="Arial"/>
+              </a:rPr>
+              <a:t>Marley Barrett, Project lead</a:t>
+            </a:r>
+          </a:p>
+        </p:txBody>
+      </p:sp>
+      <p:sp>
+        <p:nvSpPr>
+          <p:cNvPr id="65" name="Footer contact email"/>
           <p:cNvSpPr txBox="1"/>
           <p:nvPr/>
         </p:nvSpPr>
         <p:spPr>
           <a:xfrm>
-            <a:off x="5199735" y="8220455"/>
-            <a:ext cx="2024024" cy="182880"/>
+            <a:off x="4160520" y="9400032"/>
+            <a:ext cx="2926080" cy="182880"/>
           </a:xfrm>
           <a:prstGeom prst="rect">
             <a:avLst/>
@@ -5001,260 +5530,11 @@
           </a:bodyPr>
           <a:lstStyle/>
           <a:p>
-            <a:pPr algn="l"/>
-            <a:r>
-              <a:rPr sz="860" b="0">
-                <a:solidFill>
-                  <a:srgbClr val="5A5249"/>
-                </a:solidFill>
-                <a:latin typeface="Arial"/>
-              </a:rPr>
-              <a:t>Start increasing speed</a:t>
-            </a:r>
-          </a:p>
-        </p:txBody>
-      </p:sp>
-      <p:sp>
-        <p:nvSpPr>
-          <p:cNvPr id="53" name="Timeline date: Testing / Tuning"/>
-          <p:cNvSpPr txBox="1"/>
-          <p:nvPr/>
-        </p:nvSpPr>
-        <p:spPr>
-          <a:xfrm>
-            <a:off x="4038447" y="8403335"/>
-            <a:ext cx="1051560" cy="164592"/>
-          </a:xfrm>
-          <a:prstGeom prst="rect">
-            <a:avLst/>
-          </a:prstGeom>
-          <a:noFill/>
-        </p:spPr>
-        <p:txBody>
-          <a:bodyPr wrap="square" lIns="0" rIns="0" tIns="0" bIns="0" anchor="t">
-            <a:spAutoFit/>
-          </a:bodyPr>
-          <a:lstStyle/>
-          <a:p>
-            <a:pPr algn="l"/>
-            <a:r>
-              <a:rPr sz="860" b="1">
-                <a:solidFill>
-                  <a:srgbClr val="C5050C"/>
-                </a:solidFill>
-                <a:latin typeface="Arial"/>
-              </a:rPr>
-              <a:t>Until April</a:t>
-            </a:r>
-          </a:p>
-        </p:txBody>
-      </p:sp>
-      <p:sp>
-        <p:nvSpPr>
-          <p:cNvPr id="54" name="Timeline label: Testing / Tuning"/>
-          <p:cNvSpPr txBox="1"/>
-          <p:nvPr/>
-        </p:nvSpPr>
-        <p:spPr>
-          <a:xfrm>
-            <a:off x="5199735" y="8403335"/>
-            <a:ext cx="2024024" cy="182880"/>
-          </a:xfrm>
-          <a:prstGeom prst="rect">
-            <a:avLst/>
-          </a:prstGeom>
-          <a:noFill/>
-        </p:spPr>
-        <p:txBody>
-          <a:bodyPr wrap="square" lIns="0" rIns="0" tIns="0" bIns="0" anchor="t">
-            <a:spAutoFit/>
-          </a:bodyPr>
-          <a:lstStyle/>
-          <a:p>
-            <a:pPr algn="l"/>
-            <a:r>
-              <a:rPr sz="860" b="0">
-                <a:solidFill>
-                  <a:srgbClr val="5A5249"/>
-                </a:solidFill>
-                <a:latin typeface="Arial"/>
-              </a:rPr>
-              <a:t>Testing / Tuning</a:t>
-            </a:r>
-          </a:p>
-        </p:txBody>
-      </p:sp>
-      <p:sp>
-        <p:nvSpPr>
-          <p:cNvPr id="55" name="Heading: Want to help build it?"/>
-          <p:cNvSpPr txBox="1"/>
-          <p:nvPr/>
-        </p:nvSpPr>
-        <p:spPr>
-          <a:xfrm>
-            <a:off x="548640" y="8906256"/>
-            <a:ext cx="6583680" cy="274320"/>
-          </a:xfrm>
-          <a:prstGeom prst="rect">
-            <a:avLst/>
-          </a:prstGeom>
-          <a:noFill/>
-        </p:spPr>
-        <p:txBody>
-          <a:bodyPr wrap="square" lIns="0" rIns="0" tIns="0" bIns="0" anchor="t">
-            <a:spAutoFit/>
-          </a:bodyPr>
-          <a:lstStyle/>
-          <a:p>
-            <a:pPr algn="l"/>
-            <a:r>
-              <a:rPr sz="1650" b="1">
-                <a:solidFill>
-                  <a:srgbClr val="2B2620"/>
-                </a:solidFill>
-                <a:latin typeface="Arial"/>
-              </a:rPr>
-              <a:t>Want to help build it?</a:t>
-            </a:r>
-          </a:p>
-        </p:txBody>
-      </p:sp>
-      <p:sp>
-        <p:nvSpPr>
-          <p:cNvPr id="56" name="Footer text"/>
-          <p:cNvSpPr txBox="1"/>
-          <p:nvPr/>
-        </p:nvSpPr>
-        <p:spPr>
-          <a:xfrm>
-            <a:off x="548640" y="9235440"/>
-            <a:ext cx="3383280" cy="411480"/>
-          </a:xfrm>
-          <a:prstGeom prst="rect">
-            <a:avLst/>
-          </a:prstGeom>
-          <a:noFill/>
-        </p:spPr>
-        <p:txBody>
-          <a:bodyPr wrap="square" lIns="0" rIns="0" tIns="0" bIns="0" anchor="t">
-            <a:spAutoFit/>
-          </a:bodyPr>
-          <a:lstStyle/>
-          <a:p>
-            <a:pPr algn="l">
-              <a:lnSpc>
-                <a:spcPct val="120000"/>
-              </a:lnSpc>
-            </a:pPr>
-            <a:r>
-              <a:rPr sz="950" b="0">
-                <a:solidFill>
-                  <a:srgbClr val="5A5249"/>
-                </a:solidFill>
-                <a:latin typeface="Arial"/>
-              </a:rPr>
-              <a:t>We are looking for funds, parts, advisors and people to build our BOM as we design.</a:t>
-            </a:r>
-          </a:p>
-        </p:txBody>
-      </p:sp>
-      <p:sp>
-        <p:nvSpPr>
-          <p:cNvPr id="57" name="Footer link"/>
-          <p:cNvSpPr txBox="1"/>
-          <p:nvPr/>
-        </p:nvSpPr>
-        <p:spPr>
-          <a:xfrm>
-            <a:off x="4297680" y="8887968"/>
-            <a:ext cx="2926080" cy="320040"/>
-          </a:xfrm>
-          <a:prstGeom prst="rect">
-            <a:avLst/>
-          </a:prstGeom>
-          <a:noFill/>
-        </p:spPr>
-        <p:txBody>
-          <a:bodyPr wrap="square" lIns="0" rIns="0" tIns="0" bIns="0" anchor="t">
-            <a:spAutoFit/>
-          </a:bodyPr>
-          <a:lstStyle/>
-          <a:p>
             <a:pPr algn="r"/>
             <a:r>
-              <a:rPr sz="1650" b="1">
-                <a:solidFill>
-                  <a:srgbClr val="C5050C"/>
-                </a:solidFill>
-                <a:latin typeface="Arial"/>
-              </a:rPr>
-              <a:t>bit.ly/haav</a:t>
-            </a:r>
-          </a:p>
-        </p:txBody>
-      </p:sp>
-      <p:sp>
-        <p:nvSpPr>
-          <p:cNvPr id="58" name="Footer contact name"/>
-          <p:cNvSpPr txBox="1"/>
-          <p:nvPr/>
-        </p:nvSpPr>
-        <p:spPr>
-          <a:xfrm>
-            <a:off x="4297680" y="9235440"/>
-            <a:ext cx="2926080" cy="182880"/>
-          </a:xfrm>
-          <a:prstGeom prst="rect">
-            <a:avLst/>
-          </a:prstGeom>
-          <a:noFill/>
-        </p:spPr>
-        <p:txBody>
-          <a:bodyPr wrap="square" lIns="0" rIns="0" tIns="0" bIns="0" anchor="t">
-            <a:spAutoFit/>
-          </a:bodyPr>
-          <a:lstStyle/>
-          <a:p>
-            <a:pPr algn="r"/>
-            <a:r>
-              <a:rPr sz="950" b="1">
-                <a:solidFill>
-                  <a:srgbClr val="2B2620"/>
-                </a:solidFill>
-                <a:latin typeface="Arial"/>
-              </a:rPr>
-              <a:t>Marley Barrett, Project lead</a:t>
-            </a:r>
-          </a:p>
-        </p:txBody>
-      </p:sp>
-      <p:sp>
-        <p:nvSpPr>
-          <p:cNvPr id="59" name="Footer contact email"/>
-          <p:cNvSpPr txBox="1"/>
-          <p:nvPr/>
-        </p:nvSpPr>
-        <p:spPr>
-          <a:xfrm>
-            <a:off x="4297680" y="9418320"/>
-            <a:ext cx="2926080" cy="182880"/>
-          </a:xfrm>
-          <a:prstGeom prst="rect">
-            <a:avLst/>
-          </a:prstGeom>
-          <a:noFill/>
-        </p:spPr>
-        <p:txBody>
-          <a:bodyPr wrap="square" lIns="0" rIns="0" tIns="0" bIns="0" anchor="t">
-            <a:spAutoFit/>
-          </a:bodyPr>
-          <a:lstStyle/>
-          <a:p>
-            <a:pPr algn="r"/>
-            <a:r>
-              <a:rPr sz="950" b="0">
-                <a:solidFill>
-                  <a:srgbClr val="5A5249"/>
+              <a:rPr sz="900" b="0">
+                <a:solidFill>
+                  <a:srgbClr val="BDB7AD"/>
                 </a:solidFill>
                 <a:latin typeface="Arial"/>
               </a:rPr>

</xml_diff>

<commit_message>
Handout: the team's wording edits, in the white palette
Co-Authored-By: Claude Sonnet 5.5 <noreply@anthropic.com>
</commit_message>
<xml_diff>
--- a/dashboard/public/haav-handout.pptx
+++ b/dashboard/public/haav-handout.pptx
@@ -3103,7 +3103,7 @@
             <a:avLst/>
           </a:prstGeom>
           <a:solidFill>
-            <a:srgbClr val="F8F3EA"/>
+            <a:srgbClr val="FFFFFF"/>
           </a:solidFill>
           <a:ln>
             <a:noFill/>
@@ -3158,11 +3158,11 @@
             <a:r>
               <a:rPr sz="3600" b="1">
                 <a:solidFill>
-                  <a:srgbClr val="2B2620"/>
-                </a:solidFill>
-                <a:latin typeface="Arial"/>
-              </a:rPr>
-              <a:t>Haav</a:t>
+                  <a:srgbClr val="111111"/>
+                </a:solidFill>
+                <a:latin typeface="Arial"/>
+              </a:rPr>
+              <a:t>HaaV</a:t>
             </a:r>
           </a:p>
         </p:txBody>
@@ -3193,11 +3193,11 @@
             <a:r>
               <a:rPr sz="975" b="0">
                 <a:solidFill>
-                  <a:srgbClr val="5A5249"/>
-                </a:solidFill>
-                <a:latin typeface="Arial"/>
-              </a:rPr>
-              <a:t>Highly Amphibious / Autonomous Vehicle</a:t>
+                  <a:srgbClr val="555555"/>
+                </a:solidFill>
+                <a:latin typeface="Arial"/>
+              </a:rPr>
+              <a:t>Highly amphibious / autonomous Vehicle</a:t>
             </a:r>
           </a:p>
         </p:txBody>
@@ -3232,7 +3232,7 @@
                 </a:solidFill>
                 <a:latin typeface="Arial"/>
               </a:rPr>
-              <a:t>UW–Madison</a:t>
+              <a:t>Team: UW–Madison</a:t>
             </a:r>
           </a:p>
         </p:txBody>
@@ -3263,7 +3263,7 @@
             <a:r>
               <a:rPr sz="975" b="0">
                 <a:solidFill>
-                  <a:srgbClr val="5A5249"/>
+                  <a:srgbClr val="555555"/>
                 </a:solidFill>
                 <a:latin typeface="Arial"/>
               </a:rPr>
@@ -3302,11 +3302,11 @@
             <a:r>
               <a:rPr sz="2400" b="1">
                 <a:solidFill>
-                  <a:srgbClr val="2B2620"/>
-                </a:solidFill>
-                <a:latin typeface="Arial"/>
-              </a:rPr>
-              <a:t>A student team building an autonomous boat from the ground up.</a:t>
+                  <a:srgbClr val="111111"/>
+                </a:solidFill>
+                <a:latin typeface="Arial"/>
+              </a:rPr>
+              <a:t>A student team building an uncrewed autonomous boat from the ground up.</a:t>
             </a:r>
           </a:p>
         </p:txBody>
@@ -3352,11 +3352,11 @@
             </a:avLst>
           </a:prstGeom>
           <a:solidFill>
-            <a:srgbClr val="FFFDF8"/>
+            <a:srgbClr val="F5F5F5"/>
           </a:solidFill>
           <a:ln w="9525">
             <a:solidFill>
-              <a:srgbClr val="E7DECE"/>
+              <a:srgbClr val="F5F5F5"/>
             </a:solidFill>
           </a:ln>
           <a:effectLst/>
@@ -3409,11 +3409,11 @@
             <a:r>
               <a:rPr sz="1275" b="1">
                 <a:solidFill>
-                  <a:srgbClr val="2B2620"/>
-                </a:solidFill>
-                <a:latin typeface="Arial"/>
-              </a:rPr>
-              <a:t>First-principles mixed-integer linear programming</a:t>
+                  <a:srgbClr val="111111"/>
+                </a:solidFill>
+                <a:latin typeface="Arial"/>
+              </a:rPr>
+              <a:t>Ground up means simulation + modeling first</a:t>
             </a:r>
           </a:p>
         </p:txBody>
@@ -3448,29 +3448,11 @@
             <a:r>
               <a:rPr sz="900" b="0">
                 <a:solidFill>
-                  <a:srgbClr val="5A5249"/>
-                </a:solidFill>
-                <a:latin typeface="Arial"/>
-              </a:rPr>
-              <a:t>We build the model from physics up. Each constraint cuts the space of possible boats, and the optimizer finds the fastest one left. Hull resistance comes from </a:t>
-            </a:r>
-            <a:r>
-              <a:rPr sz="900" b="1">
-                <a:solidFill>
-                  <a:srgbClr val="2B2620"/>
-                </a:solidFill>
-                <a:latin typeface="Arial"/>
-              </a:rPr>
-              <a:t>Savitsky's planing-hull model</a:t>
-            </a:r>
-            <a:r>
-              <a:rPr sz="900" b="0">
-                <a:solidFill>
-                  <a:srgbClr val="5A5249"/>
-                </a:solidFill>
-                <a:latin typeface="Arial"/>
-              </a:rPr>
-              <a:t>. As we build and test, we keep updating the model and adding constraints: a hybrid of simulation and empirical data.</a:t>
+                  <a:srgbClr val="555555"/>
+                </a:solidFill>
+                <a:latin typeface="Arial"/>
+              </a:rPr>
+              <a:t>We are building the model from first principles, mixing empirical and rule-of-thumb decisions with dynamic programming. Each constraint cuts the space of possible boats, and the optimizer finds the fastest one based on current variables. As we build and test, we keep updating the model and adding constraints: a hybrid of simulation and empirical data.</a:t>
             </a:r>
           </a:p>
         </p:txBody>
@@ -3501,7 +3483,7 @@
             <a:r>
               <a:rPr sz="1275" b="1">
                 <a:solidFill>
-                  <a:srgbClr val="2B2620"/>
+                  <a:srgbClr val="111111"/>
                 </a:solidFill>
                 <a:latin typeface="Arial"/>
               </a:rPr>
@@ -3536,11 +3518,11 @@
             <a:r>
               <a:rPr sz="900" b="0">
                 <a:solidFill>
-                  <a:srgbClr val="5A5249"/>
-                </a:solidFill>
-                <a:latin typeface="Arial"/>
-              </a:rPr>
-              <a:t>Each segment of the boat is covered, and members have worked at Tesla, Northrop Grumman, Xcel Energy and Milwaukee Tool.</a:t>
+                  <a:srgbClr val="555555"/>
+                </a:solidFill>
+                <a:latin typeface="Arial"/>
+              </a:rPr>
+              <a:t>Lead members have interned at Tesla, Northrop Grumman, Xcel Energy, Fincantieri and Milwaukee Tool.</a:t>
             </a:r>
           </a:p>
         </p:txBody>
@@ -3571,7 +3553,7 @@
             <a:r>
               <a:rPr sz="950" b="1">
                 <a:solidFill>
-                  <a:srgbClr val="2B2620"/>
+                  <a:srgbClr val="111111"/>
                 </a:solidFill>
                 <a:latin typeface="Arial"/>
               </a:rPr>
@@ -3610,7 +3592,7 @@
             <a:r>
               <a:rPr sz="860" b="0">
                 <a:solidFill>
-                  <a:srgbClr val="5A5249"/>
+                  <a:srgbClr val="555555"/>
                 </a:solidFill>
                 <a:latin typeface="Arial"/>
               </a:rPr>
@@ -3645,7 +3627,7 @@
             <a:r>
               <a:rPr sz="950" b="1">
                 <a:solidFill>
-                  <a:srgbClr val="2B2620"/>
+                  <a:srgbClr val="111111"/>
                 </a:solidFill>
                 <a:latin typeface="Arial"/>
               </a:rPr>
@@ -3684,11 +3666,11 @@
             <a:r>
               <a:rPr sz="860" b="0">
                 <a:solidFill>
-                  <a:srgbClr val="5A5249"/>
-                </a:solidFill>
-                <a:latin typeface="Arial"/>
-              </a:rPr>
-              <a:t>structures, CAD and fabrication</a:t>
+                  <a:srgbClr val="555555"/>
+                </a:solidFill>
+                <a:latin typeface="Arial"/>
+              </a:rPr>
+              <a:t>structures, CAD</a:t>
             </a:r>
           </a:p>
         </p:txBody>
@@ -3719,7 +3701,7 @@
             <a:r>
               <a:rPr sz="950" b="1">
                 <a:solidFill>
-                  <a:srgbClr val="2B2620"/>
+                  <a:srgbClr val="111111"/>
                 </a:solidFill>
                 <a:latin typeface="Arial"/>
               </a:rPr>
@@ -3758,7 +3740,7 @@
             <a:r>
               <a:rPr sz="860" b="0">
                 <a:solidFill>
-                  <a:srgbClr val="5A5249"/>
+                  <a:srgbClr val="555555"/>
                 </a:solidFill>
                 <a:latin typeface="Arial"/>
               </a:rPr>
@@ -3793,7 +3775,7 @@
             <a:r>
               <a:rPr sz="950" b="1">
                 <a:solidFill>
-                  <a:srgbClr val="2B2620"/>
+                  <a:srgbClr val="111111"/>
                 </a:solidFill>
                 <a:latin typeface="Arial"/>
               </a:rPr>
@@ -3832,7 +3814,7 @@
             <a:r>
               <a:rPr sz="860" b="0">
                 <a:solidFill>
-                  <a:srgbClr val="5A5249"/>
+                  <a:srgbClr val="555555"/>
                 </a:solidFill>
                 <a:latin typeface="Arial"/>
               </a:rPr>
@@ -3843,7 +3825,7 @@
       </p:sp>
       <p:sp>
         <p:nvSpPr>
-          <p:cNvPr id="22" name="Heading: Our approach"/>
+          <p:cNvPr id="22" name="Heading: Our primary phases"/>
           <p:cNvSpPr txBox="1"/>
           <p:nvPr/>
         </p:nvSpPr>
@@ -3867,11 +3849,11 @@
             <a:r>
               <a:rPr sz="1275" b="1">
                 <a:solidFill>
-                  <a:srgbClr val="2B2620"/>
-                </a:solidFill>
-                <a:latin typeface="Arial"/>
-              </a:rPr>
-              <a:t>Our approach</a:t>
+                  <a:srgbClr val="111111"/>
+                </a:solidFill>
+                <a:latin typeface="Arial"/>
+              </a:rPr>
+              <a:t>Our primary phases</a:t>
             </a:r>
           </a:p>
         </p:txBody>
@@ -3893,11 +3875,11 @@
             </a:avLst>
           </a:prstGeom>
           <a:solidFill>
-            <a:srgbClr val="FFFDF8"/>
+            <a:srgbClr val="F5F5F5"/>
           </a:solidFill>
           <a:ln w="9525">
             <a:solidFill>
-              <a:srgbClr val="E7DECE"/>
+              <a:srgbClr val="F5F5F5"/>
             </a:solidFill>
           </a:ln>
           <a:effectLst/>
@@ -3950,7 +3932,7 @@
             <a:r>
               <a:rPr sz="1125" b="1">
                 <a:solidFill>
-                  <a:srgbClr val="2B2620"/>
+                  <a:srgbClr val="111111"/>
                 </a:solidFill>
                 <a:latin typeface="Arial"/>
               </a:rPr>
@@ -3985,11 +3967,11 @@
             <a:r>
               <a:rPr sz="900" b="1">
                 <a:solidFill>
-                  <a:srgbClr val="C5050C"/>
-                </a:solidFill>
-                <a:latin typeface="Arial"/>
-              </a:rPr>
-              <a:t>Plane well and stay light.</a:t>
+                  <a:srgbClr val="111111"/>
+                </a:solidFill>
+                <a:latin typeface="Arial"/>
+              </a:rPr>
+              <a:t>Plane fast and stay light.</a:t>
             </a:r>
           </a:p>
         </p:txBody>
@@ -4024,7 +4006,7 @@
             <a:r>
               <a:rPr sz="860" b="0">
                 <a:solidFill>
-                  <a:srgbClr val="5A5249"/>
+                  <a:srgbClr val="555555"/>
                 </a:solidFill>
                 <a:latin typeface="Arial"/>
               </a:rPr>
@@ -4040,11 +4022,11 @@
             <a:r>
               <a:rPr sz="860" b="0">
                 <a:solidFill>
-                  <a:srgbClr val="5A5249"/>
-                </a:solidFill>
-                <a:latin typeface="Arial"/>
-              </a:rPr>
-              <a:t>Shape tuned by optimization</a:t>
+                  <a:srgbClr val="555555"/>
+                </a:solidFill>
+                <a:latin typeface="Arial"/>
+              </a:rPr>
+              <a:t>Dimensions shaped by weight</a:t>
             </a:r>
           </a:p>
           <a:p>
@@ -4056,11 +4038,11 @@
             <a:r>
               <a:rPr sz="860" b="0">
                 <a:solidFill>
-                  <a:srgbClr val="5A5249"/>
-                </a:solidFill>
-                <a:latin typeface="Arial"/>
-              </a:rPr>
-              <a:t>Resistance checked in CFD first</a:t>
+                  <a:srgbClr val="555555"/>
+                </a:solidFill>
+                <a:latin typeface="Arial"/>
+              </a:rPr>
+              <a:t>Optimization shaped by hydrodynamics</a:t>
             </a:r>
           </a:p>
         </p:txBody>
@@ -4082,11 +4064,11 @@
             </a:avLst>
           </a:prstGeom>
           <a:solidFill>
-            <a:srgbClr val="FFFDF8"/>
+            <a:srgbClr val="F5F5F5"/>
           </a:solidFill>
           <a:ln w="9525">
             <a:solidFill>
-              <a:srgbClr val="E7DECE"/>
+              <a:srgbClr val="F5F5F5"/>
             </a:solidFill>
           </a:ln>
           <a:effectLst/>
@@ -4139,7 +4121,7 @@
             <a:r>
               <a:rPr sz="1125" b="1">
                 <a:solidFill>
-                  <a:srgbClr val="2B2620"/>
+                  <a:srgbClr val="111111"/>
                 </a:solidFill>
                 <a:latin typeface="Arial"/>
               </a:rPr>
@@ -4174,7 +4156,7 @@
             <a:r>
               <a:rPr sz="900" b="1">
                 <a:solidFill>
-                  <a:srgbClr val="C5050C"/>
+                  <a:srgbClr val="111111"/>
                 </a:solidFill>
                 <a:latin typeface="Arial"/>
               </a:rPr>
@@ -4213,7 +4195,7 @@
             <a:r>
               <a:rPr sz="860" b="0">
                 <a:solidFill>
-                  <a:srgbClr val="5A5249"/>
+                  <a:srgbClr val="555555"/>
                 </a:solidFill>
                 <a:latin typeface="Arial"/>
               </a:rPr>
@@ -4229,7 +4211,7 @@
             <a:r>
               <a:rPr sz="860" b="0">
                 <a:solidFill>
-                  <a:srgbClr val="5A5249"/>
+                  <a:srgbClr val="555555"/>
                 </a:solidFill>
                 <a:latin typeface="Arial"/>
               </a:rPr>
@@ -4245,7 +4227,7 @@
             <a:r>
               <a:rPr sz="860" b="0">
                 <a:solidFill>
-                  <a:srgbClr val="5A5249"/>
+                  <a:srgbClr val="555555"/>
                 </a:solidFill>
                 <a:latin typeface="Arial"/>
               </a:rPr>
@@ -4271,11 +4253,11 @@
             </a:avLst>
           </a:prstGeom>
           <a:solidFill>
-            <a:srgbClr val="FFFDF8"/>
+            <a:srgbClr val="F5F5F5"/>
           </a:solidFill>
           <a:ln w="9525">
             <a:solidFill>
-              <a:srgbClr val="E7DECE"/>
+              <a:srgbClr val="F5F5F5"/>
             </a:solidFill>
           </a:ln>
           <a:effectLst/>
@@ -4328,7 +4310,7 @@
             <a:r>
               <a:rPr sz="1125" b="1">
                 <a:solidFill>
-                  <a:srgbClr val="2B2620"/>
+                  <a:srgbClr val="111111"/>
                 </a:solidFill>
                 <a:latin typeface="Arial"/>
               </a:rPr>
@@ -4363,7 +4345,7 @@
             <a:r>
               <a:rPr sz="900" b="1">
                 <a:solidFill>
-                  <a:srgbClr val="C5050C"/>
+                  <a:srgbClr val="111111"/>
                 </a:solidFill>
                 <a:latin typeface="Arial"/>
               </a:rPr>
@@ -4402,7 +4384,7 @@
             <a:r>
               <a:rPr sz="860" b="0">
                 <a:solidFill>
-                  <a:srgbClr val="5A5249"/>
+                  <a:srgbClr val="555555"/>
                 </a:solidFill>
                 <a:latin typeface="Arial"/>
               </a:rPr>
@@ -4418,11 +4400,11 @@
             <a:r>
               <a:rPr sz="860" b="0">
                 <a:solidFill>
-                  <a:srgbClr val="5A5249"/>
-                </a:solidFill>
-                <a:latin typeface="Arial"/>
-              </a:rPr>
-              <a:t>Firmware protects the battery</a:t>
+                  <a:srgbClr val="555555"/>
+                </a:solidFill>
+                <a:latin typeface="Arial"/>
+              </a:rPr>
+              <a:t>Fundamental feedback protocols</a:t>
             </a:r>
           </a:p>
           <a:p>
@@ -4434,7 +4416,7 @@
             <a:r>
               <a:rPr sz="860" b="0">
                 <a:solidFill>
-                  <a:srgbClr val="5A5249"/>
+                  <a:srgbClr val="555555"/>
                 </a:solidFill>
                 <a:latin typeface="Arial"/>
               </a:rPr>
@@ -4469,7 +4451,7 @@
             <a:r>
               <a:rPr sz="1275" b="1">
                 <a:solidFill>
-                  <a:srgbClr val="2B2620"/>
+                  <a:srgbClr val="111111"/>
                 </a:solidFill>
                 <a:latin typeface="Arial"/>
               </a:rPr>
@@ -4504,7 +4486,7 @@
             <a:r>
               <a:rPr sz="819" b="1">
                 <a:solidFill>
-                  <a:srgbClr val="C5050C"/>
+                  <a:srgbClr val="111111"/>
                 </a:solidFill>
                 <a:latin typeface="Arial"/>
               </a:rPr>
@@ -4539,7 +4521,7 @@
             <a:r>
               <a:rPr sz="819" b="0">
                 <a:solidFill>
-                  <a:srgbClr val="5A5249"/>
+                  <a:srgbClr val="555555"/>
                 </a:solidFill>
                 <a:latin typeface="Arial"/>
               </a:rPr>
@@ -4574,7 +4556,7 @@
             <a:r>
               <a:rPr sz="819" b="1">
                 <a:solidFill>
-                  <a:srgbClr val="C5050C"/>
+                  <a:srgbClr val="111111"/>
                 </a:solidFill>
                 <a:latin typeface="Arial"/>
               </a:rPr>
@@ -4609,7 +4591,7 @@
             <a:r>
               <a:rPr sz="819" b="0">
                 <a:solidFill>
-                  <a:srgbClr val="5A5249"/>
+                  <a:srgbClr val="555555"/>
                 </a:solidFill>
                 <a:latin typeface="Arial"/>
               </a:rPr>
@@ -4644,7 +4626,7 @@
             <a:r>
               <a:rPr sz="819" b="1">
                 <a:solidFill>
-                  <a:srgbClr val="C5050C"/>
+                  <a:srgbClr val="111111"/>
                 </a:solidFill>
                 <a:latin typeface="Arial"/>
               </a:rPr>
@@ -4679,7 +4661,7 @@
             <a:r>
               <a:rPr sz="819" b="0">
                 <a:solidFill>
-                  <a:srgbClr val="5A5249"/>
+                  <a:srgbClr val="555555"/>
                 </a:solidFill>
                 <a:latin typeface="Arial"/>
               </a:rPr>
@@ -4714,7 +4696,7 @@
             <a:r>
               <a:rPr sz="819" b="1">
                 <a:solidFill>
-                  <a:srgbClr val="C5050C"/>
+                  <a:srgbClr val="111111"/>
                 </a:solidFill>
                 <a:latin typeface="Arial"/>
               </a:rPr>
@@ -4749,7 +4731,7 @@
             <a:r>
               <a:rPr sz="819" b="0">
                 <a:solidFill>
-                  <a:srgbClr val="5A5249"/>
+                  <a:srgbClr val="555555"/>
                 </a:solidFill>
                 <a:latin typeface="Arial"/>
               </a:rPr>
@@ -4784,7 +4766,7 @@
             <a:r>
               <a:rPr sz="819" b="1">
                 <a:solidFill>
-                  <a:srgbClr val="C5050C"/>
+                  <a:srgbClr val="111111"/>
                 </a:solidFill>
                 <a:latin typeface="Arial"/>
               </a:rPr>
@@ -4819,7 +4801,7 @@
             <a:r>
               <a:rPr sz="819" b="0">
                 <a:solidFill>
-                  <a:srgbClr val="5A5249"/>
+                  <a:srgbClr val="555555"/>
                 </a:solidFill>
                 <a:latin typeface="Arial"/>
               </a:rPr>
@@ -4854,7 +4836,7 @@
             <a:r>
               <a:rPr sz="819" b="1">
                 <a:solidFill>
-                  <a:srgbClr val="C5050C"/>
+                  <a:srgbClr val="111111"/>
                 </a:solidFill>
                 <a:latin typeface="Arial"/>
               </a:rPr>
@@ -4889,7 +4871,7 @@
             <a:r>
               <a:rPr sz="819" b="0">
                 <a:solidFill>
-                  <a:srgbClr val="5A5249"/>
+                  <a:srgbClr val="555555"/>
                 </a:solidFill>
                 <a:latin typeface="Arial"/>
               </a:rPr>
@@ -4924,7 +4906,7 @@
             <a:r>
               <a:rPr sz="819" b="1">
                 <a:solidFill>
-                  <a:srgbClr val="C5050C"/>
+                  <a:srgbClr val="111111"/>
                 </a:solidFill>
                 <a:latin typeface="Arial"/>
               </a:rPr>
@@ -4959,7 +4941,7 @@
             <a:r>
               <a:rPr sz="819" b="0">
                 <a:solidFill>
-                  <a:srgbClr val="5A5249"/>
+                  <a:srgbClr val="555555"/>
                 </a:solidFill>
                 <a:latin typeface="Arial"/>
               </a:rPr>
@@ -4994,7 +4976,7 @@
             <a:r>
               <a:rPr sz="819" b="1">
                 <a:solidFill>
-                  <a:srgbClr val="C5050C"/>
+                  <a:srgbClr val="111111"/>
                 </a:solidFill>
                 <a:latin typeface="Arial"/>
               </a:rPr>
@@ -5029,7 +5011,7 @@
             <a:r>
               <a:rPr sz="819" b="0">
                 <a:solidFill>
-                  <a:srgbClr val="5A5249"/>
+                  <a:srgbClr val="555555"/>
                 </a:solidFill>
                 <a:latin typeface="Arial"/>
               </a:rPr>
@@ -5064,7 +5046,7 @@
             <a:r>
               <a:rPr sz="819" b="1">
                 <a:solidFill>
-                  <a:srgbClr val="C5050C"/>
+                  <a:srgbClr val="111111"/>
                 </a:solidFill>
                 <a:latin typeface="Arial"/>
               </a:rPr>
@@ -5099,7 +5081,7 @@
             <a:r>
               <a:rPr sz="819" b="0">
                 <a:solidFill>
-                  <a:srgbClr val="5A5249"/>
+                  <a:srgbClr val="555555"/>
                 </a:solidFill>
                 <a:latin typeface="Arial"/>
               </a:rPr>
@@ -5134,7 +5116,7 @@
             <a:r>
               <a:rPr sz="819" b="1">
                 <a:solidFill>
-                  <a:srgbClr val="C5050C"/>
+                  <a:srgbClr val="111111"/>
                 </a:solidFill>
                 <a:latin typeface="Arial"/>
               </a:rPr>
@@ -5169,7 +5151,7 @@
             <a:r>
               <a:rPr sz="819" b="0">
                 <a:solidFill>
-                  <a:srgbClr val="5A5249"/>
+                  <a:srgbClr val="555555"/>
                 </a:solidFill>
                 <a:latin typeface="Arial"/>
               </a:rPr>
@@ -5204,7 +5186,7 @@
             <a:r>
               <a:rPr sz="819" b="1">
                 <a:solidFill>
-                  <a:srgbClr val="C5050C"/>
+                  <a:srgbClr val="111111"/>
                 </a:solidFill>
                 <a:latin typeface="Arial"/>
               </a:rPr>
@@ -5239,7 +5221,7 @@
             <a:r>
               <a:rPr sz="819" b="0">
                 <a:solidFill>
-                  <a:srgbClr val="5A5249"/>
+                  <a:srgbClr val="555555"/>
                 </a:solidFill>
                 <a:latin typeface="Arial"/>
               </a:rPr>
@@ -5274,7 +5256,7 @@
             <a:r>
               <a:rPr sz="819" b="1">
                 <a:solidFill>
-                  <a:srgbClr val="C5050C"/>
+                  <a:srgbClr val="111111"/>
                 </a:solidFill>
                 <a:latin typeface="Arial"/>
               </a:rPr>
@@ -5309,7 +5291,7 @@
             <a:r>
               <a:rPr sz="819" b="0">
                 <a:solidFill>
-                  <a:srgbClr val="5A5249"/>
+                  <a:srgbClr val="555555"/>
                 </a:solidFill>
                 <a:latin typeface="Arial"/>
               </a:rPr>
@@ -5335,7 +5317,7 @@
             </a:avLst>
           </a:prstGeom>
           <a:solidFill>
-            <a:srgbClr val="2B2620"/>
+            <a:srgbClr val="111111"/>
           </a:solidFill>
           <a:ln>
             <a:noFill/>
@@ -5390,11 +5372,11 @@
             <a:r>
               <a:rPr sz="1425" b="1">
                 <a:solidFill>
-                  <a:srgbClr val="F8F3EA"/>
-                </a:solidFill>
-                <a:latin typeface="Arial"/>
-              </a:rPr>
-              <a:t>Want to help build it?</a:t>
+                  <a:srgbClr val="FFFFFF"/>
+                </a:solidFill>
+                <a:latin typeface="Arial"/>
+              </a:rPr>
+              <a:t>Want to get involved?</a:t>
             </a:r>
           </a:p>
         </p:txBody>
@@ -5429,11 +5411,11 @@
             <a:r>
               <a:rPr sz="900" b="0">
                 <a:solidFill>
-                  <a:srgbClr val="BDB7AD"/>
-                </a:solidFill>
-                <a:latin typeface="Arial"/>
-              </a:rPr>
-              <a:t>We are looking for funds, parts, advisors and people to build our BOM as we design.</a:t>
+                  <a:srgbClr val="BBBBBB"/>
+                </a:solidFill>
+                <a:latin typeface="Arial"/>
+              </a:rPr>
+              <a:t>We are looking for funds, parts, advisors and supporters. Email Marley or head to our site for more information.</a:t>
             </a:r>
           </a:p>
         </p:txBody>
@@ -5464,7 +5446,7 @@
             <a:r>
               <a:rPr sz="1425" b="1">
                 <a:solidFill>
-                  <a:srgbClr val="F8F3EA"/>
+                  <a:srgbClr val="FFFFFF"/>
                 </a:solidFill>
                 <a:latin typeface="Arial"/>
               </a:rPr>
@@ -5499,7 +5481,7 @@
             <a:r>
               <a:rPr sz="900" b="1">
                 <a:solidFill>
-                  <a:srgbClr val="F8F3EA"/>
+                  <a:srgbClr val="FFFFFF"/>
                 </a:solidFill>
                 <a:latin typeface="Arial"/>
               </a:rPr>
@@ -5534,7 +5516,7 @@
             <a:r>
               <a:rPr sz="900" b="0">
                 <a:solidFill>
-                  <a:srgbClr val="BDB7AD"/>
+                  <a:srgbClr val="BBBBBB"/>
                 </a:solidFill>
                 <a:latin typeface="Arial"/>
               </a:rPr>

</xml_diff>

<commit_message>
Handout: capitalize the discipline descriptions
Co-Authored-By: Claude Sonnet 5.5 <noreply@anthropic.com>
</commit_message>
<xml_diff>
--- a/dashboard/public/haav-handout.pptx
+++ b/dashboard/public/haav-handout.pptx
@@ -3596,7 +3596,7 @@
                 </a:solidFill>
                 <a:latin typeface="Arial"/>
               </a:rPr>
-              <a:t>optimization, composites and manufacturing</a:t>
+              <a:t>Optimization, composites and manufacturing</a:t>
             </a:r>
           </a:p>
         </p:txBody>
@@ -3670,7 +3670,7 @@
                 </a:solidFill>
                 <a:latin typeface="Arial"/>
               </a:rPr>
-              <a:t>structures, CAD</a:t>
+              <a:t>Structures, CAD</a:t>
             </a:r>
           </a:p>
         </p:txBody>
@@ -3744,7 +3744,7 @@
                 </a:solidFill>
                 <a:latin typeface="Arial"/>
               </a:rPr>
-              <a:t>power, battery and high voltage</a:t>
+              <a:t>Power, battery and high voltage</a:t>
             </a:r>
           </a:p>
         </p:txBody>
@@ -3818,7 +3818,7 @@
                 </a:solidFill>
                 <a:latin typeface="Arial"/>
               </a:rPr>
-              <a:t>embedded, firmware and software</a:t>
+              <a:t>Embedded, firmware and software</a:t>
             </a:r>
           </a:p>
         </p:txBody>

</xml_diff>

<commit_message>
Handout: capitalize discipline descriptions, even phase-card padding, 'our model' wording
Co-Authored-By: Claude Sonnet 5.5 <noreply@anthropic.com>
</commit_message>
<xml_diff>
--- a/dashboard/public/haav-handout.pptx
+++ b/dashboard/public/haav-handout.pptx
@@ -3452,7 +3452,7 @@
                 </a:solidFill>
                 <a:latin typeface="Arial"/>
               </a:rPr>
-              <a:t>We are building the model from first principles, mixing empirical and rule-of-thumb decisions with dynamic programming. Each constraint cuts the space of possible boats, and the optimizer finds the fastest one based on current variables. As we build and test, we keep updating the model and adding constraints: a hybrid of simulation and empirical data.</a:t>
+              <a:t>We are building the model from first principles, mixing empirical and rule-of-thumb decisions with dynamic programming. Each constraint cuts the space of possible boats, and our model finds the fastest one based on current variables. As we build and test, we keep updating the model and adding constraints: a hybrid of simulation and empirical data.</a:t>
             </a:r>
           </a:p>
         </p:txBody>
@@ -3867,11 +3867,11 @@
         <p:spPr>
           <a:xfrm>
             <a:off x="502920" y="5824728"/>
-            <a:ext cx="2179320" cy="1143000"/>
+            <a:ext cx="2179320" cy="1188720"/>
           </a:xfrm>
           <a:prstGeom prst="roundRect">
             <a:avLst>
-              <a:gd name="adj" fmla="val 12800"/>
+              <a:gd name="adj" fmla="val 12307"/>
             </a:avLst>
           </a:prstGeom>
           <a:solidFill>
@@ -3914,7 +3914,7 @@
         </p:nvSpPr>
         <p:spPr>
           <a:xfrm>
-            <a:off x="640080" y="5897880"/>
+            <a:off x="640080" y="5971032"/>
             <a:ext cx="1905000" cy="228600"/>
           </a:xfrm>
           <a:prstGeom prst="rect">
@@ -3949,7 +3949,7 @@
         </p:nvSpPr>
         <p:spPr>
           <a:xfrm>
-            <a:off x="640080" y="6108192"/>
+            <a:off x="640080" y="6181344"/>
             <a:ext cx="1905000" cy="182880"/>
           </a:xfrm>
           <a:prstGeom prst="rect">
@@ -3984,7 +3984,7 @@
         </p:nvSpPr>
         <p:spPr>
           <a:xfrm>
-            <a:off x="640080" y="6327648"/>
+            <a:off x="640080" y="6419088"/>
             <a:ext cx="1905000" cy="548640"/>
           </a:xfrm>
           <a:prstGeom prst="rect">
@@ -4000,11 +4000,11 @@
           <a:p>
             <a:pPr algn="l">
               <a:lnSpc>
-                <a:spcPct val="115000"/>
+                <a:spcPct val="120000"/>
               </a:lnSpc>
             </a:pPr>
             <a:r>
-              <a:rPr sz="860" b="0">
+              <a:rPr sz="819" b="0">
                 <a:solidFill>
                   <a:srgbClr val="555555"/>
                 </a:solidFill>
@@ -4016,11 +4016,11 @@
           <a:p>
             <a:pPr algn="l">
               <a:lnSpc>
-                <a:spcPct val="115000"/>
+                <a:spcPct val="120000"/>
               </a:lnSpc>
             </a:pPr>
             <a:r>
-              <a:rPr sz="860" b="0">
+              <a:rPr sz="819" b="0">
                 <a:solidFill>
                   <a:srgbClr val="555555"/>
                 </a:solidFill>
@@ -4032,11 +4032,11 @@
           <a:p>
             <a:pPr algn="l">
               <a:lnSpc>
-                <a:spcPct val="115000"/>
+                <a:spcPct val="120000"/>
               </a:lnSpc>
             </a:pPr>
             <a:r>
-              <a:rPr sz="860" b="0">
+              <a:rPr sz="819" b="0">
                 <a:solidFill>
                   <a:srgbClr val="555555"/>
                 </a:solidFill>
@@ -4056,11 +4056,11 @@
         <p:spPr>
           <a:xfrm>
             <a:off x="2796540" y="5824728"/>
-            <a:ext cx="2179320" cy="1143000"/>
+            <a:ext cx="2179320" cy="1188720"/>
           </a:xfrm>
           <a:prstGeom prst="roundRect">
             <a:avLst>
-              <a:gd name="adj" fmla="val 12800"/>
+              <a:gd name="adj" fmla="val 12307"/>
             </a:avLst>
           </a:prstGeom>
           <a:solidFill>
@@ -4103,7 +4103,7 @@
         </p:nvSpPr>
         <p:spPr>
           <a:xfrm>
-            <a:off x="2933700" y="5897880"/>
+            <a:off x="2933700" y="5971032"/>
             <a:ext cx="1905000" cy="228600"/>
           </a:xfrm>
           <a:prstGeom prst="rect">
@@ -4138,7 +4138,7 @@
         </p:nvSpPr>
         <p:spPr>
           <a:xfrm>
-            <a:off x="2933700" y="6108192"/>
+            <a:off x="2933700" y="6181344"/>
             <a:ext cx="1905000" cy="182880"/>
           </a:xfrm>
           <a:prstGeom prst="rect">
@@ -4173,7 +4173,7 @@
         </p:nvSpPr>
         <p:spPr>
           <a:xfrm>
-            <a:off x="2933700" y="6327648"/>
+            <a:off x="2933700" y="6419088"/>
             <a:ext cx="1905000" cy="548640"/>
           </a:xfrm>
           <a:prstGeom prst="rect">
@@ -4189,11 +4189,11 @@
           <a:p>
             <a:pPr algn="l">
               <a:lnSpc>
-                <a:spcPct val="115000"/>
+                <a:spcPct val="120000"/>
               </a:lnSpc>
             </a:pPr>
             <a:r>
-              <a:rPr sz="860" b="0">
+              <a:rPr sz="819" b="0">
                 <a:solidFill>
                   <a:srgbClr val="555555"/>
                 </a:solidFill>
@@ -4205,11 +4205,11 @@
           <a:p>
             <a:pPr algn="l">
               <a:lnSpc>
-                <a:spcPct val="115000"/>
+                <a:spcPct val="120000"/>
               </a:lnSpc>
             </a:pPr>
             <a:r>
-              <a:rPr sz="860" b="0">
+              <a:rPr sz="819" b="0">
                 <a:solidFill>
                   <a:srgbClr val="555555"/>
                 </a:solidFill>
@@ -4221,11 +4221,11 @@
           <a:p>
             <a:pPr algn="l">
               <a:lnSpc>
-                <a:spcPct val="115000"/>
+                <a:spcPct val="120000"/>
               </a:lnSpc>
             </a:pPr>
             <a:r>
-              <a:rPr sz="860" b="0">
+              <a:rPr sz="819" b="0">
                 <a:solidFill>
                   <a:srgbClr val="555555"/>
                 </a:solidFill>
@@ -4245,11 +4245,11 @@
         <p:spPr>
           <a:xfrm>
             <a:off x="5090160" y="5824728"/>
-            <a:ext cx="2179320" cy="1143000"/>
+            <a:ext cx="2179320" cy="1188720"/>
           </a:xfrm>
           <a:prstGeom prst="roundRect">
             <a:avLst>
-              <a:gd name="adj" fmla="val 12800"/>
+              <a:gd name="adj" fmla="val 12307"/>
             </a:avLst>
           </a:prstGeom>
           <a:solidFill>
@@ -4292,7 +4292,7 @@
         </p:nvSpPr>
         <p:spPr>
           <a:xfrm>
-            <a:off x="5227320" y="5897880"/>
+            <a:off x="5227320" y="5971032"/>
             <a:ext cx="1905000" cy="228600"/>
           </a:xfrm>
           <a:prstGeom prst="rect">
@@ -4327,7 +4327,7 @@
         </p:nvSpPr>
         <p:spPr>
           <a:xfrm>
-            <a:off x="5227320" y="6108192"/>
+            <a:off x="5227320" y="6181344"/>
             <a:ext cx="1905000" cy="182880"/>
           </a:xfrm>
           <a:prstGeom prst="rect">
@@ -4362,7 +4362,7 @@
         </p:nvSpPr>
         <p:spPr>
           <a:xfrm>
-            <a:off x="5227320" y="6327648"/>
+            <a:off x="5227320" y="6419088"/>
             <a:ext cx="1905000" cy="548640"/>
           </a:xfrm>
           <a:prstGeom prst="rect">
@@ -4378,11 +4378,11 @@
           <a:p>
             <a:pPr algn="l">
               <a:lnSpc>
-                <a:spcPct val="115000"/>
+                <a:spcPct val="120000"/>
               </a:lnSpc>
             </a:pPr>
             <a:r>
-              <a:rPr sz="860" b="0">
+              <a:rPr sz="819" b="0">
                 <a:solidFill>
                   <a:srgbClr val="555555"/>
                 </a:solidFill>
@@ -4394,11 +4394,11 @@
           <a:p>
             <a:pPr algn="l">
               <a:lnSpc>
-                <a:spcPct val="115000"/>
+                <a:spcPct val="120000"/>
               </a:lnSpc>
             </a:pPr>
             <a:r>
-              <a:rPr sz="860" b="0">
+              <a:rPr sz="819" b="0">
                 <a:solidFill>
                   <a:srgbClr val="555555"/>
                 </a:solidFill>
@@ -4410,11 +4410,11 @@
           <a:p>
             <a:pPr algn="l">
               <a:lnSpc>
-                <a:spcPct val="115000"/>
+                <a:spcPct val="120000"/>
               </a:lnSpc>
             </a:pPr>
             <a:r>
-              <a:rPr sz="860" b="0">
+              <a:rPr sz="819" b="0">
                 <a:solidFill>
                   <a:srgbClr val="555555"/>
                 </a:solidFill>

</xml_diff>

<commit_message>
Handout: three quick facts, 'We are a student team', discipline wording
Co-Authored-By: Claude Sonnet 5.5 <noreply@anthropic.com>
</commit_message>
<xml_diff>
--- a/dashboard/public/haav-handout.pptx
+++ b/dashboard/public/haav-handout.pptx
@@ -3280,8 +3280,8 @@
         </p:nvSpPr>
         <p:spPr>
           <a:xfrm>
-            <a:off x="502920" y="1572768"/>
-            <a:ext cx="3931920" cy="1188720"/>
+            <a:off x="502920" y="1481328"/>
+            <a:ext cx="4480560" cy="1097280"/>
           </a:xfrm>
           <a:prstGeom prst="rect">
             <a:avLst/>
@@ -3300,13 +3300,13 @@
               </a:lnSpc>
             </a:pPr>
             <a:r>
-              <a:rPr sz="2400" b="1">
+              <a:rPr sz="2250" b="1">
                 <a:solidFill>
                   <a:srgbClr val="111111"/>
                 </a:solidFill>
                 <a:latin typeface="Arial"/>
               </a:rPr>
-              <a:t>A student team building an uncrewed autonomous boat from the ground up.</a:t>
+              <a:t>We are a student team building an uncrewed autonomous boat from the ground up.</a:t>
             </a:r>
           </a:p>
         </p:txBody>
@@ -3327,8 +3327,8 @@
         </p:blipFill>
         <p:spPr>
           <a:xfrm rot="21420000">
-            <a:off x="4983480" y="1298448"/>
-            <a:ext cx="2286000" cy="1917045"/>
+            <a:off x="5532120" y="1170432"/>
+            <a:ext cx="1737360" cy="1456954"/>
           </a:xfrm>
           <a:prstGeom prst="rect">
             <a:avLst/>
@@ -3337,18 +3337,18 @@
       </p:pic>
       <p:sp>
         <p:nvSpPr>
-          <p:cNvPr id="9" name="Model card"/>
+          <p:cNvPr id="9" name="Fact card: Speed"/>
           <p:cNvSpPr/>
           <p:nvPr/>
         </p:nvSpPr>
         <p:spPr>
           <a:xfrm>
-            <a:off x="502920" y="3227832"/>
-            <a:ext cx="6766560" cy="978408"/>
+            <a:off x="502920" y="2743200"/>
+            <a:ext cx="2179320" cy="548640"/>
           </a:xfrm>
           <a:prstGeom prst="roundRect">
             <a:avLst>
-              <a:gd name="adj" fmla="val 14953"/>
+              <a:gd name="adj" fmla="val 26666"/>
             </a:avLst>
           </a:prstGeom>
           <a:solidFill>
@@ -3385,14 +3385,14 @@
       </p:sp>
       <p:sp>
         <p:nvSpPr>
-          <p:cNvPr id="10" name="Model title"/>
+          <p:cNvPr id="10" name="Fact: 40 mph"/>
           <p:cNvSpPr txBox="1"/>
           <p:nvPr/>
         </p:nvSpPr>
         <p:spPr>
           <a:xfrm>
-            <a:off x="658368" y="3319272"/>
-            <a:ext cx="6455664" cy="274320"/>
+            <a:off x="640080" y="2807208"/>
+            <a:ext cx="1905000" cy="274320"/>
           </a:xfrm>
           <a:prstGeom prst="rect">
             <a:avLst/>
@@ -3407,27 +3407,27 @@
           <a:p>
             <a:pPr algn="l"/>
             <a:r>
-              <a:rPr sz="1275" b="1">
+              <a:rPr sz="1425" b="1">
                 <a:solidFill>
                   <a:srgbClr val="111111"/>
                 </a:solidFill>
                 <a:latin typeface="Arial"/>
               </a:rPr>
-              <a:t>Ground up means simulation + modeling first</a:t>
-            </a:r>
-          </a:p>
-        </p:txBody>
-      </p:sp>
-      <p:sp>
-        <p:nvSpPr>
-          <p:cNvPr id="11" name="Model text"/>
+              <a:t>40 mph</a:t>
+            </a:r>
+          </a:p>
+        </p:txBody>
+      </p:sp>
+      <p:sp>
+        <p:nvSpPr>
+          <p:cNvPr id="11" name="Fact label: Speed"/>
           <p:cNvSpPr txBox="1"/>
           <p:nvPr/>
         </p:nvSpPr>
         <p:spPr>
           <a:xfrm>
-            <a:off x="658368" y="3584448"/>
-            <a:ext cx="6455664" cy="594360"/>
+            <a:off x="640080" y="3063240"/>
+            <a:ext cx="1905000" cy="182880"/>
           </a:xfrm>
           <a:prstGeom prst="rect">
             <a:avLst/>
@@ -3440,438 +3440,33 @@
           </a:bodyPr>
           <a:lstStyle/>
           <a:p>
-            <a:pPr algn="l">
-              <a:lnSpc>
-                <a:spcPct val="120000"/>
-              </a:lnSpc>
-            </a:pPr>
-            <a:r>
-              <a:rPr sz="900" b="0">
+            <a:pPr algn="l"/>
+            <a:r>
+              <a:rPr sz="860" b="0">
                 <a:solidFill>
                   <a:srgbClr val="555555"/>
                 </a:solidFill>
                 <a:latin typeface="Arial"/>
               </a:rPr>
-              <a:t>We are building the model from first principles, mixing empirical and rule-of-thumb decisions with dynamic programming. Each constraint cuts the space of possible boats, and our model finds the fastest one based on current variables. As we build and test, we keep updating the model and adding constraints: a hybrid of simulation and empirical data.</a:t>
-            </a:r>
-          </a:p>
-        </p:txBody>
-      </p:sp>
-      <p:sp>
-        <p:nvSpPr>
-          <p:cNvPr id="12" name="Heading: Engineers from across UW–Madison"/>
-          <p:cNvSpPr txBox="1"/>
-          <p:nvPr/>
-        </p:nvSpPr>
-        <p:spPr>
-          <a:xfrm>
-            <a:off x="502920" y="4434840"/>
-            <a:ext cx="6583680" cy="274320"/>
-          </a:xfrm>
-          <a:prstGeom prst="rect">
-            <a:avLst/>
-          </a:prstGeom>
-          <a:noFill/>
-        </p:spPr>
-        <p:txBody>
-          <a:bodyPr wrap="square" lIns="0" rIns="0" tIns="0" bIns="0" anchor="t">
-            <a:spAutoFit/>
-          </a:bodyPr>
-          <a:lstStyle/>
-          <a:p>
-            <a:pPr algn="l"/>
-            <a:r>
-              <a:rPr sz="1275" b="1">
-                <a:solidFill>
-                  <a:srgbClr val="111111"/>
-                </a:solidFill>
-                <a:latin typeface="Arial"/>
-              </a:rPr>
-              <a:t>Engineers from across UW–Madison</a:t>
-            </a:r>
-          </a:p>
-        </p:txBody>
-      </p:sp>
-      <p:sp>
-        <p:nvSpPr>
-          <p:cNvPr id="13" name="Engineers text"/>
-          <p:cNvSpPr txBox="1"/>
-          <p:nvPr/>
-        </p:nvSpPr>
-        <p:spPr>
-          <a:xfrm>
-            <a:off x="502920" y="4690872"/>
-            <a:ext cx="6766560" cy="182880"/>
-          </a:xfrm>
-          <a:prstGeom prst="rect">
-            <a:avLst/>
-          </a:prstGeom>
-          <a:noFill/>
-        </p:spPr>
-        <p:txBody>
-          <a:bodyPr wrap="square" lIns="0" rIns="0" tIns="0" bIns="0" anchor="t">
-            <a:spAutoFit/>
-          </a:bodyPr>
-          <a:lstStyle/>
-          <a:p>
-            <a:pPr algn="l"/>
-            <a:r>
-              <a:rPr sz="900" b="0">
-                <a:solidFill>
-                  <a:srgbClr val="555555"/>
-                </a:solidFill>
-                <a:latin typeface="Arial"/>
-              </a:rPr>
-              <a:t>Lead members have interned at Tesla, Northrop Grumman, Xcel Energy, Fincantieri and Milwaukee Tool.</a:t>
-            </a:r>
-          </a:p>
-        </p:txBody>
-      </p:sp>
-      <p:sp>
-        <p:nvSpPr>
-          <p:cNvPr id="14" name="Discipline: Industrial"/>
-          <p:cNvSpPr txBox="1"/>
-          <p:nvPr/>
-        </p:nvSpPr>
-        <p:spPr>
-          <a:xfrm>
-            <a:off x="502920" y="4937760"/>
-            <a:ext cx="1565910" cy="182880"/>
-          </a:xfrm>
-          <a:prstGeom prst="rect">
-            <a:avLst/>
-          </a:prstGeom>
-          <a:noFill/>
-        </p:spPr>
-        <p:txBody>
-          <a:bodyPr wrap="square" lIns="0" rIns="0" tIns="0" bIns="0" anchor="t">
-            <a:spAutoFit/>
-          </a:bodyPr>
-          <a:lstStyle/>
-          <a:p>
-            <a:pPr algn="l"/>
-            <a:r>
-              <a:rPr sz="950" b="1">
-                <a:solidFill>
-                  <a:srgbClr val="111111"/>
-                </a:solidFill>
-                <a:latin typeface="Arial"/>
-              </a:rPr>
-              <a:t>Industrial</a:t>
-            </a:r>
-          </a:p>
-        </p:txBody>
-      </p:sp>
-      <p:sp>
-        <p:nvSpPr>
-          <p:cNvPr id="15" name="Discipline text: Industrial"/>
-          <p:cNvSpPr txBox="1"/>
-          <p:nvPr/>
-        </p:nvSpPr>
-        <p:spPr>
-          <a:xfrm>
-            <a:off x="502920" y="5120640"/>
-            <a:ext cx="1474470" cy="365760"/>
-          </a:xfrm>
-          <a:prstGeom prst="rect">
-            <a:avLst/>
-          </a:prstGeom>
-          <a:noFill/>
-        </p:spPr>
-        <p:txBody>
-          <a:bodyPr wrap="square" lIns="0" rIns="0" tIns="0" bIns="0" anchor="t">
-            <a:spAutoFit/>
-          </a:bodyPr>
-          <a:lstStyle/>
-          <a:p>
-            <a:pPr algn="l">
-              <a:lnSpc>
-                <a:spcPct val="110000"/>
-              </a:lnSpc>
-            </a:pPr>
-            <a:r>
-              <a:rPr sz="860" b="0">
-                <a:solidFill>
-                  <a:srgbClr val="555555"/>
-                </a:solidFill>
-                <a:latin typeface="Arial"/>
-              </a:rPr>
-              <a:t>Optimization, composites and manufacturing</a:t>
-            </a:r>
-          </a:p>
-        </p:txBody>
-      </p:sp>
-      <p:sp>
-        <p:nvSpPr>
-          <p:cNvPr id="16" name="Discipline: Mechanical"/>
-          <p:cNvSpPr txBox="1"/>
-          <p:nvPr/>
-        </p:nvSpPr>
-        <p:spPr>
-          <a:xfrm>
-            <a:off x="2251710" y="4937760"/>
-            <a:ext cx="1565910" cy="182880"/>
-          </a:xfrm>
-          <a:prstGeom prst="rect">
-            <a:avLst/>
-          </a:prstGeom>
-          <a:noFill/>
-        </p:spPr>
-        <p:txBody>
-          <a:bodyPr wrap="square" lIns="0" rIns="0" tIns="0" bIns="0" anchor="t">
-            <a:spAutoFit/>
-          </a:bodyPr>
-          <a:lstStyle/>
-          <a:p>
-            <a:pPr algn="l"/>
-            <a:r>
-              <a:rPr sz="950" b="1">
-                <a:solidFill>
-                  <a:srgbClr val="111111"/>
-                </a:solidFill>
-                <a:latin typeface="Arial"/>
-              </a:rPr>
-              <a:t>Mechanical</a:t>
-            </a:r>
-          </a:p>
-        </p:txBody>
-      </p:sp>
-      <p:sp>
-        <p:nvSpPr>
-          <p:cNvPr id="17" name="Discipline text: Mechanical"/>
-          <p:cNvSpPr txBox="1"/>
-          <p:nvPr/>
-        </p:nvSpPr>
-        <p:spPr>
-          <a:xfrm>
-            <a:off x="2251710" y="5120640"/>
-            <a:ext cx="1474470" cy="365760"/>
-          </a:xfrm>
-          <a:prstGeom prst="rect">
-            <a:avLst/>
-          </a:prstGeom>
-          <a:noFill/>
-        </p:spPr>
-        <p:txBody>
-          <a:bodyPr wrap="square" lIns="0" rIns="0" tIns="0" bIns="0" anchor="t">
-            <a:spAutoFit/>
-          </a:bodyPr>
-          <a:lstStyle/>
-          <a:p>
-            <a:pPr algn="l">
-              <a:lnSpc>
-                <a:spcPct val="110000"/>
-              </a:lnSpc>
-            </a:pPr>
-            <a:r>
-              <a:rPr sz="860" b="0">
-                <a:solidFill>
-                  <a:srgbClr val="555555"/>
-                </a:solidFill>
-                <a:latin typeface="Arial"/>
-              </a:rPr>
-              <a:t>Structures, CAD</a:t>
-            </a:r>
-          </a:p>
-        </p:txBody>
-      </p:sp>
-      <p:sp>
-        <p:nvSpPr>
-          <p:cNvPr id="18" name="Discipline: Electrical"/>
-          <p:cNvSpPr txBox="1"/>
-          <p:nvPr/>
-        </p:nvSpPr>
-        <p:spPr>
-          <a:xfrm>
-            <a:off x="4000500" y="4937760"/>
-            <a:ext cx="1565910" cy="182880"/>
-          </a:xfrm>
-          <a:prstGeom prst="rect">
-            <a:avLst/>
-          </a:prstGeom>
-          <a:noFill/>
-        </p:spPr>
-        <p:txBody>
-          <a:bodyPr wrap="square" lIns="0" rIns="0" tIns="0" bIns="0" anchor="t">
-            <a:spAutoFit/>
-          </a:bodyPr>
-          <a:lstStyle/>
-          <a:p>
-            <a:pPr algn="l"/>
-            <a:r>
-              <a:rPr sz="950" b="1">
-                <a:solidFill>
-                  <a:srgbClr val="111111"/>
-                </a:solidFill>
-                <a:latin typeface="Arial"/>
-              </a:rPr>
-              <a:t>Electrical</a:t>
-            </a:r>
-          </a:p>
-        </p:txBody>
-      </p:sp>
-      <p:sp>
-        <p:nvSpPr>
-          <p:cNvPr id="19" name="Discipline text: Electrical"/>
-          <p:cNvSpPr txBox="1"/>
-          <p:nvPr/>
-        </p:nvSpPr>
-        <p:spPr>
-          <a:xfrm>
-            <a:off x="4000500" y="5120640"/>
-            <a:ext cx="1474470" cy="365760"/>
-          </a:xfrm>
-          <a:prstGeom prst="rect">
-            <a:avLst/>
-          </a:prstGeom>
-          <a:noFill/>
-        </p:spPr>
-        <p:txBody>
-          <a:bodyPr wrap="square" lIns="0" rIns="0" tIns="0" bIns="0" anchor="t">
-            <a:spAutoFit/>
-          </a:bodyPr>
-          <a:lstStyle/>
-          <a:p>
-            <a:pPr algn="l">
-              <a:lnSpc>
-                <a:spcPct val="110000"/>
-              </a:lnSpc>
-            </a:pPr>
-            <a:r>
-              <a:rPr sz="860" b="0">
-                <a:solidFill>
-                  <a:srgbClr val="555555"/>
-                </a:solidFill>
-                <a:latin typeface="Arial"/>
-              </a:rPr>
-              <a:t>Power, battery and high voltage</a:t>
-            </a:r>
-          </a:p>
-        </p:txBody>
-      </p:sp>
-      <p:sp>
-        <p:nvSpPr>
-          <p:cNvPr id="20" name="Discipline: Computer"/>
-          <p:cNvSpPr txBox="1"/>
-          <p:nvPr/>
-        </p:nvSpPr>
-        <p:spPr>
-          <a:xfrm>
-            <a:off x="5749290" y="4937760"/>
-            <a:ext cx="1565910" cy="182880"/>
-          </a:xfrm>
-          <a:prstGeom prst="rect">
-            <a:avLst/>
-          </a:prstGeom>
-          <a:noFill/>
-        </p:spPr>
-        <p:txBody>
-          <a:bodyPr wrap="square" lIns="0" rIns="0" tIns="0" bIns="0" anchor="t">
-            <a:spAutoFit/>
-          </a:bodyPr>
-          <a:lstStyle/>
-          <a:p>
-            <a:pPr algn="l"/>
-            <a:r>
-              <a:rPr sz="950" b="1">
-                <a:solidFill>
-                  <a:srgbClr val="111111"/>
-                </a:solidFill>
-                <a:latin typeface="Arial"/>
-              </a:rPr>
-              <a:t>Computer</a:t>
-            </a:r>
-          </a:p>
-        </p:txBody>
-      </p:sp>
-      <p:sp>
-        <p:nvSpPr>
-          <p:cNvPr id="21" name="Discipline text: Computer"/>
-          <p:cNvSpPr txBox="1"/>
-          <p:nvPr/>
-        </p:nvSpPr>
-        <p:spPr>
-          <a:xfrm>
-            <a:off x="5749290" y="5120640"/>
-            <a:ext cx="1474470" cy="365760"/>
-          </a:xfrm>
-          <a:prstGeom prst="rect">
-            <a:avLst/>
-          </a:prstGeom>
-          <a:noFill/>
-        </p:spPr>
-        <p:txBody>
-          <a:bodyPr wrap="square" lIns="0" rIns="0" tIns="0" bIns="0" anchor="t">
-            <a:spAutoFit/>
-          </a:bodyPr>
-          <a:lstStyle/>
-          <a:p>
-            <a:pPr algn="l">
-              <a:lnSpc>
-                <a:spcPct val="110000"/>
-              </a:lnSpc>
-            </a:pPr>
-            <a:r>
-              <a:rPr sz="860" b="0">
-                <a:solidFill>
-                  <a:srgbClr val="555555"/>
-                </a:solidFill>
-                <a:latin typeface="Arial"/>
-              </a:rPr>
-              <a:t>Embedded, firmware and software</a:t>
-            </a:r>
-          </a:p>
-        </p:txBody>
-      </p:sp>
-      <p:sp>
-        <p:nvSpPr>
-          <p:cNvPr id="22" name="Heading: Our primary phases"/>
-          <p:cNvSpPr txBox="1"/>
-          <p:nvPr/>
-        </p:nvSpPr>
-        <p:spPr>
-          <a:xfrm>
-            <a:off x="502920" y="5577840"/>
-            <a:ext cx="6583680" cy="274320"/>
-          </a:xfrm>
-          <a:prstGeom prst="rect">
-            <a:avLst/>
-          </a:prstGeom>
-          <a:noFill/>
-        </p:spPr>
-        <p:txBody>
-          <a:bodyPr wrap="square" lIns="0" rIns="0" tIns="0" bIns="0" anchor="t">
-            <a:spAutoFit/>
-          </a:bodyPr>
-          <a:lstStyle/>
-          <a:p>
-            <a:pPr algn="l"/>
-            <a:r>
-              <a:rPr sz="1275" b="1">
-                <a:solidFill>
-                  <a:srgbClr val="111111"/>
-                </a:solidFill>
-                <a:latin typeface="Arial"/>
-              </a:rPr>
-              <a:t>Our primary phases</a:t>
-            </a:r>
-          </a:p>
-        </p:txBody>
-      </p:sp>
-      <p:sp>
-        <p:nvSpPr>
-          <p:cNvPr id="23" name="Card: Hull"/>
+              <a:t>Speed</a:t>
+            </a:r>
+          </a:p>
+        </p:txBody>
+      </p:sp>
+      <p:sp>
+        <p:nvSpPr>
+          <p:cNvPr id="12" name="Fact card: Weight"/>
           <p:cNvSpPr/>
           <p:nvPr/>
         </p:nvSpPr>
         <p:spPr>
           <a:xfrm>
-            <a:off x="502920" y="5824728"/>
-            <a:ext cx="2179320" cy="1188720"/>
+            <a:off x="2796540" y="2743200"/>
+            <a:ext cx="2179320" cy="548640"/>
           </a:xfrm>
           <a:prstGeom prst="roundRect">
             <a:avLst>
-              <a:gd name="adj" fmla="val 12307"/>
+              <a:gd name="adj" fmla="val 26666"/>
             </a:avLst>
           </a:prstGeom>
           <a:solidFill>
@@ -3908,14 +3503,14 @@
       </p:sp>
       <p:sp>
         <p:nvSpPr>
-          <p:cNvPr id="24" name="Part: Hull"/>
+          <p:cNvPr id="13" name="Fact: Under 80 lbs"/>
           <p:cNvSpPr txBox="1"/>
           <p:nvPr/>
         </p:nvSpPr>
         <p:spPr>
           <a:xfrm>
-            <a:off x="640080" y="5971032"/>
-            <a:ext cx="1905000" cy="228600"/>
+            <a:off x="2933700" y="2807208"/>
+            <a:ext cx="1905000" cy="274320"/>
           </a:xfrm>
           <a:prstGeom prst="rect">
             <a:avLst/>
@@ -3930,26 +3525,26 @@
           <a:p>
             <a:pPr algn="l"/>
             <a:r>
-              <a:rPr sz="1125" b="1">
+              <a:rPr sz="1425" b="1">
                 <a:solidFill>
                   <a:srgbClr val="111111"/>
                 </a:solidFill>
                 <a:latin typeface="Arial"/>
               </a:rPr>
-              <a:t>Hull</a:t>
-            </a:r>
-          </a:p>
-        </p:txBody>
-      </p:sp>
-      <p:sp>
-        <p:nvSpPr>
-          <p:cNvPr id="25" name="Part tagline: Hull"/>
+              <a:t>Under 80 lbs</a:t>
+            </a:r>
+          </a:p>
+        </p:txBody>
+      </p:sp>
+      <p:sp>
+        <p:nvSpPr>
+          <p:cNvPr id="14" name="Fact label: Weight"/>
           <p:cNvSpPr txBox="1"/>
           <p:nvPr/>
         </p:nvSpPr>
         <p:spPr>
           <a:xfrm>
-            <a:off x="640080" y="6181344"/>
+            <a:off x="2933700" y="3063240"/>
             <a:ext cx="1905000" cy="182880"/>
           </a:xfrm>
           <a:prstGeom prst="rect">
@@ -3965,102 +3560,31 @@
           <a:p>
             <a:pPr algn="l"/>
             <a:r>
-              <a:rPr sz="900" b="1">
-                <a:solidFill>
-                  <a:srgbClr val="111111"/>
-                </a:solidFill>
-                <a:latin typeface="Arial"/>
-              </a:rPr>
-              <a:t>Plane fast and stay light.</a:t>
-            </a:r>
-          </a:p>
-        </p:txBody>
-      </p:sp>
-      <p:sp>
-        <p:nvSpPr>
-          <p:cNvPr id="26" name="Part points: Hull"/>
-          <p:cNvSpPr txBox="1"/>
-          <p:nvPr/>
-        </p:nvSpPr>
-        <p:spPr>
-          <a:xfrm>
-            <a:off x="640080" y="6419088"/>
-            <a:ext cx="1905000" cy="548640"/>
-          </a:xfrm>
-          <a:prstGeom prst="rect">
-            <a:avLst/>
-          </a:prstGeom>
-          <a:noFill/>
-        </p:spPr>
-        <p:txBody>
-          <a:bodyPr wrap="square" lIns="0" rIns="0" tIns="0" bIns="0" anchor="t">
-            <a:spAutoFit/>
-          </a:bodyPr>
-          <a:lstStyle/>
-          <a:p>
-            <a:pPr algn="l">
-              <a:lnSpc>
-                <a:spcPct val="120000"/>
-              </a:lnSpc>
-            </a:pPr>
-            <a:r>
-              <a:rPr sz="819" b="0">
+              <a:rPr sz="860" b="0">
                 <a:solidFill>
                   <a:srgbClr val="555555"/>
                 </a:solidFill>
                 <a:latin typeface="Arial"/>
               </a:rPr>
-              <a:t>Hybrid planing composite hull</a:t>
-            </a:r>
-          </a:p>
-          <a:p>
-            <a:pPr algn="l">
-              <a:lnSpc>
-                <a:spcPct val="120000"/>
-              </a:lnSpc>
-            </a:pPr>
-            <a:r>
-              <a:rPr sz="819" b="0">
-                <a:solidFill>
-                  <a:srgbClr val="555555"/>
-                </a:solidFill>
-                <a:latin typeface="Arial"/>
-              </a:rPr>
-              <a:t>Dimensions shaped by weight</a:t>
-            </a:r>
-          </a:p>
-          <a:p>
-            <a:pPr algn="l">
-              <a:lnSpc>
-                <a:spcPct val="120000"/>
-              </a:lnSpc>
-            </a:pPr>
-            <a:r>
-              <a:rPr sz="819" b="0">
-                <a:solidFill>
-                  <a:srgbClr val="555555"/>
-                </a:solidFill>
-                <a:latin typeface="Arial"/>
-              </a:rPr>
-              <a:t>Optimization shaped by hydrodynamics</a:t>
-            </a:r>
-          </a:p>
-        </p:txBody>
-      </p:sp>
-      <p:sp>
-        <p:nvSpPr>
-          <p:cNvPr id="27" name="Card: Electric"/>
+              <a:t>Weight</a:t>
+            </a:r>
+          </a:p>
+        </p:txBody>
+      </p:sp>
+      <p:sp>
+        <p:nvSpPr>
+          <p:cNvPr id="15" name="Fact card: With LoRa backup"/>
           <p:cNvSpPr/>
           <p:nvPr/>
         </p:nvSpPr>
         <p:spPr>
           <a:xfrm>
-            <a:off x="2796540" y="5824728"/>
-            <a:ext cx="2179320" cy="1188720"/>
+            <a:off x="5090160" y="2743200"/>
+            <a:ext cx="2179320" cy="548640"/>
           </a:xfrm>
           <a:prstGeom prst="roundRect">
             <a:avLst>
-              <a:gd name="adj" fmla="val 12307"/>
+              <a:gd name="adj" fmla="val 26666"/>
             </a:avLst>
           </a:prstGeom>
           <a:solidFill>
@@ -4097,14 +3621,14 @@
       </p:sp>
       <p:sp>
         <p:nvSpPr>
-          <p:cNvPr id="28" name="Part: Electric"/>
+          <p:cNvPr id="16" name="Fact: Realtime LTE"/>
           <p:cNvSpPr txBox="1"/>
           <p:nvPr/>
         </p:nvSpPr>
         <p:spPr>
           <a:xfrm>
-            <a:off x="2933700" y="5971032"/>
-            <a:ext cx="1905000" cy="228600"/>
+            <a:off x="5227320" y="2807208"/>
+            <a:ext cx="1905000" cy="274320"/>
           </a:xfrm>
           <a:prstGeom prst="rect">
             <a:avLst/>
@@ -4119,26 +3643,26 @@
           <a:p>
             <a:pPr algn="l"/>
             <a:r>
-              <a:rPr sz="1125" b="1">
+              <a:rPr sz="1425" b="1">
                 <a:solidFill>
                   <a:srgbClr val="111111"/>
                 </a:solidFill>
                 <a:latin typeface="Arial"/>
               </a:rPr>
-              <a:t>Electric</a:t>
-            </a:r>
-          </a:p>
-        </p:txBody>
-      </p:sp>
-      <p:sp>
-        <p:nvSpPr>
-          <p:cNvPr id="29" name="Part tagline: Electric"/>
+              <a:t>Realtime LTE</a:t>
+            </a:r>
+          </a:p>
+        </p:txBody>
+      </p:sp>
+      <p:sp>
+        <p:nvSpPr>
+          <p:cNvPr id="17" name="Fact label: With LoRa backup"/>
           <p:cNvSpPr txBox="1"/>
           <p:nvPr/>
         </p:nvSpPr>
         <p:spPr>
           <a:xfrm>
-            <a:off x="2933700" y="6181344"/>
+            <a:off x="5227320" y="3063240"/>
             <a:ext cx="1905000" cy="182880"/>
           </a:xfrm>
           <a:prstGeom prst="rect">
@@ -4154,102 +3678,31 @@
           <a:p>
             <a:pPr algn="l"/>
             <a:r>
-              <a:rPr sz="900" b="1">
-                <a:solidFill>
-                  <a:srgbClr val="111111"/>
-                </a:solidFill>
-                <a:latin typeface="Arial"/>
-              </a:rPr>
-              <a:t>Every watt-hour to speed.</a:t>
-            </a:r>
-          </a:p>
-        </p:txBody>
-      </p:sp>
-      <p:sp>
-        <p:nvSpPr>
-          <p:cNvPr id="30" name="Part points: Electric"/>
-          <p:cNvSpPr txBox="1"/>
-          <p:nvPr/>
-        </p:nvSpPr>
-        <p:spPr>
-          <a:xfrm>
-            <a:off x="2933700" y="6419088"/>
-            <a:ext cx="1905000" cy="548640"/>
-          </a:xfrm>
-          <a:prstGeom prst="rect">
-            <a:avLst/>
-          </a:prstGeom>
-          <a:noFill/>
-        </p:spPr>
-        <p:txBody>
-          <a:bodyPr wrap="square" lIns="0" rIns="0" tIns="0" bIns="0" anchor="t">
-            <a:spAutoFit/>
-          </a:bodyPr>
-          <a:lstStyle/>
-          <a:p>
-            <a:pPr algn="l">
-              <a:lnSpc>
-                <a:spcPct val="120000"/>
-              </a:lnSpc>
-            </a:pPr>
-            <a:r>
-              <a:rPr sz="819" b="0">
+              <a:rPr sz="860" b="0">
                 <a:solidFill>
                   <a:srgbClr val="555555"/>
                 </a:solidFill>
                 <a:latin typeface="Arial"/>
               </a:rPr>
-              <a:t>High-voltage battery storage</a:t>
-            </a:r>
-          </a:p>
-          <a:p>
-            <a:pPr algn="l">
-              <a:lnSpc>
-                <a:spcPct val="120000"/>
-              </a:lnSpc>
-            </a:pPr>
-            <a:r>
-              <a:rPr sz="819" b="0">
-                <a:solidFill>
-                  <a:srgbClr val="555555"/>
-                </a:solidFill>
-                <a:latin typeface="Arial"/>
-              </a:rPr>
-              <a:t>Propulsion sized by the model</a:t>
-            </a:r>
-          </a:p>
-          <a:p>
-            <a:pPr algn="l">
-              <a:lnSpc>
-                <a:spcPct val="120000"/>
-              </a:lnSpc>
-            </a:pPr>
-            <a:r>
-              <a:rPr sz="819" b="0">
-                <a:solidFill>
-                  <a:srgbClr val="555555"/>
-                </a:solidFill>
-                <a:latin typeface="Arial"/>
-              </a:rPr>
-              <a:t>Propulsion and cooling co-designed</a:t>
-            </a:r>
-          </a:p>
-        </p:txBody>
-      </p:sp>
-      <p:sp>
-        <p:nvSpPr>
-          <p:cNvPr id="31" name="Card: Autonomous"/>
+              <a:t>With LoRa backup</a:t>
+            </a:r>
+          </a:p>
+        </p:txBody>
+      </p:sp>
+      <p:sp>
+        <p:nvSpPr>
+          <p:cNvPr id="18" name="Model card"/>
           <p:cNvSpPr/>
           <p:nvPr/>
         </p:nvSpPr>
         <p:spPr>
           <a:xfrm>
-            <a:off x="5090160" y="5824728"/>
-            <a:ext cx="2179320" cy="1188720"/>
+            <a:off x="502920" y="3438144"/>
+            <a:ext cx="6766560" cy="960120"/>
           </a:xfrm>
           <a:prstGeom prst="roundRect">
             <a:avLst>
-              <a:gd name="adj" fmla="val 12307"/>
+              <a:gd name="adj" fmla="val 15238"/>
             </a:avLst>
           </a:prstGeom>
           <a:solidFill>
@@ -4286,14 +3739,14 @@
       </p:sp>
       <p:sp>
         <p:nvSpPr>
-          <p:cNvPr id="32" name="Part: Autonomous"/>
+          <p:cNvPr id="19" name="Model title"/>
           <p:cNvSpPr txBox="1"/>
           <p:nvPr/>
         </p:nvSpPr>
         <p:spPr>
           <a:xfrm>
-            <a:off x="5227320" y="5971032"/>
-            <a:ext cx="1905000" cy="228600"/>
+            <a:off x="658368" y="3529584"/>
+            <a:ext cx="6455664" cy="274320"/>
           </a:xfrm>
           <a:prstGeom prst="rect">
             <a:avLst/>
@@ -4308,62 +3761,27 @@
           <a:p>
             <a:pPr algn="l"/>
             <a:r>
-              <a:rPr sz="1125" b="1">
+              <a:rPr sz="1275" b="1">
                 <a:solidFill>
                   <a:srgbClr val="111111"/>
                 </a:solidFill>
                 <a:latin typeface="Arial"/>
               </a:rPr>
-              <a:t>Autonomous</a:t>
-            </a:r>
-          </a:p>
-        </p:txBody>
-      </p:sp>
-      <p:sp>
-        <p:nvSpPr>
-          <p:cNvPr id="33" name="Part tagline: Autonomous"/>
+              <a:t>Ground up means simulation + modeling first</a:t>
+            </a:r>
+          </a:p>
+        </p:txBody>
+      </p:sp>
+      <p:sp>
+        <p:nvSpPr>
+          <p:cNvPr id="20" name="Model text"/>
           <p:cNvSpPr txBox="1"/>
           <p:nvPr/>
         </p:nvSpPr>
         <p:spPr>
           <a:xfrm>
-            <a:off x="5227320" y="6181344"/>
-            <a:ext cx="1905000" cy="182880"/>
-          </a:xfrm>
-          <a:prstGeom prst="rect">
-            <a:avLst/>
-          </a:prstGeom>
-          <a:noFill/>
-        </p:spPr>
-        <p:txBody>
-          <a:bodyPr wrap="square" lIns="0" rIns="0" tIns="0" bIns="0" anchor="t">
-            <a:spAutoFit/>
-          </a:bodyPr>
-          <a:lstStyle/>
-          <a:p>
-            <a:pPr algn="l"/>
-            <a:r>
-              <a:rPr sz="900" b="1">
-                <a:solidFill>
-                  <a:srgbClr val="111111"/>
-                </a:solidFill>
-                <a:latin typeface="Arial"/>
-              </a:rPr>
-              <a:t>Manage drift and controls.</a:t>
-            </a:r>
-          </a:p>
-        </p:txBody>
-      </p:sp>
-      <p:sp>
-        <p:nvSpPr>
-          <p:cNvPr id="34" name="Part points: Autonomous"/>
-          <p:cNvSpPr txBox="1"/>
-          <p:nvPr/>
-        </p:nvSpPr>
-        <p:spPr>
-          <a:xfrm>
-            <a:off x="5227320" y="6419088"/>
-            <a:ext cx="1905000" cy="548640"/>
+            <a:off x="658368" y="3785615"/>
+            <a:ext cx="6455664" cy="594360"/>
           </a:xfrm>
           <a:prstGeom prst="rect">
             <a:avLst/>
@@ -4382,59 +3800,245 @@
               </a:lnSpc>
             </a:pPr>
             <a:r>
-              <a:rPr sz="819" b="0">
+              <a:rPr sz="860" b="0">
                 <a:solidFill>
                   <a:srgbClr val="555555"/>
                 </a:solidFill>
                 <a:latin typeface="Arial"/>
               </a:rPr>
-              <a:t>GPS, IMU and LIDAR sensing</a:t>
-            </a:r>
-          </a:p>
+              <a:t>We are building the model from first principles, mixing empirical and rule-of-thumb decisions with dynamic programming. Each constraint cuts the space of possible boats, and our model finds the fastest one based on current variables. As we build and test, we keep updating the model and adding constraints: a hybrid of simulation and empirical data.</a:t>
+            </a:r>
+          </a:p>
+        </p:txBody>
+      </p:sp>
+      <p:sp>
+        <p:nvSpPr>
+          <p:cNvPr id="21" name="Heading: Engineers from across UW–Madison"/>
+          <p:cNvSpPr txBox="1"/>
+          <p:nvPr/>
+        </p:nvSpPr>
+        <p:spPr>
+          <a:xfrm>
+            <a:off x="502920" y="4553712"/>
+            <a:ext cx="6583680" cy="274320"/>
+          </a:xfrm>
+          <a:prstGeom prst="rect">
+            <a:avLst/>
+          </a:prstGeom>
+          <a:noFill/>
+        </p:spPr>
+        <p:txBody>
+          <a:bodyPr wrap="square" lIns="0" rIns="0" tIns="0" bIns="0" anchor="t">
+            <a:spAutoFit/>
+          </a:bodyPr>
+          <a:lstStyle/>
+          <a:p>
+            <a:pPr algn="l"/>
+            <a:r>
+              <a:rPr sz="1275" b="1">
+                <a:solidFill>
+                  <a:srgbClr val="111111"/>
+                </a:solidFill>
+                <a:latin typeface="Arial"/>
+              </a:rPr>
+              <a:t>Engineers from across UW–Madison</a:t>
+            </a:r>
+          </a:p>
+        </p:txBody>
+      </p:sp>
+      <p:sp>
+        <p:nvSpPr>
+          <p:cNvPr id="22" name="Engineers text"/>
+          <p:cNvSpPr txBox="1"/>
+          <p:nvPr/>
+        </p:nvSpPr>
+        <p:spPr>
+          <a:xfrm>
+            <a:off x="502920" y="4818888"/>
+            <a:ext cx="6766560" cy="182880"/>
+          </a:xfrm>
+          <a:prstGeom prst="rect">
+            <a:avLst/>
+          </a:prstGeom>
+          <a:noFill/>
+        </p:spPr>
+        <p:txBody>
+          <a:bodyPr wrap="square" lIns="0" rIns="0" tIns="0" bIns="0" anchor="t">
+            <a:spAutoFit/>
+          </a:bodyPr>
+          <a:lstStyle/>
+          <a:p>
+            <a:pPr algn="l"/>
+            <a:r>
+              <a:rPr sz="900" b="0">
+                <a:solidFill>
+                  <a:srgbClr val="555555"/>
+                </a:solidFill>
+                <a:latin typeface="Arial"/>
+              </a:rPr>
+              <a:t>Lead members have interned at Tesla, Northrop Grumman, Xcel Energy, Fincantieri and Milwaukee Tool.</a:t>
+            </a:r>
+          </a:p>
+        </p:txBody>
+      </p:sp>
+      <p:sp>
+        <p:nvSpPr>
+          <p:cNvPr id="23" name="Discipline: Industrial"/>
+          <p:cNvSpPr txBox="1"/>
+          <p:nvPr/>
+        </p:nvSpPr>
+        <p:spPr>
+          <a:xfrm>
+            <a:off x="502920" y="5047488"/>
+            <a:ext cx="1565910" cy="182880"/>
+          </a:xfrm>
+          <a:prstGeom prst="rect">
+            <a:avLst/>
+          </a:prstGeom>
+          <a:noFill/>
+        </p:spPr>
+        <p:txBody>
+          <a:bodyPr wrap="square" lIns="0" rIns="0" tIns="0" bIns="0" anchor="t">
+            <a:spAutoFit/>
+          </a:bodyPr>
+          <a:lstStyle/>
+          <a:p>
+            <a:pPr algn="l"/>
+            <a:r>
+              <a:rPr sz="950" b="1">
+                <a:solidFill>
+                  <a:srgbClr val="111111"/>
+                </a:solidFill>
+                <a:latin typeface="Arial"/>
+              </a:rPr>
+              <a:t>Industrial</a:t>
+            </a:r>
+          </a:p>
+        </p:txBody>
+      </p:sp>
+      <p:sp>
+        <p:nvSpPr>
+          <p:cNvPr id="24" name="Discipline text: Industrial"/>
+          <p:cNvSpPr txBox="1"/>
+          <p:nvPr/>
+        </p:nvSpPr>
+        <p:spPr>
+          <a:xfrm>
+            <a:off x="502920" y="5230368"/>
+            <a:ext cx="1474470" cy="365760"/>
+          </a:xfrm>
+          <a:prstGeom prst="rect">
+            <a:avLst/>
+          </a:prstGeom>
+          <a:noFill/>
+        </p:spPr>
+        <p:txBody>
+          <a:bodyPr wrap="square" lIns="0" rIns="0" tIns="0" bIns="0" anchor="t">
+            <a:spAutoFit/>
+          </a:bodyPr>
+          <a:lstStyle/>
           <a:p>
             <a:pPr algn="l">
               <a:lnSpc>
-                <a:spcPct val="120000"/>
+                <a:spcPct val="110000"/>
               </a:lnSpc>
             </a:pPr>
             <a:r>
-              <a:rPr sz="819" b="0">
+              <a:rPr sz="860" b="0">
                 <a:solidFill>
                   <a:srgbClr val="555555"/>
                 </a:solidFill>
                 <a:latin typeface="Arial"/>
               </a:rPr>
-              <a:t>Fundamental feedback protocols</a:t>
-            </a:r>
-          </a:p>
+              <a:t>Optimization, composites and manufacturing</a:t>
+            </a:r>
+          </a:p>
+        </p:txBody>
+      </p:sp>
+      <p:sp>
+        <p:nvSpPr>
+          <p:cNvPr id="25" name="Discipline: Mechanical"/>
+          <p:cNvSpPr txBox="1"/>
+          <p:nvPr/>
+        </p:nvSpPr>
+        <p:spPr>
+          <a:xfrm>
+            <a:off x="2251710" y="5047488"/>
+            <a:ext cx="1565910" cy="182880"/>
+          </a:xfrm>
+          <a:prstGeom prst="rect">
+            <a:avLst/>
+          </a:prstGeom>
+          <a:noFill/>
+        </p:spPr>
+        <p:txBody>
+          <a:bodyPr wrap="square" lIns="0" rIns="0" tIns="0" bIns="0" anchor="t">
+            <a:spAutoFit/>
+          </a:bodyPr>
+          <a:lstStyle/>
+          <a:p>
+            <a:pPr algn="l"/>
+            <a:r>
+              <a:rPr sz="950" b="1">
+                <a:solidFill>
+                  <a:srgbClr val="111111"/>
+                </a:solidFill>
+                <a:latin typeface="Arial"/>
+              </a:rPr>
+              <a:t>Mechanical</a:t>
+            </a:r>
+          </a:p>
+        </p:txBody>
+      </p:sp>
+      <p:sp>
+        <p:nvSpPr>
+          <p:cNvPr id="26" name="Discipline text: Mechanical"/>
+          <p:cNvSpPr txBox="1"/>
+          <p:nvPr/>
+        </p:nvSpPr>
+        <p:spPr>
+          <a:xfrm>
+            <a:off x="2251710" y="5230368"/>
+            <a:ext cx="1474470" cy="365760"/>
+          </a:xfrm>
+          <a:prstGeom prst="rect">
+            <a:avLst/>
+          </a:prstGeom>
+          <a:noFill/>
+        </p:spPr>
+        <p:txBody>
+          <a:bodyPr wrap="square" lIns="0" rIns="0" tIns="0" bIns="0" anchor="t">
+            <a:spAutoFit/>
+          </a:bodyPr>
+          <a:lstStyle/>
           <a:p>
             <a:pPr algn="l">
               <a:lnSpc>
-                <a:spcPct val="120000"/>
+                <a:spcPct val="110000"/>
               </a:lnSpc>
             </a:pPr>
             <a:r>
-              <a:rPr sz="819" b="0">
+              <a:rPr sz="860" b="0">
                 <a:solidFill>
                   <a:srgbClr val="555555"/>
                 </a:solidFill>
                 <a:latin typeface="Arial"/>
               </a:rPr>
-              <a:t>Software plans the route</a:t>
-            </a:r>
-          </a:p>
-        </p:txBody>
-      </p:sp>
-      <p:sp>
-        <p:nvSpPr>
-          <p:cNvPr id="35" name="Heading: Timeline"/>
+              <a:t>Structures, CAD, fabrication</a:t>
+            </a:r>
+          </a:p>
+        </p:txBody>
+      </p:sp>
+      <p:sp>
+        <p:nvSpPr>
+          <p:cNvPr id="27" name="Discipline: Electrical"/>
           <p:cNvSpPr txBox="1"/>
           <p:nvPr/>
         </p:nvSpPr>
         <p:spPr>
           <a:xfrm>
-            <a:off x="502920" y="7132320"/>
-            <a:ext cx="6583680" cy="274320"/>
+            <a:off x="4000500" y="5047488"/>
+            <a:ext cx="1565910" cy="182880"/>
           </a:xfrm>
           <a:prstGeom prst="rect">
             <a:avLst/>
@@ -4449,27 +4053,27 @@
           <a:p>
             <a:pPr algn="l"/>
             <a:r>
-              <a:rPr sz="1275" b="1">
+              <a:rPr sz="950" b="1">
                 <a:solidFill>
                   <a:srgbClr val="111111"/>
                 </a:solidFill>
                 <a:latin typeface="Arial"/>
               </a:rPr>
-              <a:t>Timeline</a:t>
-            </a:r>
-          </a:p>
-        </p:txBody>
-      </p:sp>
-      <p:sp>
-        <p:nvSpPr>
-          <p:cNvPr id="36" name="Timeline date: Hull design frozen"/>
+              <a:t>Electrical</a:t>
+            </a:r>
+          </a:p>
+        </p:txBody>
+      </p:sp>
+      <p:sp>
+        <p:nvSpPr>
+          <p:cNvPr id="28" name="Discipline text: Electrical"/>
           <p:cNvSpPr txBox="1"/>
           <p:nvPr/>
         </p:nvSpPr>
         <p:spPr>
           <a:xfrm>
-            <a:off x="502920" y="7406640"/>
-            <a:ext cx="1005840" cy="164592"/>
+            <a:off x="4000500" y="5230368"/>
+            <a:ext cx="1474470" cy="365760"/>
           </a:xfrm>
           <a:prstGeom prst="rect">
             <a:avLst/>
@@ -4482,29 +4086,33 @@
           </a:bodyPr>
           <a:lstStyle/>
           <a:p>
-            <a:pPr algn="l"/>
-            <a:r>
-              <a:rPr sz="819" b="1">
-                <a:solidFill>
-                  <a:srgbClr val="111111"/>
-                </a:solidFill>
-                <a:latin typeface="Arial"/>
-              </a:rPr>
-              <a:t>Oct 25</a:t>
-            </a:r>
-          </a:p>
-        </p:txBody>
-      </p:sp>
-      <p:sp>
-        <p:nvSpPr>
-          <p:cNvPr id="37" name="Timeline label: Hull design frozen"/>
+            <a:pPr algn="l">
+              <a:lnSpc>
+                <a:spcPct val="110000"/>
+              </a:lnSpc>
+            </a:pPr>
+            <a:r>
+              <a:rPr sz="860" b="0">
+                <a:solidFill>
+                  <a:srgbClr val="555555"/>
+                </a:solidFill>
+                <a:latin typeface="Arial"/>
+              </a:rPr>
+              <a:t>Power, battery and high voltage</a:t>
+            </a:r>
+          </a:p>
+        </p:txBody>
+      </p:sp>
+      <p:sp>
+        <p:nvSpPr>
+          <p:cNvPr id="29" name="Discipline: Computer"/>
           <p:cNvSpPr txBox="1"/>
           <p:nvPr/>
         </p:nvSpPr>
         <p:spPr>
           <a:xfrm>
-            <a:off x="1600200" y="7406640"/>
-            <a:ext cx="2133752" cy="169164"/>
+            <a:off x="5749290" y="5047488"/>
+            <a:ext cx="1565910" cy="182880"/>
           </a:xfrm>
           <a:prstGeom prst="rect">
             <a:avLst/>
@@ -4519,27 +4127,27 @@
           <a:p>
             <a:pPr algn="l"/>
             <a:r>
-              <a:rPr sz="819" b="0">
-                <a:solidFill>
-                  <a:srgbClr val="555555"/>
-                </a:solidFill>
-                <a:latin typeface="Arial"/>
-              </a:rPr>
-              <a:t>Hull design frozen</a:t>
-            </a:r>
-          </a:p>
-        </p:txBody>
-      </p:sp>
-      <p:sp>
-        <p:nvSpPr>
-          <p:cNvPr id="38" name="Timeline date: Preliminary design review"/>
+              <a:rPr sz="950" b="1">
+                <a:solidFill>
+                  <a:srgbClr val="111111"/>
+                </a:solidFill>
+                <a:latin typeface="Arial"/>
+              </a:rPr>
+              <a:t>Computer</a:t>
+            </a:r>
+          </a:p>
+        </p:txBody>
+      </p:sp>
+      <p:sp>
+        <p:nvSpPr>
+          <p:cNvPr id="30" name="Discipline text: Computer"/>
           <p:cNvSpPr txBox="1"/>
           <p:nvPr/>
         </p:nvSpPr>
         <p:spPr>
           <a:xfrm>
-            <a:off x="502920" y="7575804"/>
-            <a:ext cx="1005840" cy="164592"/>
+            <a:off x="5749290" y="5230368"/>
+            <a:ext cx="1474470" cy="365760"/>
           </a:xfrm>
           <a:prstGeom prst="rect">
             <a:avLst/>
@@ -4552,29 +4160,33 @@
           </a:bodyPr>
           <a:lstStyle/>
           <a:p>
-            <a:pPr algn="l"/>
-            <a:r>
-              <a:rPr sz="819" b="1">
-                <a:solidFill>
-                  <a:srgbClr val="111111"/>
-                </a:solidFill>
-                <a:latin typeface="Arial"/>
-              </a:rPr>
-              <a:t>Nov 1</a:t>
-            </a:r>
-          </a:p>
-        </p:txBody>
-      </p:sp>
-      <p:sp>
-        <p:nvSpPr>
-          <p:cNvPr id="39" name="Timeline label: Preliminary design review"/>
+            <a:pPr algn="l">
+              <a:lnSpc>
+                <a:spcPct val="110000"/>
+              </a:lnSpc>
+            </a:pPr>
+            <a:r>
+              <a:rPr sz="860" b="0">
+                <a:solidFill>
+                  <a:srgbClr val="555555"/>
+                </a:solidFill>
+                <a:latin typeface="Arial"/>
+              </a:rPr>
+              <a:t>Firmware, software, controls</a:t>
+            </a:r>
+          </a:p>
+        </p:txBody>
+      </p:sp>
+      <p:sp>
+        <p:nvSpPr>
+          <p:cNvPr id="31" name="Heading: Our primary phases"/>
           <p:cNvSpPr txBox="1"/>
           <p:nvPr/>
         </p:nvSpPr>
         <p:spPr>
           <a:xfrm>
-            <a:off x="1600200" y="7575804"/>
-            <a:ext cx="2133752" cy="169164"/>
+            <a:off x="502920" y="5641848"/>
+            <a:ext cx="6583680" cy="274320"/>
           </a:xfrm>
           <a:prstGeom prst="rect">
             <a:avLst/>
@@ -4589,738 +4201,40 @@
           <a:p>
             <a:pPr algn="l"/>
             <a:r>
-              <a:rPr sz="819" b="0">
-                <a:solidFill>
-                  <a:srgbClr val="555555"/>
-                </a:solidFill>
-                <a:latin typeface="Arial"/>
-              </a:rPr>
-              <a:t>Preliminary design review</a:t>
-            </a:r>
-          </a:p>
-        </p:txBody>
-      </p:sp>
-      <p:sp>
-        <p:nvSpPr>
-          <p:cNvPr id="40" name="Timeline date: Critical and long-lead parts are ordered"/>
-          <p:cNvSpPr txBox="1"/>
-          <p:nvPr/>
-        </p:nvSpPr>
-        <p:spPr>
-          <a:xfrm>
-            <a:off x="502920" y="7744968"/>
-            <a:ext cx="1005840" cy="164592"/>
-          </a:xfrm>
-          <a:prstGeom prst="rect">
-            <a:avLst/>
-          </a:prstGeom>
-          <a:noFill/>
-        </p:spPr>
-        <p:txBody>
-          <a:bodyPr wrap="square" lIns="0" rIns="0" tIns="0" bIns="0" anchor="t">
-            <a:spAutoFit/>
-          </a:bodyPr>
-          <a:lstStyle/>
-          <a:p>
-            <a:pPr algn="l"/>
-            <a:r>
-              <a:rPr sz="819" b="1">
+              <a:rPr sz="1275" b="1">
                 <a:solidFill>
                   <a:srgbClr val="111111"/>
                 </a:solidFill>
                 <a:latin typeface="Arial"/>
               </a:rPr>
-              <a:t>Nov 10</a:t>
-            </a:r>
-          </a:p>
-        </p:txBody>
-      </p:sp>
-      <p:sp>
-        <p:nvSpPr>
-          <p:cNvPr id="41" name="Timeline label: Critical and long-lead parts are ordered"/>
-          <p:cNvSpPr txBox="1"/>
-          <p:nvPr/>
-        </p:nvSpPr>
-        <p:spPr>
-          <a:xfrm>
-            <a:off x="1600200" y="7744968"/>
-            <a:ext cx="2133752" cy="169164"/>
-          </a:xfrm>
-          <a:prstGeom prst="rect">
-            <a:avLst/>
-          </a:prstGeom>
-          <a:noFill/>
-        </p:spPr>
-        <p:txBody>
-          <a:bodyPr wrap="square" lIns="0" rIns="0" tIns="0" bIns="0" anchor="t">
-            <a:spAutoFit/>
-          </a:bodyPr>
-          <a:lstStyle/>
-          <a:p>
-            <a:pPr algn="l"/>
-            <a:r>
-              <a:rPr sz="819" b="0">
-                <a:solidFill>
-                  <a:srgbClr val="555555"/>
-                </a:solidFill>
-                <a:latin typeface="Arial"/>
-              </a:rPr>
-              <a:t>Critical and long-lead parts are ordered</a:t>
-            </a:r>
-          </a:p>
-        </p:txBody>
-      </p:sp>
-      <p:sp>
-        <p:nvSpPr>
-          <p:cNvPr id="42" name="Timeline date: Mechanical and electrical design frozen"/>
-          <p:cNvSpPr txBox="1"/>
-          <p:nvPr/>
-        </p:nvSpPr>
-        <p:spPr>
-          <a:xfrm>
-            <a:off x="502920" y="7914132"/>
-            <a:ext cx="1005840" cy="164592"/>
-          </a:xfrm>
-          <a:prstGeom prst="rect">
-            <a:avLst/>
-          </a:prstGeom>
-          <a:noFill/>
-        </p:spPr>
-        <p:txBody>
-          <a:bodyPr wrap="square" lIns="0" rIns="0" tIns="0" bIns="0" anchor="t">
-            <a:spAutoFit/>
-          </a:bodyPr>
-          <a:lstStyle/>
-          <a:p>
-            <a:pPr algn="l"/>
-            <a:r>
-              <a:rPr sz="819" b="1">
-                <a:solidFill>
-                  <a:srgbClr val="111111"/>
-                </a:solidFill>
-                <a:latin typeface="Arial"/>
-              </a:rPr>
-              <a:t>Nov 20</a:t>
-            </a:r>
-          </a:p>
-        </p:txBody>
-      </p:sp>
-      <p:sp>
-        <p:nvSpPr>
-          <p:cNvPr id="43" name="Timeline label: Mechanical and electrical design frozen"/>
-          <p:cNvSpPr txBox="1"/>
-          <p:nvPr/>
-        </p:nvSpPr>
-        <p:spPr>
-          <a:xfrm>
-            <a:off x="1600200" y="7914132"/>
-            <a:ext cx="2133752" cy="169164"/>
-          </a:xfrm>
-          <a:prstGeom prst="rect">
-            <a:avLst/>
-          </a:prstGeom>
-          <a:noFill/>
-        </p:spPr>
-        <p:txBody>
-          <a:bodyPr wrap="square" lIns="0" rIns="0" tIns="0" bIns="0" anchor="t">
-            <a:spAutoFit/>
-          </a:bodyPr>
-          <a:lstStyle/>
-          <a:p>
-            <a:pPr algn="l"/>
-            <a:r>
-              <a:rPr sz="819" b="0">
-                <a:solidFill>
-                  <a:srgbClr val="555555"/>
-                </a:solidFill>
-                <a:latin typeface="Arial"/>
-              </a:rPr>
-              <a:t>Mechanical and electrical design frozen</a:t>
-            </a:r>
-          </a:p>
-        </p:txBody>
-      </p:sp>
-      <p:sp>
-        <p:nvSpPr>
-          <p:cNvPr id="44" name="Timeline date: Build the hull, composite parts and any custom-milled parts"/>
-          <p:cNvSpPr txBox="1"/>
-          <p:nvPr/>
-        </p:nvSpPr>
-        <p:spPr>
-          <a:xfrm>
-            <a:off x="502920" y="8083296"/>
-            <a:ext cx="1005840" cy="164592"/>
-          </a:xfrm>
-          <a:prstGeom prst="rect">
-            <a:avLst/>
-          </a:prstGeom>
-          <a:noFill/>
-        </p:spPr>
-        <p:txBody>
-          <a:bodyPr wrap="square" lIns="0" rIns="0" tIns="0" bIns="0" anchor="t">
-            <a:spAutoFit/>
-          </a:bodyPr>
-          <a:lstStyle/>
-          <a:p>
-            <a:pPr algn="l"/>
-            <a:r>
-              <a:rPr sz="819" b="1">
-                <a:solidFill>
-                  <a:srgbClr val="111111"/>
-                </a:solidFill>
-                <a:latin typeface="Arial"/>
-              </a:rPr>
-              <a:t>Nov 20–Dec 20</a:t>
-            </a:r>
-          </a:p>
-        </p:txBody>
-      </p:sp>
-      <p:sp>
-        <p:nvSpPr>
-          <p:cNvPr id="45" name="Timeline label: Build the hull, composite parts and any custom-milled parts"/>
-          <p:cNvSpPr txBox="1"/>
-          <p:nvPr/>
-        </p:nvSpPr>
-        <p:spPr>
-          <a:xfrm>
-            <a:off x="1600200" y="8083296"/>
-            <a:ext cx="2133752" cy="288036"/>
-          </a:xfrm>
-          <a:prstGeom prst="rect">
-            <a:avLst/>
-          </a:prstGeom>
-          <a:noFill/>
-        </p:spPr>
-        <p:txBody>
-          <a:bodyPr wrap="square" lIns="0" rIns="0" tIns="0" bIns="0" anchor="t">
-            <a:spAutoFit/>
-          </a:bodyPr>
-          <a:lstStyle/>
-          <a:p>
-            <a:pPr algn="l"/>
-            <a:r>
-              <a:rPr sz="819" b="0">
-                <a:solidFill>
-                  <a:srgbClr val="555555"/>
-                </a:solidFill>
-                <a:latin typeface="Arial"/>
-              </a:rPr>
-              <a:t>Build the hull, composite parts and any custom-milled parts</a:t>
-            </a:r>
-          </a:p>
-        </p:txBody>
-      </p:sp>
-      <p:sp>
-        <p:nvSpPr>
-          <p:cNvPr id="46" name="Timeline date: First float and tow test"/>
-          <p:cNvSpPr txBox="1"/>
-          <p:nvPr/>
-        </p:nvSpPr>
-        <p:spPr>
-          <a:xfrm>
-            <a:off x="502920" y="8371332"/>
-            <a:ext cx="1005840" cy="164592"/>
-          </a:xfrm>
-          <a:prstGeom prst="rect">
-            <a:avLst/>
-          </a:prstGeom>
-          <a:noFill/>
-        </p:spPr>
-        <p:txBody>
-          <a:bodyPr wrap="square" lIns="0" rIns="0" tIns="0" bIns="0" anchor="t">
-            <a:spAutoFit/>
-          </a:bodyPr>
-          <a:lstStyle/>
-          <a:p>
-            <a:pPr algn="l"/>
-            <a:r>
-              <a:rPr sz="819" b="1">
-                <a:solidFill>
-                  <a:srgbClr val="111111"/>
-                </a:solidFill>
-                <a:latin typeface="Arial"/>
-              </a:rPr>
-              <a:t>Jan 8</a:t>
-            </a:r>
-          </a:p>
-        </p:txBody>
-      </p:sp>
-      <p:sp>
-        <p:nvSpPr>
-          <p:cNvPr id="47" name="Timeline label: First float and tow test"/>
-          <p:cNvSpPr txBox="1"/>
-          <p:nvPr/>
-        </p:nvSpPr>
-        <p:spPr>
-          <a:xfrm>
-            <a:off x="1600200" y="8371332"/>
-            <a:ext cx="2133752" cy="169164"/>
-          </a:xfrm>
-          <a:prstGeom prst="rect">
-            <a:avLst/>
-          </a:prstGeom>
-          <a:noFill/>
-        </p:spPr>
-        <p:txBody>
-          <a:bodyPr wrap="square" lIns="0" rIns="0" tIns="0" bIns="0" anchor="t">
-            <a:spAutoFit/>
-          </a:bodyPr>
-          <a:lstStyle/>
-          <a:p>
-            <a:pPr algn="l"/>
-            <a:r>
-              <a:rPr sz="819" b="0">
-                <a:solidFill>
-                  <a:srgbClr val="555555"/>
-                </a:solidFill>
-                <a:latin typeface="Arial"/>
-              </a:rPr>
-              <a:t>First float and tow test</a:t>
-            </a:r>
-          </a:p>
-        </p:txBody>
-      </p:sp>
-      <p:sp>
-        <p:nvSpPr>
-          <p:cNvPr id="48" name="Timeline date: Manufacture and assemble everything"/>
-          <p:cNvSpPr txBox="1"/>
-          <p:nvPr/>
-        </p:nvSpPr>
-        <p:spPr>
-          <a:xfrm>
-            <a:off x="4038447" y="7406640"/>
-            <a:ext cx="1005840" cy="164592"/>
-          </a:xfrm>
-          <a:prstGeom prst="rect">
-            <a:avLst/>
-          </a:prstGeom>
-          <a:noFill/>
-        </p:spPr>
-        <p:txBody>
-          <a:bodyPr wrap="square" lIns="0" rIns="0" tIns="0" bIns="0" anchor="t">
-            <a:spAutoFit/>
-          </a:bodyPr>
-          <a:lstStyle/>
-          <a:p>
-            <a:pPr algn="l"/>
-            <a:r>
-              <a:rPr sz="819" b="1">
-                <a:solidFill>
-                  <a:srgbClr val="111111"/>
-                </a:solidFill>
-                <a:latin typeface="Arial"/>
-              </a:rPr>
-              <a:t>Jan 8–30</a:t>
-            </a:r>
-          </a:p>
-        </p:txBody>
-      </p:sp>
-      <p:sp>
-        <p:nvSpPr>
-          <p:cNvPr id="49" name="Timeline label: Manufacture and assemble everything"/>
-          <p:cNvSpPr txBox="1"/>
-          <p:nvPr/>
-        </p:nvSpPr>
-        <p:spPr>
-          <a:xfrm>
-            <a:off x="5135727" y="7406640"/>
-            <a:ext cx="2133752" cy="169164"/>
-          </a:xfrm>
-          <a:prstGeom prst="rect">
-            <a:avLst/>
-          </a:prstGeom>
-          <a:noFill/>
-        </p:spPr>
-        <p:txBody>
-          <a:bodyPr wrap="square" lIns="0" rIns="0" tIns="0" bIns="0" anchor="t">
-            <a:spAutoFit/>
-          </a:bodyPr>
-          <a:lstStyle/>
-          <a:p>
-            <a:pPr algn="l"/>
-            <a:r>
-              <a:rPr sz="819" b="0">
-                <a:solidFill>
-                  <a:srgbClr val="555555"/>
-                </a:solidFill>
-                <a:latin typeface="Arial"/>
-              </a:rPr>
-              <a:t>Manufacture and assemble everything</a:t>
-            </a:r>
-          </a:p>
-        </p:txBody>
-      </p:sp>
-      <p:sp>
-        <p:nvSpPr>
-          <p:cNvPr id="50" name="Timeline date: Build likely spare parts, in parallel"/>
-          <p:cNvSpPr txBox="1"/>
-          <p:nvPr/>
-        </p:nvSpPr>
-        <p:spPr>
-          <a:xfrm>
-            <a:off x="4038447" y="7575804"/>
-            <a:ext cx="1005840" cy="164592"/>
-          </a:xfrm>
-          <a:prstGeom prst="rect">
-            <a:avLst/>
-          </a:prstGeom>
-          <a:noFill/>
-        </p:spPr>
-        <p:txBody>
-          <a:bodyPr wrap="square" lIns="0" rIns="0" tIns="0" bIns="0" anchor="t">
-            <a:spAutoFit/>
-          </a:bodyPr>
-          <a:lstStyle/>
-          <a:p>
-            <a:pPr algn="l"/>
-            <a:r>
-              <a:rPr sz="819" b="1">
-                <a:solidFill>
-                  <a:srgbClr val="111111"/>
-                </a:solidFill>
-                <a:latin typeface="Arial"/>
-              </a:rPr>
-              <a:t>Jan 8–30</a:t>
-            </a:r>
-          </a:p>
-        </p:txBody>
-      </p:sp>
-      <p:sp>
-        <p:nvSpPr>
-          <p:cNvPr id="51" name="Timeline label: Build likely spare parts, in parallel"/>
-          <p:cNvSpPr txBox="1"/>
-          <p:nvPr/>
-        </p:nvSpPr>
-        <p:spPr>
-          <a:xfrm>
-            <a:off x="5135727" y="7575804"/>
-            <a:ext cx="2133752" cy="169164"/>
-          </a:xfrm>
-          <a:prstGeom prst="rect">
-            <a:avLst/>
-          </a:prstGeom>
-          <a:noFill/>
-        </p:spPr>
-        <p:txBody>
-          <a:bodyPr wrap="square" lIns="0" rIns="0" tIns="0" bIns="0" anchor="t">
-            <a:spAutoFit/>
-          </a:bodyPr>
-          <a:lstStyle/>
-          <a:p>
-            <a:pPr algn="l"/>
-            <a:r>
-              <a:rPr sz="819" b="0">
-                <a:solidFill>
-                  <a:srgbClr val="555555"/>
-                </a:solidFill>
-                <a:latin typeface="Arial"/>
-              </a:rPr>
-              <a:t>Build likely spare parts, in parallel</a:t>
-            </a:r>
-          </a:p>
-        </p:txBody>
-      </p:sp>
-      <p:sp>
-        <p:nvSpPr>
-          <p:cNvPr id="52" name="Timeline date: First nautical mile"/>
-          <p:cNvSpPr txBox="1"/>
-          <p:nvPr/>
-        </p:nvSpPr>
-        <p:spPr>
-          <a:xfrm>
-            <a:off x="4038447" y="7744968"/>
-            <a:ext cx="1005840" cy="164592"/>
-          </a:xfrm>
-          <a:prstGeom prst="rect">
-            <a:avLst/>
-          </a:prstGeom>
-          <a:noFill/>
-        </p:spPr>
-        <p:txBody>
-          <a:bodyPr wrap="square" lIns="0" rIns="0" tIns="0" bIns="0" anchor="t">
-            <a:spAutoFit/>
-          </a:bodyPr>
-          <a:lstStyle/>
-          <a:p>
-            <a:pPr algn="l"/>
-            <a:r>
-              <a:rPr sz="819" b="1">
-                <a:solidFill>
-                  <a:srgbClr val="111111"/>
-                </a:solidFill>
-                <a:latin typeface="Arial"/>
-              </a:rPr>
-              <a:t>Jan 31</a:t>
-            </a:r>
-          </a:p>
-        </p:txBody>
-      </p:sp>
-      <p:sp>
-        <p:nvSpPr>
-          <p:cNvPr id="53" name="Timeline label: First nautical mile"/>
-          <p:cNvSpPr txBox="1"/>
-          <p:nvPr/>
-        </p:nvSpPr>
-        <p:spPr>
-          <a:xfrm>
-            <a:off x="5135727" y="7744968"/>
-            <a:ext cx="2133752" cy="169164"/>
-          </a:xfrm>
-          <a:prstGeom prst="rect">
-            <a:avLst/>
-          </a:prstGeom>
-          <a:noFill/>
-        </p:spPr>
-        <p:txBody>
-          <a:bodyPr wrap="square" lIns="0" rIns="0" tIns="0" bIns="0" anchor="t">
-            <a:spAutoFit/>
-          </a:bodyPr>
-          <a:lstStyle/>
-          <a:p>
-            <a:pPr algn="l"/>
-            <a:r>
-              <a:rPr sz="819" b="0">
-                <a:solidFill>
-                  <a:srgbClr val="555555"/>
-                </a:solidFill>
-                <a:latin typeface="Arial"/>
-              </a:rPr>
-              <a:t>First nautical mile</a:t>
-            </a:r>
-          </a:p>
-        </p:txBody>
-      </p:sp>
-      <p:sp>
-        <p:nvSpPr>
-          <p:cNvPr id="54" name="Timeline date: Slow drives on the water"/>
-          <p:cNvSpPr txBox="1"/>
-          <p:nvPr/>
-        </p:nvSpPr>
-        <p:spPr>
-          <a:xfrm>
-            <a:off x="4038447" y="7914132"/>
-            <a:ext cx="1005840" cy="164592"/>
-          </a:xfrm>
-          <a:prstGeom prst="rect">
-            <a:avLst/>
-          </a:prstGeom>
-          <a:noFill/>
-        </p:spPr>
-        <p:txBody>
-          <a:bodyPr wrap="square" lIns="0" rIns="0" tIns="0" bIns="0" anchor="t">
-            <a:spAutoFit/>
-          </a:bodyPr>
-          <a:lstStyle/>
-          <a:p>
-            <a:pPr algn="l"/>
-            <a:r>
-              <a:rPr sz="819" b="1">
-                <a:solidFill>
-                  <a:srgbClr val="111111"/>
-                </a:solidFill>
-                <a:latin typeface="Arial"/>
-              </a:rPr>
-              <a:t>Feb 1–14</a:t>
-            </a:r>
-          </a:p>
-        </p:txBody>
-      </p:sp>
-      <p:sp>
-        <p:nvSpPr>
-          <p:cNvPr id="55" name="Timeline label: Slow drives on the water"/>
-          <p:cNvSpPr txBox="1"/>
-          <p:nvPr/>
-        </p:nvSpPr>
-        <p:spPr>
-          <a:xfrm>
-            <a:off x="5135727" y="7914132"/>
-            <a:ext cx="2133752" cy="169164"/>
-          </a:xfrm>
-          <a:prstGeom prst="rect">
-            <a:avLst/>
-          </a:prstGeom>
-          <a:noFill/>
-        </p:spPr>
-        <p:txBody>
-          <a:bodyPr wrap="square" lIns="0" rIns="0" tIns="0" bIns="0" anchor="t">
-            <a:spAutoFit/>
-          </a:bodyPr>
-          <a:lstStyle/>
-          <a:p>
-            <a:pPr algn="l"/>
-            <a:r>
-              <a:rPr sz="819" b="0">
-                <a:solidFill>
-                  <a:srgbClr val="555555"/>
-                </a:solidFill>
-                <a:latin typeface="Arial"/>
-              </a:rPr>
-              <a:t>Slow drives on the water</a:t>
-            </a:r>
-          </a:p>
-        </p:txBody>
-      </p:sp>
-      <p:sp>
-        <p:nvSpPr>
-          <p:cNvPr id="56" name="Timeline date: Start increasing speed"/>
-          <p:cNvSpPr txBox="1"/>
-          <p:nvPr/>
-        </p:nvSpPr>
-        <p:spPr>
-          <a:xfrm>
-            <a:off x="4038447" y="8083296"/>
-            <a:ext cx="1005840" cy="164592"/>
-          </a:xfrm>
-          <a:prstGeom prst="rect">
-            <a:avLst/>
-          </a:prstGeom>
-          <a:noFill/>
-        </p:spPr>
-        <p:txBody>
-          <a:bodyPr wrap="square" lIns="0" rIns="0" tIns="0" bIns="0" anchor="t">
-            <a:spAutoFit/>
-          </a:bodyPr>
-          <a:lstStyle/>
-          <a:p>
-            <a:pPr algn="l"/>
-            <a:r>
-              <a:rPr sz="819" b="1">
-                <a:solidFill>
-                  <a:srgbClr val="111111"/>
-                </a:solidFill>
-                <a:latin typeface="Arial"/>
-              </a:rPr>
-              <a:t>Feb 15</a:t>
-            </a:r>
-          </a:p>
-        </p:txBody>
-      </p:sp>
-      <p:sp>
-        <p:nvSpPr>
-          <p:cNvPr id="57" name="Timeline label: Start increasing speed"/>
-          <p:cNvSpPr txBox="1"/>
-          <p:nvPr/>
-        </p:nvSpPr>
-        <p:spPr>
-          <a:xfrm>
-            <a:off x="5135727" y="8083296"/>
-            <a:ext cx="2133752" cy="169164"/>
-          </a:xfrm>
-          <a:prstGeom prst="rect">
-            <a:avLst/>
-          </a:prstGeom>
-          <a:noFill/>
-        </p:spPr>
-        <p:txBody>
-          <a:bodyPr wrap="square" lIns="0" rIns="0" tIns="0" bIns="0" anchor="t">
-            <a:spAutoFit/>
-          </a:bodyPr>
-          <a:lstStyle/>
-          <a:p>
-            <a:pPr algn="l"/>
-            <a:r>
-              <a:rPr sz="819" b="0">
-                <a:solidFill>
-                  <a:srgbClr val="555555"/>
-                </a:solidFill>
-                <a:latin typeface="Arial"/>
-              </a:rPr>
-              <a:t>Start increasing speed</a:t>
-            </a:r>
-          </a:p>
-        </p:txBody>
-      </p:sp>
-      <p:sp>
-        <p:nvSpPr>
-          <p:cNvPr id="58" name="Timeline date: Testing / Tuning"/>
-          <p:cNvSpPr txBox="1"/>
-          <p:nvPr/>
-        </p:nvSpPr>
-        <p:spPr>
-          <a:xfrm>
-            <a:off x="4038447" y="8252460"/>
-            <a:ext cx="1005840" cy="164592"/>
-          </a:xfrm>
-          <a:prstGeom prst="rect">
-            <a:avLst/>
-          </a:prstGeom>
-          <a:noFill/>
-        </p:spPr>
-        <p:txBody>
-          <a:bodyPr wrap="square" lIns="0" rIns="0" tIns="0" bIns="0" anchor="t">
-            <a:spAutoFit/>
-          </a:bodyPr>
-          <a:lstStyle/>
-          <a:p>
-            <a:pPr algn="l"/>
-            <a:r>
-              <a:rPr sz="819" b="1">
-                <a:solidFill>
-                  <a:srgbClr val="111111"/>
-                </a:solidFill>
-                <a:latin typeface="Arial"/>
-              </a:rPr>
-              <a:t>Until April</a:t>
-            </a:r>
-          </a:p>
-        </p:txBody>
-      </p:sp>
-      <p:sp>
-        <p:nvSpPr>
-          <p:cNvPr id="59" name="Timeline label: Testing / Tuning"/>
-          <p:cNvSpPr txBox="1"/>
-          <p:nvPr/>
-        </p:nvSpPr>
-        <p:spPr>
-          <a:xfrm>
-            <a:off x="5135727" y="8252460"/>
-            <a:ext cx="2133752" cy="169164"/>
-          </a:xfrm>
-          <a:prstGeom prst="rect">
-            <a:avLst/>
-          </a:prstGeom>
-          <a:noFill/>
-        </p:spPr>
-        <p:txBody>
-          <a:bodyPr wrap="square" lIns="0" rIns="0" tIns="0" bIns="0" anchor="t">
-            <a:spAutoFit/>
-          </a:bodyPr>
-          <a:lstStyle/>
-          <a:p>
-            <a:pPr algn="l"/>
-            <a:r>
-              <a:rPr sz="819" b="0">
-                <a:solidFill>
-                  <a:srgbClr val="555555"/>
-                </a:solidFill>
-                <a:latin typeface="Arial"/>
-              </a:rPr>
-              <a:t>Testing / Tuning</a:t>
-            </a:r>
-          </a:p>
-        </p:txBody>
-      </p:sp>
-      <p:sp>
-        <p:nvSpPr>
-          <p:cNvPr id="60" name="Footer card"/>
+              <a:t>Our primary phases</a:t>
+            </a:r>
+          </a:p>
+        </p:txBody>
+      </p:sp>
+      <p:sp>
+        <p:nvSpPr>
+          <p:cNvPr id="32" name="Card: Hull"/>
           <p:cNvSpPr/>
           <p:nvPr/>
         </p:nvSpPr>
         <p:spPr>
           <a:xfrm>
-            <a:off x="502920" y="8823960"/>
-            <a:ext cx="6766560" cy="822960"/>
+            <a:off x="502920" y="5897880"/>
+            <a:ext cx="2179320" cy="1188720"/>
           </a:xfrm>
           <a:prstGeom prst="roundRect">
             <a:avLst>
-              <a:gd name="adj" fmla="val 17777"/>
+              <a:gd name="adj" fmla="val 12307"/>
             </a:avLst>
           </a:prstGeom>
           <a:solidFill>
-            <a:srgbClr val="111111"/>
+            <a:srgbClr val="F5F5F5"/>
           </a:solidFill>
-          <a:ln>
-            <a:noFill/>
+          <a:ln w="9525">
+            <a:solidFill>
+              <a:srgbClr val="F5F5F5"/>
+            </a:solidFill>
           </a:ln>
           <a:effectLst/>
         </p:spPr>
@@ -5348,7 +4262,1447 @@
       </p:sp>
       <p:sp>
         <p:nvSpPr>
-          <p:cNvPr id="61" name="Footer title"/>
+          <p:cNvPr id="33" name="Part: Hull"/>
+          <p:cNvSpPr txBox="1"/>
+          <p:nvPr/>
+        </p:nvSpPr>
+        <p:spPr>
+          <a:xfrm>
+            <a:off x="640080" y="6044184"/>
+            <a:ext cx="1905000" cy="228600"/>
+          </a:xfrm>
+          <a:prstGeom prst="rect">
+            <a:avLst/>
+          </a:prstGeom>
+          <a:noFill/>
+        </p:spPr>
+        <p:txBody>
+          <a:bodyPr wrap="square" lIns="0" rIns="0" tIns="0" bIns="0" anchor="t">
+            <a:spAutoFit/>
+          </a:bodyPr>
+          <a:lstStyle/>
+          <a:p>
+            <a:pPr algn="l"/>
+            <a:r>
+              <a:rPr sz="1125" b="1">
+                <a:solidFill>
+                  <a:srgbClr val="111111"/>
+                </a:solidFill>
+                <a:latin typeface="Arial"/>
+              </a:rPr>
+              <a:t>Hull</a:t>
+            </a:r>
+          </a:p>
+        </p:txBody>
+      </p:sp>
+      <p:sp>
+        <p:nvSpPr>
+          <p:cNvPr id="34" name="Part tagline: Hull"/>
+          <p:cNvSpPr txBox="1"/>
+          <p:nvPr/>
+        </p:nvSpPr>
+        <p:spPr>
+          <a:xfrm>
+            <a:off x="640080" y="6254496"/>
+            <a:ext cx="1905000" cy="182880"/>
+          </a:xfrm>
+          <a:prstGeom prst="rect">
+            <a:avLst/>
+          </a:prstGeom>
+          <a:noFill/>
+        </p:spPr>
+        <p:txBody>
+          <a:bodyPr wrap="square" lIns="0" rIns="0" tIns="0" bIns="0" anchor="t">
+            <a:spAutoFit/>
+          </a:bodyPr>
+          <a:lstStyle/>
+          <a:p>
+            <a:pPr algn="l"/>
+            <a:r>
+              <a:rPr sz="900" b="1">
+                <a:solidFill>
+                  <a:srgbClr val="111111"/>
+                </a:solidFill>
+                <a:latin typeface="Arial"/>
+              </a:rPr>
+              <a:t>Plane fast and stay light.</a:t>
+            </a:r>
+          </a:p>
+        </p:txBody>
+      </p:sp>
+      <p:sp>
+        <p:nvSpPr>
+          <p:cNvPr id="35" name="Part points: Hull"/>
+          <p:cNvSpPr txBox="1"/>
+          <p:nvPr/>
+        </p:nvSpPr>
+        <p:spPr>
+          <a:xfrm>
+            <a:off x="640080" y="6492240"/>
+            <a:ext cx="1905000" cy="548640"/>
+          </a:xfrm>
+          <a:prstGeom prst="rect">
+            <a:avLst/>
+          </a:prstGeom>
+          <a:noFill/>
+        </p:spPr>
+        <p:txBody>
+          <a:bodyPr wrap="square" lIns="0" rIns="0" tIns="0" bIns="0" anchor="t">
+            <a:spAutoFit/>
+          </a:bodyPr>
+          <a:lstStyle/>
+          <a:p>
+            <a:pPr algn="l">
+              <a:lnSpc>
+                <a:spcPct val="120000"/>
+              </a:lnSpc>
+            </a:pPr>
+            <a:r>
+              <a:rPr sz="819" b="0">
+                <a:solidFill>
+                  <a:srgbClr val="555555"/>
+                </a:solidFill>
+                <a:latin typeface="Arial"/>
+              </a:rPr>
+              <a:t>Hybrid planing composite hull</a:t>
+            </a:r>
+          </a:p>
+          <a:p>
+            <a:pPr algn="l">
+              <a:lnSpc>
+                <a:spcPct val="120000"/>
+              </a:lnSpc>
+            </a:pPr>
+            <a:r>
+              <a:rPr sz="819" b="0">
+                <a:solidFill>
+                  <a:srgbClr val="555555"/>
+                </a:solidFill>
+                <a:latin typeface="Arial"/>
+              </a:rPr>
+              <a:t>Dimensions shaped by weight</a:t>
+            </a:r>
+          </a:p>
+          <a:p>
+            <a:pPr algn="l">
+              <a:lnSpc>
+                <a:spcPct val="120000"/>
+              </a:lnSpc>
+            </a:pPr>
+            <a:r>
+              <a:rPr sz="819" b="0">
+                <a:solidFill>
+                  <a:srgbClr val="555555"/>
+                </a:solidFill>
+                <a:latin typeface="Arial"/>
+              </a:rPr>
+              <a:t>Optimization shaped by hydrodynamics</a:t>
+            </a:r>
+          </a:p>
+        </p:txBody>
+      </p:sp>
+      <p:sp>
+        <p:nvSpPr>
+          <p:cNvPr id="36" name="Card: Electric"/>
+          <p:cNvSpPr/>
+          <p:nvPr/>
+        </p:nvSpPr>
+        <p:spPr>
+          <a:xfrm>
+            <a:off x="2796540" y="5897880"/>
+            <a:ext cx="2179320" cy="1188720"/>
+          </a:xfrm>
+          <a:prstGeom prst="roundRect">
+            <a:avLst>
+              <a:gd name="adj" fmla="val 12307"/>
+            </a:avLst>
+          </a:prstGeom>
+          <a:solidFill>
+            <a:srgbClr val="F5F5F5"/>
+          </a:solidFill>
+          <a:ln w="9525">
+            <a:solidFill>
+              <a:srgbClr val="F5F5F5"/>
+            </a:solidFill>
+          </a:ln>
+          <a:effectLst/>
+        </p:spPr>
+        <p:style>
+          <a:lnRef idx="1">
+            <a:schemeClr val="accent1"/>
+          </a:lnRef>
+          <a:fillRef idx="3">
+            <a:schemeClr val="accent1"/>
+          </a:fillRef>
+          <a:effectRef idx="2">
+            <a:schemeClr val="accent1"/>
+          </a:effectRef>
+          <a:fontRef idx="minor">
+            <a:schemeClr val="lt1"/>
+          </a:fontRef>
+        </p:style>
+        <p:txBody>
+          <a:bodyPr rtlCol="0" anchor="ctr"/>
+          <a:lstStyle/>
+          <a:p>
+            <a:pPr algn="ctr"/>
+          </a:p>
+        </p:txBody>
+      </p:sp>
+      <p:sp>
+        <p:nvSpPr>
+          <p:cNvPr id="37" name="Part: Electric"/>
+          <p:cNvSpPr txBox="1"/>
+          <p:nvPr/>
+        </p:nvSpPr>
+        <p:spPr>
+          <a:xfrm>
+            <a:off x="2933700" y="6044184"/>
+            <a:ext cx="1905000" cy="228600"/>
+          </a:xfrm>
+          <a:prstGeom prst="rect">
+            <a:avLst/>
+          </a:prstGeom>
+          <a:noFill/>
+        </p:spPr>
+        <p:txBody>
+          <a:bodyPr wrap="square" lIns="0" rIns="0" tIns="0" bIns="0" anchor="t">
+            <a:spAutoFit/>
+          </a:bodyPr>
+          <a:lstStyle/>
+          <a:p>
+            <a:pPr algn="l"/>
+            <a:r>
+              <a:rPr sz="1125" b="1">
+                <a:solidFill>
+                  <a:srgbClr val="111111"/>
+                </a:solidFill>
+                <a:latin typeface="Arial"/>
+              </a:rPr>
+              <a:t>Electric</a:t>
+            </a:r>
+          </a:p>
+        </p:txBody>
+      </p:sp>
+      <p:sp>
+        <p:nvSpPr>
+          <p:cNvPr id="38" name="Part tagline: Electric"/>
+          <p:cNvSpPr txBox="1"/>
+          <p:nvPr/>
+        </p:nvSpPr>
+        <p:spPr>
+          <a:xfrm>
+            <a:off x="2933700" y="6254496"/>
+            <a:ext cx="1905000" cy="182880"/>
+          </a:xfrm>
+          <a:prstGeom prst="rect">
+            <a:avLst/>
+          </a:prstGeom>
+          <a:noFill/>
+        </p:spPr>
+        <p:txBody>
+          <a:bodyPr wrap="square" lIns="0" rIns="0" tIns="0" bIns="0" anchor="t">
+            <a:spAutoFit/>
+          </a:bodyPr>
+          <a:lstStyle/>
+          <a:p>
+            <a:pPr algn="l"/>
+            <a:r>
+              <a:rPr sz="900" b="1">
+                <a:solidFill>
+                  <a:srgbClr val="111111"/>
+                </a:solidFill>
+                <a:latin typeface="Arial"/>
+              </a:rPr>
+              <a:t>Every watt-hour to speed.</a:t>
+            </a:r>
+          </a:p>
+        </p:txBody>
+      </p:sp>
+      <p:sp>
+        <p:nvSpPr>
+          <p:cNvPr id="39" name="Part points: Electric"/>
+          <p:cNvSpPr txBox="1"/>
+          <p:nvPr/>
+        </p:nvSpPr>
+        <p:spPr>
+          <a:xfrm>
+            <a:off x="2933700" y="6492240"/>
+            <a:ext cx="1905000" cy="548640"/>
+          </a:xfrm>
+          <a:prstGeom prst="rect">
+            <a:avLst/>
+          </a:prstGeom>
+          <a:noFill/>
+        </p:spPr>
+        <p:txBody>
+          <a:bodyPr wrap="square" lIns="0" rIns="0" tIns="0" bIns="0" anchor="t">
+            <a:spAutoFit/>
+          </a:bodyPr>
+          <a:lstStyle/>
+          <a:p>
+            <a:pPr algn="l">
+              <a:lnSpc>
+                <a:spcPct val="120000"/>
+              </a:lnSpc>
+            </a:pPr>
+            <a:r>
+              <a:rPr sz="819" b="0">
+                <a:solidFill>
+                  <a:srgbClr val="555555"/>
+                </a:solidFill>
+                <a:latin typeface="Arial"/>
+              </a:rPr>
+              <a:t>High-voltage battery storage</a:t>
+            </a:r>
+          </a:p>
+          <a:p>
+            <a:pPr algn="l">
+              <a:lnSpc>
+                <a:spcPct val="120000"/>
+              </a:lnSpc>
+            </a:pPr>
+            <a:r>
+              <a:rPr sz="819" b="0">
+                <a:solidFill>
+                  <a:srgbClr val="555555"/>
+                </a:solidFill>
+                <a:latin typeface="Arial"/>
+              </a:rPr>
+              <a:t>Propulsion sized by the model</a:t>
+            </a:r>
+          </a:p>
+          <a:p>
+            <a:pPr algn="l">
+              <a:lnSpc>
+                <a:spcPct val="120000"/>
+              </a:lnSpc>
+            </a:pPr>
+            <a:r>
+              <a:rPr sz="819" b="0">
+                <a:solidFill>
+                  <a:srgbClr val="555555"/>
+                </a:solidFill>
+                <a:latin typeface="Arial"/>
+              </a:rPr>
+              <a:t>Propulsion and cooling co-designed</a:t>
+            </a:r>
+          </a:p>
+        </p:txBody>
+      </p:sp>
+      <p:sp>
+        <p:nvSpPr>
+          <p:cNvPr id="40" name="Card: Autonomous"/>
+          <p:cNvSpPr/>
+          <p:nvPr/>
+        </p:nvSpPr>
+        <p:spPr>
+          <a:xfrm>
+            <a:off x="5090160" y="5897880"/>
+            <a:ext cx="2179320" cy="1188720"/>
+          </a:xfrm>
+          <a:prstGeom prst="roundRect">
+            <a:avLst>
+              <a:gd name="adj" fmla="val 12307"/>
+            </a:avLst>
+          </a:prstGeom>
+          <a:solidFill>
+            <a:srgbClr val="F5F5F5"/>
+          </a:solidFill>
+          <a:ln w="9525">
+            <a:solidFill>
+              <a:srgbClr val="F5F5F5"/>
+            </a:solidFill>
+          </a:ln>
+          <a:effectLst/>
+        </p:spPr>
+        <p:style>
+          <a:lnRef idx="1">
+            <a:schemeClr val="accent1"/>
+          </a:lnRef>
+          <a:fillRef idx="3">
+            <a:schemeClr val="accent1"/>
+          </a:fillRef>
+          <a:effectRef idx="2">
+            <a:schemeClr val="accent1"/>
+          </a:effectRef>
+          <a:fontRef idx="minor">
+            <a:schemeClr val="lt1"/>
+          </a:fontRef>
+        </p:style>
+        <p:txBody>
+          <a:bodyPr rtlCol="0" anchor="ctr"/>
+          <a:lstStyle/>
+          <a:p>
+            <a:pPr algn="ctr"/>
+          </a:p>
+        </p:txBody>
+      </p:sp>
+      <p:sp>
+        <p:nvSpPr>
+          <p:cNvPr id="41" name="Part: Autonomous"/>
+          <p:cNvSpPr txBox="1"/>
+          <p:nvPr/>
+        </p:nvSpPr>
+        <p:spPr>
+          <a:xfrm>
+            <a:off x="5227320" y="6044184"/>
+            <a:ext cx="1905000" cy="228600"/>
+          </a:xfrm>
+          <a:prstGeom prst="rect">
+            <a:avLst/>
+          </a:prstGeom>
+          <a:noFill/>
+        </p:spPr>
+        <p:txBody>
+          <a:bodyPr wrap="square" lIns="0" rIns="0" tIns="0" bIns="0" anchor="t">
+            <a:spAutoFit/>
+          </a:bodyPr>
+          <a:lstStyle/>
+          <a:p>
+            <a:pPr algn="l"/>
+            <a:r>
+              <a:rPr sz="1125" b="1">
+                <a:solidFill>
+                  <a:srgbClr val="111111"/>
+                </a:solidFill>
+                <a:latin typeface="Arial"/>
+              </a:rPr>
+              <a:t>Autonomous</a:t>
+            </a:r>
+          </a:p>
+        </p:txBody>
+      </p:sp>
+      <p:sp>
+        <p:nvSpPr>
+          <p:cNvPr id="42" name="Part tagline: Autonomous"/>
+          <p:cNvSpPr txBox="1"/>
+          <p:nvPr/>
+        </p:nvSpPr>
+        <p:spPr>
+          <a:xfrm>
+            <a:off x="5227320" y="6254496"/>
+            <a:ext cx="1905000" cy="182880"/>
+          </a:xfrm>
+          <a:prstGeom prst="rect">
+            <a:avLst/>
+          </a:prstGeom>
+          <a:noFill/>
+        </p:spPr>
+        <p:txBody>
+          <a:bodyPr wrap="square" lIns="0" rIns="0" tIns="0" bIns="0" anchor="t">
+            <a:spAutoFit/>
+          </a:bodyPr>
+          <a:lstStyle/>
+          <a:p>
+            <a:pPr algn="l"/>
+            <a:r>
+              <a:rPr sz="900" b="1">
+                <a:solidFill>
+                  <a:srgbClr val="111111"/>
+                </a:solidFill>
+                <a:latin typeface="Arial"/>
+              </a:rPr>
+              <a:t>Manage drift and controls.</a:t>
+            </a:r>
+          </a:p>
+        </p:txBody>
+      </p:sp>
+      <p:sp>
+        <p:nvSpPr>
+          <p:cNvPr id="43" name="Part points: Autonomous"/>
+          <p:cNvSpPr txBox="1"/>
+          <p:nvPr/>
+        </p:nvSpPr>
+        <p:spPr>
+          <a:xfrm>
+            <a:off x="5227320" y="6492240"/>
+            <a:ext cx="1905000" cy="548640"/>
+          </a:xfrm>
+          <a:prstGeom prst="rect">
+            <a:avLst/>
+          </a:prstGeom>
+          <a:noFill/>
+        </p:spPr>
+        <p:txBody>
+          <a:bodyPr wrap="square" lIns="0" rIns="0" tIns="0" bIns="0" anchor="t">
+            <a:spAutoFit/>
+          </a:bodyPr>
+          <a:lstStyle/>
+          <a:p>
+            <a:pPr algn="l">
+              <a:lnSpc>
+                <a:spcPct val="120000"/>
+              </a:lnSpc>
+            </a:pPr>
+            <a:r>
+              <a:rPr sz="819" b="0">
+                <a:solidFill>
+                  <a:srgbClr val="555555"/>
+                </a:solidFill>
+                <a:latin typeface="Arial"/>
+              </a:rPr>
+              <a:t>GPS, IMU and LIDAR sensing</a:t>
+            </a:r>
+          </a:p>
+          <a:p>
+            <a:pPr algn="l">
+              <a:lnSpc>
+                <a:spcPct val="120000"/>
+              </a:lnSpc>
+            </a:pPr>
+            <a:r>
+              <a:rPr sz="819" b="0">
+                <a:solidFill>
+                  <a:srgbClr val="555555"/>
+                </a:solidFill>
+                <a:latin typeface="Arial"/>
+              </a:rPr>
+              <a:t>Fundamental feedback protocols</a:t>
+            </a:r>
+          </a:p>
+          <a:p>
+            <a:pPr algn="l">
+              <a:lnSpc>
+                <a:spcPct val="120000"/>
+              </a:lnSpc>
+            </a:pPr>
+            <a:r>
+              <a:rPr sz="819" b="0">
+                <a:solidFill>
+                  <a:srgbClr val="555555"/>
+                </a:solidFill>
+                <a:latin typeface="Arial"/>
+              </a:rPr>
+              <a:t>Software plans the route</a:t>
+            </a:r>
+          </a:p>
+        </p:txBody>
+      </p:sp>
+      <p:sp>
+        <p:nvSpPr>
+          <p:cNvPr id="44" name="Heading: Timeline"/>
+          <p:cNvSpPr txBox="1"/>
+          <p:nvPr/>
+        </p:nvSpPr>
+        <p:spPr>
+          <a:xfrm>
+            <a:off x="502920" y="7251192"/>
+            <a:ext cx="6583680" cy="274320"/>
+          </a:xfrm>
+          <a:prstGeom prst="rect">
+            <a:avLst/>
+          </a:prstGeom>
+          <a:noFill/>
+        </p:spPr>
+        <p:txBody>
+          <a:bodyPr wrap="square" lIns="0" rIns="0" tIns="0" bIns="0" anchor="t">
+            <a:spAutoFit/>
+          </a:bodyPr>
+          <a:lstStyle/>
+          <a:p>
+            <a:pPr algn="l"/>
+            <a:r>
+              <a:rPr sz="1275" b="1">
+                <a:solidFill>
+                  <a:srgbClr val="111111"/>
+                </a:solidFill>
+                <a:latin typeface="Arial"/>
+              </a:rPr>
+              <a:t>Timeline</a:t>
+            </a:r>
+          </a:p>
+        </p:txBody>
+      </p:sp>
+      <p:sp>
+        <p:nvSpPr>
+          <p:cNvPr id="45" name="Timeline date: Hull design frozen"/>
+          <p:cNvSpPr txBox="1"/>
+          <p:nvPr/>
+        </p:nvSpPr>
+        <p:spPr>
+          <a:xfrm>
+            <a:off x="502920" y="7534656"/>
+            <a:ext cx="1005840" cy="164592"/>
+          </a:xfrm>
+          <a:prstGeom prst="rect">
+            <a:avLst/>
+          </a:prstGeom>
+          <a:noFill/>
+        </p:spPr>
+        <p:txBody>
+          <a:bodyPr wrap="square" lIns="0" rIns="0" tIns="0" bIns="0" anchor="t">
+            <a:spAutoFit/>
+          </a:bodyPr>
+          <a:lstStyle/>
+          <a:p>
+            <a:pPr algn="l"/>
+            <a:r>
+              <a:rPr sz="819" b="1">
+                <a:solidFill>
+                  <a:srgbClr val="111111"/>
+                </a:solidFill>
+                <a:latin typeface="Arial"/>
+              </a:rPr>
+              <a:t>Oct 25</a:t>
+            </a:r>
+          </a:p>
+        </p:txBody>
+      </p:sp>
+      <p:sp>
+        <p:nvSpPr>
+          <p:cNvPr id="46" name="Timeline label: Hull design frozen"/>
+          <p:cNvSpPr txBox="1"/>
+          <p:nvPr/>
+        </p:nvSpPr>
+        <p:spPr>
+          <a:xfrm>
+            <a:off x="1600200" y="7534656"/>
+            <a:ext cx="2133752" cy="162763"/>
+          </a:xfrm>
+          <a:prstGeom prst="rect">
+            <a:avLst/>
+          </a:prstGeom>
+          <a:noFill/>
+        </p:spPr>
+        <p:txBody>
+          <a:bodyPr wrap="square" lIns="0" rIns="0" tIns="0" bIns="0" anchor="t">
+            <a:spAutoFit/>
+          </a:bodyPr>
+          <a:lstStyle/>
+          <a:p>
+            <a:pPr algn="l"/>
+            <a:r>
+              <a:rPr sz="819" b="0">
+                <a:solidFill>
+                  <a:srgbClr val="555555"/>
+                </a:solidFill>
+                <a:latin typeface="Arial"/>
+              </a:rPr>
+              <a:t>Hull design frozen</a:t>
+            </a:r>
+          </a:p>
+        </p:txBody>
+      </p:sp>
+      <p:sp>
+        <p:nvSpPr>
+          <p:cNvPr id="47" name="Timeline date: Preliminary design review"/>
+          <p:cNvSpPr txBox="1"/>
+          <p:nvPr/>
+        </p:nvSpPr>
+        <p:spPr>
+          <a:xfrm>
+            <a:off x="502920" y="7697419"/>
+            <a:ext cx="1005840" cy="164592"/>
+          </a:xfrm>
+          <a:prstGeom prst="rect">
+            <a:avLst/>
+          </a:prstGeom>
+          <a:noFill/>
+        </p:spPr>
+        <p:txBody>
+          <a:bodyPr wrap="square" lIns="0" rIns="0" tIns="0" bIns="0" anchor="t">
+            <a:spAutoFit/>
+          </a:bodyPr>
+          <a:lstStyle/>
+          <a:p>
+            <a:pPr algn="l"/>
+            <a:r>
+              <a:rPr sz="819" b="1">
+                <a:solidFill>
+                  <a:srgbClr val="111111"/>
+                </a:solidFill>
+                <a:latin typeface="Arial"/>
+              </a:rPr>
+              <a:t>Nov 1</a:t>
+            </a:r>
+          </a:p>
+        </p:txBody>
+      </p:sp>
+      <p:sp>
+        <p:nvSpPr>
+          <p:cNvPr id="48" name="Timeline label: Preliminary design review"/>
+          <p:cNvSpPr txBox="1"/>
+          <p:nvPr/>
+        </p:nvSpPr>
+        <p:spPr>
+          <a:xfrm>
+            <a:off x="1600200" y="7697419"/>
+            <a:ext cx="2133752" cy="162763"/>
+          </a:xfrm>
+          <a:prstGeom prst="rect">
+            <a:avLst/>
+          </a:prstGeom>
+          <a:noFill/>
+        </p:spPr>
+        <p:txBody>
+          <a:bodyPr wrap="square" lIns="0" rIns="0" tIns="0" bIns="0" anchor="t">
+            <a:spAutoFit/>
+          </a:bodyPr>
+          <a:lstStyle/>
+          <a:p>
+            <a:pPr algn="l"/>
+            <a:r>
+              <a:rPr sz="819" b="0">
+                <a:solidFill>
+                  <a:srgbClr val="555555"/>
+                </a:solidFill>
+                <a:latin typeface="Arial"/>
+              </a:rPr>
+              <a:t>Preliminary design review</a:t>
+            </a:r>
+          </a:p>
+        </p:txBody>
+      </p:sp>
+      <p:sp>
+        <p:nvSpPr>
+          <p:cNvPr id="49" name="Timeline date: Critical and long-lead parts are ordered"/>
+          <p:cNvSpPr txBox="1"/>
+          <p:nvPr/>
+        </p:nvSpPr>
+        <p:spPr>
+          <a:xfrm>
+            <a:off x="502920" y="7860182"/>
+            <a:ext cx="1005840" cy="164592"/>
+          </a:xfrm>
+          <a:prstGeom prst="rect">
+            <a:avLst/>
+          </a:prstGeom>
+          <a:noFill/>
+        </p:spPr>
+        <p:txBody>
+          <a:bodyPr wrap="square" lIns="0" rIns="0" tIns="0" bIns="0" anchor="t">
+            <a:spAutoFit/>
+          </a:bodyPr>
+          <a:lstStyle/>
+          <a:p>
+            <a:pPr algn="l"/>
+            <a:r>
+              <a:rPr sz="819" b="1">
+                <a:solidFill>
+                  <a:srgbClr val="111111"/>
+                </a:solidFill>
+                <a:latin typeface="Arial"/>
+              </a:rPr>
+              <a:t>Nov 10</a:t>
+            </a:r>
+          </a:p>
+        </p:txBody>
+      </p:sp>
+      <p:sp>
+        <p:nvSpPr>
+          <p:cNvPr id="50" name="Timeline label: Critical and long-lead parts are ordered"/>
+          <p:cNvSpPr txBox="1"/>
+          <p:nvPr/>
+        </p:nvSpPr>
+        <p:spPr>
+          <a:xfrm>
+            <a:off x="1600200" y="7860182"/>
+            <a:ext cx="2133752" cy="162763"/>
+          </a:xfrm>
+          <a:prstGeom prst="rect">
+            <a:avLst/>
+          </a:prstGeom>
+          <a:noFill/>
+        </p:spPr>
+        <p:txBody>
+          <a:bodyPr wrap="square" lIns="0" rIns="0" tIns="0" bIns="0" anchor="t">
+            <a:spAutoFit/>
+          </a:bodyPr>
+          <a:lstStyle/>
+          <a:p>
+            <a:pPr algn="l"/>
+            <a:r>
+              <a:rPr sz="819" b="0">
+                <a:solidFill>
+                  <a:srgbClr val="555555"/>
+                </a:solidFill>
+                <a:latin typeface="Arial"/>
+              </a:rPr>
+              <a:t>Critical and long-lead parts are ordered</a:t>
+            </a:r>
+          </a:p>
+        </p:txBody>
+      </p:sp>
+      <p:sp>
+        <p:nvSpPr>
+          <p:cNvPr id="51" name="Timeline date: Mechanical and electrical design frozen"/>
+          <p:cNvSpPr txBox="1"/>
+          <p:nvPr/>
+        </p:nvSpPr>
+        <p:spPr>
+          <a:xfrm>
+            <a:off x="502920" y="8022945"/>
+            <a:ext cx="1005840" cy="164592"/>
+          </a:xfrm>
+          <a:prstGeom prst="rect">
+            <a:avLst/>
+          </a:prstGeom>
+          <a:noFill/>
+        </p:spPr>
+        <p:txBody>
+          <a:bodyPr wrap="square" lIns="0" rIns="0" tIns="0" bIns="0" anchor="t">
+            <a:spAutoFit/>
+          </a:bodyPr>
+          <a:lstStyle/>
+          <a:p>
+            <a:pPr algn="l"/>
+            <a:r>
+              <a:rPr sz="819" b="1">
+                <a:solidFill>
+                  <a:srgbClr val="111111"/>
+                </a:solidFill>
+                <a:latin typeface="Arial"/>
+              </a:rPr>
+              <a:t>Nov 20</a:t>
+            </a:r>
+          </a:p>
+        </p:txBody>
+      </p:sp>
+      <p:sp>
+        <p:nvSpPr>
+          <p:cNvPr id="52" name="Timeline label: Mechanical and electrical design frozen"/>
+          <p:cNvSpPr txBox="1"/>
+          <p:nvPr/>
+        </p:nvSpPr>
+        <p:spPr>
+          <a:xfrm>
+            <a:off x="1600200" y="8022945"/>
+            <a:ext cx="2133752" cy="162763"/>
+          </a:xfrm>
+          <a:prstGeom prst="rect">
+            <a:avLst/>
+          </a:prstGeom>
+          <a:noFill/>
+        </p:spPr>
+        <p:txBody>
+          <a:bodyPr wrap="square" lIns="0" rIns="0" tIns="0" bIns="0" anchor="t">
+            <a:spAutoFit/>
+          </a:bodyPr>
+          <a:lstStyle/>
+          <a:p>
+            <a:pPr algn="l"/>
+            <a:r>
+              <a:rPr sz="819" b="0">
+                <a:solidFill>
+                  <a:srgbClr val="555555"/>
+                </a:solidFill>
+                <a:latin typeface="Arial"/>
+              </a:rPr>
+              <a:t>Mechanical and electrical design frozen</a:t>
+            </a:r>
+          </a:p>
+        </p:txBody>
+      </p:sp>
+      <p:sp>
+        <p:nvSpPr>
+          <p:cNvPr id="53" name="Timeline date: Build the hull, composite parts and any custom-milled parts"/>
+          <p:cNvSpPr txBox="1"/>
+          <p:nvPr/>
+        </p:nvSpPr>
+        <p:spPr>
+          <a:xfrm>
+            <a:off x="502920" y="8185708"/>
+            <a:ext cx="1005840" cy="164592"/>
+          </a:xfrm>
+          <a:prstGeom prst="rect">
+            <a:avLst/>
+          </a:prstGeom>
+          <a:noFill/>
+        </p:spPr>
+        <p:txBody>
+          <a:bodyPr wrap="square" lIns="0" rIns="0" tIns="0" bIns="0" anchor="t">
+            <a:spAutoFit/>
+          </a:bodyPr>
+          <a:lstStyle/>
+          <a:p>
+            <a:pPr algn="l"/>
+            <a:r>
+              <a:rPr sz="819" b="1">
+                <a:solidFill>
+                  <a:srgbClr val="111111"/>
+                </a:solidFill>
+                <a:latin typeface="Arial"/>
+              </a:rPr>
+              <a:t>Nov 20–Dec 20</a:t>
+            </a:r>
+          </a:p>
+        </p:txBody>
+      </p:sp>
+      <p:sp>
+        <p:nvSpPr>
+          <p:cNvPr id="54" name="Timeline label: Build the hull, composite parts and any custom-milled parts"/>
+          <p:cNvSpPr txBox="1"/>
+          <p:nvPr/>
+        </p:nvSpPr>
+        <p:spPr>
+          <a:xfrm>
+            <a:off x="1600200" y="8185708"/>
+            <a:ext cx="2133752" cy="277063"/>
+          </a:xfrm>
+          <a:prstGeom prst="rect">
+            <a:avLst/>
+          </a:prstGeom>
+          <a:noFill/>
+        </p:spPr>
+        <p:txBody>
+          <a:bodyPr wrap="square" lIns="0" rIns="0" tIns="0" bIns="0" anchor="t">
+            <a:spAutoFit/>
+          </a:bodyPr>
+          <a:lstStyle/>
+          <a:p>
+            <a:pPr algn="l"/>
+            <a:r>
+              <a:rPr sz="819" b="0">
+                <a:solidFill>
+                  <a:srgbClr val="555555"/>
+                </a:solidFill>
+                <a:latin typeface="Arial"/>
+              </a:rPr>
+              <a:t>Build the hull, composite parts and any custom-milled parts</a:t>
+            </a:r>
+          </a:p>
+        </p:txBody>
+      </p:sp>
+      <p:sp>
+        <p:nvSpPr>
+          <p:cNvPr id="55" name="Timeline date: First float and tow test"/>
+          <p:cNvSpPr txBox="1"/>
+          <p:nvPr/>
+        </p:nvSpPr>
+        <p:spPr>
+          <a:xfrm>
+            <a:off x="502920" y="8462772"/>
+            <a:ext cx="1005840" cy="164592"/>
+          </a:xfrm>
+          <a:prstGeom prst="rect">
+            <a:avLst/>
+          </a:prstGeom>
+          <a:noFill/>
+        </p:spPr>
+        <p:txBody>
+          <a:bodyPr wrap="square" lIns="0" rIns="0" tIns="0" bIns="0" anchor="t">
+            <a:spAutoFit/>
+          </a:bodyPr>
+          <a:lstStyle/>
+          <a:p>
+            <a:pPr algn="l"/>
+            <a:r>
+              <a:rPr sz="819" b="1">
+                <a:solidFill>
+                  <a:srgbClr val="111111"/>
+                </a:solidFill>
+                <a:latin typeface="Arial"/>
+              </a:rPr>
+              <a:t>Jan 8</a:t>
+            </a:r>
+          </a:p>
+        </p:txBody>
+      </p:sp>
+      <p:sp>
+        <p:nvSpPr>
+          <p:cNvPr id="56" name="Timeline label: First float and tow test"/>
+          <p:cNvSpPr txBox="1"/>
+          <p:nvPr/>
+        </p:nvSpPr>
+        <p:spPr>
+          <a:xfrm>
+            <a:off x="1600200" y="8462772"/>
+            <a:ext cx="2133752" cy="162763"/>
+          </a:xfrm>
+          <a:prstGeom prst="rect">
+            <a:avLst/>
+          </a:prstGeom>
+          <a:noFill/>
+        </p:spPr>
+        <p:txBody>
+          <a:bodyPr wrap="square" lIns="0" rIns="0" tIns="0" bIns="0" anchor="t">
+            <a:spAutoFit/>
+          </a:bodyPr>
+          <a:lstStyle/>
+          <a:p>
+            <a:pPr algn="l"/>
+            <a:r>
+              <a:rPr sz="819" b="0">
+                <a:solidFill>
+                  <a:srgbClr val="555555"/>
+                </a:solidFill>
+                <a:latin typeface="Arial"/>
+              </a:rPr>
+              <a:t>First float and tow test</a:t>
+            </a:r>
+          </a:p>
+        </p:txBody>
+      </p:sp>
+      <p:sp>
+        <p:nvSpPr>
+          <p:cNvPr id="57" name="Timeline date: Manufacture and assemble everything"/>
+          <p:cNvSpPr txBox="1"/>
+          <p:nvPr/>
+        </p:nvSpPr>
+        <p:spPr>
+          <a:xfrm>
+            <a:off x="4038447" y="7534656"/>
+            <a:ext cx="1005840" cy="164592"/>
+          </a:xfrm>
+          <a:prstGeom prst="rect">
+            <a:avLst/>
+          </a:prstGeom>
+          <a:noFill/>
+        </p:spPr>
+        <p:txBody>
+          <a:bodyPr wrap="square" lIns="0" rIns="0" tIns="0" bIns="0" anchor="t">
+            <a:spAutoFit/>
+          </a:bodyPr>
+          <a:lstStyle/>
+          <a:p>
+            <a:pPr algn="l"/>
+            <a:r>
+              <a:rPr sz="819" b="1">
+                <a:solidFill>
+                  <a:srgbClr val="111111"/>
+                </a:solidFill>
+                <a:latin typeface="Arial"/>
+              </a:rPr>
+              <a:t>Jan 8–30</a:t>
+            </a:r>
+          </a:p>
+        </p:txBody>
+      </p:sp>
+      <p:sp>
+        <p:nvSpPr>
+          <p:cNvPr id="58" name="Timeline label: Manufacture and assemble everything"/>
+          <p:cNvSpPr txBox="1"/>
+          <p:nvPr/>
+        </p:nvSpPr>
+        <p:spPr>
+          <a:xfrm>
+            <a:off x="5135727" y="7534656"/>
+            <a:ext cx="2133752" cy="162763"/>
+          </a:xfrm>
+          <a:prstGeom prst="rect">
+            <a:avLst/>
+          </a:prstGeom>
+          <a:noFill/>
+        </p:spPr>
+        <p:txBody>
+          <a:bodyPr wrap="square" lIns="0" rIns="0" tIns="0" bIns="0" anchor="t">
+            <a:spAutoFit/>
+          </a:bodyPr>
+          <a:lstStyle/>
+          <a:p>
+            <a:pPr algn="l"/>
+            <a:r>
+              <a:rPr sz="819" b="0">
+                <a:solidFill>
+                  <a:srgbClr val="555555"/>
+                </a:solidFill>
+                <a:latin typeface="Arial"/>
+              </a:rPr>
+              <a:t>Manufacture and assemble everything</a:t>
+            </a:r>
+          </a:p>
+        </p:txBody>
+      </p:sp>
+      <p:sp>
+        <p:nvSpPr>
+          <p:cNvPr id="59" name="Timeline date: Build likely spare parts, in parallel"/>
+          <p:cNvSpPr txBox="1"/>
+          <p:nvPr/>
+        </p:nvSpPr>
+        <p:spPr>
+          <a:xfrm>
+            <a:off x="4038447" y="7697419"/>
+            <a:ext cx="1005840" cy="164592"/>
+          </a:xfrm>
+          <a:prstGeom prst="rect">
+            <a:avLst/>
+          </a:prstGeom>
+          <a:noFill/>
+        </p:spPr>
+        <p:txBody>
+          <a:bodyPr wrap="square" lIns="0" rIns="0" tIns="0" bIns="0" anchor="t">
+            <a:spAutoFit/>
+          </a:bodyPr>
+          <a:lstStyle/>
+          <a:p>
+            <a:pPr algn="l"/>
+            <a:r>
+              <a:rPr sz="819" b="1">
+                <a:solidFill>
+                  <a:srgbClr val="111111"/>
+                </a:solidFill>
+                <a:latin typeface="Arial"/>
+              </a:rPr>
+              <a:t>Jan 8–30</a:t>
+            </a:r>
+          </a:p>
+        </p:txBody>
+      </p:sp>
+      <p:sp>
+        <p:nvSpPr>
+          <p:cNvPr id="60" name="Timeline label: Build likely spare parts, in parallel"/>
+          <p:cNvSpPr txBox="1"/>
+          <p:nvPr/>
+        </p:nvSpPr>
+        <p:spPr>
+          <a:xfrm>
+            <a:off x="5135727" y="7697419"/>
+            <a:ext cx="2133752" cy="162763"/>
+          </a:xfrm>
+          <a:prstGeom prst="rect">
+            <a:avLst/>
+          </a:prstGeom>
+          <a:noFill/>
+        </p:spPr>
+        <p:txBody>
+          <a:bodyPr wrap="square" lIns="0" rIns="0" tIns="0" bIns="0" anchor="t">
+            <a:spAutoFit/>
+          </a:bodyPr>
+          <a:lstStyle/>
+          <a:p>
+            <a:pPr algn="l"/>
+            <a:r>
+              <a:rPr sz="819" b="0">
+                <a:solidFill>
+                  <a:srgbClr val="555555"/>
+                </a:solidFill>
+                <a:latin typeface="Arial"/>
+              </a:rPr>
+              <a:t>Build likely spare parts, in parallel</a:t>
+            </a:r>
+          </a:p>
+        </p:txBody>
+      </p:sp>
+      <p:sp>
+        <p:nvSpPr>
+          <p:cNvPr id="61" name="Timeline date: First nautical mile"/>
+          <p:cNvSpPr txBox="1"/>
+          <p:nvPr/>
+        </p:nvSpPr>
+        <p:spPr>
+          <a:xfrm>
+            <a:off x="4038447" y="7860182"/>
+            <a:ext cx="1005840" cy="164592"/>
+          </a:xfrm>
+          <a:prstGeom prst="rect">
+            <a:avLst/>
+          </a:prstGeom>
+          <a:noFill/>
+        </p:spPr>
+        <p:txBody>
+          <a:bodyPr wrap="square" lIns="0" rIns="0" tIns="0" bIns="0" anchor="t">
+            <a:spAutoFit/>
+          </a:bodyPr>
+          <a:lstStyle/>
+          <a:p>
+            <a:pPr algn="l"/>
+            <a:r>
+              <a:rPr sz="819" b="1">
+                <a:solidFill>
+                  <a:srgbClr val="111111"/>
+                </a:solidFill>
+                <a:latin typeface="Arial"/>
+              </a:rPr>
+              <a:t>Jan 31</a:t>
+            </a:r>
+          </a:p>
+        </p:txBody>
+      </p:sp>
+      <p:sp>
+        <p:nvSpPr>
+          <p:cNvPr id="62" name="Timeline label: First nautical mile"/>
+          <p:cNvSpPr txBox="1"/>
+          <p:nvPr/>
+        </p:nvSpPr>
+        <p:spPr>
+          <a:xfrm>
+            <a:off x="5135727" y="7860182"/>
+            <a:ext cx="2133752" cy="162763"/>
+          </a:xfrm>
+          <a:prstGeom prst="rect">
+            <a:avLst/>
+          </a:prstGeom>
+          <a:noFill/>
+        </p:spPr>
+        <p:txBody>
+          <a:bodyPr wrap="square" lIns="0" rIns="0" tIns="0" bIns="0" anchor="t">
+            <a:spAutoFit/>
+          </a:bodyPr>
+          <a:lstStyle/>
+          <a:p>
+            <a:pPr algn="l"/>
+            <a:r>
+              <a:rPr sz="819" b="0">
+                <a:solidFill>
+                  <a:srgbClr val="555555"/>
+                </a:solidFill>
+                <a:latin typeface="Arial"/>
+              </a:rPr>
+              <a:t>First nautical mile</a:t>
+            </a:r>
+          </a:p>
+        </p:txBody>
+      </p:sp>
+      <p:sp>
+        <p:nvSpPr>
+          <p:cNvPr id="63" name="Timeline date: Slow drives on the water"/>
+          <p:cNvSpPr txBox="1"/>
+          <p:nvPr/>
+        </p:nvSpPr>
+        <p:spPr>
+          <a:xfrm>
+            <a:off x="4038447" y="8022945"/>
+            <a:ext cx="1005840" cy="164592"/>
+          </a:xfrm>
+          <a:prstGeom prst="rect">
+            <a:avLst/>
+          </a:prstGeom>
+          <a:noFill/>
+        </p:spPr>
+        <p:txBody>
+          <a:bodyPr wrap="square" lIns="0" rIns="0" tIns="0" bIns="0" anchor="t">
+            <a:spAutoFit/>
+          </a:bodyPr>
+          <a:lstStyle/>
+          <a:p>
+            <a:pPr algn="l"/>
+            <a:r>
+              <a:rPr sz="819" b="1">
+                <a:solidFill>
+                  <a:srgbClr val="111111"/>
+                </a:solidFill>
+                <a:latin typeface="Arial"/>
+              </a:rPr>
+              <a:t>Feb 1–14</a:t>
+            </a:r>
+          </a:p>
+        </p:txBody>
+      </p:sp>
+      <p:sp>
+        <p:nvSpPr>
+          <p:cNvPr id="64" name="Timeline label: Slow drives on the water"/>
+          <p:cNvSpPr txBox="1"/>
+          <p:nvPr/>
+        </p:nvSpPr>
+        <p:spPr>
+          <a:xfrm>
+            <a:off x="5135727" y="8022945"/>
+            <a:ext cx="2133752" cy="162763"/>
+          </a:xfrm>
+          <a:prstGeom prst="rect">
+            <a:avLst/>
+          </a:prstGeom>
+          <a:noFill/>
+        </p:spPr>
+        <p:txBody>
+          <a:bodyPr wrap="square" lIns="0" rIns="0" tIns="0" bIns="0" anchor="t">
+            <a:spAutoFit/>
+          </a:bodyPr>
+          <a:lstStyle/>
+          <a:p>
+            <a:pPr algn="l"/>
+            <a:r>
+              <a:rPr sz="819" b="0">
+                <a:solidFill>
+                  <a:srgbClr val="555555"/>
+                </a:solidFill>
+                <a:latin typeface="Arial"/>
+              </a:rPr>
+              <a:t>Slow drives on the water</a:t>
+            </a:r>
+          </a:p>
+        </p:txBody>
+      </p:sp>
+      <p:sp>
+        <p:nvSpPr>
+          <p:cNvPr id="65" name="Timeline date: Start increasing speed"/>
+          <p:cNvSpPr txBox="1"/>
+          <p:nvPr/>
+        </p:nvSpPr>
+        <p:spPr>
+          <a:xfrm>
+            <a:off x="4038447" y="8185708"/>
+            <a:ext cx="1005840" cy="164592"/>
+          </a:xfrm>
+          <a:prstGeom prst="rect">
+            <a:avLst/>
+          </a:prstGeom>
+          <a:noFill/>
+        </p:spPr>
+        <p:txBody>
+          <a:bodyPr wrap="square" lIns="0" rIns="0" tIns="0" bIns="0" anchor="t">
+            <a:spAutoFit/>
+          </a:bodyPr>
+          <a:lstStyle/>
+          <a:p>
+            <a:pPr algn="l"/>
+            <a:r>
+              <a:rPr sz="819" b="1">
+                <a:solidFill>
+                  <a:srgbClr val="111111"/>
+                </a:solidFill>
+                <a:latin typeface="Arial"/>
+              </a:rPr>
+              <a:t>Feb 15</a:t>
+            </a:r>
+          </a:p>
+        </p:txBody>
+      </p:sp>
+      <p:sp>
+        <p:nvSpPr>
+          <p:cNvPr id="66" name="Timeline label: Start increasing speed"/>
+          <p:cNvSpPr txBox="1"/>
+          <p:nvPr/>
+        </p:nvSpPr>
+        <p:spPr>
+          <a:xfrm>
+            <a:off x="5135727" y="8185708"/>
+            <a:ext cx="2133752" cy="162763"/>
+          </a:xfrm>
+          <a:prstGeom prst="rect">
+            <a:avLst/>
+          </a:prstGeom>
+          <a:noFill/>
+        </p:spPr>
+        <p:txBody>
+          <a:bodyPr wrap="square" lIns="0" rIns="0" tIns="0" bIns="0" anchor="t">
+            <a:spAutoFit/>
+          </a:bodyPr>
+          <a:lstStyle/>
+          <a:p>
+            <a:pPr algn="l"/>
+            <a:r>
+              <a:rPr sz="819" b="0">
+                <a:solidFill>
+                  <a:srgbClr val="555555"/>
+                </a:solidFill>
+                <a:latin typeface="Arial"/>
+              </a:rPr>
+              <a:t>Start increasing speed</a:t>
+            </a:r>
+          </a:p>
+        </p:txBody>
+      </p:sp>
+      <p:sp>
+        <p:nvSpPr>
+          <p:cNvPr id="67" name="Timeline date: Testing / Tuning"/>
+          <p:cNvSpPr txBox="1"/>
+          <p:nvPr/>
+        </p:nvSpPr>
+        <p:spPr>
+          <a:xfrm>
+            <a:off x="4038447" y="8348472"/>
+            <a:ext cx="1005840" cy="164592"/>
+          </a:xfrm>
+          <a:prstGeom prst="rect">
+            <a:avLst/>
+          </a:prstGeom>
+          <a:noFill/>
+        </p:spPr>
+        <p:txBody>
+          <a:bodyPr wrap="square" lIns="0" rIns="0" tIns="0" bIns="0" anchor="t">
+            <a:spAutoFit/>
+          </a:bodyPr>
+          <a:lstStyle/>
+          <a:p>
+            <a:pPr algn="l"/>
+            <a:r>
+              <a:rPr sz="819" b="1">
+                <a:solidFill>
+                  <a:srgbClr val="111111"/>
+                </a:solidFill>
+                <a:latin typeface="Arial"/>
+              </a:rPr>
+              <a:t>Until April</a:t>
+            </a:r>
+          </a:p>
+        </p:txBody>
+      </p:sp>
+      <p:sp>
+        <p:nvSpPr>
+          <p:cNvPr id="68" name="Timeline label: Testing / Tuning"/>
+          <p:cNvSpPr txBox="1"/>
+          <p:nvPr/>
+        </p:nvSpPr>
+        <p:spPr>
+          <a:xfrm>
+            <a:off x="5135727" y="8348472"/>
+            <a:ext cx="2133752" cy="162763"/>
+          </a:xfrm>
+          <a:prstGeom prst="rect">
+            <a:avLst/>
+          </a:prstGeom>
+          <a:noFill/>
+        </p:spPr>
+        <p:txBody>
+          <a:bodyPr wrap="square" lIns="0" rIns="0" tIns="0" bIns="0" anchor="t">
+            <a:spAutoFit/>
+          </a:bodyPr>
+          <a:lstStyle/>
+          <a:p>
+            <a:pPr algn="l"/>
+            <a:r>
+              <a:rPr sz="819" b="0">
+                <a:solidFill>
+                  <a:srgbClr val="555555"/>
+                </a:solidFill>
+                <a:latin typeface="Arial"/>
+              </a:rPr>
+              <a:t>Testing / Tuning</a:t>
+            </a:r>
+          </a:p>
+        </p:txBody>
+      </p:sp>
+      <p:sp>
+        <p:nvSpPr>
+          <p:cNvPr id="69" name="Footer card"/>
+          <p:cNvSpPr/>
+          <p:nvPr/>
+        </p:nvSpPr>
+        <p:spPr>
+          <a:xfrm>
+            <a:off x="502920" y="8823960"/>
+            <a:ext cx="6766560" cy="822960"/>
+          </a:xfrm>
+          <a:prstGeom prst="roundRect">
+            <a:avLst>
+              <a:gd name="adj" fmla="val 17777"/>
+            </a:avLst>
+          </a:prstGeom>
+          <a:solidFill>
+            <a:srgbClr val="111111"/>
+          </a:solidFill>
+          <a:ln>
+            <a:noFill/>
+          </a:ln>
+          <a:effectLst/>
+        </p:spPr>
+        <p:style>
+          <a:lnRef idx="1">
+            <a:schemeClr val="accent1"/>
+          </a:lnRef>
+          <a:fillRef idx="3">
+            <a:schemeClr val="accent1"/>
+          </a:fillRef>
+          <a:effectRef idx="2">
+            <a:schemeClr val="accent1"/>
+          </a:effectRef>
+          <a:fontRef idx="minor">
+            <a:schemeClr val="lt1"/>
+          </a:fontRef>
+        </p:style>
+        <p:txBody>
+          <a:bodyPr rtlCol="0" anchor="ctr"/>
+          <a:lstStyle/>
+          <a:p>
+            <a:pPr algn="ctr"/>
+          </a:p>
+        </p:txBody>
+      </p:sp>
+      <p:sp>
+        <p:nvSpPr>
+          <p:cNvPr id="70" name="Footer title"/>
           <p:cNvSpPr txBox="1"/>
           <p:nvPr/>
         </p:nvSpPr>
@@ -5383,7 +5737,7 @@
       </p:sp>
       <p:sp>
         <p:nvSpPr>
-          <p:cNvPr id="62" name="Footer text"/>
+          <p:cNvPr id="71" name="Footer text"/>
           <p:cNvSpPr txBox="1"/>
           <p:nvPr/>
         </p:nvSpPr>
@@ -5422,7 +5776,7 @@
       </p:sp>
       <p:sp>
         <p:nvSpPr>
-          <p:cNvPr id="63" name="Footer link"/>
+          <p:cNvPr id="72" name="Footer link"/>
           <p:cNvSpPr txBox="1"/>
           <p:nvPr/>
         </p:nvSpPr>
@@ -5457,7 +5811,7 @@
       </p:sp>
       <p:sp>
         <p:nvSpPr>
-          <p:cNvPr id="64" name="Footer contact name"/>
+          <p:cNvPr id="73" name="Footer contact name"/>
           <p:cNvSpPr txBox="1"/>
           <p:nvPr/>
         </p:nvSpPr>
@@ -5492,7 +5846,7 @@
       </p:sp>
       <p:sp>
         <p:nvSpPr>
-          <p:cNvPr id="65" name="Footer contact email"/>
+          <p:cNvPr id="74" name="Footer contact email"/>
           <p:cNvSpPr txBox="1"/>
           <p:nvPr/>
         </p:nvSpPr>

</xml_diff>

<commit_message>
Handout: 30 mph autonomously, integrated software and controller
Co-Authored-By: Claude Sonnet 5.5 <noreply@anthropic.com>
</commit_message>
<xml_diff>
--- a/dashboard/public/haav-handout.pptx
+++ b/dashboard/public/haav-handout.pptx
@@ -3337,7 +3337,7 @@
       </p:pic>
       <p:sp>
         <p:nvSpPr>
-          <p:cNvPr id="9" name="Fact card: Speed"/>
+          <p:cNvPr id="9" name="Fact card: Autonomously"/>
           <p:cNvSpPr/>
           <p:nvPr/>
         </p:nvSpPr>
@@ -3385,7 +3385,7 @@
       </p:sp>
       <p:sp>
         <p:nvSpPr>
-          <p:cNvPr id="10" name="Fact: 40 mph"/>
+          <p:cNvPr id="10" name="Fact: 30 mph"/>
           <p:cNvSpPr txBox="1"/>
           <p:nvPr/>
         </p:nvSpPr>
@@ -3413,14 +3413,14 @@
                 </a:solidFill>
                 <a:latin typeface="Arial"/>
               </a:rPr>
-              <a:t>40 mph</a:t>
-            </a:r>
-          </a:p>
-        </p:txBody>
-      </p:sp>
-      <p:sp>
-        <p:nvSpPr>
-          <p:cNvPr id="11" name="Fact label: Speed"/>
+              <a:t>30 mph</a:t>
+            </a:r>
+          </a:p>
+        </p:txBody>
+      </p:sp>
+      <p:sp>
+        <p:nvSpPr>
+          <p:cNvPr id="11" name="Fact label: Autonomously"/>
           <p:cNvSpPr txBox="1"/>
           <p:nvPr/>
         </p:nvSpPr>
@@ -3448,14 +3448,14 @@
                 </a:solidFill>
                 <a:latin typeface="Arial"/>
               </a:rPr>
-              <a:t>Speed</a:t>
-            </a:r>
-          </a:p>
-        </p:txBody>
-      </p:sp>
-      <p:sp>
-        <p:nvSpPr>
-          <p:cNvPr id="12" name="Fact card: Weight"/>
+              <a:t>Autonomously</a:t>
+            </a:r>
+          </a:p>
+        </p:txBody>
+      </p:sp>
+      <p:sp>
+        <p:nvSpPr>
+          <p:cNvPr id="12" name="Fact card: Software and controller"/>
           <p:cNvSpPr/>
           <p:nvPr/>
         </p:nvSpPr>
@@ -3503,7 +3503,7 @@
       </p:sp>
       <p:sp>
         <p:nvSpPr>
-          <p:cNvPr id="13" name="Fact: Under 80 lbs"/>
+          <p:cNvPr id="13" name="Fact: Integrated"/>
           <p:cNvSpPr txBox="1"/>
           <p:nvPr/>
         </p:nvSpPr>
@@ -3531,14 +3531,14 @@
                 </a:solidFill>
                 <a:latin typeface="Arial"/>
               </a:rPr>
-              <a:t>Under 80 lbs</a:t>
-            </a:r>
-          </a:p>
-        </p:txBody>
-      </p:sp>
-      <p:sp>
-        <p:nvSpPr>
-          <p:cNvPr id="14" name="Fact label: Weight"/>
+              <a:t>Integrated</a:t>
+            </a:r>
+          </a:p>
+        </p:txBody>
+      </p:sp>
+      <p:sp>
+        <p:nvSpPr>
+          <p:cNvPr id="14" name="Fact label: Software and controller"/>
           <p:cNvSpPr txBox="1"/>
           <p:nvPr/>
         </p:nvSpPr>
@@ -3566,7 +3566,7 @@
                 </a:solidFill>
                 <a:latin typeface="Arial"/>
               </a:rPr>
-              <a:t>Weight</a:t>
+              <a:t>Software and controller</a:t>
             </a:r>
           </a:p>
         </p:txBody>

</xml_diff>

<commit_message>
style(design): re-export the PDF and PowerPoint with the polish fixes
Co-Authored-By: Claude Sonnet 5.5 <noreply@anthropic.com>
</commit_message>
<xml_diff>
--- a/dashboard/public/haav-handout.pptx
+++ b/dashboard/public/haav-handout.pptx
@@ -3280,7 +3280,7 @@
         </p:nvSpPr>
         <p:spPr>
           <a:xfrm>
-            <a:off x="502920" y="1481328"/>
+            <a:off x="502920" y="1371600"/>
             <a:ext cx="4480560" cy="1097280"/>
           </a:xfrm>
           <a:prstGeom prst="rect">
@@ -3327,7 +3327,7 @@
         </p:blipFill>
         <p:spPr>
           <a:xfrm rot="21420000">
-            <a:off x="5532120" y="1170432"/>
+            <a:off x="5532120" y="1060704"/>
             <a:ext cx="1737360" cy="1456954"/>
           </a:xfrm>
           <a:prstGeom prst="rect">
@@ -3343,7 +3343,7 @@
         </p:nvSpPr>
         <p:spPr>
           <a:xfrm>
-            <a:off x="502920" y="2743200"/>
+            <a:off x="502920" y="2633472"/>
             <a:ext cx="2179320" cy="548640"/>
           </a:xfrm>
           <a:prstGeom prst="roundRect">
@@ -3391,8 +3391,8 @@
         </p:nvSpPr>
         <p:spPr>
           <a:xfrm>
-            <a:off x="640080" y="2807208"/>
-            <a:ext cx="1905000" cy="274320"/>
+            <a:off x="640080" y="2679191"/>
+            <a:ext cx="1905000" cy="320040"/>
           </a:xfrm>
           <a:prstGeom prst="rect">
             <a:avLst/>
@@ -3407,7 +3407,7 @@
           <a:p>
             <a:pPr algn="l"/>
             <a:r>
-              <a:rPr sz="1425" b="1">
+              <a:rPr sz="1650" b="1">
                 <a:solidFill>
                   <a:srgbClr val="111111"/>
                 </a:solidFill>
@@ -3426,7 +3426,7 @@
         </p:nvSpPr>
         <p:spPr>
           <a:xfrm>
-            <a:off x="640080" y="3063240"/>
+            <a:off x="640080" y="2980944"/>
             <a:ext cx="1905000" cy="182880"/>
           </a:xfrm>
           <a:prstGeom prst="rect">
@@ -3461,7 +3461,7 @@
         </p:nvSpPr>
         <p:spPr>
           <a:xfrm>
-            <a:off x="2796540" y="2743200"/>
+            <a:off x="2796540" y="2633472"/>
             <a:ext cx="2179320" cy="548640"/>
           </a:xfrm>
           <a:prstGeom prst="roundRect">
@@ -3509,8 +3509,8 @@
         </p:nvSpPr>
         <p:spPr>
           <a:xfrm>
-            <a:off x="2933700" y="2807208"/>
-            <a:ext cx="1905000" cy="274320"/>
+            <a:off x="2933700" y="2679191"/>
+            <a:ext cx="1905000" cy="320040"/>
           </a:xfrm>
           <a:prstGeom prst="rect">
             <a:avLst/>
@@ -3525,7 +3525,7 @@
           <a:p>
             <a:pPr algn="l"/>
             <a:r>
-              <a:rPr sz="1425" b="1">
+              <a:rPr sz="1650" b="1">
                 <a:solidFill>
                   <a:srgbClr val="111111"/>
                 </a:solidFill>
@@ -3544,7 +3544,7 @@
         </p:nvSpPr>
         <p:spPr>
           <a:xfrm>
-            <a:off x="2933700" y="3063240"/>
+            <a:off x="2933700" y="2980944"/>
             <a:ext cx="1905000" cy="182880"/>
           </a:xfrm>
           <a:prstGeom prst="rect">
@@ -3579,7 +3579,7 @@
         </p:nvSpPr>
         <p:spPr>
           <a:xfrm>
-            <a:off x="5090160" y="2743200"/>
+            <a:off x="5090160" y="2633472"/>
             <a:ext cx="2179320" cy="548640"/>
           </a:xfrm>
           <a:prstGeom prst="roundRect">
@@ -3627,8 +3627,8 @@
         </p:nvSpPr>
         <p:spPr>
           <a:xfrm>
-            <a:off x="5227320" y="2807208"/>
-            <a:ext cx="1905000" cy="274320"/>
+            <a:off x="5227320" y="2679191"/>
+            <a:ext cx="1905000" cy="320040"/>
           </a:xfrm>
           <a:prstGeom prst="rect">
             <a:avLst/>
@@ -3643,7 +3643,7 @@
           <a:p>
             <a:pPr algn="l"/>
             <a:r>
-              <a:rPr sz="1425" b="1">
+              <a:rPr sz="1650" b="1">
                 <a:solidFill>
                   <a:srgbClr val="111111"/>
                 </a:solidFill>
@@ -3662,7 +3662,7 @@
         </p:nvSpPr>
         <p:spPr>
           <a:xfrm>
-            <a:off x="5227320" y="3063240"/>
+            <a:off x="5227320" y="2980944"/>
             <a:ext cx="1905000" cy="182880"/>
           </a:xfrm>
           <a:prstGeom prst="rect">
@@ -3697,7 +3697,7 @@
         </p:nvSpPr>
         <p:spPr>
           <a:xfrm>
-            <a:off x="502920" y="3438144"/>
+            <a:off x="502920" y="3328415"/>
             <a:ext cx="6766560" cy="960120"/>
           </a:xfrm>
           <a:prstGeom prst="roundRect">
@@ -3745,7 +3745,7 @@
         </p:nvSpPr>
         <p:spPr>
           <a:xfrm>
-            <a:off x="658368" y="3529584"/>
+            <a:off x="658368" y="3419856"/>
             <a:ext cx="6455664" cy="274320"/>
           </a:xfrm>
           <a:prstGeom prst="rect">
@@ -3780,7 +3780,7 @@
         </p:nvSpPr>
         <p:spPr>
           <a:xfrm>
-            <a:off x="658368" y="3785615"/>
+            <a:off x="658368" y="3675887"/>
             <a:ext cx="6455664" cy="594360"/>
           </a:xfrm>
           <a:prstGeom prst="rect">
@@ -3819,7 +3819,7 @@
         </p:nvSpPr>
         <p:spPr>
           <a:xfrm>
-            <a:off x="502920" y="4553712"/>
+            <a:off x="502920" y="4443984"/>
             <a:ext cx="6583680" cy="274320"/>
           </a:xfrm>
           <a:prstGeom prst="rect">
@@ -3854,7 +3854,7 @@
         </p:nvSpPr>
         <p:spPr>
           <a:xfrm>
-            <a:off x="502920" y="4818888"/>
+            <a:off x="502920" y="4709159"/>
             <a:ext cx="6766560" cy="182880"/>
           </a:xfrm>
           <a:prstGeom prst="rect">
@@ -3889,7 +3889,7 @@
         </p:nvSpPr>
         <p:spPr>
           <a:xfrm>
-            <a:off x="502920" y="5047488"/>
+            <a:off x="502920" y="4937759"/>
             <a:ext cx="1565910" cy="182880"/>
           </a:xfrm>
           <a:prstGeom prst="rect">
@@ -3924,7 +3924,7 @@
         </p:nvSpPr>
         <p:spPr>
           <a:xfrm>
-            <a:off x="502920" y="5230368"/>
+            <a:off x="502920" y="5120640"/>
             <a:ext cx="1474470" cy="365760"/>
           </a:xfrm>
           <a:prstGeom prst="rect">
@@ -3963,7 +3963,7 @@
         </p:nvSpPr>
         <p:spPr>
           <a:xfrm>
-            <a:off x="2251710" y="5047488"/>
+            <a:off x="2251710" y="4937759"/>
             <a:ext cx="1565910" cy="182880"/>
           </a:xfrm>
           <a:prstGeom prst="rect">
@@ -3998,7 +3998,7 @@
         </p:nvSpPr>
         <p:spPr>
           <a:xfrm>
-            <a:off x="2251710" y="5230368"/>
+            <a:off x="2251710" y="5120640"/>
             <a:ext cx="1474470" cy="365760"/>
           </a:xfrm>
           <a:prstGeom prst="rect">
@@ -4037,7 +4037,7 @@
         </p:nvSpPr>
         <p:spPr>
           <a:xfrm>
-            <a:off x="4000500" y="5047488"/>
+            <a:off x="4000500" y="4937759"/>
             <a:ext cx="1565910" cy="182880"/>
           </a:xfrm>
           <a:prstGeom prst="rect">
@@ -4072,7 +4072,7 @@
         </p:nvSpPr>
         <p:spPr>
           <a:xfrm>
-            <a:off x="4000500" y="5230368"/>
+            <a:off x="4000500" y="5120640"/>
             <a:ext cx="1474470" cy="365760"/>
           </a:xfrm>
           <a:prstGeom prst="rect">
@@ -4111,7 +4111,7 @@
         </p:nvSpPr>
         <p:spPr>
           <a:xfrm>
-            <a:off x="5749290" y="5047488"/>
+            <a:off x="5749290" y="4937759"/>
             <a:ext cx="1565910" cy="182880"/>
           </a:xfrm>
           <a:prstGeom prst="rect">
@@ -4146,7 +4146,7 @@
         </p:nvSpPr>
         <p:spPr>
           <a:xfrm>
-            <a:off x="5749290" y="5230368"/>
+            <a:off x="5749290" y="5120640"/>
             <a:ext cx="1474470" cy="365760"/>
           </a:xfrm>
           <a:prstGeom prst="rect">
@@ -4185,7 +4185,7 @@
         </p:nvSpPr>
         <p:spPr>
           <a:xfrm>
-            <a:off x="502920" y="5641848"/>
+            <a:off x="502920" y="5532120"/>
             <a:ext cx="6583680" cy="274320"/>
           </a:xfrm>
           <a:prstGeom prst="rect">
@@ -4220,7 +4220,7 @@
         </p:nvSpPr>
         <p:spPr>
           <a:xfrm>
-            <a:off x="502920" y="5897880"/>
+            <a:off x="502920" y="5788152"/>
             <a:ext cx="2179320" cy="1188720"/>
           </a:xfrm>
           <a:prstGeom prst="roundRect">
@@ -4268,7 +4268,7 @@
         </p:nvSpPr>
         <p:spPr>
           <a:xfrm>
-            <a:off x="640080" y="6044184"/>
+            <a:off x="640080" y="5934456"/>
             <a:ext cx="1905000" cy="228600"/>
           </a:xfrm>
           <a:prstGeom prst="rect">
@@ -4303,7 +4303,7 @@
         </p:nvSpPr>
         <p:spPr>
           <a:xfrm>
-            <a:off x="640080" y="6254496"/>
+            <a:off x="640080" y="6144768"/>
             <a:ext cx="1905000" cy="182880"/>
           </a:xfrm>
           <a:prstGeom prst="rect">
@@ -4338,7 +4338,7 @@
         </p:nvSpPr>
         <p:spPr>
           <a:xfrm>
-            <a:off x="640080" y="6492240"/>
+            <a:off x="640080" y="6382512"/>
             <a:ext cx="1905000" cy="548640"/>
           </a:xfrm>
           <a:prstGeom prst="rect">
@@ -4409,7 +4409,7 @@
         </p:nvSpPr>
         <p:spPr>
           <a:xfrm>
-            <a:off x="2796540" y="5897880"/>
+            <a:off x="2796540" y="5788152"/>
             <a:ext cx="2179320" cy="1188720"/>
           </a:xfrm>
           <a:prstGeom prst="roundRect">
@@ -4457,7 +4457,7 @@
         </p:nvSpPr>
         <p:spPr>
           <a:xfrm>
-            <a:off x="2933700" y="6044184"/>
+            <a:off x="2933700" y="5934456"/>
             <a:ext cx="1905000" cy="228600"/>
           </a:xfrm>
           <a:prstGeom prst="rect">
@@ -4492,7 +4492,7 @@
         </p:nvSpPr>
         <p:spPr>
           <a:xfrm>
-            <a:off x="2933700" y="6254496"/>
+            <a:off x="2933700" y="6144768"/>
             <a:ext cx="1905000" cy="182880"/>
           </a:xfrm>
           <a:prstGeom prst="rect">
@@ -4527,7 +4527,7 @@
         </p:nvSpPr>
         <p:spPr>
           <a:xfrm>
-            <a:off x="2933700" y="6492240"/>
+            <a:off x="2933700" y="6382512"/>
             <a:ext cx="1905000" cy="548640"/>
           </a:xfrm>
           <a:prstGeom prst="rect">
@@ -4598,7 +4598,7 @@
         </p:nvSpPr>
         <p:spPr>
           <a:xfrm>
-            <a:off x="5090160" y="5897880"/>
+            <a:off x="5090160" y="5788152"/>
             <a:ext cx="2179320" cy="1188720"/>
           </a:xfrm>
           <a:prstGeom prst="roundRect">
@@ -4646,7 +4646,7 @@
         </p:nvSpPr>
         <p:spPr>
           <a:xfrm>
-            <a:off x="5227320" y="6044184"/>
+            <a:off x="5227320" y="5934456"/>
             <a:ext cx="1905000" cy="228600"/>
           </a:xfrm>
           <a:prstGeom prst="rect">
@@ -4681,7 +4681,7 @@
         </p:nvSpPr>
         <p:spPr>
           <a:xfrm>
-            <a:off x="5227320" y="6254496"/>
+            <a:off x="5227320" y="6144768"/>
             <a:ext cx="1905000" cy="182880"/>
           </a:xfrm>
           <a:prstGeom prst="rect">
@@ -4716,7 +4716,7 @@
         </p:nvSpPr>
         <p:spPr>
           <a:xfrm>
-            <a:off x="5227320" y="6492240"/>
+            <a:off x="5227320" y="6382512"/>
             <a:ext cx="1905000" cy="548640"/>
           </a:xfrm>
           <a:prstGeom prst="rect">
@@ -4787,7 +4787,7 @@
         </p:nvSpPr>
         <p:spPr>
           <a:xfrm>
-            <a:off x="502920" y="7251192"/>
+            <a:off x="502920" y="7141464"/>
             <a:ext cx="6583680" cy="274320"/>
           </a:xfrm>
           <a:prstGeom prst="rect">
@@ -4822,7 +4822,7 @@
         </p:nvSpPr>
         <p:spPr>
           <a:xfrm>
-            <a:off x="502920" y="7534656"/>
+            <a:off x="502920" y="7424928"/>
             <a:ext cx="1005840" cy="164592"/>
           </a:xfrm>
           <a:prstGeom prst="rect">
@@ -4857,8 +4857,8 @@
         </p:nvSpPr>
         <p:spPr>
           <a:xfrm>
-            <a:off x="1600200" y="7534656"/>
-            <a:ext cx="2133752" cy="162763"/>
+            <a:off x="1463040" y="7424928"/>
+            <a:ext cx="2270912" cy="162763"/>
           </a:xfrm>
           <a:prstGeom prst="rect">
             <a:avLst/>
@@ -4892,7 +4892,7 @@
         </p:nvSpPr>
         <p:spPr>
           <a:xfrm>
-            <a:off x="502920" y="7697419"/>
+            <a:off x="502920" y="7587691"/>
             <a:ext cx="1005840" cy="164592"/>
           </a:xfrm>
           <a:prstGeom prst="rect">
@@ -4927,8 +4927,8 @@
         </p:nvSpPr>
         <p:spPr>
           <a:xfrm>
-            <a:off x="1600200" y="7697419"/>
-            <a:ext cx="2133752" cy="162763"/>
+            <a:off x="1463040" y="7587691"/>
+            <a:ext cx="2270912" cy="162763"/>
           </a:xfrm>
           <a:prstGeom prst="rect">
             <a:avLst/>
@@ -4962,7 +4962,7 @@
         </p:nvSpPr>
         <p:spPr>
           <a:xfrm>
-            <a:off x="502920" y="7860182"/>
+            <a:off x="502920" y="7750454"/>
             <a:ext cx="1005840" cy="164592"/>
           </a:xfrm>
           <a:prstGeom prst="rect">
@@ -4997,8 +4997,8 @@
         </p:nvSpPr>
         <p:spPr>
           <a:xfrm>
-            <a:off x="1600200" y="7860182"/>
-            <a:ext cx="2133752" cy="162763"/>
+            <a:off x="1463040" y="7750454"/>
+            <a:ext cx="2270912" cy="162763"/>
           </a:xfrm>
           <a:prstGeom prst="rect">
             <a:avLst/>
@@ -5032,7 +5032,7 @@
         </p:nvSpPr>
         <p:spPr>
           <a:xfrm>
-            <a:off x="502920" y="8022945"/>
+            <a:off x="502920" y="7913217"/>
             <a:ext cx="1005840" cy="164592"/>
           </a:xfrm>
           <a:prstGeom prst="rect">
@@ -5067,8 +5067,8 @@
         </p:nvSpPr>
         <p:spPr>
           <a:xfrm>
-            <a:off x="1600200" y="8022945"/>
-            <a:ext cx="2133752" cy="162763"/>
+            <a:off x="1463040" y="7913217"/>
+            <a:ext cx="2270912" cy="162763"/>
           </a:xfrm>
           <a:prstGeom prst="rect">
             <a:avLst/>
@@ -5102,7 +5102,7 @@
         </p:nvSpPr>
         <p:spPr>
           <a:xfrm>
-            <a:off x="502920" y="8185708"/>
+            <a:off x="502920" y="8075980"/>
             <a:ext cx="1005840" cy="164592"/>
           </a:xfrm>
           <a:prstGeom prst="rect">
@@ -5137,8 +5137,8 @@
         </p:nvSpPr>
         <p:spPr>
           <a:xfrm>
-            <a:off x="1600200" y="8185708"/>
-            <a:ext cx="2133752" cy="277063"/>
+            <a:off x="1463040" y="8075980"/>
+            <a:ext cx="2270912" cy="277063"/>
           </a:xfrm>
           <a:prstGeom prst="rect">
             <a:avLst/>
@@ -5172,7 +5172,7 @@
         </p:nvSpPr>
         <p:spPr>
           <a:xfrm>
-            <a:off x="502920" y="8462772"/>
+            <a:off x="502920" y="8353044"/>
             <a:ext cx="1005840" cy="164592"/>
           </a:xfrm>
           <a:prstGeom prst="rect">
@@ -5207,8 +5207,8 @@
         </p:nvSpPr>
         <p:spPr>
           <a:xfrm>
-            <a:off x="1600200" y="8462772"/>
-            <a:ext cx="2133752" cy="162763"/>
+            <a:off x="1463040" y="8353044"/>
+            <a:ext cx="2270912" cy="162763"/>
           </a:xfrm>
           <a:prstGeom prst="rect">
             <a:avLst/>
@@ -5242,7 +5242,7 @@
         </p:nvSpPr>
         <p:spPr>
           <a:xfrm>
-            <a:off x="4038447" y="7534656"/>
+            <a:off x="4038447" y="7424928"/>
             <a:ext cx="1005840" cy="164592"/>
           </a:xfrm>
           <a:prstGeom prst="rect">
@@ -5277,8 +5277,8 @@
         </p:nvSpPr>
         <p:spPr>
           <a:xfrm>
-            <a:off x="5135727" y="7534656"/>
-            <a:ext cx="2133752" cy="162763"/>
+            <a:off x="4998567" y="7424928"/>
+            <a:ext cx="2270912" cy="162763"/>
           </a:xfrm>
           <a:prstGeom prst="rect">
             <a:avLst/>
@@ -5312,7 +5312,7 @@
         </p:nvSpPr>
         <p:spPr>
           <a:xfrm>
-            <a:off x="4038447" y="7697419"/>
+            <a:off x="4038447" y="7587691"/>
             <a:ext cx="1005840" cy="164592"/>
           </a:xfrm>
           <a:prstGeom prst="rect">
@@ -5347,8 +5347,8 @@
         </p:nvSpPr>
         <p:spPr>
           <a:xfrm>
-            <a:off x="5135727" y="7697419"/>
-            <a:ext cx="2133752" cy="162763"/>
+            <a:off x="4998567" y="7587691"/>
+            <a:ext cx="2270912" cy="162763"/>
           </a:xfrm>
           <a:prstGeom prst="rect">
             <a:avLst/>
@@ -5382,7 +5382,7 @@
         </p:nvSpPr>
         <p:spPr>
           <a:xfrm>
-            <a:off x="4038447" y="7860182"/>
+            <a:off x="4038447" y="7750454"/>
             <a:ext cx="1005840" cy="164592"/>
           </a:xfrm>
           <a:prstGeom prst="rect">
@@ -5417,8 +5417,8 @@
         </p:nvSpPr>
         <p:spPr>
           <a:xfrm>
-            <a:off x="5135727" y="7860182"/>
-            <a:ext cx="2133752" cy="162763"/>
+            <a:off x="4998567" y="7750454"/>
+            <a:ext cx="2270912" cy="162763"/>
           </a:xfrm>
           <a:prstGeom prst="rect">
             <a:avLst/>
@@ -5452,7 +5452,7 @@
         </p:nvSpPr>
         <p:spPr>
           <a:xfrm>
-            <a:off x="4038447" y="8022945"/>
+            <a:off x="4038447" y="7913217"/>
             <a:ext cx="1005840" cy="164592"/>
           </a:xfrm>
           <a:prstGeom prst="rect">
@@ -5487,8 +5487,8 @@
         </p:nvSpPr>
         <p:spPr>
           <a:xfrm>
-            <a:off x="5135727" y="8022945"/>
-            <a:ext cx="2133752" cy="162763"/>
+            <a:off x="4998567" y="7913217"/>
+            <a:ext cx="2270912" cy="162763"/>
           </a:xfrm>
           <a:prstGeom prst="rect">
             <a:avLst/>
@@ -5522,7 +5522,7 @@
         </p:nvSpPr>
         <p:spPr>
           <a:xfrm>
-            <a:off x="4038447" y="8185708"/>
+            <a:off x="4038447" y="8075980"/>
             <a:ext cx="1005840" cy="164592"/>
           </a:xfrm>
           <a:prstGeom prst="rect">
@@ -5557,8 +5557,8 @@
         </p:nvSpPr>
         <p:spPr>
           <a:xfrm>
-            <a:off x="5135727" y="8185708"/>
-            <a:ext cx="2133752" cy="162763"/>
+            <a:off x="4998567" y="8075980"/>
+            <a:ext cx="2270912" cy="162763"/>
           </a:xfrm>
           <a:prstGeom prst="rect">
             <a:avLst/>
@@ -5592,7 +5592,7 @@
         </p:nvSpPr>
         <p:spPr>
           <a:xfrm>
-            <a:off x="4038447" y="8348472"/>
+            <a:off x="4038447" y="8238744"/>
             <a:ext cx="1005840" cy="164592"/>
           </a:xfrm>
           <a:prstGeom prst="rect">
@@ -5627,8 +5627,8 @@
         </p:nvSpPr>
         <p:spPr>
           <a:xfrm>
-            <a:off x="5135727" y="8348472"/>
-            <a:ext cx="2133752" cy="162763"/>
+            <a:off x="4998567" y="8238744"/>
+            <a:ext cx="2270912" cy="162763"/>
           </a:xfrm>
           <a:prstGeom prst="rect">
             <a:avLst/>

</xml_diff>